<commit_message>
Align paper and deck with APA 7 academic writing guidelines
Paragraph-level attribution, "et al." from first mention, no dashes as
separators, third person outside the personal-opinion section, each chapter
on a new page, David/Times New Roman 12 double-spaced, reference list
without sub-headings and cross-checked against the body.

Co-Authored-By: Claude Fable 5.1 <noreply@anthropic.com>
Claude-Session: https://claude.ai/code/session_01XaGvnsaHG3kPyCY3aGBByx
</commit_message>
<xml_diff>
--- a/career-management-final-project/ניהול קריירה - התמודדות עם חוסר ודאות תעסוקתי - מצגת.pptx
+++ b/career-management-final-project/ניהול קריירה - התמודדות עם חוסר ודאות תעסוקתי - מצגת.pptx
@@ -3388,7 +3388,7 @@
                 <a:ea typeface="Arial" pitchFamily="34" charset="-122"/>
                 <a:cs typeface="Arial" pitchFamily="34" charset="-120"/>
               </a:rPr>
-              <a:t>המאמר המשלים של לי, הואנג ואשפורד (2018) מוסיף: העוצמה משתנה בין תרבויות ומדינות, ובעולם העבודה החדש חוסר ביטחון הוא מצב כרוני, לא אירוע.</a:t>
+              <a:t>המאמר המשלים של לי ואחרים (Lee et al., 2018) מוסיף: העוצמה משתנה בין תרבויות ומדינות, ובעולם העבודה החדש חוסר ביטחון הוא מצב כרוני, לא אירוע.</a:t>
             </a:r>
             <a:endParaRPr lang="he-IL" sz="1400" dirty="0"/>
           </a:p>
@@ -4000,7 +4000,7 @@
                 <a:ea typeface="Arial" pitchFamily="34" charset="-122"/>
                 <a:cs typeface="Arial" pitchFamily="34" charset="-120"/>
               </a:rPr>
-              <a:t>המאמר צודק שחוסר ביטחון הוא בעיקר גורם לחץ מזיק. אבל לאור "ממשבר להזדמנות" והתרבות הישראלית של אלתור, אנחנו מאמינים שמידה של חוסר ודאות יכולה להיות מנוע לצמיחה – בתנאי שיש משאבים. בלי משאבים חוסר ודאות משתק; עם משאבים הוא מניע.</a:t>
+              <a:t>המאמר צודק שחוסר ביטחון הוא בעיקר גורם לחץ מזיק. אבל לאור "ממשבר להזדמנות" (דבדבני דקל, 2026ב) והתרבות הישראלית של אלתור, אנחנו מאמינים שמידה של חוסר ודאות יכולה להיות מנוע לצמיחה – בתנאי שיש משאבים. בלי משאבים חוסר ודאות משתק; עם משאבים הוא מניע.</a:t>
             </a:r>
             <a:endParaRPr lang="he-IL" sz="1450" dirty="0"/>
           </a:p>
@@ -5761,7 +5761,7 @@
                 <a:ea typeface="Arial" pitchFamily="34" charset="-122"/>
                 <a:cs typeface="Arial" pitchFamily="34" charset="-120"/>
               </a:rPr>
-              <a:t>מתחבר ל"שלושת סלי הכלים" מהקורס: רשת אנשים = תמיכה, זהות מקצועית = פחות איום איכותני, למידה = יכולת תעסוקה</a:t>
+              <a:t>מתחבר ל"שלושת סלי הכלים" מהקורס (דבדבני דקל, 2026א): רשת אנשים = תמיכה, זהות מקצועית = פחות איום איכותני, למידה = יכולת תעסוקה</a:t>
             </a:r>
             <a:endParaRPr lang="he-IL" sz="1350" dirty="0"/>
           </a:p>
@@ -7662,8 +7662,8 @@
         </p:nvSpPr>
         <p:spPr>
           <a:xfrm>
-            <a:off x="548640" y="1234440"/>
-            <a:ext cx="11091672" cy="4206240"/>
+            <a:off x="548640" y="1188720"/>
+            <a:ext cx="11091672" cy="3931920"/>
           </a:xfrm>
           <a:prstGeom prst="rect">
             <a:avLst/>
@@ -7682,7 +7682,7 @@
               <a:buNone/>
             </a:pPr>
             <a:r>
-              <a:rPr lang="en-US" sz="1050" dirty="0">
+              <a:rPr lang="en-US" sz="1000" dirty="0">
                 <a:solidFill>
                   <a:srgbClr val="1F2937"/>
                 </a:solidFill>
@@ -7692,7 +7692,7 @@
               </a:rPr>
               <a:t>Ashford, S. J., Lee, C., &amp; Bobko, P. (1989). Content, causes, and consequences of job insecurity: A theory-based measure and substantive test. Academy of Management Journal, 32(4), 803–829.</a:t>
             </a:r>
-            <a:endParaRPr lang="en-US" sz="1050" dirty="0"/>
+            <a:endParaRPr lang="en-US" sz="1000" dirty="0"/>
           </a:p>
           <a:p>
             <a:pPr algn="l" indent="0" marL="0">
@@ -7702,7 +7702,7 @@
               <a:buNone/>
             </a:pPr>
             <a:r>
-              <a:rPr lang="en-US" sz="1050" dirty="0">
+              <a:rPr lang="en-US" sz="1000" dirty="0">
                 <a:solidFill>
                   <a:srgbClr val="1F2937"/>
                 </a:solidFill>
@@ -7712,7 +7712,7 @@
               </a:rPr>
               <a:t>Hellgren, J., Sverke, M., &amp; Isaksson, K. (1999). A two-dimensional approach to job insecurity: Consequences for employee attitudes and well-being. European Journal of Work and Organizational Psychology, 8(2), 179–195.</a:t>
             </a:r>
-            <a:endParaRPr lang="en-US" sz="1050" dirty="0"/>
+            <a:endParaRPr lang="en-US" sz="1000" dirty="0"/>
           </a:p>
           <a:p>
             <a:pPr algn="l" indent="0" marL="0">
@@ -7722,7 +7722,7 @@
               <a:buNone/>
             </a:pPr>
             <a:r>
-              <a:rPr lang="en-US" sz="1050" dirty="0">
+              <a:rPr lang="en-US" sz="1000" dirty="0">
                 <a:solidFill>
                   <a:srgbClr val="1F2937"/>
                 </a:solidFill>
@@ -7732,7 +7732,7 @@
               </a:rPr>
               <a:t>Hobfoll, S. E. (1989). Conservation of resources: A new attempt at conceptualizing stress. American Psychologist, 44(3), 513–524.</a:t>
             </a:r>
-            <a:endParaRPr lang="en-US" sz="1050" dirty="0"/>
+            <a:endParaRPr lang="en-US" sz="1000" dirty="0"/>
           </a:p>
           <a:p>
             <a:pPr algn="l" indent="0" marL="0">
@@ -7742,7 +7742,7 @@
               <a:buNone/>
             </a:pPr>
             <a:r>
-              <a:rPr lang="en-US" sz="1050" dirty="0">
+              <a:rPr lang="en-US" sz="1000" dirty="0">
                 <a:solidFill>
                   <a:srgbClr val="1F2937"/>
                 </a:solidFill>
@@ -7752,7 +7752,7 @@
               </a:rPr>
               <a:t>Hone, L. (2019). 3 secrets of resilient people [Video]. TED Conferences. https://www.ted.com/talks/lucy_hone_the_three_secrets_of_resilient_people</a:t>
             </a:r>
-            <a:endParaRPr lang="en-US" sz="1050" dirty="0"/>
+            <a:endParaRPr lang="en-US" sz="1000" dirty="0"/>
           </a:p>
           <a:p>
             <a:pPr algn="l" indent="0" marL="0">
@@ -7762,7 +7762,7 @@
               <a:buNone/>
             </a:pPr>
             <a:r>
-              <a:rPr lang="en-US" sz="1050" dirty="0">
+              <a:rPr lang="en-US" sz="1000" dirty="0">
                 <a:solidFill>
                   <a:srgbClr val="1F2937"/>
                 </a:solidFill>
@@ -7772,7 +7772,7 @@
               </a:rPr>
               <a:t>Jiang, L., &amp; Lavaysse, L. M. (2018). Cognitive and affective job insecurity: A meta-analysis and a primary study. Journal of Management, 44(6), 2307–2342. https://doi.org/10.1177/0149206318773853</a:t>
             </a:r>
-            <a:endParaRPr lang="en-US" sz="1050" dirty="0"/>
+            <a:endParaRPr lang="en-US" sz="1000" dirty="0"/>
           </a:p>
           <a:p>
             <a:pPr algn="l" indent="0" marL="0">
@@ -7782,7 +7782,7 @@
               <a:buNone/>
             </a:pPr>
             <a:r>
-              <a:rPr lang="en-US" sz="1050" dirty="0">
+              <a:rPr lang="en-US" sz="1000" dirty="0">
                 <a:solidFill>
                   <a:srgbClr val="1F2937"/>
                 </a:solidFill>
@@ -7792,7 +7792,7 @@
               </a:rPr>
               <a:t>Lazarus, R. S., &amp; Folkman, S. (1984). Stress, appraisal, and coping. Springer.</a:t>
             </a:r>
-            <a:endParaRPr lang="en-US" sz="1050" dirty="0"/>
+            <a:endParaRPr lang="en-US" sz="1000" dirty="0"/>
           </a:p>
           <a:p>
             <a:pPr algn="l" indent="0" marL="0">
@@ -7802,7 +7802,7 @@
               <a:buNone/>
             </a:pPr>
             <a:r>
-              <a:rPr lang="en-US" sz="1050" dirty="0">
+              <a:rPr lang="en-US" sz="1000" dirty="0">
                 <a:solidFill>
                   <a:srgbClr val="1F2937"/>
                 </a:solidFill>
@@ -7812,7 +7812,7 @@
               </a:rPr>
               <a:t>Lee, C., Huang, G.-H., &amp; Ashford, S. J. (2018). Job insecurity and the changing workplace: Recent developments and the future trends in job insecurity research. Annual Review of Organizational Psychology and Organizational Behavior, 5, 335–359. https://doi.org/10.1146/annurev-orgpsych-032117-104651</a:t>
             </a:r>
-            <a:endParaRPr lang="en-US" sz="1050" dirty="0"/>
+            <a:endParaRPr lang="en-US" sz="1000" dirty="0"/>
           </a:p>
           <a:p>
             <a:pPr algn="l" indent="0" marL="0">
@@ -7822,7 +7822,7 @@
               <a:buNone/>
             </a:pPr>
             <a:r>
-              <a:rPr lang="en-US" sz="1050" dirty="0">
+              <a:rPr lang="en-US" sz="1000" dirty="0">
                 <a:solidFill>
                   <a:srgbClr val="1F2937"/>
                 </a:solidFill>
@@ -7832,7 +7832,7 @@
               </a:rPr>
               <a:t>Russo, M., Shteigman, A., &amp; Carmeli, A. (2016). Workplace and family support and work–life balance: Implications for individual psychological availability and energy at work. The Journal of Positive Psychology, 11(2), 173–188.</a:t>
             </a:r>
-            <a:endParaRPr lang="en-US" sz="1050" dirty="0"/>
+            <a:endParaRPr lang="en-US" sz="1000" dirty="0"/>
           </a:p>
           <a:p>
             <a:pPr algn="l" indent="0" marL="0">
@@ -7842,7 +7842,7 @@
               <a:buNone/>
             </a:pPr>
             <a:r>
-              <a:rPr lang="en-US" sz="1050" dirty="0">
+              <a:rPr lang="en-US" sz="1000" dirty="0">
                 <a:solidFill>
                   <a:srgbClr val="1F2937"/>
                 </a:solidFill>
@@ -7852,7 +7852,7 @@
               </a:rPr>
               <a:t>Schein, E. H. (1996). Career anchors revisited: Implications for career development in the 21st century. Academy of Management Executive, 10(4), 80–88.</a:t>
             </a:r>
-            <a:endParaRPr lang="en-US" sz="1050" dirty="0"/>
+            <a:endParaRPr lang="en-US" sz="1000" dirty="0"/>
           </a:p>
           <a:p>
             <a:pPr algn="l" indent="0" marL="0">
@@ -7862,7 +7862,7 @@
               <a:buNone/>
             </a:pPr>
             <a:r>
-              <a:rPr lang="en-US" sz="1050" dirty="0">
+              <a:rPr lang="en-US" sz="1000" dirty="0">
                 <a:solidFill>
                   <a:srgbClr val="1F2937"/>
                 </a:solidFill>
@@ -7872,7 +7872,7 @@
               </a:rPr>
               <a:t>Shoss, M. K. (2017). Job insecurity: An integrative review and agenda for future research. Journal of Management, 43(6), 1911–1939. https://doi.org/10.1177/0149206317691574</a:t>
             </a:r>
-            <a:endParaRPr lang="en-US" sz="1050" dirty="0"/>
+            <a:endParaRPr lang="en-US" sz="1000" dirty="0"/>
           </a:p>
         </p:txBody>
       </p:sp>
@@ -7884,8 +7884,8 @@
         </p:nvSpPr>
         <p:spPr>
           <a:xfrm>
-            <a:off x="548640" y="5486400"/>
-            <a:ext cx="11091672" cy="868680"/>
+            <a:off x="548640" y="5120640"/>
+            <a:ext cx="11091672" cy="1280160"/>
           </a:xfrm>
           <a:prstGeom prst="rect">
             <a:avLst/>
@@ -7918,6 +7918,9 @@
           </a:p>
           <a:p>
             <a:pPr algn="r" indent="0" marL="0">
+              <a:spcAft>
+                <a:spcPts val="500"/>
+              </a:spcAft>
               <a:buNone/>
             </a:pPr>
             <a:r>
@@ -7929,7 +7932,44 @@
                 <a:ea typeface="Arial" pitchFamily="34" charset="-122"/>
                 <a:cs typeface="Arial" pitchFamily="34" charset="-120"/>
               </a:rPr>
-              <a:t>TheMarker (2026, 21 ביוני). הקשיים של מנהלי הייטק ב-2026: גיוס עובדים מתאימים – והתייעלות AI.</a:t>
+              <a:t>דבדבני דקל, מ' (2026א). מחזון ורעיון למציאות ממשית [מצגת הרצאה]. ניהול קריירה בארגונים, הקריה האקדמית אונו.</a:t>
+            </a:r>
+            <a:endParaRPr lang="he-IL" sz="1050" dirty="0"/>
+          </a:p>
+          <a:p>
+            <a:pPr algn="r" indent="0" marL="0">
+              <a:spcAft>
+                <a:spcPts val="500"/>
+              </a:spcAft>
+              <a:buNone/>
+            </a:pPr>
+            <a:r>
+              <a:rPr lang="he-IL" altLang="en-US" sz="1050" dirty="0">
+                <a:solidFill>
+                  <a:srgbClr val="1F2937"/>
+                </a:solidFill>
+                <a:latin typeface="Arial" pitchFamily="34" charset="0"/>
+                <a:ea typeface="Arial" pitchFamily="34" charset="-122"/>
+                <a:cs typeface="Arial" pitchFamily="34" charset="-120"/>
+              </a:rPr>
+              <a:t>דבדבני דקל, מ' (2026ב). עסקים בצל הקורונה: ממשבר להזדמנות, איך עושים את זה? [מצגת הרצאה]. ניהול קריירה בארגונים, הקריה האקדמית אונו.</a:t>
+            </a:r>
+            <a:endParaRPr lang="he-IL" sz="1050" dirty="0"/>
+          </a:p>
+          <a:p>
+            <a:pPr algn="r" indent="0" marL="0">
+              <a:buNone/>
+            </a:pPr>
+            <a:r>
+              <a:rPr lang="he-IL" altLang="en-US" sz="1050" dirty="0">
+                <a:solidFill>
+                  <a:srgbClr val="1F2937"/>
+                </a:solidFill>
+                <a:latin typeface="Arial" pitchFamily="34" charset="0"/>
+                <a:ea typeface="Arial" pitchFamily="34" charset="-122"/>
+                <a:cs typeface="Arial" pitchFamily="34" charset="-120"/>
+              </a:rPr>
+              <a:t>הקשיים של מנהלי הייטק ב-2026: גיוס עובדים מתאימים והתייעלות AI. (2026, 21 ביוני). TheMarker.</a:t>
             </a:r>
             <a:endParaRPr lang="he-IL" sz="1050" dirty="0"/>
           </a:p>
@@ -10759,7 +10799,7 @@
                 <a:ea typeface="Arial" pitchFamily="34" charset="-122"/>
                 <a:cs typeface="Arial" pitchFamily="34" charset="-120"/>
               </a:rPr>
-              <a:t>גלי פיטורים ו"התייעלות AI" בראש סדר היום של מנהלים ב-2026 (TheMarker, 21.6.2026)</a:t>
+              <a:t>גלי פיטורים ו"התייעלות AI" בראש סדר היום של מנהלים ב-2026 ("הקשיים של מנהלי הייטק", 2026)</a:t>
             </a:r>
             <a:endParaRPr lang="he-IL" sz="1250" dirty="0"/>
           </a:p>
@@ -11723,7 +11763,7 @@
                 <a:ea typeface="Arial" pitchFamily="34" charset="-122"/>
                 <a:cs typeface="Arial" pitchFamily="34" charset="-120"/>
               </a:rPr>
-              <a:t>Lee, C., Huang, G.-H., &amp; Ashford, S. J. (2018). Job insecurity and the changing workplace. Annual Review of Organizational Psychology and Organizational Behavior, 5, 335–359.</a:t>
+              <a:t>Lee, C., Huang, G.-H., &amp; Ashford, S. J. (2018). Job insecurity and the changing workplace. Annual Review of Organizational Psychology and Organizational Behavior, 5, 335-359.</a:t>
             </a:r>
             <a:endParaRPr lang="en-US" sz="1250" dirty="0"/>
           </a:p>

</xml_diff>

<commit_message>
Trim reference list to the two chosen articles and course materials
Remove supporting-literature citations, cite classic sources as secondary
citations through the main article, and add a visible heading rule.

Co-Authored-By: Claude Fable 5.1 <noreply@anthropic.com>
Claude-Session: https://claude.ai/code/session_01XaGvnsaHG3kPyCY3aGBByx
</commit_message>
<xml_diff>
--- a/career-management-final-project/ניהול קריירה - התמודדות עם חוסר ודאות תעסוקתי - מצגת.pptx
+++ b/career-management-final-project/ניהול קריירה - התמודדות עם חוסר ודאות תעסוקתי - מצגת.pptx
@@ -3809,7 +3809,7 @@
                 <a:ea typeface="Arial" pitchFamily="34" charset="-122"/>
                 <a:cs typeface="Arial" pitchFamily="34" charset="-120"/>
               </a:rPr>
-              <a:t>ההיפוך: המטא-אנליזה של לוסטד ואחרים (Låstad et al., 2025) מראה שחוסר ביטחון מקטין יוזמה ופיתוח מיומנויות. מי שמרגיש שאין לו משאבים לא מעצב את תפקידו, אלא מגן על מה שנשאר. לכן בונים ניהוליות בתקופות של יציבות, לא מחכים לאיום.</a:t>
+              <a:t>ההיפוך: מי שמרגיש שאין לו מספיק משאבים לא מעצב את תפקידו, אלא מגן על מה שנשאר. והמאמר המשלים מראה שהאיום הטכנולוגי פוגע בביצועים דרך חוסר הביטחון (Chung et al., 2025). לכן בונים ניהוליות בתקופות של יציבות, לא מחכים לאיום.</a:t>
             </a:r>
             <a:endParaRPr lang="he-IL" sz="1400" dirty="0"/>
           </a:p>
@@ -8229,7 +8229,7 @@
                 <a:ea typeface="Arial" pitchFamily="34" charset="-122"/>
                 <a:cs typeface="Arial" pitchFamily="34" charset="-120"/>
               </a:rPr>
-              <a:t>Antonovsky, A. (1987). Unraveling the mystery of health: How people manage stress and stay well. Jossey-Bass.</a:t>
+              <a:t>Cetkovská, K., Bauer, G. F., &amp; Tušl, M. (2026). The role of needs-based job crafting in strengthening work-related sense of coherence: A two-wave panel study. Scandinavian Journal of Work and Organizational Psychology, 11(1), Article 14. https://doi.org/10.16993/sjwop.389</a:t>
             </a:r>
             <a:endParaRPr lang="en-US" sz="1100" dirty="0"/>
           </a:p>
@@ -8249,7 +8249,7 @@
                 <a:ea typeface="Arial" pitchFamily="34" charset="-122"/>
                 <a:cs typeface="Arial" pitchFamily="34" charset="-120"/>
               </a:rPr>
-              <a:t>Cetkovská, K., Bauer, G. F., &amp; Tušl, M. (2026). The role of needs-based job crafting in strengthening work-related sense of coherence: A two-wave panel study. Scandinavian Journal of Work and Organizational Psychology, 11(1), Article 14. https://doi.org/10.16993/sjwop.389</a:t>
+              <a:t>Chung, Y. W., Im, S., Kim, J. E., &amp; Yun, J. K. (2025). Artificial intelligence awareness, career resilience, job insecurity and behavioural outcomes. Australian Journal of Psychology, 77(1), Article 2559910. https://doi.org/10.1080/00049530.2025.2559910</a:t>
             </a:r>
             <a:endParaRPr lang="en-US" sz="1100" dirty="0"/>
           </a:p>
@@ -8269,47 +8269,7 @@
                 <a:ea typeface="Arial" pitchFamily="34" charset="-122"/>
                 <a:cs typeface="Arial" pitchFamily="34" charset="-120"/>
               </a:rPr>
-              <a:t>Chung, Y. W., Im, S., Kim, J. E., &amp; Yun, J. K. (2025). Artificial intelligence awareness, career resilience, job insecurity and behavioural outcomes. Australian Journal of Psychology, 77(1), Article 2559910. https://doi.org/10.1080/00049530.2025.2559910</a:t>
-            </a:r>
-            <a:endParaRPr lang="en-US" sz="1100" dirty="0"/>
-          </a:p>
-          <a:p>
-            <a:pPr algn="l" indent="0" marL="0">
-              <a:spcAft>
-                <a:spcPts val="600"/>
-              </a:spcAft>
-              <a:buNone/>
-            </a:pPr>
-            <a:r>
-              <a:rPr lang="en-US" sz="1100" dirty="0">
-                <a:solidFill>
-                  <a:srgbClr val="1F2937"/>
-                </a:solidFill>
-                <a:latin typeface="Arial" pitchFamily="34" charset="0"/>
-                <a:ea typeface="Arial" pitchFamily="34" charset="-122"/>
-                <a:cs typeface="Arial" pitchFamily="34" charset="-120"/>
-              </a:rPr>
               <a:t>Hone, L. (2019). 3 secrets of resilient people [Video]. TED Conferences. https://www.ted.com/talks/lucy_hone_the_three_secrets_of_resilient_people</a:t>
-            </a:r>
-            <a:endParaRPr lang="en-US" sz="1100" dirty="0"/>
-          </a:p>
-          <a:p>
-            <a:pPr algn="l" indent="0" marL="0">
-              <a:spcAft>
-                <a:spcPts val="600"/>
-              </a:spcAft>
-              <a:buNone/>
-            </a:pPr>
-            <a:r>
-              <a:rPr lang="en-US" sz="1100" dirty="0">
-                <a:solidFill>
-                  <a:srgbClr val="1F2937"/>
-                </a:solidFill>
-                <a:latin typeface="Arial" pitchFamily="34" charset="0"/>
-                <a:ea typeface="Arial" pitchFamily="34" charset="-122"/>
-                <a:cs typeface="Arial" pitchFamily="34" charset="-120"/>
-              </a:rPr>
-              <a:t>Låstad, L., Pienaar, J., Näswall, K., Richter, A., Hellgren, J., &amp; Sverke, M. (2025). Moving on up now? A meta-analysis of the associations between job insecurity and career-related outcomes. Scandinavian Journal of Work and Organizational Psychology, 10(1), Article 2. https://doi.org/10.16993/sjwop.275</a:t>
             </a:r>
             <a:endParaRPr lang="en-US" sz="1100" dirty="0"/>
           </a:p>
@@ -8392,6 +8352,26 @@
                 <a:cs typeface="Arial" pitchFamily="34" charset="-120"/>
               </a:rPr>
               <a:t>דבדבני דקל, מ' (2026ב). עסקים בצל הקורונה: ממשבר להזדמנות, איך עושים את זה? [מצגת הרצאה]. ניהול קריירה בארגונים, הקריה האקדמית אונו.</a:t>
+            </a:r>
+            <a:endParaRPr lang="he-IL" sz="1100" dirty="0"/>
+          </a:p>
+          <a:p>
+            <a:pPr algn="r" indent="0" marL="0">
+              <a:spcAft>
+                <a:spcPts val="500"/>
+              </a:spcAft>
+              <a:buNone/>
+            </a:pPr>
+            <a:r>
+              <a:rPr lang="he-IL" altLang="en-US" sz="1100" dirty="0">
+                <a:solidFill>
+                  <a:srgbClr val="1F2937"/>
+                </a:solidFill>
+                <a:latin typeface="Arial" pitchFamily="34" charset="0"/>
+                <a:ea typeface="Arial" pitchFamily="34" charset="-122"/>
+                <a:cs typeface="Arial" pitchFamily="34" charset="-120"/>
+              </a:rPr>
+              <a:t>דבדבני דקל, מ' (2026ג). ניתוח הסרט "השטן לובשת פראדה" לפי תיאוריות קריירה [מצגת הרצאה]. ניהול קריירה בארגונים, הקריה האקדמית אונו.</a:t>
             </a:r>
             <a:endParaRPr lang="he-IL" sz="1100" dirty="0"/>
           </a:p>
@@ -12173,7 +12153,7 @@
                 <a:ea typeface="Arial" pitchFamily="34" charset="-122"/>
                 <a:cs typeface="Arial" pitchFamily="34" charset="-120"/>
               </a:rPr>
-              <a:t>מאמר משלים (2025, גישה פתוחה) וראיות תומכות</a:t>
+              <a:t>מאמר משלים (2025, גישה פתוחה)</a:t>
             </a:r>
             <a:endParaRPr lang="he-IL" sz="1500" dirty="0"/>
           </a:p>
@@ -12216,26 +12196,6 @@
                 <a:cs typeface="Arial" pitchFamily="34" charset="-120"/>
               </a:rPr>
               <a:t>Chung, Y. W., Im, S., Kim, J. E., &amp; Yun, J. K. (2025). Artificial intelligence awareness, career resilience, job insecurity and behavioural outcomes. Australian Journal of Psychology, 77(1), Article 2559910.</a:t>
-            </a:r>
-            <a:endParaRPr lang="en-US" sz="1200" dirty="0"/>
-          </a:p>
-          <a:p>
-            <a:pPr algn="r" indent="0" marL="0">
-              <a:spcAft>
-                <a:spcPts val="600"/>
-              </a:spcAft>
-              <a:buNone/>
-            </a:pPr>
-            <a:r>
-              <a:rPr lang="en-US" sz="1200" dirty="0">
-                <a:solidFill>
-                  <a:srgbClr val="1F2937"/>
-                </a:solidFill>
-                <a:latin typeface="Arial" pitchFamily="34" charset="0"/>
-                <a:ea typeface="Arial" pitchFamily="34" charset="-122"/>
-                <a:cs typeface="Arial" pitchFamily="34" charset="-120"/>
-              </a:rPr>
-              <a:t>Låstad, L., et al. (2025). Moving on up now? A meta-analysis of the associations between job insecurity and career-related outcomes. Scandinavian Journal of Work and Organizational Psychology, 10(1), Article 2.</a:t>
             </a:r>
             <a:endParaRPr lang="en-US" sz="1200" dirty="0"/>
           </a:p>
@@ -12489,7 +12449,7 @@
                 <a:ea typeface="Arial" pitchFamily="34" charset="-122"/>
                 <a:cs typeface="Arial" pitchFamily="34" charset="-120"/>
               </a:rPr>
-              <a:t>מהגישה הסלוטוגנית של אנטונובסקי (1987): לא "למה חולים" אלא "איך נשארים בריאים למרות הלחץ"</a:t>
+              <a:t>מהגישה הסלוטוגנית של אנטונובסקי, כפי שמובאת במאמר: לא "למה חולים" אלא "איך נשארים בריאים למרות הלחץ"</a:t>
             </a:r>
             <a:endParaRPr lang="he-IL" sz="1250" dirty="0"/>
           </a:p>

</xml_diff>

<commit_message>
Drop lecture presentations from the reference list
Course concepts are now described as learned in the course without a
parenthetical citation, and the three lecture-presentation entries are
removed from the paper and the deck.

Co-Authored-By: Claude Fable 5.1 <noreply@anthropic.com>
Claude-Session: https://claude.ai/code/session_01XaGvnsaHG3kPyCY3aGBByx
</commit_message>
<xml_diff>
--- a/career-management-final-project/ניהול קריירה - התמודדות עם חוסר ודאות תעסוקתי - מצגת.pptx
+++ b/career-management-final-project/ניהול קריירה - התמודדות עם חוסר ודאות תעסוקתי - מצגת.pptx
@@ -4400,7 +4400,7 @@
                 <a:ea typeface="Arial" pitchFamily="34" charset="-122"/>
                 <a:cs typeface="Arial" pitchFamily="34" charset="-120"/>
               </a:rPr>
-              <a:t>המאמר משלים את "ממשבר להזדמנות" (דבדבני דקל, 2026ב): משבר לא הופך להזדמנות מעצמו, אלא כשמישהו מעצב אותו כך. אבל המסר צריך להיות כפול: לעצב את התפקיד עכשיו, כשעוד יש משאבים, ולזכור שמי שמרגיש שאין לו משאבים צריך קודם תמיכה ולא עצות.</a:t>
+              <a:t>המאמר משלים את "ממשבר להזדמנות": משבר לא הופך להזדמנות מעצמו, אלא כשמישהו מעצב אותו כך. אבל המסר צריך להיות כפול: לעצב את התפקיד עכשיו, כשעוד יש משאבים, ולזכור שמי שמרגיש שאין לו משאבים צריך קודם תמיכה ולא עצות.</a:t>
             </a:r>
             <a:endParaRPr lang="he-IL" sz="1450" dirty="0"/>
           </a:p>
@@ -6161,7 +6161,7 @@
                 <a:ea typeface="Arial" pitchFamily="34" charset="-122"/>
                 <a:cs typeface="Arial" pitchFamily="34" charset="-120"/>
               </a:rPr>
-              <a:t>מתחבר ל"שלושת סלי הכלים" מהקורס (דבדבני דקל, 2026א): רשת אנשים = שייכות, התפתחות = מיומנות, זהות מקצועית = משמעות. המאמר מוסיף אוטונומיה וראיה אמפירית</a:t>
+              <a:t>מתחבר ל"שלושת סלי הכלים" מהקורס: רשת אנשים = שייכות, התפתחות = מיומנות, זהות מקצועית = משמעות. המאמר מוסיף אוטונומיה וראיה אמפירית</a:t>
             </a:r>
             <a:endParaRPr lang="he-IL" sz="1300" dirty="0"/>
           </a:p>
@@ -8312,66 +8312,6 @@
                 <a:cs typeface="Arial" pitchFamily="34" charset="-120"/>
               </a:rPr>
               <a:t>בנק ישראל. (2025, 11 במרץ). ההשפעה הצפויה של בינה מלאכותית יוצרת על העובדים: השלכות על המדיניות בשוק העבודה [תיבה מתוך דוח בנק ישראל לשנת 2024]. https://www.boi.org.il/publications/pressreleases/11-3-25/</a:t>
-            </a:r>
-            <a:endParaRPr lang="he-IL" sz="1100" dirty="0"/>
-          </a:p>
-          <a:p>
-            <a:pPr algn="r" indent="0" marL="0">
-              <a:spcAft>
-                <a:spcPts val="500"/>
-              </a:spcAft>
-              <a:buNone/>
-            </a:pPr>
-            <a:r>
-              <a:rPr lang="he-IL" altLang="en-US" sz="1100" dirty="0">
-                <a:solidFill>
-                  <a:srgbClr val="1F2937"/>
-                </a:solidFill>
-                <a:latin typeface="Arial" pitchFamily="34" charset="0"/>
-                <a:ea typeface="Arial" pitchFamily="34" charset="-122"/>
-                <a:cs typeface="Arial" pitchFamily="34" charset="-120"/>
-              </a:rPr>
-              <a:t>דבדבני דקל, מ' (2026א). מחזון ורעיון למציאות ממשית [מצגת הרצאה]. ניהול קריירה בארגונים, הקריה האקדמית אונו.</a:t>
-            </a:r>
-            <a:endParaRPr lang="he-IL" sz="1100" dirty="0"/>
-          </a:p>
-          <a:p>
-            <a:pPr algn="r" indent="0" marL="0">
-              <a:spcAft>
-                <a:spcPts val="500"/>
-              </a:spcAft>
-              <a:buNone/>
-            </a:pPr>
-            <a:r>
-              <a:rPr lang="he-IL" altLang="en-US" sz="1100" dirty="0">
-                <a:solidFill>
-                  <a:srgbClr val="1F2937"/>
-                </a:solidFill>
-                <a:latin typeface="Arial" pitchFamily="34" charset="0"/>
-                <a:ea typeface="Arial" pitchFamily="34" charset="-122"/>
-                <a:cs typeface="Arial" pitchFamily="34" charset="-120"/>
-              </a:rPr>
-              <a:t>דבדבני דקל, מ' (2026ב). עסקים בצל הקורונה: ממשבר להזדמנות, איך עושים את זה? [מצגת הרצאה]. ניהול קריירה בארגונים, הקריה האקדמית אונו.</a:t>
-            </a:r>
-            <a:endParaRPr lang="he-IL" sz="1100" dirty="0"/>
-          </a:p>
-          <a:p>
-            <a:pPr algn="r" indent="0" marL="0">
-              <a:spcAft>
-                <a:spcPts val="500"/>
-              </a:spcAft>
-              <a:buNone/>
-            </a:pPr>
-            <a:r>
-              <a:rPr lang="he-IL" altLang="en-US" sz="1100" dirty="0">
-                <a:solidFill>
-                  <a:srgbClr val="1F2937"/>
-                </a:solidFill>
-                <a:latin typeface="Arial" pitchFamily="34" charset="0"/>
-                <a:ea typeface="Arial" pitchFamily="34" charset="-122"/>
-                <a:cs typeface="Arial" pitchFamily="34" charset="-120"/>
-              </a:rPr>
-              <a:t>דבדבני דקל, מ' (2026ג). ניתוח הסרט "השטן לובשת פראדה" לפי תיאוריות קריירה [מצגת הרצאה]. ניהול קריירה בארגונים, הקריה האקדמית אונו.</a:t>
             </a:r>
             <a:endParaRPr lang="he-IL" sz="1100" dirty="0"/>
           </a:p>

</xml_diff>

<commit_message>
Integrate course material, continuous prose in the deck, and the college logo
Add an integrative section linking the article to the course concepts (three
toolkits, professional identity questions, augmented career, Herzberg, career
anchors, Super, Russo et al. 2016), rewrite bullet slides as short cited
paragraphs, add a course-material slide, and place the Ono logo on the paper
cover and the deck.

Co-Authored-By: Claude Fable 5.1 <noreply@anthropic.com>
Claude-Session: https://claude.ai/code/session_01XaGvnsaHG3kPyCY3aGBByx
</commit_message>
<xml_diff>
--- a/career-management-final-project/ניהול קריירה - התמודדות עם חוסר ודאות תעסוקתי - מצגת.pptx
+++ b/career-management-final-project/ניהול קריירה - התמודדות עם חוסר ודאות תעסוקתי - מצגת.pptx
@@ -21,9 +21,10 @@
     <p:sldId id="269" r:id="rId15"/>
     <p:sldId id="270" r:id="rId16"/>
     <p:sldId id="271" r:id="rId17"/>
+    <p:sldId id="272" r:id="rId18"/>
   </p:sldIdLst>
   <p:notesMasterIdLst>
-    <p:notesMasterId r:id="rId18"/>
+    <p:notesMasterId r:id="rId19"/>
   </p:notesMasterIdLst>
   <p:sldSz cx="12192000" cy="6858000"/>
   <p:notesSz cx="6858000" cy="12192000"/>
@@ -1268,7 +1269,7 @@
           <a:p>
             <a:r>
               <a:rPr lang="en-US" dirty="0"/>
-              <a:t>להגיד את הביקורת בקול. ועדיין, זה המאמר שנתן לנו הכי הרבה מה לעשות מחר בבוקר.</a:t>
+              <a:t>שקופית קצרה: להראות שהמאמר לא מחליף את הקורס אלא נותן לו ראיות. לעצור על שורה אחת בטבלה, למשל הרצברג: המניעים = התקרבות, ההיגייניים = הימנעות.</a:t>
             </a:r>
             <a:endParaRPr lang="en-US" dirty="0"/>
           </a:p>
@@ -1356,7 +1357,7 @@
           <a:p>
             <a:r>
               <a:rPr lang="en-US" dirty="0"/>
-              <a:t>להקרין כ-90 שניות (לבדוק את הטיים-קוד מראש). לחבר: "לבחור במה להתמקד" זה בדיוק לעצב את התפקיד סביב מה שבשליטתי.</a:t>
+              <a:t>להגיד את הביקורת בקול. ועדיין, זה המאמר שנתן לנו הכי הרבה מה לעשות מחר בבוקר.</a:t>
             </a:r>
             <a:endParaRPr lang="en-US" dirty="0"/>
           </a:p>
@@ -1444,7 +1445,7 @@
           <a:p>
             <a:r>
               <a:rPr lang="en-US" dirty="0"/>
-              <a:t>זה הכלי שאנחנו משאירים לכיתה. ארבעה צרכים, שאלה אחת לכל צורך, ופעולות שאפשר לעשות גם במשרה סטודנטיאלית. ניתוק והרפיה חשובים להתאוששות, אבל לפי המאמר לא משנים את תפיסת העבודה.</a:t>
+              <a:t>להקרין כ-90 שניות (לבדוק את הטיים-קוד מראש). לחבר: "לבחור במה להתמקד" זה בדיוק לעצב את התפקיד סביב מה שבשליטתי.</a:t>
             </a:r>
             <a:endParaRPr lang="en-US" dirty="0"/>
           </a:p>
@@ -1532,7 +1533,7 @@
           <a:p>
             <a:r>
               <a:rPr lang="en-US" dirty="0"/>
-              <a:t>לחלק כרטיסיות מודפסות או להשאיר את השקופית. אחרי השיתוף לחבר לממצא: "פעולות כאלה, לפי המאמר, מנבאות עלייה בבהירות, בשליטה ובמשמעות חצי שנה מאוחר יותר. ושימו לב: אף אחד לא בחר 'לנוח יותר'. זה נכון, וזה גם מה שהמאמר מצא".</a:t>
+              <a:t>זה הכלי שאנחנו משאירים לכיתה. ארבעה צרכים, שאלה אחת לכל צורך, ופעולות שאפשר לעשות גם במשרה סטודנטיאלית. ניתוק והרפיה חשובים להתאוששות, אבל לפי המאמר לא משנים את תפיסת העבודה.</a:t>
             </a:r>
             <a:endParaRPr lang="en-US" dirty="0"/>
           </a:p>
@@ -1620,7 +1621,7 @@
           <a:p>
             <a:r>
               <a:rPr lang="en-US" dirty="0"/>
-              <a:t>לחזור לתוצאות הסקר מהפתיחה: "מי שסימן נמוך בשאלה 1 או 2: המאמר אומר שזה לא גזירת גורל, ושהפעולה שכתבתם עכשיו היא בדיוק הדרך לשנות את זה". לסיים במסר ולפתוח לשאלות.</a:t>
+              <a:t>לחלק כרטיסיות מודפסות או להשאיר את השקופית. אחרי השיתוף לחבר לממצא: "פעולות כאלה, לפי המאמר, מנבאות עלייה בבהירות, בשליטה ובמשמעות חצי שנה מאוחר יותר. ושימו לב: אף אחד לא בחר 'לנוח יותר'. זה נכון, וזה גם מה שהמאמר מצא".</a:t>
             </a:r>
             <a:endParaRPr lang="en-US" dirty="0"/>
           </a:p>
@@ -1708,7 +1709,7 @@
           <a:p>
             <a:r>
               <a:rPr lang="en-US" dirty="0"/>
-              <a:t/>
+              <a:t>לחזור לתוצאות הסקר מהפתיחה: "מי שסימן נמוך בשאלה 1 או 2: המאמר אומר שזה לא גזירת גורל, ושהפעולה שכתבתם עכשיו היא בדיוק הדרך לשנות את זה". לסיים במסר ולפתוח לשאלות.</a:t>
             </a:r>
             <a:endParaRPr lang="en-US" dirty="0"/>
           </a:p>
@@ -1732,6 +1733,94 @@
             <a:fld id="{F7021451-1387-4CA6-816F-3879F97B5CBC}" type="slidenum">
               <a:rPr lang="en-US"/>
               <a:t>16</a:t>
+            </a:fld>
+            <a:endParaRPr lang="en-US"/>
+          </a:p>
+        </p:txBody>
+      </p:sp>
+    </p:spTree>
+    <p:extLst>
+      <p:ext uri="{BB962C8B-B14F-4D97-AF65-F5344CB8AC3E}">
+        <p14:creationId xmlns:p14="http://schemas.microsoft.com/office/powerpoint/2010/main" val="1024086991"/>
+      </p:ext>
+    </p:extLst>
+  </p:cSld>
+  <p:clrMapOvr>
+    <a:masterClrMapping/>
+  </p:clrMapOvr>
+</p:notes>
+</file>
+
+<file path=ppt/notesSlides/notesSlide17.xml><?xml version="1.0" encoding="utf-8"?>
+<p:notes xmlns:a="http://schemas.openxmlformats.org/drawingml/2006/main" xmlns:r="http://schemas.openxmlformats.org/officeDocument/2006/relationships" xmlns:p="http://schemas.openxmlformats.org/presentationml/2006/main">
+  <p:cSld>
+    <p:spTree>
+      <p:nvGrpSpPr>
+        <p:cNvPr id="1" name=""/>
+        <p:cNvGrpSpPr/>
+        <p:nvPr/>
+      </p:nvGrpSpPr>
+      <p:grpSpPr>
+        <a:xfrm>
+          <a:off x="0" y="0"/>
+          <a:ext cx="0" cy="0"/>
+          <a:chOff x="0" y="0"/>
+          <a:chExt cx="0" cy="0"/>
+        </a:xfrm>
+      </p:grpSpPr>
+      <p:sp>
+        <p:nvSpPr>
+          <p:cNvPr id="2" name="Slide Image Placeholder 1"/>
+          <p:cNvSpPr>
+            <a:spLocks noGrp="1" noRot="1" noChangeAspect="1"/>
+          </p:cNvSpPr>
+          <p:nvPr>
+            <p:ph type="sldImg"/>
+          </p:nvPr>
+        </p:nvSpPr>
+        <p:spPr/>
+      </p:sp>
+      <p:sp>
+        <p:nvSpPr>
+          <p:cNvPr id="3" name="Notes Placeholder 2"/>
+          <p:cNvSpPr>
+            <a:spLocks noGrp="1"/>
+          </p:cNvSpPr>
+          <p:nvPr>
+            <p:ph type="body" idx="1"/>
+          </p:nvPr>
+        </p:nvSpPr>
+        <p:spPr/>
+        <p:txBody>
+          <a:bodyPr/>
+          <a:lstStyle/>
+          <a:p>
+            <a:r>
+              <a:rPr lang="en-US" dirty="0"/>
+              <a:t/>
+            </a:r>
+            <a:endParaRPr lang="en-US" dirty="0"/>
+          </a:p>
+        </p:txBody>
+      </p:sp>
+      <p:sp>
+        <p:nvSpPr>
+          <p:cNvPr id="4" name="Slide Number Placeholder 3"/>
+          <p:cNvSpPr>
+            <a:spLocks noGrp="1"/>
+          </p:cNvSpPr>
+          <p:nvPr>
+            <p:ph type="sldNum" sz="quarter" idx="10"/>
+          </p:nvPr>
+        </p:nvSpPr>
+        <p:spPr/>
+        <p:txBody>
+          <a:bodyPr/>
+          <a:lstStyle/>
+          <a:p>
+            <a:fld id="{F7021451-1387-4CA6-816F-3879F97B5CBC}" type="slidenum">
+              <a:rPr lang="en-US"/>
+              <a:t>17</a:t>
             </a:fld>
             <a:endParaRPr lang="en-US"/>
           </a:p>
@@ -2818,26 +2907,52 @@
         </p:nvSpPr>
         <p:spPr>
           <a:xfrm>
-            <a:off x="10424160" y="-1920240"/>
-            <a:ext cx="3291840" cy="3291840"/>
-          </a:xfrm>
-          <a:prstGeom prst="ellipse">
-            <a:avLst/>
+            <a:off x="9966960" y="320040"/>
+            <a:ext cx="1691640" cy="1691640"/>
+          </a:xfrm>
+          <a:prstGeom prst="roundRect">
+            <a:avLst>
+              <a:gd name="adj" fmla="val 8108"/>
+            </a:avLst>
           </a:prstGeom>
           <a:solidFill>
-            <a:srgbClr val="FCA311"/>
+            <a:srgbClr val="FFFFFF"/>
           </a:solidFill>
           <a:ln w="12700">
             <a:solidFill>
-              <a:srgbClr val="FCA311"/>
+              <a:srgbClr val="FFFFFF"/>
             </a:solidFill>
             <a:prstDash val="solid"/>
           </a:ln>
         </p:spPr>
       </p:sp>
-      <p:sp>
-        <p:nvSpPr>
-          <p:cNvPr id="4" name="Text 2"/>
+      <p:pic>
+        <p:nvPicPr>
+          <p:cNvPr id="4" name="Image 0" descr="/tmp/claude-0/-home-user-clickwriting-landing/d2627f80-c93a-5206-ba5d-647532b375c9/scratchpad/ono-logo.jpg">    </p:cNvPr>
+          <p:cNvPicPr>
+            <a:picLocks noChangeAspect="1"/>
+          </p:cNvPicPr>
+          <p:nvPr/>
+        </p:nvPicPr>
+        <p:blipFill>
+          <a:blip r:embed="rId1"/>
+          <a:stretch>
+            <a:fillRect/>
+          </a:stretch>
+        </p:blipFill>
+        <p:spPr>
+          <a:xfrm>
+            <a:off x="10058400" y="411480"/>
+            <a:ext cx="1508760" cy="1508760"/>
+          </a:xfrm>
+          <a:prstGeom prst="rect">
+            <a:avLst/>
+          </a:prstGeom>
+        </p:spPr>
+      </p:pic>
+      <p:sp>
+        <p:nvSpPr>
+          <p:cNvPr id="5" name="Text 2"/>
           <p:cNvSpPr txBox="1"/>
           <p:nvPr/>
         </p:nvSpPr>
@@ -2876,7 +2991,7 @@
       </p:sp>
       <p:sp>
         <p:nvSpPr>
-          <p:cNvPr id="5" name="Text 3"/>
+          <p:cNvPr id="6" name="Text 3"/>
           <p:cNvSpPr txBox="1"/>
           <p:nvPr/>
         </p:nvSpPr>
@@ -2915,7 +3030,7 @@
       </p:sp>
       <p:sp>
         <p:nvSpPr>
-          <p:cNvPr id="6" name="Text 4"/>
+          <p:cNvPr id="7" name="Text 4"/>
           <p:cNvSpPr txBox="1"/>
           <p:nvPr/>
         </p:nvSpPr>
@@ -2954,7 +3069,7 @@
       </p:sp>
       <p:sp>
         <p:nvSpPr>
-          <p:cNvPr id="7" name="Text 5"/>
+          <p:cNvPr id="8" name="Text 5"/>
           <p:cNvSpPr txBox="1"/>
           <p:nvPr/>
         </p:nvSpPr>
@@ -2993,7 +3108,7 @@
       </p:sp>
       <p:sp>
         <p:nvSpPr>
-          <p:cNvPr id="8" name="Shape 6"/>
+          <p:cNvPr id="9" name="Shape 6"/>
           <p:cNvSpPr/>
           <p:nvPr/>
         </p:nvSpPr>
@@ -3027,7 +3142,7 @@
       </p:sp>
       <p:sp>
         <p:nvSpPr>
-          <p:cNvPr id="9" name="Text 7"/>
+          <p:cNvPr id="10" name="Text 7"/>
           <p:cNvSpPr txBox="1"/>
           <p:nvPr/>
         </p:nvSpPr>
@@ -3066,7 +3181,7 @@
       </p:sp>
       <p:sp>
         <p:nvSpPr>
-          <p:cNvPr id="10" name="Text 8"/>
+          <p:cNvPr id="11" name="Text 8"/>
           <p:cNvSpPr txBox="1"/>
           <p:nvPr/>
         </p:nvSpPr>
@@ -3148,7 +3263,7 @@
       </p:sp>
       <p:sp>
         <p:nvSpPr>
-          <p:cNvPr id="11" name="Text 9"/>
+          <p:cNvPr id="12" name="Text 9"/>
           <p:cNvSpPr txBox="1"/>
           <p:nvPr/>
         </p:nvSpPr>
@@ -3951,6 +4066,1217 @@
                 <a:ea typeface="Arial" pitchFamily="34" charset="-122"/>
                 <a:cs typeface="Arial" pitchFamily="34" charset="-120"/>
               </a:rPr>
+              <a:t>חיבור לחומר הנלמד בקורס</a:t>
+            </a:r>
+            <a:endParaRPr lang="he-IL" sz="3000" dirty="0"/>
+          </a:p>
+        </p:txBody>
+      </p:sp>
+      <p:graphicFrame>
+        <p:nvGraphicFramePr>
+          <p:cNvPr id="12" name="Table 0"/>
+          <p:cNvGraphicFramePr>
+            <a:graphicFrameLocks noGrp="1"/>
+          </p:cNvGraphicFramePr>
+          <p:nvPr>
+            <p:extLst>
+              <p:ext uri="{D42A27DB-BD31-4B8C-83A1-F6EECF244321}">
+                <p14:modId xmlns:p14="http://schemas.microsoft.com/office/powerpoint/2010/main" val="1579011935"/>
+              </p:ext>
+            </p:extLst>
+          </p:nvPr>
+        </p:nvGraphicFramePr>
+        <p:xfrm>
+          <a:off x="5943600" y="1280160"/>
+          <a:ext cx="5696712" cy="914400"/>
+        </p:xfrm>
+        <a:graphic>
+          <a:graphicData uri="http://schemas.openxmlformats.org/drawingml/2006/table">
+            <a:tbl>
+              <a:tblPr/>
+              <a:tblGrid>
+                <a:gridCol w="2926080"/>
+                <a:gridCol w="2770632"/>
+              </a:tblGrid>
+              <a:tr h="411480">
+                <a:tc>
+                  <a:txBody>
+                    <a:bodyPr/>
+                    <a:lstStyle/>
+                    <a:p>
+                      <a:pPr rtl="1" algn="r" indent="0" marL="0">
+                        <a:buNone/>
+                      </a:pPr>
+                      <a:r>
+                        <a:rPr lang="en-US" sz="1300" b="1" dirty="0">
+                          <a:solidFill>
+                            <a:srgbClr val="FFFFFF"/>
+                          </a:solidFill>
+                          <a:latin typeface="Arial" pitchFamily="34" charset="0"/>
+                          <a:ea typeface="Arial" pitchFamily="34" charset="-122"/>
+                          <a:cs typeface="Arial" pitchFamily="34" charset="-120"/>
+                        </a:rPr>
+                        <a:t>המקבילה במאמר</a:t>
+                      </a:r>
+                      <a:endParaRPr lang="en-US" sz="1300" dirty="0">
+                        <a:latin typeface="Arial" charset="0"/>
+                        <a:ea typeface="Arial" charset="0"/>
+                        <a:cs typeface="Arial" charset="0"/>
+                      </a:endParaRPr>
+                    </a:p>
+                  </a:txBody>
+                  <a:tcPr marL="54864" marR="54864" marT="54864" marB="54864" anchor="ctr">
+                    <a:lnL w="12700" cap="flat" cmpd="sng" algn="ctr">
+                      <a:solidFill>
+                        <a:srgbClr val="D1D5DB"/>
+                      </a:solidFill>
+                      <a:prstDash val="solid"/>
+                      <a:round/>
+                      <a:headEnd type="none" w="med" len="med"/>
+                      <a:tailEnd type="none" w="med" len="med"/>
+                    </a:lnL>
+                    <a:lnR w="12700" cap="flat" cmpd="sng" algn="ctr">
+                      <a:solidFill>
+                        <a:srgbClr val="D1D5DB"/>
+                      </a:solidFill>
+                      <a:prstDash val="solid"/>
+                      <a:round/>
+                      <a:headEnd type="none" w="med" len="med"/>
+                      <a:tailEnd type="none" w="med" len="med"/>
+                    </a:lnR>
+                    <a:lnT w="12700" cap="flat" cmpd="sng" algn="ctr">
+                      <a:solidFill>
+                        <a:srgbClr val="D1D5DB"/>
+                      </a:solidFill>
+                      <a:prstDash val="solid"/>
+                      <a:round/>
+                      <a:headEnd type="none" w="med" len="med"/>
+                      <a:tailEnd type="none" w="med" len="med"/>
+                    </a:lnT>
+                    <a:lnB w="12700" cap="flat" cmpd="sng" algn="ctr">
+                      <a:solidFill>
+                        <a:srgbClr val="D1D5DB"/>
+                      </a:solidFill>
+                      <a:prstDash val="solid"/>
+                      <a:round/>
+                      <a:headEnd type="none" w="med" len="med"/>
+                      <a:tailEnd type="none" w="med" len="med"/>
+                    </a:lnB>
+                    <a:solidFill>
+                      <a:srgbClr val="14213D"/>
+                    </a:solidFill>
+                  </a:tcPr>
+                </a:tc>
+                <a:tc>
+                  <a:txBody>
+                    <a:bodyPr/>
+                    <a:lstStyle/>
+                    <a:p>
+                      <a:pPr rtl="1" algn="r" indent="0" marL="0">
+                        <a:buNone/>
+                      </a:pPr>
+                      <a:r>
+                        <a:rPr lang="en-US" sz="1300" b="1" dirty="0">
+                          <a:solidFill>
+                            <a:srgbClr val="FFFFFF"/>
+                          </a:solidFill>
+                          <a:latin typeface="Arial" pitchFamily="34" charset="0"/>
+                          <a:ea typeface="Arial" pitchFamily="34" charset="-122"/>
+                          <a:cs typeface="Arial" pitchFamily="34" charset="-120"/>
+                        </a:rPr>
+                        <a:t>מושג מהקורס</a:t>
+                      </a:r>
+                      <a:endParaRPr lang="en-US" sz="1300" dirty="0">
+                        <a:latin typeface="Arial" charset="0"/>
+                        <a:ea typeface="Arial" charset="0"/>
+                        <a:cs typeface="Arial" charset="0"/>
+                      </a:endParaRPr>
+                    </a:p>
+                  </a:txBody>
+                  <a:tcPr marL="54864" marR="54864" marT="54864" marB="54864" anchor="ctr">
+                    <a:lnL w="12700" cap="flat" cmpd="sng" algn="ctr">
+                      <a:solidFill>
+                        <a:srgbClr val="D1D5DB"/>
+                      </a:solidFill>
+                      <a:prstDash val="solid"/>
+                      <a:round/>
+                      <a:headEnd type="none" w="med" len="med"/>
+                      <a:tailEnd type="none" w="med" len="med"/>
+                    </a:lnL>
+                    <a:lnR w="12700" cap="flat" cmpd="sng" algn="ctr">
+                      <a:solidFill>
+                        <a:srgbClr val="D1D5DB"/>
+                      </a:solidFill>
+                      <a:prstDash val="solid"/>
+                      <a:round/>
+                      <a:headEnd type="none" w="med" len="med"/>
+                      <a:tailEnd type="none" w="med" len="med"/>
+                    </a:lnR>
+                    <a:lnT w="12700" cap="flat" cmpd="sng" algn="ctr">
+                      <a:solidFill>
+                        <a:srgbClr val="D1D5DB"/>
+                      </a:solidFill>
+                      <a:prstDash val="solid"/>
+                      <a:round/>
+                      <a:headEnd type="none" w="med" len="med"/>
+                      <a:tailEnd type="none" w="med" len="med"/>
+                    </a:lnT>
+                    <a:lnB w="12700" cap="flat" cmpd="sng" algn="ctr">
+                      <a:solidFill>
+                        <a:srgbClr val="D1D5DB"/>
+                      </a:solidFill>
+                      <a:prstDash val="solid"/>
+                      <a:round/>
+                      <a:headEnd type="none" w="med" len="med"/>
+                      <a:tailEnd type="none" w="med" len="med"/>
+                    </a:lnB>
+                    <a:solidFill>
+                      <a:srgbClr val="14213D"/>
+                    </a:solidFill>
+                  </a:tcPr>
+                </a:tc>
+              </a:tr>
+              <a:tr h="685800">
+                <a:tc>
+                  <a:txBody>
+                    <a:bodyPr/>
+                    <a:lstStyle/>
+                    <a:p>
+                      <a:pPr rtl="1" algn="r" indent="0" marL="0">
+                        <a:buNone/>
+                      </a:pPr>
+                      <a:r>
+                        <a:rPr lang="en-US" sz="1150" dirty="0">
+                          <a:solidFill>
+                            <a:srgbClr val="1F2937"/>
+                          </a:solidFill>
+                          <a:latin typeface="Arial" pitchFamily="34" charset="0"/>
+                          <a:ea typeface="Arial" pitchFamily="34" charset="-122"/>
+                          <a:cs typeface="Arial" pitchFamily="34" charset="-120"/>
+                        </a:rPr>
+                        <a:t>שייכות, משמעות, מיומנות: צרכי ההתקרבות שבונים תחושת קוהרנטיות</a:t>
+                      </a:r>
+                      <a:endParaRPr lang="en-US" sz="1150" dirty="0">
+                        <a:latin typeface="Arial" charset="0"/>
+                        <a:ea typeface="Arial" charset="0"/>
+                        <a:cs typeface="Arial" charset="0"/>
+                      </a:endParaRPr>
+                    </a:p>
+                  </a:txBody>
+                  <a:tcPr marL="54864" marR="54864" marT="54864" marB="54864" anchor="ctr">
+                    <a:lnL w="12700" cap="flat" cmpd="sng" algn="ctr">
+                      <a:solidFill>
+                        <a:srgbClr val="D1D5DB"/>
+                      </a:solidFill>
+                      <a:prstDash val="solid"/>
+                      <a:round/>
+                      <a:headEnd type="none" w="med" len="med"/>
+                      <a:tailEnd type="none" w="med" len="med"/>
+                    </a:lnL>
+                    <a:lnR w="12700" cap="flat" cmpd="sng" algn="ctr">
+                      <a:solidFill>
+                        <a:srgbClr val="D1D5DB"/>
+                      </a:solidFill>
+                      <a:prstDash val="solid"/>
+                      <a:round/>
+                      <a:headEnd type="none" w="med" len="med"/>
+                      <a:tailEnd type="none" w="med" len="med"/>
+                    </a:lnR>
+                    <a:lnT w="12700" cap="flat" cmpd="sng" algn="ctr">
+                      <a:solidFill>
+                        <a:srgbClr val="D1D5DB"/>
+                      </a:solidFill>
+                      <a:prstDash val="solid"/>
+                      <a:round/>
+                      <a:headEnd type="none" w="med" len="med"/>
+                      <a:tailEnd type="none" w="med" len="med"/>
+                    </a:lnT>
+                    <a:lnB w="12700" cap="flat" cmpd="sng" algn="ctr">
+                      <a:solidFill>
+                        <a:srgbClr val="D1D5DB"/>
+                      </a:solidFill>
+                      <a:prstDash val="solid"/>
+                      <a:round/>
+                      <a:headEnd type="none" w="med" len="med"/>
+                      <a:tailEnd type="none" w="med" len="med"/>
+                    </a:lnB>
+                    <a:solidFill>
+                      <a:srgbClr val="FFFFFF"/>
+                    </a:solidFill>
+                  </a:tcPr>
+                </a:tc>
+                <a:tc>
+                  <a:txBody>
+                    <a:bodyPr/>
+                    <a:lstStyle/>
+                    <a:p>
+                      <a:pPr rtl="1" algn="r" indent="0" marL="0">
+                        <a:buNone/>
+                      </a:pPr>
+                      <a:r>
+                        <a:rPr lang="en-US" sz="1150" b="1" dirty="0">
+                          <a:solidFill>
+                            <a:srgbClr val="1F2937"/>
+                          </a:solidFill>
+                          <a:latin typeface="Arial" pitchFamily="34" charset="0"/>
+                          <a:ea typeface="Arial" pitchFamily="34" charset="-122"/>
+                          <a:cs typeface="Arial" pitchFamily="34" charset="-120"/>
+                        </a:rPr>
+                        <a:t>שלושת סלי הכלים: רשת אנשים, זהות מקצועית, התפתחות</a:t>
+                      </a:r>
+                      <a:endParaRPr lang="en-US" sz="1150" dirty="0">
+                        <a:latin typeface="Arial" charset="0"/>
+                        <a:ea typeface="Arial" charset="0"/>
+                        <a:cs typeface="Arial" charset="0"/>
+                      </a:endParaRPr>
+                    </a:p>
+                  </a:txBody>
+                  <a:tcPr marL="54864" marR="54864" marT="54864" marB="54864" anchor="ctr">
+                    <a:lnL w="12700" cap="flat" cmpd="sng" algn="ctr">
+                      <a:solidFill>
+                        <a:srgbClr val="D1D5DB"/>
+                      </a:solidFill>
+                      <a:prstDash val="solid"/>
+                      <a:round/>
+                      <a:headEnd type="none" w="med" len="med"/>
+                      <a:tailEnd type="none" w="med" len="med"/>
+                    </a:lnL>
+                    <a:lnR w="12700" cap="flat" cmpd="sng" algn="ctr">
+                      <a:solidFill>
+                        <a:srgbClr val="D1D5DB"/>
+                      </a:solidFill>
+                      <a:prstDash val="solid"/>
+                      <a:round/>
+                      <a:headEnd type="none" w="med" len="med"/>
+                      <a:tailEnd type="none" w="med" len="med"/>
+                    </a:lnR>
+                    <a:lnT w="12700" cap="flat" cmpd="sng" algn="ctr">
+                      <a:solidFill>
+                        <a:srgbClr val="D1D5DB"/>
+                      </a:solidFill>
+                      <a:prstDash val="solid"/>
+                      <a:round/>
+                      <a:headEnd type="none" w="med" len="med"/>
+                      <a:tailEnd type="none" w="med" len="med"/>
+                    </a:lnT>
+                    <a:lnB w="12700" cap="flat" cmpd="sng" algn="ctr">
+                      <a:solidFill>
+                        <a:srgbClr val="D1D5DB"/>
+                      </a:solidFill>
+                      <a:prstDash val="solid"/>
+                      <a:round/>
+                      <a:headEnd type="none" w="med" len="med"/>
+                      <a:tailEnd type="none" w="med" len="med"/>
+                    </a:lnB>
+                    <a:solidFill>
+                      <a:srgbClr val="FFFFFF"/>
+                    </a:solidFill>
+                  </a:tcPr>
+                </a:tc>
+              </a:tr>
+              <a:tr h="685800">
+                <a:tc>
+                  <a:txBody>
+                    <a:bodyPr/>
+                    <a:lstStyle/>
+                    <a:p>
+                      <a:pPr rtl="1" algn="r" indent="0" marL="0">
+                        <a:buNone/>
+                      </a:pPr>
+                      <a:r>
+                        <a:rPr lang="en-US" sz="1150" dirty="0">
+                          <a:solidFill>
+                            <a:srgbClr val="1F2937"/>
+                          </a:solidFill>
+                          <a:latin typeface="Arial" pitchFamily="34" charset="0"/>
+                          <a:ea typeface="Arial" pitchFamily="34" charset="-122"/>
+                          <a:cs typeface="Arial" pitchFamily="34" charset="-120"/>
+                        </a:rPr>
+                        <a:t>צורך המשמעות</a:t>
+                      </a:r>
+                      <a:endParaRPr lang="en-US" sz="1150" dirty="0">
+                        <a:latin typeface="Arial" charset="0"/>
+                        <a:ea typeface="Arial" charset="0"/>
+                        <a:cs typeface="Arial" charset="0"/>
+                      </a:endParaRPr>
+                    </a:p>
+                  </a:txBody>
+                  <a:tcPr marL="54864" marR="54864" marT="54864" marB="54864" anchor="ctr">
+                    <a:lnL w="12700" cap="flat" cmpd="sng" algn="ctr">
+                      <a:solidFill>
+                        <a:srgbClr val="D1D5DB"/>
+                      </a:solidFill>
+                      <a:prstDash val="solid"/>
+                      <a:round/>
+                      <a:headEnd type="none" w="med" len="med"/>
+                      <a:tailEnd type="none" w="med" len="med"/>
+                    </a:lnL>
+                    <a:lnR w="12700" cap="flat" cmpd="sng" algn="ctr">
+                      <a:solidFill>
+                        <a:srgbClr val="D1D5DB"/>
+                      </a:solidFill>
+                      <a:prstDash val="solid"/>
+                      <a:round/>
+                      <a:headEnd type="none" w="med" len="med"/>
+                      <a:tailEnd type="none" w="med" len="med"/>
+                    </a:lnR>
+                    <a:lnT w="12700" cap="flat" cmpd="sng" algn="ctr">
+                      <a:solidFill>
+                        <a:srgbClr val="D1D5DB"/>
+                      </a:solidFill>
+                      <a:prstDash val="solid"/>
+                      <a:round/>
+                      <a:headEnd type="none" w="med" len="med"/>
+                      <a:tailEnd type="none" w="med" len="med"/>
+                    </a:lnT>
+                    <a:lnB w="12700" cap="flat" cmpd="sng" algn="ctr">
+                      <a:solidFill>
+                        <a:srgbClr val="D1D5DB"/>
+                      </a:solidFill>
+                      <a:prstDash val="solid"/>
+                      <a:round/>
+                      <a:headEnd type="none" w="med" len="med"/>
+                      <a:tailEnd type="none" w="med" len="med"/>
+                    </a:lnB>
+                    <a:solidFill>
+                      <a:srgbClr val="FFFFFF"/>
+                    </a:solidFill>
+                  </a:tcPr>
+                </a:tc>
+                <a:tc>
+                  <a:txBody>
+                    <a:bodyPr/>
+                    <a:lstStyle/>
+                    <a:p>
+                      <a:pPr rtl="1" algn="r" indent="0" marL="0">
+                        <a:buNone/>
+                      </a:pPr>
+                      <a:r>
+                        <a:rPr lang="en-US" sz="1150" b="1" dirty="0">
+                          <a:solidFill>
+                            <a:srgbClr val="1F2937"/>
+                          </a:solidFill>
+                          <a:latin typeface="Arial" pitchFamily="34" charset="0"/>
+                          <a:ea typeface="Arial" pitchFamily="34" charset="-122"/>
+                          <a:cs typeface="Arial" pitchFamily="34" charset="-120"/>
+                        </a:rPr>
+                        <a:t>חמש השאלות של הזהות המקצועית: איזה ערך אני מביא, למי הוא נחוץ</a:t>
+                      </a:r>
+                      <a:endParaRPr lang="en-US" sz="1150" dirty="0">
+                        <a:latin typeface="Arial" charset="0"/>
+                        <a:ea typeface="Arial" charset="0"/>
+                        <a:cs typeface="Arial" charset="0"/>
+                      </a:endParaRPr>
+                    </a:p>
+                  </a:txBody>
+                  <a:tcPr marL="54864" marR="54864" marT="54864" marB="54864" anchor="ctr">
+                    <a:lnL w="12700" cap="flat" cmpd="sng" algn="ctr">
+                      <a:solidFill>
+                        <a:srgbClr val="D1D5DB"/>
+                      </a:solidFill>
+                      <a:prstDash val="solid"/>
+                      <a:round/>
+                      <a:headEnd type="none" w="med" len="med"/>
+                      <a:tailEnd type="none" w="med" len="med"/>
+                    </a:lnL>
+                    <a:lnR w="12700" cap="flat" cmpd="sng" algn="ctr">
+                      <a:solidFill>
+                        <a:srgbClr val="D1D5DB"/>
+                      </a:solidFill>
+                      <a:prstDash val="solid"/>
+                      <a:round/>
+                      <a:headEnd type="none" w="med" len="med"/>
+                      <a:tailEnd type="none" w="med" len="med"/>
+                    </a:lnR>
+                    <a:lnT w="12700" cap="flat" cmpd="sng" algn="ctr">
+                      <a:solidFill>
+                        <a:srgbClr val="D1D5DB"/>
+                      </a:solidFill>
+                      <a:prstDash val="solid"/>
+                      <a:round/>
+                      <a:headEnd type="none" w="med" len="med"/>
+                      <a:tailEnd type="none" w="med" len="med"/>
+                    </a:lnT>
+                    <a:lnB w="12700" cap="flat" cmpd="sng" algn="ctr">
+                      <a:solidFill>
+                        <a:srgbClr val="D1D5DB"/>
+                      </a:solidFill>
+                      <a:prstDash val="solid"/>
+                      <a:round/>
+                      <a:headEnd type="none" w="med" len="med"/>
+                      <a:tailEnd type="none" w="med" len="med"/>
+                    </a:lnB>
+                    <a:solidFill>
+                      <a:srgbClr val="FFFFFF"/>
+                    </a:solidFill>
+                  </a:tcPr>
+                </a:tc>
+              </a:tr>
+              <a:tr h="685800">
+                <a:tc>
+                  <a:txBody>
+                    <a:bodyPr/>
+                    <a:lstStyle/>
+                    <a:p>
+                      <a:pPr rtl="1" algn="r" indent="0" marL="0">
+                        <a:buNone/>
+                      </a:pPr>
+                      <a:r>
+                        <a:rPr lang="en-US" sz="1150" dirty="0">
+                          <a:solidFill>
+                            <a:srgbClr val="1F2937"/>
+                          </a:solidFill>
+                          <a:latin typeface="Arial" pitchFamily="34" charset="0"/>
+                          <a:ea typeface="Arial" pitchFamily="34" charset="-122"/>
+                          <a:cs typeface="Arial" pitchFamily="34" charset="-120"/>
+                        </a:rPr>
+                        <a:t>ספירלת הרווח: כל צעד של עיצוב תפקיד מאפשר את הבא</a:t>
+                      </a:r>
+                      <a:endParaRPr lang="en-US" sz="1150" dirty="0">
+                        <a:latin typeface="Arial" charset="0"/>
+                        <a:ea typeface="Arial" charset="0"/>
+                        <a:cs typeface="Arial" charset="0"/>
+                      </a:endParaRPr>
+                    </a:p>
+                  </a:txBody>
+                  <a:tcPr marL="54864" marR="54864" marT="54864" marB="54864" anchor="ctr">
+                    <a:lnL w="12700" cap="flat" cmpd="sng" algn="ctr">
+                      <a:solidFill>
+                        <a:srgbClr val="D1D5DB"/>
+                      </a:solidFill>
+                      <a:prstDash val="solid"/>
+                      <a:round/>
+                      <a:headEnd type="none" w="med" len="med"/>
+                      <a:tailEnd type="none" w="med" len="med"/>
+                    </a:lnL>
+                    <a:lnR w="12700" cap="flat" cmpd="sng" algn="ctr">
+                      <a:solidFill>
+                        <a:srgbClr val="D1D5DB"/>
+                      </a:solidFill>
+                      <a:prstDash val="solid"/>
+                      <a:round/>
+                      <a:headEnd type="none" w="med" len="med"/>
+                      <a:tailEnd type="none" w="med" len="med"/>
+                    </a:lnR>
+                    <a:lnT w="12700" cap="flat" cmpd="sng" algn="ctr">
+                      <a:solidFill>
+                        <a:srgbClr val="D1D5DB"/>
+                      </a:solidFill>
+                      <a:prstDash val="solid"/>
+                      <a:round/>
+                      <a:headEnd type="none" w="med" len="med"/>
+                      <a:tailEnd type="none" w="med" len="med"/>
+                    </a:lnT>
+                    <a:lnB w="12700" cap="flat" cmpd="sng" algn="ctr">
+                      <a:solidFill>
+                        <a:srgbClr val="D1D5DB"/>
+                      </a:solidFill>
+                      <a:prstDash val="solid"/>
+                      <a:round/>
+                      <a:headEnd type="none" w="med" len="med"/>
+                      <a:tailEnd type="none" w="med" len="med"/>
+                    </a:lnB>
+                    <a:solidFill>
+                      <a:srgbClr val="FFFFFF"/>
+                    </a:solidFill>
+                  </a:tcPr>
+                </a:tc>
+                <a:tc>
+                  <a:txBody>
+                    <a:bodyPr/>
+                    <a:lstStyle/>
+                    <a:p>
+                      <a:pPr rtl="1" algn="r" indent="0" marL="0">
+                        <a:buNone/>
+                      </a:pPr>
+                      <a:r>
+                        <a:rPr lang="en-US" sz="1150" b="1" dirty="0">
+                          <a:solidFill>
+                            <a:srgbClr val="1F2937"/>
+                          </a:solidFill>
+                          <a:latin typeface="Arial" pitchFamily="34" charset="0"/>
+                          <a:ea typeface="Arial" pitchFamily="34" charset="-122"/>
+                          <a:cs typeface="Arial" pitchFamily="34" charset="-120"/>
+                        </a:rPr>
+                        <a:t>קריירה רבודה וקיר הטיפוס</a:t>
+                      </a:r>
+                      <a:endParaRPr lang="en-US" sz="1150" dirty="0">
+                        <a:latin typeface="Arial" charset="0"/>
+                        <a:ea typeface="Arial" charset="0"/>
+                        <a:cs typeface="Arial" charset="0"/>
+                      </a:endParaRPr>
+                    </a:p>
+                  </a:txBody>
+                  <a:tcPr marL="54864" marR="54864" marT="54864" marB="54864" anchor="ctr">
+                    <a:lnL w="12700" cap="flat" cmpd="sng" algn="ctr">
+                      <a:solidFill>
+                        <a:srgbClr val="D1D5DB"/>
+                      </a:solidFill>
+                      <a:prstDash val="solid"/>
+                      <a:round/>
+                      <a:headEnd type="none" w="med" len="med"/>
+                      <a:tailEnd type="none" w="med" len="med"/>
+                    </a:lnL>
+                    <a:lnR w="12700" cap="flat" cmpd="sng" algn="ctr">
+                      <a:solidFill>
+                        <a:srgbClr val="D1D5DB"/>
+                      </a:solidFill>
+                      <a:prstDash val="solid"/>
+                      <a:round/>
+                      <a:headEnd type="none" w="med" len="med"/>
+                      <a:tailEnd type="none" w="med" len="med"/>
+                    </a:lnR>
+                    <a:lnT w="12700" cap="flat" cmpd="sng" algn="ctr">
+                      <a:solidFill>
+                        <a:srgbClr val="D1D5DB"/>
+                      </a:solidFill>
+                      <a:prstDash val="solid"/>
+                      <a:round/>
+                      <a:headEnd type="none" w="med" len="med"/>
+                      <a:tailEnd type="none" w="med" len="med"/>
+                    </a:lnT>
+                    <a:lnB w="12700" cap="flat" cmpd="sng" algn="ctr">
+                      <a:solidFill>
+                        <a:srgbClr val="D1D5DB"/>
+                      </a:solidFill>
+                      <a:prstDash val="solid"/>
+                      <a:round/>
+                      <a:headEnd type="none" w="med" len="med"/>
+                      <a:tailEnd type="none" w="med" len="med"/>
+                    </a:lnB>
+                    <a:solidFill>
+                      <a:srgbClr val="FFFFFF"/>
+                    </a:solidFill>
+                  </a:tcPr>
+                </a:tc>
+              </a:tr>
+              <a:tr h="685800">
+                <a:tc>
+                  <a:txBody>
+                    <a:bodyPr/>
+                    <a:lstStyle/>
+                    <a:p>
+                      <a:pPr rtl="1" algn="r" indent="0" marL="0">
+                        <a:buNone/>
+                      </a:pPr>
+                      <a:r>
+                        <a:rPr lang="en-US" sz="1150" dirty="0">
+                          <a:solidFill>
+                            <a:srgbClr val="1F2937"/>
+                          </a:solidFill>
+                          <a:latin typeface="Arial" pitchFamily="34" charset="0"/>
+                          <a:ea typeface="Arial" pitchFamily="34" charset="-122"/>
+                          <a:cs typeface="Arial" pitchFamily="34" charset="-120"/>
+                        </a:rPr>
+                        <a:t>משמעותיות ומיומנות (מניעים) לעומת צרכי הימנעות (היגייניים)</a:t>
+                      </a:r>
+                      <a:endParaRPr lang="en-US" sz="1150" dirty="0">
+                        <a:latin typeface="Arial" charset="0"/>
+                        <a:ea typeface="Arial" charset="0"/>
+                        <a:cs typeface="Arial" charset="0"/>
+                      </a:endParaRPr>
+                    </a:p>
+                  </a:txBody>
+                  <a:tcPr marL="54864" marR="54864" marT="54864" marB="54864" anchor="ctr">
+                    <a:lnL w="12700" cap="flat" cmpd="sng" algn="ctr">
+                      <a:solidFill>
+                        <a:srgbClr val="D1D5DB"/>
+                      </a:solidFill>
+                      <a:prstDash val="solid"/>
+                      <a:round/>
+                      <a:headEnd type="none" w="med" len="med"/>
+                      <a:tailEnd type="none" w="med" len="med"/>
+                    </a:lnL>
+                    <a:lnR w="12700" cap="flat" cmpd="sng" algn="ctr">
+                      <a:solidFill>
+                        <a:srgbClr val="D1D5DB"/>
+                      </a:solidFill>
+                      <a:prstDash val="solid"/>
+                      <a:round/>
+                      <a:headEnd type="none" w="med" len="med"/>
+                      <a:tailEnd type="none" w="med" len="med"/>
+                    </a:lnR>
+                    <a:lnT w="12700" cap="flat" cmpd="sng" algn="ctr">
+                      <a:solidFill>
+                        <a:srgbClr val="D1D5DB"/>
+                      </a:solidFill>
+                      <a:prstDash val="solid"/>
+                      <a:round/>
+                      <a:headEnd type="none" w="med" len="med"/>
+                      <a:tailEnd type="none" w="med" len="med"/>
+                    </a:lnT>
+                    <a:lnB w="12700" cap="flat" cmpd="sng" algn="ctr">
+                      <a:solidFill>
+                        <a:srgbClr val="D1D5DB"/>
+                      </a:solidFill>
+                      <a:prstDash val="solid"/>
+                      <a:round/>
+                      <a:headEnd type="none" w="med" len="med"/>
+                      <a:tailEnd type="none" w="med" len="med"/>
+                    </a:lnB>
+                    <a:solidFill>
+                      <a:srgbClr val="FFFFFF"/>
+                    </a:solidFill>
+                  </a:tcPr>
+                </a:tc>
+                <a:tc>
+                  <a:txBody>
+                    <a:bodyPr/>
+                    <a:lstStyle/>
+                    <a:p>
+                      <a:pPr rtl="1" algn="r" indent="0" marL="0">
+                        <a:buNone/>
+                      </a:pPr>
+                      <a:r>
+                        <a:rPr lang="en-US" sz="1150" b="1" dirty="0">
+                          <a:solidFill>
+                            <a:srgbClr val="1F2937"/>
+                          </a:solidFill>
+                          <a:latin typeface="Arial" pitchFamily="34" charset="0"/>
+                          <a:ea typeface="Arial" pitchFamily="34" charset="-122"/>
+                          <a:cs typeface="Arial" pitchFamily="34" charset="-120"/>
+                        </a:rPr>
+                        <a:t>הגורמים המניעים וההיגייניים של הרצברג</a:t>
+                      </a:r>
+                      <a:endParaRPr lang="en-US" sz="1150" dirty="0">
+                        <a:latin typeface="Arial" charset="0"/>
+                        <a:ea typeface="Arial" charset="0"/>
+                        <a:cs typeface="Arial" charset="0"/>
+                      </a:endParaRPr>
+                    </a:p>
+                  </a:txBody>
+                  <a:tcPr marL="54864" marR="54864" marT="54864" marB="54864" anchor="ctr">
+                    <a:lnL w="12700" cap="flat" cmpd="sng" algn="ctr">
+                      <a:solidFill>
+                        <a:srgbClr val="D1D5DB"/>
+                      </a:solidFill>
+                      <a:prstDash val="solid"/>
+                      <a:round/>
+                      <a:headEnd type="none" w="med" len="med"/>
+                      <a:tailEnd type="none" w="med" len="med"/>
+                    </a:lnL>
+                    <a:lnR w="12700" cap="flat" cmpd="sng" algn="ctr">
+                      <a:solidFill>
+                        <a:srgbClr val="D1D5DB"/>
+                      </a:solidFill>
+                      <a:prstDash val="solid"/>
+                      <a:round/>
+                      <a:headEnd type="none" w="med" len="med"/>
+                      <a:tailEnd type="none" w="med" len="med"/>
+                    </a:lnR>
+                    <a:lnT w="12700" cap="flat" cmpd="sng" algn="ctr">
+                      <a:solidFill>
+                        <a:srgbClr val="D1D5DB"/>
+                      </a:solidFill>
+                      <a:prstDash val="solid"/>
+                      <a:round/>
+                      <a:headEnd type="none" w="med" len="med"/>
+                      <a:tailEnd type="none" w="med" len="med"/>
+                    </a:lnT>
+                    <a:lnB w="12700" cap="flat" cmpd="sng" algn="ctr">
+                      <a:solidFill>
+                        <a:srgbClr val="D1D5DB"/>
+                      </a:solidFill>
+                      <a:prstDash val="solid"/>
+                      <a:round/>
+                      <a:headEnd type="none" w="med" len="med"/>
+                      <a:tailEnd type="none" w="med" len="med"/>
+                    </a:lnB>
+                    <a:solidFill>
+                      <a:srgbClr val="FFFFFF"/>
+                    </a:solidFill>
+                  </a:tcPr>
+                </a:tc>
+              </a:tr>
+              <a:tr h="685800">
+                <a:tc>
+                  <a:txBody>
+                    <a:bodyPr/>
+                    <a:lstStyle/>
+                    <a:p>
+                      <a:pPr rtl="1" algn="r" indent="0" marL="0">
+                        <a:buNone/>
+                      </a:pPr>
+                      <a:r>
+                        <a:rPr lang="en-US" sz="1150" dirty="0">
+                          <a:solidFill>
+                            <a:srgbClr val="1F2937"/>
+                          </a:solidFill>
+                          <a:latin typeface="Arial" pitchFamily="34" charset="0"/>
+                          <a:ea typeface="Arial" pitchFamily="34" charset="-122"/>
+                          <a:cs typeface="Arial" pitchFamily="34" charset="-120"/>
+                        </a:rPr>
+                        <a:t>צורך האוטונומיה ורכיב המובנות</a:t>
+                      </a:r>
+                      <a:endParaRPr lang="en-US" sz="1150" dirty="0">
+                        <a:latin typeface="Arial" charset="0"/>
+                        <a:ea typeface="Arial" charset="0"/>
+                        <a:cs typeface="Arial" charset="0"/>
+                      </a:endParaRPr>
+                    </a:p>
+                  </a:txBody>
+                  <a:tcPr marL="54864" marR="54864" marT="54864" marB="54864" anchor="ctr">
+                    <a:lnL w="12700" cap="flat" cmpd="sng" algn="ctr">
+                      <a:solidFill>
+                        <a:srgbClr val="D1D5DB"/>
+                      </a:solidFill>
+                      <a:prstDash val="solid"/>
+                      <a:round/>
+                      <a:headEnd type="none" w="med" len="med"/>
+                      <a:tailEnd type="none" w="med" len="med"/>
+                    </a:lnL>
+                    <a:lnR w="12700" cap="flat" cmpd="sng" algn="ctr">
+                      <a:solidFill>
+                        <a:srgbClr val="D1D5DB"/>
+                      </a:solidFill>
+                      <a:prstDash val="solid"/>
+                      <a:round/>
+                      <a:headEnd type="none" w="med" len="med"/>
+                      <a:tailEnd type="none" w="med" len="med"/>
+                    </a:lnR>
+                    <a:lnT w="12700" cap="flat" cmpd="sng" algn="ctr">
+                      <a:solidFill>
+                        <a:srgbClr val="D1D5DB"/>
+                      </a:solidFill>
+                      <a:prstDash val="solid"/>
+                      <a:round/>
+                      <a:headEnd type="none" w="med" len="med"/>
+                      <a:tailEnd type="none" w="med" len="med"/>
+                    </a:lnT>
+                    <a:lnB w="12700" cap="flat" cmpd="sng" algn="ctr">
+                      <a:solidFill>
+                        <a:srgbClr val="D1D5DB"/>
+                      </a:solidFill>
+                      <a:prstDash val="solid"/>
+                      <a:round/>
+                      <a:headEnd type="none" w="med" len="med"/>
+                      <a:tailEnd type="none" w="med" len="med"/>
+                    </a:lnB>
+                    <a:solidFill>
+                      <a:srgbClr val="FFFFFF"/>
+                    </a:solidFill>
+                  </a:tcPr>
+                </a:tc>
+                <a:tc>
+                  <a:txBody>
+                    <a:bodyPr/>
+                    <a:lstStyle/>
+                    <a:p>
+                      <a:pPr rtl="1" algn="r" indent="0" marL="0">
+                        <a:buNone/>
+                      </a:pPr>
+                      <a:r>
+                        <a:rPr lang="en-US" sz="1150" b="1" dirty="0">
+                          <a:solidFill>
+                            <a:srgbClr val="1F2937"/>
+                          </a:solidFill>
+                          <a:latin typeface="Arial" pitchFamily="34" charset="0"/>
+                          <a:ea typeface="Arial" pitchFamily="34" charset="-122"/>
+                          <a:cs typeface="Arial" pitchFamily="34" charset="-120"/>
+                        </a:rPr>
+                        <a:t>עוגני קריירה: אוטונומיה לעומת ביטחון ויציבות</a:t>
+                      </a:r>
+                      <a:endParaRPr lang="en-US" sz="1150" dirty="0">
+                        <a:latin typeface="Arial" charset="0"/>
+                        <a:ea typeface="Arial" charset="0"/>
+                        <a:cs typeface="Arial" charset="0"/>
+                      </a:endParaRPr>
+                    </a:p>
+                  </a:txBody>
+                  <a:tcPr marL="54864" marR="54864" marT="54864" marB="54864" anchor="ctr">
+                    <a:lnL w="12700" cap="flat" cmpd="sng" algn="ctr">
+                      <a:solidFill>
+                        <a:srgbClr val="D1D5DB"/>
+                      </a:solidFill>
+                      <a:prstDash val="solid"/>
+                      <a:round/>
+                      <a:headEnd type="none" w="med" len="med"/>
+                      <a:tailEnd type="none" w="med" len="med"/>
+                    </a:lnL>
+                    <a:lnR w="12700" cap="flat" cmpd="sng" algn="ctr">
+                      <a:solidFill>
+                        <a:srgbClr val="D1D5DB"/>
+                      </a:solidFill>
+                      <a:prstDash val="solid"/>
+                      <a:round/>
+                      <a:headEnd type="none" w="med" len="med"/>
+                      <a:tailEnd type="none" w="med" len="med"/>
+                    </a:lnR>
+                    <a:lnT w="12700" cap="flat" cmpd="sng" algn="ctr">
+                      <a:solidFill>
+                        <a:srgbClr val="D1D5DB"/>
+                      </a:solidFill>
+                      <a:prstDash val="solid"/>
+                      <a:round/>
+                      <a:headEnd type="none" w="med" len="med"/>
+                      <a:tailEnd type="none" w="med" len="med"/>
+                    </a:lnT>
+                    <a:lnB w="12700" cap="flat" cmpd="sng" algn="ctr">
+                      <a:solidFill>
+                        <a:srgbClr val="D1D5DB"/>
+                      </a:solidFill>
+                      <a:prstDash val="solid"/>
+                      <a:round/>
+                      <a:headEnd type="none" w="med" len="med"/>
+                      <a:tailEnd type="none" w="med" len="med"/>
+                    </a:lnB>
+                    <a:solidFill>
+                      <a:srgbClr val="FFFFFF"/>
+                    </a:solidFill>
+                  </a:tcPr>
+                </a:tc>
+              </a:tr>
+              <a:tr h="685800">
+                <a:tc>
+                  <a:txBody>
+                    <a:bodyPr/>
+                    <a:lstStyle/>
+                    <a:p>
+                      <a:pPr rtl="1" algn="r" indent="0" marL="0">
+                        <a:buNone/>
+                      </a:pPr>
+                      <a:r>
+                        <a:rPr lang="en-US" sz="1150" dirty="0">
+                          <a:solidFill>
+                            <a:srgbClr val="1F2937"/>
+                          </a:solidFill>
+                          <a:latin typeface="Arial" pitchFamily="34" charset="0"/>
+                          <a:ea typeface="Arial" pitchFamily="34" charset="-122"/>
+                          <a:cs typeface="Arial" pitchFamily="34" charset="-120"/>
+                        </a:rPr>
+                        <a:t>ניהוליות: "יש לי מספיק משאבים", המנוע ליוזמה</a:t>
+                      </a:r>
+                      <a:endParaRPr lang="en-US" sz="1150" dirty="0">
+                        <a:latin typeface="Arial" charset="0"/>
+                        <a:ea typeface="Arial" charset="0"/>
+                        <a:cs typeface="Arial" charset="0"/>
+                      </a:endParaRPr>
+                    </a:p>
+                  </a:txBody>
+                  <a:tcPr marL="54864" marR="54864" marT="54864" marB="54864" anchor="ctr">
+                    <a:lnL w="12700" cap="flat" cmpd="sng" algn="ctr">
+                      <a:solidFill>
+                        <a:srgbClr val="D1D5DB"/>
+                      </a:solidFill>
+                      <a:prstDash val="solid"/>
+                      <a:round/>
+                      <a:headEnd type="none" w="med" len="med"/>
+                      <a:tailEnd type="none" w="med" len="med"/>
+                    </a:lnL>
+                    <a:lnR w="12700" cap="flat" cmpd="sng" algn="ctr">
+                      <a:solidFill>
+                        <a:srgbClr val="D1D5DB"/>
+                      </a:solidFill>
+                      <a:prstDash val="solid"/>
+                      <a:round/>
+                      <a:headEnd type="none" w="med" len="med"/>
+                      <a:tailEnd type="none" w="med" len="med"/>
+                    </a:lnR>
+                    <a:lnT w="12700" cap="flat" cmpd="sng" algn="ctr">
+                      <a:solidFill>
+                        <a:srgbClr val="D1D5DB"/>
+                      </a:solidFill>
+                      <a:prstDash val="solid"/>
+                      <a:round/>
+                      <a:headEnd type="none" w="med" len="med"/>
+                      <a:tailEnd type="none" w="med" len="med"/>
+                    </a:lnT>
+                    <a:lnB w="12700" cap="flat" cmpd="sng" algn="ctr">
+                      <a:solidFill>
+                        <a:srgbClr val="D1D5DB"/>
+                      </a:solidFill>
+                      <a:prstDash val="solid"/>
+                      <a:round/>
+                      <a:headEnd type="none" w="med" len="med"/>
+                      <a:tailEnd type="none" w="med" len="med"/>
+                    </a:lnB>
+                    <a:solidFill>
+                      <a:srgbClr val="FFFFFF"/>
+                    </a:solidFill>
+                  </a:tcPr>
+                </a:tc>
+                <a:tc>
+                  <a:txBody>
+                    <a:bodyPr/>
+                    <a:lstStyle/>
+                    <a:p>
+                      <a:pPr rtl="1" algn="r" indent="0" marL="0">
+                        <a:buNone/>
+                      </a:pPr>
+                      <a:r>
+                        <a:rPr lang="en-US" sz="1150" b="1" dirty="0">
+                          <a:solidFill>
+                            <a:srgbClr val="1F2937"/>
+                          </a:solidFill>
+                          <a:latin typeface="Arial" pitchFamily="34" charset="0"/>
+                          <a:ea typeface="Arial" pitchFamily="34" charset="-122"/>
+                          <a:cs typeface="Arial" pitchFamily="34" charset="-120"/>
+                        </a:rPr>
+                        <a:t>תמיכה בעבודה ובמשפחה וזמינות פסיכולוגית (Russo et al., 2016)</a:t>
+                      </a:r>
+                      <a:endParaRPr lang="en-US" sz="1150" dirty="0">
+                        <a:latin typeface="Arial" charset="0"/>
+                        <a:ea typeface="Arial" charset="0"/>
+                        <a:cs typeface="Arial" charset="0"/>
+                      </a:endParaRPr>
+                    </a:p>
+                  </a:txBody>
+                  <a:tcPr marL="54864" marR="54864" marT="54864" marB="54864" anchor="ctr">
+                    <a:lnL w="12700" cap="flat" cmpd="sng" algn="ctr">
+                      <a:solidFill>
+                        <a:srgbClr val="D1D5DB"/>
+                      </a:solidFill>
+                      <a:prstDash val="solid"/>
+                      <a:round/>
+                      <a:headEnd type="none" w="med" len="med"/>
+                      <a:tailEnd type="none" w="med" len="med"/>
+                    </a:lnL>
+                    <a:lnR w="12700" cap="flat" cmpd="sng" algn="ctr">
+                      <a:solidFill>
+                        <a:srgbClr val="D1D5DB"/>
+                      </a:solidFill>
+                      <a:prstDash val="solid"/>
+                      <a:round/>
+                      <a:headEnd type="none" w="med" len="med"/>
+                      <a:tailEnd type="none" w="med" len="med"/>
+                    </a:lnR>
+                    <a:lnT w="12700" cap="flat" cmpd="sng" algn="ctr">
+                      <a:solidFill>
+                        <a:srgbClr val="D1D5DB"/>
+                      </a:solidFill>
+                      <a:prstDash val="solid"/>
+                      <a:round/>
+                      <a:headEnd type="none" w="med" len="med"/>
+                      <a:tailEnd type="none" w="med" len="med"/>
+                    </a:lnT>
+                    <a:lnB w="12700" cap="flat" cmpd="sng" algn="ctr">
+                      <a:solidFill>
+                        <a:srgbClr val="D1D5DB"/>
+                      </a:solidFill>
+                      <a:prstDash val="solid"/>
+                      <a:round/>
+                      <a:headEnd type="none" w="med" len="med"/>
+                      <a:tailEnd type="none" w="med" len="med"/>
+                    </a:lnB>
+                    <a:solidFill>
+                      <a:srgbClr val="FFFFFF"/>
+                    </a:solidFill>
+                  </a:tcPr>
+                </a:tc>
+              </a:tr>
+            </a:tbl>
+          </a:graphicData>
+        </a:graphic>
+      </p:graphicFrame>
+      <p:sp>
+        <p:nvSpPr>
+          <p:cNvPr id="4" name="Shape 1"/>
+          <p:cNvSpPr/>
+          <p:nvPr/>
+        </p:nvSpPr>
+        <p:spPr>
+          <a:xfrm>
+            <a:off x="548640" y="1280160"/>
+            <a:ext cx="5120640" cy="4983480"/>
+          </a:xfrm>
+          <a:prstGeom prst="roundRect">
+            <a:avLst>
+              <a:gd name="adj" fmla="val 2202"/>
+            </a:avLst>
+          </a:prstGeom>
+          <a:solidFill>
+            <a:srgbClr val="F4F6FA"/>
+          </a:solidFill>
+          <a:ln w="12700">
+            <a:solidFill>
+              <a:srgbClr val="F4F6FA"/>
+            </a:solidFill>
+            <a:prstDash val="solid"/>
+          </a:ln>
+          <a:effectLst>
+            <a:outerShdw sx="100000" sy="100000" kx="0" ky="0" algn="bl" rotWithShape="0" blurRad="50800" dist="25400" dir="5400000">
+              <a:srgbClr val="000000">
+                <a:alpha val="12000"/>
+              </a:srgbClr>
+            </a:outerShdw>
+          </a:effectLst>
+        </p:spPr>
+      </p:sp>
+      <p:sp>
+        <p:nvSpPr>
+          <p:cNvPr id="5" name="Text 2"/>
+          <p:cNvSpPr txBox="1"/>
+          <p:nvPr/>
+        </p:nvSpPr>
+        <p:spPr>
+          <a:xfrm>
+            <a:off x="777240" y="1463040"/>
+            <a:ext cx="4663440" cy="4663440"/>
+          </a:xfrm>
+          <a:prstGeom prst="rect">
+            <a:avLst/>
+          </a:prstGeom>
+          <a:noFill/>
+          <a:ln/>
+        </p:spPr>
+        <p:txBody>
+          <a:bodyPr wrap="square" lIns="0" tIns="0" rIns="0" bIns="0" rtlCol="0" anchor="t"/>
+          <a:lstStyle/>
+          <a:p>
+            <a:pPr rtl="1" algn="r" indent="0" marL="0">
+              <a:buNone/>
+            </a:pPr>
+            <a:r>
+              <a:rPr lang="he-IL" altLang="en-US" sz="1350" dirty="0">
+                <a:solidFill>
+                  <a:srgbClr val="1F2937"/>
+                </a:solidFill>
+                <a:latin typeface="Arial" pitchFamily="34" charset="0"/>
+                <a:ea typeface="Arial" pitchFamily="34" charset="-122"/>
+                <a:cs typeface="Arial" pitchFamily="34" charset="-120"/>
+              </a:rPr>
+              <a:t>המאמר אינו זר לחומר הקורס אלא מעניק לו בסיס אמפירי. שלושת סלי הכלים שנלמדו בקורס מקבילים כמעט אחד לאחד לצרכי ההתקרבות שנמצאו כבונים תחושת קוהרנטיות, והרעיון של קריירה רבודה, שבה כל שלב נבנה על קודמו, הוא בדיוק ספירלת הרווח שהמחקר מתעד. הגורמים המניעים של הרצברג ועוגני הקריירה מסבירים מדוע צרכים שונים חשובים לעובדים שונים, ומאמר החובה של Russo ואחרים (2016) מראה שתמיכה מהסביבה מזינה את הזמינות הפסיכולוגית, כלומר את תחושת הניהוליות שהמחקר מזהה כמנוע ליוזמה (Cetkovská et al., 2026).</a:t>
+            </a:r>
+            <a:endParaRPr lang="he-IL" sz="1350" dirty="0"/>
+          </a:p>
+        </p:txBody>
+      </p:sp>
+      <p:sp>
+        <p:nvSpPr>
+          <p:cNvPr id="6" name="Text 3"/>
+          <p:cNvSpPr txBox="1"/>
+          <p:nvPr/>
+        </p:nvSpPr>
+        <p:spPr>
+          <a:xfrm>
+            <a:off x="5943600" y="6446520"/>
+            <a:ext cx="5696712" cy="274320"/>
+          </a:xfrm>
+          <a:prstGeom prst="rect">
+            <a:avLst/>
+          </a:prstGeom>
+          <a:noFill/>
+          <a:ln/>
+        </p:spPr>
+        <p:txBody>
+          <a:bodyPr wrap="square" lIns="0" tIns="0" rIns="0" bIns="0" rtlCol="0" anchor="ctr"/>
+          <a:lstStyle/>
+          <a:p>
+            <a:pPr rtl="1" algn="r" indent="0" marL="0">
+              <a:buNone/>
+            </a:pPr>
+            <a:r>
+              <a:rPr lang="he-IL" altLang="en-US" sz="1000" dirty="0">
+                <a:solidFill>
+                  <a:srgbClr val="6B7280"/>
+                </a:solidFill>
+                <a:latin typeface="Arial" pitchFamily="34" charset="0"/>
+                <a:ea typeface="Arial" pitchFamily="34" charset="-122"/>
+                <a:cs typeface="Arial" pitchFamily="34" charset="-120"/>
+              </a:rPr>
+              <a:t>ניהול קריירה בארגונים | הקריה האקדמית אונו</a:t>
+            </a:r>
+            <a:endParaRPr lang="he-IL" sz="1000" dirty="0"/>
+          </a:p>
+        </p:txBody>
+      </p:sp>
+      <p:sp>
+        <p:nvSpPr>
+          <p:cNvPr id="7" name="Text 4"/>
+          <p:cNvSpPr txBox="1"/>
+          <p:nvPr/>
+        </p:nvSpPr>
+        <p:spPr>
+          <a:xfrm>
+            <a:off x="548640" y="6446520"/>
+            <a:ext cx="914400" cy="274320"/>
+          </a:xfrm>
+          <a:prstGeom prst="rect">
+            <a:avLst/>
+          </a:prstGeom>
+          <a:noFill/>
+          <a:ln/>
+        </p:spPr>
+        <p:txBody>
+          <a:bodyPr wrap="square" lIns="0" tIns="0" rIns="0" bIns="0" rtlCol="0" anchor="ctr"/>
+          <a:lstStyle/>
+          <a:p>
+            <a:pPr rtl="1" algn="l" indent="0" marL="0">
+              <a:buNone/>
+            </a:pPr>
+            <a:r>
+              <a:rPr lang="he-IL" altLang="en-US" sz="1000" dirty="0">
+                <a:solidFill>
+                  <a:srgbClr val="6B7280"/>
+                </a:solidFill>
+                <a:latin typeface="Arial" pitchFamily="34" charset="0"/>
+                <a:ea typeface="Arial" pitchFamily="34" charset="-122"/>
+                <a:cs typeface="Arial" pitchFamily="34" charset="-120"/>
+              </a:rPr>
+              <a:t>11</a:t>
+            </a:r>
+            <a:endParaRPr lang="he-IL" sz="1000" dirty="0"/>
+          </a:p>
+        </p:txBody>
+      </p:sp>
+    </p:spTree>
+  </p:cSld>
+  <p:clrMapOvr>
+    <a:masterClrMapping/>
+  </p:clrMapOvr>
+</p:sld>
+</file>
+
+<file path=ppt/slides/slide12.xml><?xml version="1.0" encoding="utf-8"?>
+<p:sld xmlns:a="http://schemas.openxmlformats.org/drawingml/2006/main" xmlns:r="http://schemas.openxmlformats.org/officeDocument/2006/relationships" xmlns:p="http://schemas.openxmlformats.org/presentationml/2006/main">
+  <p:cSld name="Slide 12">
+    <p:spTree>
+      <p:nvGrpSpPr>
+        <p:cNvPr id="1" name=""/>
+        <p:cNvGrpSpPr/>
+        <p:nvPr/>
+      </p:nvGrpSpPr>
+      <p:grpSpPr>
+        <a:xfrm>
+          <a:off x="0" y="0"/>
+          <a:ext cx="0" cy="0"/>
+          <a:chOff x="0" y="0"/>
+          <a:chExt cx="0" cy="0"/>
+        </a:xfrm>
+      </p:grpSpPr>
+      <p:sp>
+        <p:nvSpPr>
+          <p:cNvPr id="2" name="Text 0"/>
+          <p:cNvSpPr txBox="1"/>
+          <p:nvPr/>
+        </p:nvSpPr>
+        <p:spPr>
+          <a:xfrm>
+            <a:off x="548640" y="320040"/>
+            <a:ext cx="11091672" cy="822960"/>
+          </a:xfrm>
+          <a:prstGeom prst="rect">
+            <a:avLst/>
+          </a:prstGeom>
+          <a:noFill/>
+          <a:ln/>
+        </p:spPr>
+        <p:txBody>
+          <a:bodyPr wrap="square" lIns="0" tIns="0" rIns="0" bIns="0" rtlCol="0" anchor="ctr"/>
+          <a:lstStyle/>
+          <a:p>
+            <a:pPr rtl="1" algn="r" indent="0" marL="0">
+              <a:buNone/>
+            </a:pPr>
+            <a:r>
+              <a:rPr lang="he-IL" altLang="en-US" sz="3000" b="1" dirty="0">
+                <a:solidFill>
+                  <a:srgbClr val="14213D"/>
+                </a:solidFill>
+                <a:latin typeface="Arial" pitchFamily="34" charset="0"/>
+                <a:ea typeface="Arial" pitchFamily="34" charset="-122"/>
+                <a:cs typeface="Arial" pitchFamily="34" charset="-120"/>
+              </a:rPr>
               <a:t>תובנות, ביקורת ודעה אישית</a:t>
             </a:r>
             <a:endParaRPr lang="he-IL" sz="3000" dirty="0"/>
@@ -4024,7 +5350,7 @@
                 <a:ea typeface="Arial" pitchFamily="34" charset="-122"/>
                 <a:cs typeface="Arial" pitchFamily="34" charset="-120"/>
               </a:rPr>
-              <a:t>👍 מה אהבנו</a:t>
+              <a:t>מה אהבנו</a:t>
             </a:r>
             <a:endParaRPr lang="he-IL" sz="1800" dirty="0"/>
           </a:p>
@@ -4039,7 +5365,7 @@
         <p:spPr>
           <a:xfrm>
             <a:off x="6492240" y="1920240"/>
-            <a:ext cx="4937760" cy="2194560"/>
+            <a:ext cx="4937760" cy="2240280"/>
           </a:xfrm>
           <a:prstGeom prst="rect">
             <a:avLst/>
@@ -4051,15 +5377,11 @@
           <a:bodyPr wrap="square" lIns="0" tIns="0" rIns="0" bIns="0" rtlCol="0" anchor="t"/>
           <a:lstStyle/>
           <a:p>
-            <a:pPr algn="r" marL="342900" indent="-342900">
-              <a:spcAft>
-                <a:spcPts val="500"/>
-              </a:spcAft>
-              <a:buSzPct val="100000"/>
-              <a:buChar char="•"/>
-            </a:pPr>
-            <a:r>
-              <a:rPr lang="he-IL" altLang="en-US" sz="1300" dirty="0">
+            <a:pPr rtl="1" algn="r" indent="0" marL="0">
+              <a:buNone/>
+            </a:pPr>
+            <a:r>
+              <a:rPr lang="he-IL" altLang="en-US" sz="1250" dirty="0">
                 <a:solidFill>
                   <a:srgbClr val="1F2937"/>
                 </a:solidFill>
@@ -4067,72 +5389,9 @@
                 <a:ea typeface="Arial" pitchFamily="34" charset="-122"/>
                 <a:cs typeface="Arial" pitchFamily="34" charset="-120"/>
               </a:rPr>
-              <a:t>נקודת המבט: מה עוזר, לא רק מה מזיק. רעיון ישראלי מבן-גוריון</a:t>
-            </a:r>
-            <a:endParaRPr lang="he-IL" sz="1300" dirty="0"/>
-          </a:p>
-          <a:p>
-            <a:pPr algn="r" marL="342900" indent="-342900">
-              <a:spcAft>
-                <a:spcPts val="500"/>
-              </a:spcAft>
-              <a:buSzPct val="100000"/>
-              <a:buChar char="•"/>
-            </a:pPr>
-            <a:r>
-              <a:rPr lang="he-IL" altLang="en-US" sz="1300" dirty="0">
-                <a:solidFill>
-                  <a:srgbClr val="1F2937"/>
-                </a:solidFill>
-                <a:latin typeface="Arial" pitchFamily="34" charset="0"/>
-                <a:ea typeface="Arial" pitchFamily="34" charset="-122"/>
-                <a:cs typeface="Arial" pitchFamily="34" charset="-120"/>
-              </a:rPr>
-              <a:t>פרקטי: שישה צרכים, שאלות פשוטות, פעולות לשבועיים</a:t>
-            </a:r>
-            <a:endParaRPr lang="he-IL" sz="1300" dirty="0"/>
-          </a:p>
-          <a:p>
-            <a:pPr algn="r" marL="342900" indent="-342900">
-              <a:spcAft>
-                <a:spcPts val="500"/>
-              </a:spcAft>
-              <a:buSzPct val="100000"/>
-              <a:buChar char="•"/>
-            </a:pPr>
-            <a:r>
-              <a:rPr lang="he-IL" altLang="en-US" sz="1300" dirty="0">
-                <a:solidFill>
-                  <a:srgbClr val="1F2937"/>
-                </a:solidFill>
-                <a:latin typeface="Arial" pitchFamily="34" charset="0"/>
-                <a:ea typeface="Arial" pitchFamily="34" charset="-122"/>
-                <a:cs typeface="Arial" pitchFamily="34" charset="-120"/>
-              </a:rPr>
-              <a:t>כנות: כמעט עמוד שלם על מגבלות, כולל ממצא שקשה להם להסביר</a:t>
-            </a:r>
-            <a:endParaRPr lang="he-IL" sz="1300" dirty="0"/>
-          </a:p>
-          <a:p>
-            <a:pPr algn="r" marL="342900" indent="-342900">
-              <a:spcAft>
-                <a:spcPts val="500"/>
-              </a:spcAft>
-              <a:buSzPct val="100000"/>
-              <a:buChar char="•"/>
-            </a:pPr>
-            <a:r>
-              <a:rPr lang="he-IL" altLang="en-US" sz="1300" dirty="0">
-                <a:solidFill>
-                  <a:srgbClr val="1F2937"/>
-                </a:solidFill>
-                <a:latin typeface="Arial" pitchFamily="34" charset="0"/>
-                <a:ea typeface="Arial" pitchFamily="34" charset="-122"/>
-                <a:cs typeface="Arial" pitchFamily="34" charset="-120"/>
-              </a:rPr>
-              <a:t>זמין לכולם בחינם</a:t>
-            </a:r>
-            <a:endParaRPr lang="he-IL" sz="1300" dirty="0"/>
+              <a:t>אהבנו את נקודת המבט של המאמר, ששואל מה עוזר לעובדים ולא רק מה מזיק להם, ואת הפרקטיות שלו: שישה צרכים, שאלות פשוטות ופעולות שאפשר לבצע בשבועיים. הערכנו את הכנות של המחברים, שמקדישים כמעט עמוד שלם למגבלות, כולל ממצא שקשה להם להסביר, ואת העובדה שהמאמר זמין לכולם בחינם (Cetkovská et al., 2026).</a:t>
+            </a:r>
+            <a:endParaRPr lang="he-IL" sz="1250" dirty="0"/>
           </a:p>
         </p:txBody>
       </p:sp>
@@ -4203,7 +5462,7 @@
                 <a:ea typeface="Arial" pitchFamily="34" charset="-122"/>
                 <a:cs typeface="Arial" pitchFamily="34" charset="-120"/>
               </a:rPr>
-              <a:t>🤔 מה חסר לנו</a:t>
+              <a:t>מה חסר לנו</a:t>
             </a:r>
             <a:endParaRPr lang="he-IL" sz="1800" dirty="0"/>
           </a:p>
@@ -4218,7 +5477,7 @@
         <p:spPr>
           <a:xfrm>
             <a:off x="777240" y="1920240"/>
-            <a:ext cx="4937760" cy="2194560"/>
+            <a:ext cx="4937760" cy="2240280"/>
           </a:xfrm>
           <a:prstGeom prst="rect">
             <a:avLst/>
@@ -4230,15 +5489,11 @@
           <a:bodyPr wrap="square" lIns="0" tIns="0" rIns="0" bIns="0" rtlCol="0" anchor="t"/>
           <a:lstStyle/>
           <a:p>
-            <a:pPr algn="r" marL="342900" indent="-342900">
-              <a:spcAft>
-                <a:spcPts val="500"/>
-              </a:spcAft>
-              <a:buSzPct val="100000"/>
-              <a:buChar char="•"/>
-            </a:pPr>
-            <a:r>
-              <a:rPr lang="he-IL" altLang="en-US" sz="1300" dirty="0">
+            <a:pPr rtl="1" algn="r" indent="0" marL="0">
+              <a:buNone/>
+            </a:pPr>
+            <a:r>
+              <a:rPr lang="he-IL" altLang="en-US" sz="1250" dirty="0">
                 <a:solidFill>
                   <a:srgbClr val="1F2937"/>
                 </a:solidFill>
@@ -4246,51 +5501,9 @@
                 <a:ea typeface="Arial" pitchFamily="34" charset="-122"/>
                 <a:cs typeface="Arial" pitchFamily="34" charset="-120"/>
               </a:rPr>
-              <a:t>לא מודד חוסר ביטחון במישרין. את החיבור לנושא בנינו בעצמנו</a:t>
-            </a:r>
-            <a:endParaRPr lang="he-IL" sz="1300" dirty="0"/>
-          </a:p>
-          <a:p>
-            <a:pPr algn="r" marL="342900" indent="-342900">
-              <a:spcAft>
-                <a:spcPts val="500"/>
-              </a:spcAft>
-              <a:buSzPct val="100000"/>
-              <a:buChar char="•"/>
-            </a:pPr>
-            <a:r>
-              <a:rPr lang="he-IL" altLang="en-US" sz="1300" dirty="0">
-                <a:solidFill>
-                  <a:srgbClr val="1F2937"/>
-                </a:solidFill>
-                <a:latin typeface="Arial" pitchFamily="34" charset="0"/>
-                <a:ea typeface="Arial" pitchFamily="34" charset="-122"/>
-                <a:cs typeface="Arial" pitchFamily="34" charset="-120"/>
-              </a:rPr>
-              <a:t>מדגם גרמני-שווייצרי, גיל ממוצע 49, ביטחון סוציאלי גבוה. האם המרחב לעצב תפקיד קיים גם אצלנו?</a:t>
-            </a:r>
-            <a:endParaRPr lang="he-IL" sz="1300" dirty="0"/>
-          </a:p>
-          <a:p>
-            <a:pPr algn="r" marL="342900" indent="-342900">
-              <a:spcAft>
-                <a:spcPts val="500"/>
-              </a:spcAft>
-              <a:buSzPct val="100000"/>
-              <a:buChar char="•"/>
-            </a:pPr>
-            <a:r>
-              <a:rPr lang="he-IL" altLang="en-US" sz="1300" dirty="0">
-                <a:solidFill>
-                  <a:srgbClr val="1F2937"/>
-                </a:solidFill>
-                <a:latin typeface="Arial" pitchFamily="34" charset="0"/>
-                <a:ea typeface="Arial" pitchFamily="34" charset="-122"/>
-                <a:cs typeface="Arial" pitchFamily="34" charset="-120"/>
-              </a:rPr>
-              <a:t>שכירים בתפקיד קיים בלבד. לא מחפשי עבודה, לא עצמאים</a:t>
-            </a:r>
-            <a:endParaRPr lang="he-IL" sz="1300" dirty="0"/>
+              <a:t>המאמר אינו מודד חוסר ביטחון תעסוקתי במישרין, ואת החיבור לנושא בנינו בעצמנו דרך המאמר המשלים. המדגם גרמני ושווייצרי, בגיל ממוצע של כמעט 49, מתרבות עבודה עם ביטחון סוציאלי גבוה, ולא ברור שהמרחב לעצב תפקיד קיים גם אצל סטודנטים ישראלים בתחילת הדרך. המחקר עוסק בשכירים בתפקיד קיים בלבד, ולא במחפשי עבודה או בעצמאים.</a:t>
+            </a:r>
+            <a:endParaRPr lang="he-IL" sz="1250" dirty="0"/>
           </a:p>
         </p:txBody>
       </p:sp>
@@ -4478,7 +5691,7 @@
                 <a:ea typeface="Arial" pitchFamily="34" charset="-122"/>
                 <a:cs typeface="Arial" pitchFamily="34" charset="-120"/>
               </a:rPr>
-              <a:t>11</a:t>
+              <a:t>12</a:t>
             </a:r>
             <a:endParaRPr lang="he-IL" sz="1000" dirty="0"/>
           </a:p>
@@ -4492,9 +5705,9 @@
 </p:sld>
 </file>
 
-<file path=ppt/slides/slide12.xml><?xml version="1.0" encoding="utf-8"?>
+<file path=ppt/slides/slide13.xml><?xml version="1.0" encoding="utf-8"?>
 <p:sld xmlns:a="http://schemas.openxmlformats.org/drawingml/2006/main" xmlns:r="http://schemas.openxmlformats.org/officeDocument/2006/relationships" xmlns:p="http://schemas.openxmlformats.org/presentationml/2006/main">
-  <p:cSld name="Slide 12">
+  <p:cSld name="Slide 13">
     <p:bg>
       <p:bgPr>
         <a:solidFill>
@@ -4742,7 +5955,7 @@
         <p:spPr>
           <a:xfrm>
             <a:off x="731520" y="1965960"/>
-            <a:ext cx="5212080" cy="2560320"/>
+            <a:ext cx="5212080" cy="2651760"/>
           </a:xfrm>
           <a:prstGeom prst="rect">
             <a:avLst/>
@@ -4754,15 +5967,11 @@
           <a:bodyPr wrap="square" lIns="0" tIns="0" rIns="0" bIns="0" rtlCol="0" anchor="t"/>
           <a:lstStyle/>
           <a:p>
-            <a:pPr algn="r" marL="342900" indent="-342900">
-              <a:spcAft>
-                <a:spcPts val="800"/>
-              </a:spcAft>
-              <a:buSzPct val="100000"/>
-              <a:buChar char="•"/>
-            </a:pPr>
-            <a:r>
-              <a:rPr lang="he-IL" altLang="en-US" sz="1450" dirty="0">
+            <a:pPr rtl="1" algn="r" indent="0" marL="0">
+              <a:buNone/>
+            </a:pPr>
+            <a:r>
+              <a:rPr lang="he-IL" altLang="en-US" sz="1350" dirty="0">
                 <a:solidFill>
                   <a:srgbClr val="FFFFFF"/>
                 </a:solidFill>
@@ -4770,51 +5979,9 @@
                 <a:ea typeface="Arial" pitchFamily="34" charset="-122"/>
                 <a:cs typeface="Arial" pitchFamily="34" charset="-120"/>
               </a:rPr>
-              <a:t>"דברים רעים קורים": קבלת חוסר הוודאות כחלק מהחיים</a:t>
-            </a:r>
-            <a:endParaRPr lang="he-IL" sz="1450" dirty="0"/>
-          </a:p>
-          <a:p>
-            <a:pPr algn="r" marL="342900" indent="-342900">
-              <a:spcAft>
-                <a:spcPts val="800"/>
-              </a:spcAft>
-              <a:buSzPct val="100000"/>
-              <a:buChar char="•"/>
-            </a:pPr>
-            <a:r>
-              <a:rPr lang="he-IL" altLang="en-US" sz="1450" dirty="0">
-                <a:solidFill>
-                  <a:srgbClr val="FFFFFF"/>
-                </a:solidFill>
-                <a:latin typeface="Arial" pitchFamily="34" charset="0"/>
-                <a:ea typeface="Arial" pitchFamily="34" charset="-122"/>
-                <a:cs typeface="Arial" pitchFamily="34" charset="-120"/>
-              </a:rPr>
-              <a:t>לבחור במה להתמקד: מה בשליטתי. זו המובנות והניהוליות</a:t>
-            </a:r>
-            <a:endParaRPr lang="he-IL" sz="1450" dirty="0"/>
-          </a:p>
-          <a:p>
-            <a:pPr algn="r" marL="342900" indent="-342900">
-              <a:spcAft>
-                <a:spcPts val="800"/>
-              </a:spcAft>
-              <a:buSzPct val="100000"/>
-              <a:buChar char="•"/>
-            </a:pPr>
-            <a:r>
-              <a:rPr lang="he-IL" altLang="en-US" sz="1450" dirty="0">
-                <a:solidFill>
-                  <a:srgbClr val="FFFFFF"/>
-                </a:solidFill>
-                <a:latin typeface="Arial" pitchFamily="34" charset="0"/>
-                <a:ea typeface="Arial" pitchFamily="34" charset="-122"/>
-                <a:cs typeface="Arial" pitchFamily="34" charset="-120"/>
-              </a:rPr>
-              <a:t>"האם זה עוזר לי או פוגע בי?": האם אני מעצב את המצב או רק שורד אותו</a:t>
-            </a:r>
-            <a:endParaRPr lang="he-IL" sz="1450" dirty="0"/>
+              <a:t>חוקרת החוסן לוסי הון מציעה שלושה עקרונות: לקבל שדברים רעים קורים כחלק מהחיים, לבחור במה להתמקד ולהפנות את הקשב למה שבשליטתנו, ולשאול על כל פעולה האם היא עוזרת או פוגעת (Hone, 2019). שני העקרונות האחרונים הם, במונחי המאמר, חיזוק המובנות והניהוליות והבחירה לעצב את המצב במקום רק לשרוד אותו.</a:t>
+            </a:r>
+            <a:endParaRPr lang="he-IL" sz="1350" dirty="0"/>
           </a:p>
         </p:txBody>
       </p:sp>
@@ -4963,7 +6130,7 @@
                 <a:ea typeface="Arial" pitchFamily="34" charset="-122"/>
                 <a:cs typeface="Arial" pitchFamily="34" charset="-120"/>
               </a:rPr>
-              <a:t>12</a:t>
+              <a:t>13</a:t>
             </a:r>
             <a:endParaRPr lang="he-IL" sz="1000" dirty="0"/>
           </a:p>
@@ -4977,9 +6144,9 @@
 </p:sld>
 </file>
 
-<file path=ppt/slides/slide13.xml><?xml version="1.0" encoding="utf-8"?>
+<file path=ppt/slides/slide14.xml><?xml version="1.0" encoding="utf-8"?>
 <p:sld xmlns:a="http://schemas.openxmlformats.org/drawingml/2006/main" xmlns:r="http://schemas.openxmlformats.org/officeDocument/2006/relationships" xmlns:p="http://schemas.openxmlformats.org/presentationml/2006/main">
-  <p:cSld name="Slide 13">
+  <p:cSld name="Slide 14">
     <p:spTree>
       <p:nvGrpSpPr>
         <p:cNvPr id="1" name=""/>
@@ -5035,7 +6202,7 @@
       </p:sp>
       <p:graphicFrame>
         <p:nvGraphicFramePr>
-          <p:cNvPr id="14" name="Table 0"/>
+          <p:cNvPr id="15" name="Table 0"/>
           <p:cNvGraphicFramePr>
             <a:graphicFrameLocks noGrp="1"/>
           </p:cNvGraphicFramePr>
@@ -6239,7 +7406,7 @@
                 <a:ea typeface="Arial" pitchFamily="34" charset="-122"/>
                 <a:cs typeface="Arial" pitchFamily="34" charset="-120"/>
               </a:rPr>
-              <a:t>13</a:t>
+              <a:t>14</a:t>
             </a:r>
             <a:endParaRPr lang="he-IL" sz="1000" dirty="0"/>
           </a:p>
@@ -6253,9 +7420,9 @@
 </p:sld>
 </file>
 
-<file path=ppt/slides/slide14.xml><?xml version="1.0" encoding="utf-8"?>
+<file path=ppt/slides/slide15.xml><?xml version="1.0" encoding="utf-8"?>
 <p:sld xmlns:a="http://schemas.openxmlformats.org/drawingml/2006/main" xmlns:r="http://schemas.openxmlformats.org/officeDocument/2006/relationships" xmlns:p="http://schemas.openxmlformats.org/presentationml/2006/main">
-  <p:cSld name="Slide 14">
+  <p:cSld name="Slide 15">
     <p:bg>
       <p:bgPr>
         <a:solidFill>
@@ -7326,7 +8493,7 @@
                 <a:ea typeface="Arial" pitchFamily="34" charset="-122"/>
                 <a:cs typeface="Arial" pitchFamily="34" charset="-120"/>
               </a:rPr>
-              <a:t>14</a:t>
+              <a:t>15</a:t>
             </a:r>
             <a:endParaRPr lang="he-IL" sz="1000" dirty="0"/>
           </a:p>
@@ -7340,9 +8507,9 @@
 </p:sld>
 </file>
 
-<file path=ppt/slides/slide15.xml><?xml version="1.0" encoding="utf-8"?>
+<file path=ppt/slides/slide16.xml><?xml version="1.0" encoding="utf-8"?>
 <p:sld xmlns:a="http://schemas.openxmlformats.org/drawingml/2006/main" xmlns:r="http://schemas.openxmlformats.org/officeDocument/2006/relationships" xmlns:p="http://schemas.openxmlformats.org/presentationml/2006/main">
-  <p:cSld name="Slide 15">
+  <p:cSld name="Slide 16">
     <p:bg>
       <p:bgPr>
         <a:solidFill>
@@ -8123,7 +9290,7 @@
                 <a:ea typeface="Arial" pitchFamily="34" charset="-122"/>
                 <a:cs typeface="Arial" pitchFamily="34" charset="-120"/>
               </a:rPr>
-              <a:t>15</a:t>
+              <a:t>16</a:t>
             </a:r>
             <a:endParaRPr lang="he-IL" sz="1000" dirty="0"/>
           </a:p>
@@ -8137,9 +9304,9 @@
 </p:sld>
 </file>
 
-<file path=ppt/slides/slide16.xml><?xml version="1.0" encoding="utf-8"?>
+<file path=ppt/slides/slide17.xml><?xml version="1.0" encoding="utf-8"?>
 <p:sld xmlns:a="http://schemas.openxmlformats.org/drawingml/2006/main" xmlns:r="http://schemas.openxmlformats.org/officeDocument/2006/relationships" xmlns:p="http://schemas.openxmlformats.org/presentationml/2006/main">
-  <p:cSld name="Slide 16">
+  <p:cSld name="Slide 17">
     <p:spTree>
       <p:nvGrpSpPr>
         <p:cNvPr id="1" name=""/>
@@ -8193,9 +9360,33 @@
           </a:p>
         </p:txBody>
       </p:sp>
-      <p:sp>
-        <p:nvSpPr>
-          <p:cNvPr id="3" name="Text 1"/>
+      <p:pic>
+        <p:nvPicPr>
+          <p:cNvPr id="3" name="Image 0" descr="/tmp/claude-0/-home-user-clickwriting-landing/d2627f80-c93a-5206-ba5d-647532b375c9/scratchpad/ono-logo.jpg">    </p:cNvPr>
+          <p:cNvPicPr>
+            <a:picLocks noChangeAspect="1"/>
+          </p:cNvPicPr>
+          <p:nvPr/>
+        </p:nvPicPr>
+        <p:blipFill>
+          <a:blip r:embed="rId1"/>
+          <a:stretch>
+            <a:fillRect/>
+          </a:stretch>
+        </p:blipFill>
+        <p:spPr>
+          <a:xfrm>
+            <a:off x="548640" y="5394960"/>
+            <a:ext cx="914400" cy="914400"/>
+          </a:xfrm>
+          <a:prstGeom prst="rect">
+            <a:avLst/>
+          </a:prstGeom>
+        </p:spPr>
+      </p:pic>
+      <p:sp>
+        <p:nvSpPr>
+          <p:cNvPr id="4" name="Text 1"/>
           <p:cNvSpPr txBox="1"/>
           <p:nvPr/>
         </p:nvSpPr>
@@ -8273,11 +9464,31 @@
             </a:r>
             <a:endParaRPr lang="en-US" sz="1100" dirty="0"/>
           </a:p>
-        </p:txBody>
-      </p:sp>
-      <p:sp>
-        <p:nvSpPr>
-          <p:cNvPr id="4" name="Text 2"/>
+          <a:p>
+            <a:pPr algn="l" indent="0" marL="0">
+              <a:spcAft>
+                <a:spcPts val="600"/>
+              </a:spcAft>
+              <a:buNone/>
+            </a:pPr>
+            <a:r>
+              <a:rPr lang="en-US" sz="1100" dirty="0">
+                <a:solidFill>
+                  <a:srgbClr val="1F2937"/>
+                </a:solidFill>
+                <a:latin typeface="Arial" pitchFamily="34" charset="0"/>
+                <a:ea typeface="Arial" pitchFamily="34" charset="-122"/>
+                <a:cs typeface="Arial" pitchFamily="34" charset="-120"/>
+              </a:rPr>
+              <a:t>Russo, M., Shteigman, A., &amp; Carmeli, A. (2016). Workplace and family support and work-life balance: Implications for individual psychological availability and energy at work. The Journal of Positive Psychology, 11(2), 173-188. https://doi.org/10.1080/17439760.2015.1025424</a:t>
+            </a:r>
+            <a:endParaRPr lang="en-US" sz="1100" dirty="0"/>
+          </a:p>
+        </p:txBody>
+      </p:sp>
+      <p:sp>
+        <p:nvSpPr>
+          <p:cNvPr id="5" name="Text 2"/>
           <p:cNvSpPr txBox="1"/>
           <p:nvPr/>
         </p:nvSpPr>
@@ -8336,7 +9547,7 @@
       </p:sp>
       <p:sp>
         <p:nvSpPr>
-          <p:cNvPr id="5" name="Text 3"/>
+          <p:cNvPr id="6" name="Text 3"/>
           <p:cNvSpPr txBox="1"/>
           <p:nvPr/>
         </p:nvSpPr>
@@ -8375,7 +9586,7 @@
       </p:sp>
       <p:sp>
         <p:nvSpPr>
-          <p:cNvPr id="6" name="Text 4"/>
+          <p:cNvPr id="7" name="Text 4"/>
           <p:cNvSpPr txBox="1"/>
           <p:nvPr/>
         </p:nvSpPr>
@@ -8406,7 +9617,7 @@
                 <a:ea typeface="Arial" pitchFamily="34" charset="-122"/>
                 <a:cs typeface="Arial" pitchFamily="34" charset="-120"/>
               </a:rPr>
-              <a:t>16</a:t>
+              <a:t>17</a:t>
             </a:r>
             <a:endParaRPr lang="he-IL" sz="1000" dirty="0"/>
           </a:p>
@@ -9252,7 +10463,7 @@
                 <a:ea typeface="Arial" pitchFamily="34" charset="-122"/>
                 <a:cs typeface="Arial" pitchFamily="34" charset="-120"/>
               </a:rPr>
-              <a:t>מאמר משלים ותובנות</a:t>
+              <a:t>מאמר משלים, חומר הקורס ותובנות</a:t>
             </a:r>
             <a:endParaRPr lang="he-IL" sz="1800" dirty="0"/>
           </a:p>
@@ -9291,7 +10502,7 @@
                 <a:ea typeface="Arial" pitchFamily="34" charset="-122"/>
                 <a:cs typeface="Arial" pitchFamily="34" charset="-120"/>
               </a:rPr>
-              <a:t>בינה מלאכותית וחוסן קריירה</a:t>
+              <a:t>בינה מלאכותית, סלי הכלים, הרצברג</a:t>
             </a:r>
             <a:endParaRPr lang="he-IL" sz="1500" dirty="0"/>
           </a:p>
@@ -9330,7 +10541,7 @@
                 <a:ea typeface="Arial" pitchFamily="34" charset="-122"/>
                 <a:cs typeface="Arial" pitchFamily="34" charset="-120"/>
               </a:rPr>
-              <a:t>1 דק'</a:t>
+              <a:t>1.5 דק'</a:t>
             </a:r>
             <a:endParaRPr lang="he-IL" sz="1300" dirty="0"/>
           </a:p>
@@ -9545,7 +10756,7 @@
                 <a:ea typeface="Arial" pitchFamily="34" charset="-122"/>
                 <a:cs typeface="Arial" pitchFamily="34" charset="-120"/>
               </a:rPr>
-              <a:t>3 דק'</a:t>
+              <a:t>2.5 דק'</a:t>
             </a:r>
             <a:endParaRPr lang="he-IL" sz="1300" dirty="0"/>
           </a:p>
@@ -11680,11 +12891,11 @@
         <p:spPr>
           <a:xfrm>
             <a:off x="4846320" y="1325880"/>
-            <a:ext cx="6793992" cy="3108960"/>
+            <a:ext cx="6793992" cy="3246120"/>
           </a:xfrm>
           <a:prstGeom prst="roundRect">
             <a:avLst>
-              <a:gd name="adj" fmla="val 3529"/>
+              <a:gd name="adj" fmla="val 3380"/>
             </a:avLst>
           </a:prstGeom>
           <a:solidFill>
@@ -11714,7 +12925,7 @@
         <p:spPr>
           <a:xfrm>
             <a:off x="5074920" y="1463040"/>
-            <a:ext cx="6355080" cy="914400"/>
+            <a:ext cx="6355080" cy="868680"/>
           </a:xfrm>
           <a:prstGeom prst="rect">
             <a:avLst/>
@@ -11730,7 +12941,7 @@
               <a:buNone/>
             </a:pPr>
             <a:r>
-              <a:rPr lang="en-US" sz="1800" b="1" dirty="0">
+              <a:rPr lang="en-US" sz="1700" b="1" dirty="0">
                 <a:solidFill>
                   <a:srgbClr val="FFFFFF"/>
                 </a:solidFill>
@@ -11740,7 +12951,7 @@
               </a:rPr>
               <a:t>The Role of Needs-Based Job Crafting in Strengthening Work-Related Sense of Coherence: A Two-Wave Panel Study</a:t>
             </a:r>
-            <a:endParaRPr lang="en-US" sz="1800" dirty="0"/>
+            <a:endParaRPr lang="en-US" sz="1700" dirty="0"/>
           </a:p>
         </p:txBody>
       </p:sp>
@@ -11752,8 +12963,8 @@
         </p:nvSpPr>
         <p:spPr>
           <a:xfrm>
-            <a:off x="5074920" y="2423160"/>
-            <a:ext cx="6355080" cy="457200"/>
+            <a:off x="5074920" y="2331720"/>
+            <a:ext cx="6355080" cy="411480"/>
           </a:xfrm>
           <a:prstGeom prst="rect">
             <a:avLst/>
@@ -11769,7 +12980,7 @@
               <a:buNone/>
             </a:pPr>
             <a:r>
-              <a:rPr lang="en-US" sz="1200" dirty="0">
+              <a:rPr lang="en-US" sz="1150" dirty="0">
                 <a:solidFill>
                   <a:srgbClr val="FCA311"/>
                 </a:solidFill>
@@ -11779,7 +12990,7 @@
               </a:rPr>
               <a:t>Cetkovská, Bauer &amp; Tušl  |  Scandinavian Journal of Work and Organizational Psychology, 11(1)  |  2026</a:t>
             </a:r>
-            <a:endParaRPr lang="en-US" sz="1200" dirty="0"/>
+            <a:endParaRPr lang="en-US" sz="1150" dirty="0"/>
           </a:p>
         </p:txBody>
       </p:sp>
@@ -11791,8 +13002,8 @@
         </p:nvSpPr>
         <p:spPr>
           <a:xfrm>
-            <a:off x="5074920" y="2926080"/>
-            <a:ext cx="6355080" cy="1463040"/>
+            <a:off x="5074920" y="2788920"/>
+            <a:ext cx="6355080" cy="1737360"/>
           </a:xfrm>
           <a:prstGeom prst="rect">
             <a:avLst/>
@@ -11804,15 +13015,11 @@
           <a:bodyPr wrap="square" lIns="0" tIns="0" rIns="0" bIns="0" rtlCol="0" anchor="t"/>
           <a:lstStyle/>
           <a:p>
-            <a:pPr algn="r" marL="342900" indent="-342900">
-              <a:spcAft>
-                <a:spcPts val="600"/>
-              </a:spcAft>
-              <a:buSzPct val="100000"/>
-              <a:buChar char="•"/>
-            </a:pPr>
-            <a:r>
-              <a:rPr lang="he-IL" altLang="en-US" sz="1300" dirty="0">
+            <a:pPr rtl="1" algn="r" indent="0" marL="0">
+              <a:buNone/>
+            </a:pPr>
+            <a:r>
+              <a:rPr lang="he-IL" altLang="en-US" sz="1250" dirty="0">
                 <a:solidFill>
                   <a:srgbClr val="E5EAF3"/>
                 </a:solidFill>
@@ -11820,51 +13027,9 @@
                 <a:ea typeface="Arial" pitchFamily="34" charset="-122"/>
                 <a:cs typeface="Arial" pitchFamily="34" charset="-120"/>
               </a:rPr>
-              <a:t>מחקר אורך: 924 עובדים בגרמניה ובשווייץ, שתי מדידות בהפרש של חצי שנה</a:t>
-            </a:r>
-            <a:endParaRPr lang="he-IL" sz="1300" dirty="0"/>
-          </a:p>
-          <a:p>
-            <a:pPr algn="r" marL="342900" indent="-342900">
-              <a:spcAft>
-                <a:spcPts val="600"/>
-              </a:spcAft>
-              <a:buSzPct val="100000"/>
-              <a:buChar char="•"/>
-            </a:pPr>
-            <a:r>
-              <a:rPr lang="he-IL" altLang="en-US" sz="1300" dirty="0">
-                <a:solidFill>
-                  <a:srgbClr val="E5EAF3"/>
-                </a:solidFill>
-                <a:latin typeface="Arial" pitchFamily="34" charset="0"/>
-                <a:ea typeface="Arial" pitchFamily="34" charset="-122"/>
-                <a:cs typeface="Arial" pitchFamily="34" charset="-120"/>
-              </a:rPr>
-              <a:t>כתב עת שפיט, גישה פתוחה מלאה (Open Access), הוצאת אוניברסיטת סטוקהולם</a:t>
-            </a:r>
-            <a:endParaRPr lang="he-IL" sz="1300" dirty="0"/>
-          </a:p>
-          <a:p>
-            <a:pPr algn="r" marL="342900" indent="-342900">
-              <a:spcAft>
-                <a:spcPts val="600"/>
-              </a:spcAft>
-              <a:buSzPct val="100000"/>
-              <a:buChar char="•"/>
-            </a:pPr>
-            <a:r>
-              <a:rPr lang="he-IL" altLang="en-US" sz="1300" dirty="0">
-                <a:solidFill>
-                  <a:srgbClr val="E5EAF3"/>
-                </a:solidFill>
-                <a:latin typeface="Arial" pitchFamily="34" charset="0"/>
-                <a:ea typeface="Arial" pitchFamily="34" charset="-122"/>
-                <a:cs typeface="Arial" pitchFamily="34" charset="-120"/>
-              </a:rPr>
-              <a:t>המחברים: אוניברסיטת קארל בפראג והמרכז לסלוטוגנזה באוניברסיטת ציריך. מימון: הקרן הלאומית השווייצרית למדע</a:t>
-            </a:r>
-            <a:endParaRPr lang="he-IL" sz="1300" dirty="0"/>
+              <a:t>המאמר הוא מחקר אורך שעקב אחר 924 עובדים בגרמניה ובשווייץ בשתי מדידות בהפרש של חצי שנה, ובחן האם עיצוב תפקיד מבוסס צרכים מחזק את תחושת הקוהרנטיות בעבודה. הוא פורסם בכתב עת שפיט בגישה פתוחה מלאה בהוצאת אוניברסיטת סטוקהולם, על ידי חוקרים מאוניברסיטת קארל בפראג ומהמרכז לסלוטוגנזה באוניברסיטת ציריך, במימון הקרן הלאומית השווייצרית למדע (Cetkovská et al., 2026).</a:t>
+            </a:r>
+            <a:endParaRPr lang="he-IL" sz="1250" dirty="0"/>
           </a:p>
         </p:txBody>
       </p:sp>
@@ -11877,11 +13042,11 @@
         <p:spPr>
           <a:xfrm>
             <a:off x="548640" y="1325880"/>
-            <a:ext cx="4023360" cy="3108960"/>
+            <a:ext cx="4023360" cy="3246120"/>
           </a:xfrm>
           <a:prstGeom prst="roundRect">
             <a:avLst>
-              <a:gd name="adj" fmla="val 3529"/>
+              <a:gd name="adj" fmla="val 3380"/>
             </a:avLst>
           </a:prstGeom>
           <a:solidFill>
@@ -11927,7 +13092,7 @@
               <a:buNone/>
             </a:pPr>
             <a:r>
-              <a:rPr lang="he-IL" altLang="en-US" sz="1800" b="1" dirty="0">
+              <a:rPr lang="he-IL" altLang="en-US" sz="1700" b="1" dirty="0">
                 <a:solidFill>
                   <a:srgbClr val="14213D"/>
                 </a:solidFill>
@@ -11937,7 +13102,7 @@
               </a:rPr>
               <a:t>למה בחרנו בו?</a:t>
             </a:r>
-            <a:endParaRPr lang="he-IL" sz="1800" dirty="0"/>
+            <a:endParaRPr lang="he-IL" sz="1700" dirty="0"/>
           </a:p>
         </p:txBody>
       </p:sp>
@@ -11949,8 +13114,8 @@
         </p:nvSpPr>
         <p:spPr>
           <a:xfrm>
-            <a:off x="777240" y="1965960"/>
-            <a:ext cx="3566160" cy="2377440"/>
+            <a:off x="777240" y="1920240"/>
+            <a:ext cx="3566160" cy="2560320"/>
           </a:xfrm>
           <a:prstGeom prst="rect">
             <a:avLst/>
@@ -11962,15 +13127,11 @@
           <a:bodyPr wrap="square" lIns="0" tIns="0" rIns="0" bIns="0" rtlCol="0" anchor="t"/>
           <a:lstStyle/>
           <a:p>
-            <a:pPr algn="r" marL="342900" indent="-342900">
-              <a:spcAft>
-                <a:spcPts val="600"/>
-              </a:spcAft>
-              <a:buSzPct val="100000"/>
-              <a:buChar char="•"/>
-            </a:pPr>
-            <a:r>
-              <a:rPr lang="he-IL" altLang="en-US" sz="1300" dirty="0">
+            <a:pPr rtl="1" algn="r" indent="0" marL="0">
+              <a:buNone/>
+            </a:pPr>
+            <a:r>
+              <a:rPr lang="he-IL" altLang="en-US" sz="1250" dirty="0">
                 <a:solidFill>
                   <a:srgbClr val="1F2937"/>
                 </a:solidFill>
@@ -11978,51 +13139,9 @@
                 <a:ea typeface="Arial" pitchFamily="34" charset="-122"/>
                 <a:cs typeface="Arial" pitchFamily="34" charset="-120"/>
               </a:rPr>
-              <a:t>שואל מה עוזר, לא רק מה מזיק</a:t>
-            </a:r>
-            <a:endParaRPr lang="he-IL" sz="1300" dirty="0"/>
-          </a:p>
-          <a:p>
-            <a:pPr algn="r" marL="342900" indent="-342900">
-              <a:spcAft>
-                <a:spcPts val="600"/>
-              </a:spcAft>
-              <a:buSzPct val="100000"/>
-              <a:buChar char="•"/>
-            </a:pPr>
-            <a:r>
-              <a:rPr lang="he-IL" altLang="en-US" sz="1300" dirty="0">
-                <a:solidFill>
-                  <a:srgbClr val="1F2937"/>
-                </a:solidFill>
-                <a:latin typeface="Arial" pitchFamily="34" charset="0"/>
-                <a:ea typeface="Arial" pitchFamily="34" charset="-122"/>
-                <a:cs typeface="Arial" pitchFamily="34" charset="-120"/>
-              </a:rPr>
-              <a:t>נותן כלי שבשליטת העובד, בלי לחכות לארגון</a:t>
-            </a:r>
-            <a:endParaRPr lang="he-IL" sz="1300" dirty="0"/>
-          </a:p>
-          <a:p>
-            <a:pPr algn="r" marL="342900" indent="-342900">
-              <a:spcAft>
-                <a:spcPts val="600"/>
-              </a:spcAft>
-              <a:buSzPct val="100000"/>
-              <a:buChar char="•"/>
-            </a:pPr>
-            <a:r>
-              <a:rPr lang="he-IL" altLang="en-US" sz="1300" dirty="0">
-                <a:solidFill>
-                  <a:srgbClr val="1F2937"/>
-                </a:solidFill>
-                <a:latin typeface="Arial" pitchFamily="34" charset="0"/>
-                <a:ea typeface="Arial" pitchFamily="34" charset="-122"/>
-                <a:cs typeface="Arial" pitchFamily="34" charset="-120"/>
-              </a:rPr>
-              <a:t>מבוסס על רעיון של חוקר שפעל בישראל: אהרן אנטונובסקי מאוניברסיטת בן-גוריון</a:t>
-            </a:r>
-            <a:endParaRPr lang="he-IL" sz="1300" dirty="0"/>
+              <a:t>בחרנו במאמר משום שהוא שואל מה עוזר לעובדים ולא רק מה מזיק להם, ומשום שהוא מציע כלי שנמצא בשליטת העובד עצמו ואינו תלוי בארגון. הוא נשען על רעיון שפיתח אהרן אנטונובסקי, שפעל באוניברסיטת בן-גוריון בנגב, ולכן מתחבר גם להקשר הישראלי של הכיתה.</a:t>
+            </a:r>
+            <a:endParaRPr lang="he-IL" sz="1250" dirty="0"/>
           </a:p>
         </p:txBody>
       </p:sp>
@@ -12034,12 +13153,12 @@
         </p:nvSpPr>
         <p:spPr>
           <a:xfrm>
-            <a:off x="548640" y="4663440"/>
-            <a:ext cx="11091672" cy="1600200"/>
+            <a:off x="548640" y="4754880"/>
+            <a:ext cx="11091672" cy="1508760"/>
           </a:xfrm>
           <a:prstGeom prst="roundRect">
             <a:avLst>
-              <a:gd name="adj" fmla="val 6857"/>
+              <a:gd name="adj" fmla="val 7273"/>
             </a:avLst>
           </a:prstGeom>
           <a:solidFill>
@@ -12068,8 +13187,8 @@
         </p:nvSpPr>
         <p:spPr>
           <a:xfrm>
-            <a:off x="777240" y="4754880"/>
-            <a:ext cx="10607040" cy="411480"/>
+            <a:off x="777240" y="4828032"/>
+            <a:ext cx="10607040" cy="365760"/>
           </a:xfrm>
           <a:prstGeom prst="rect">
             <a:avLst/>
@@ -12085,7 +13204,7 @@
               <a:buNone/>
             </a:pPr>
             <a:r>
-              <a:rPr lang="he-IL" altLang="en-US" sz="1500" b="1" dirty="0">
+              <a:rPr lang="he-IL" altLang="en-US" sz="1400" b="1" dirty="0">
                 <a:solidFill>
                   <a:srgbClr val="2A9D8F"/>
                 </a:solidFill>
@@ -12095,7 +13214,7 @@
               </a:rPr>
               <a:t>מאמר משלים (2025, גישה פתוחה)</a:t>
             </a:r>
-            <a:endParaRPr lang="he-IL" sz="1500" dirty="0"/>
+            <a:endParaRPr lang="he-IL" sz="1400" dirty="0"/>
           </a:p>
         </p:txBody>
       </p:sp>
@@ -12107,7 +13226,7 @@
         </p:nvSpPr>
         <p:spPr>
           <a:xfrm>
-            <a:off x="777240" y="5166360"/>
+            <a:off x="777240" y="5193792"/>
             <a:ext cx="10607040" cy="1005840"/>
           </a:xfrm>
           <a:prstGeom prst="rect">
@@ -12120,14 +13239,11 @@
           <a:bodyPr wrap="square" lIns="0" tIns="0" rIns="0" bIns="0" rtlCol="0" anchor="t"/>
           <a:lstStyle/>
           <a:p>
-            <a:pPr algn="r" indent="0" marL="0">
-              <a:spcAft>
-                <a:spcPts val="600"/>
-              </a:spcAft>
-              <a:buNone/>
-            </a:pPr>
-            <a:r>
-              <a:rPr lang="en-US" sz="1200" dirty="0">
+            <a:pPr rtl="1" algn="r" indent="0" marL="0">
+              <a:buNone/>
+            </a:pPr>
+            <a:r>
+              <a:rPr lang="he-IL" altLang="en-US" sz="1250" dirty="0">
                 <a:solidFill>
                   <a:srgbClr val="1F2937"/>
                 </a:solidFill>
@@ -12135,9 +13251,9 @@
                 <a:ea typeface="Arial" pitchFamily="34" charset="-122"/>
                 <a:cs typeface="Arial" pitchFamily="34" charset="-120"/>
               </a:rPr>
-              <a:t>Chung, Y. W., Im, S., Kim, J. E., &amp; Yun, J. K. (2025). Artificial intelligence awareness, career resilience, job insecurity and behavioural outcomes. Australian Journal of Psychology, 77(1), Article 2559910.</a:t>
-            </a:r>
-            <a:endParaRPr lang="en-US" sz="1200" dirty="0"/>
+              <a:t>לצורך הצגת שני מאמרים נבחר מחקר אורך שבחן כיצד המודעות לבינה מלאכותית מייצרת חוסר ביטחון תעסוקתי וכיצד חוסן קריירה ממתן אותו (Chung, Im, Kim &amp; Yun, 2025, Australian Journal of Psychology, 77(1), Article 2559910). המאמר המשלים מספק את האבחנה, והמאמר המרכזי את הטיפול.</a:t>
+            </a:r>
+            <a:endParaRPr lang="he-IL" sz="1250" dirty="0"/>
           </a:p>
         </p:txBody>
       </p:sp>
@@ -14876,12 +15992,8 @@
           <a:bodyPr wrap="square" lIns="0" tIns="0" rIns="0" bIns="0" rtlCol="0" anchor="t"/>
           <a:lstStyle/>
           <a:p>
-            <a:pPr algn="r" marL="342900" indent="-342900">
-              <a:spcAft>
-                <a:spcPts val="500"/>
-              </a:spcAft>
-              <a:buSzPct val="100000"/>
-              <a:buChar char="•"/>
+            <a:pPr rtl="1" algn="r" indent="0" marL="0">
+              <a:buNone/>
             </a:pPr>
             <a:r>
               <a:rPr lang="he-IL" altLang="en-US" sz="1200" dirty="0">
@@ -14892,49 +16004,7 @@
                 <a:ea typeface="Arial" pitchFamily="34" charset="-122"/>
                 <a:cs typeface="Arial" pitchFamily="34" charset="-120"/>
               </a:rPr>
-              <a:t>הירוק מובהק, האפור לא: רק עיצוב לצרכי התקרבות משנה את התפיסה</a:t>
-            </a:r>
-            <a:endParaRPr lang="he-IL" sz="1200" dirty="0"/>
-          </a:p>
-          <a:p>
-            <a:pPr algn="r" marL="342900" indent="-342900">
-              <a:spcAft>
-                <a:spcPts val="500"/>
-              </a:spcAft>
-              <a:buSzPct val="100000"/>
-              <a:buChar char="•"/>
-            </a:pPr>
-            <a:r>
-              <a:rPr lang="he-IL" altLang="en-US" sz="1200" dirty="0">
-                <a:solidFill>
-                  <a:srgbClr val="1F2937"/>
-                </a:solidFill>
-                <a:latin typeface="Arial" pitchFamily="34" charset="0"/>
-                <a:ea typeface="Arial" pitchFamily="34" charset="-122"/>
-                <a:cs typeface="Arial" pitchFamily="34" charset="-120"/>
-              </a:rPr>
-              <a:t>אפקטים בינוניים, אבל מעבר ליציבות גבוהה (0.61 עד 0.70) של המדדים עצמם</a:t>
-            </a:r>
-            <a:endParaRPr lang="he-IL" sz="1200" dirty="0"/>
-          </a:p>
-          <a:p>
-            <a:pPr algn="r" marL="342900" indent="-342900">
-              <a:spcAft>
-                <a:spcPts val="500"/>
-              </a:spcAft>
-              <a:buSzPct val="100000"/>
-              <a:buChar char="•"/>
-            </a:pPr>
-            <a:r>
-              <a:rPr lang="he-IL" altLang="en-US" sz="1200" dirty="0">
-                <a:solidFill>
-                  <a:srgbClr val="1F2937"/>
-                </a:solidFill>
-                <a:latin typeface="Arial" pitchFamily="34" charset="0"/>
-                <a:ea typeface="Arial" pitchFamily="34" charset="-122"/>
-                <a:cs typeface="Arial" pitchFamily="34" charset="-120"/>
-              </a:rPr>
-              <a:t>ניתוח פאנל צולב: כיווניות בזמן, לא הוכחת סיבתיות</a:t>
+              <a:t>רק עיצוב התפקיד לצרכי התקרבות (בירוק) ניבא באופן מובהק את שלושת הרכיבים. האפקטים בינוניים, אך הם מתקבלים מעבר ליציבות גבוהה (0.61 עד 0.70) של המדדים עצמם, ולכן כל שינוי שנשמר אחרי חצי שנה משמעותי. מדובר בקשרים בזמן ולא בהוכחת סיבתיות (Cetkovská et al., 2026).</a:t>
             </a:r>
             <a:endParaRPr lang="he-IL" sz="1200" dirty="0"/>
           </a:p>
@@ -15653,15 +16723,11 @@
           <a:bodyPr wrap="square" lIns="0" tIns="0" rIns="0" bIns="0" rtlCol="0" anchor="t"/>
           <a:lstStyle/>
           <a:p>
-            <a:pPr algn="r" marL="342900" indent="-342900">
-              <a:spcAft>
-                <a:spcPts val="400"/>
-              </a:spcAft>
-              <a:buSzPct val="100000"/>
-              <a:buChar char="•"/>
-            </a:pPr>
-            <a:r>
-              <a:rPr lang="he-IL" altLang="en-US" sz="1350" dirty="0">
+            <a:pPr rtl="1" algn="r" indent="0" marL="0">
+              <a:buNone/>
+            </a:pPr>
+            <a:r>
+              <a:rPr lang="he-IL" altLang="en-US" sz="1300" dirty="0">
                 <a:solidFill>
                   <a:srgbClr val="1F2937"/>
                 </a:solidFill>
@@ -15669,51 +16735,9 @@
                 <a:ea typeface="Arial" pitchFamily="34" charset="-122"/>
                 <a:cs typeface="Arial" pitchFamily="34" charset="-120"/>
               </a:rPr>
-              <a:t>מחקר אורך בשלוש נקודות זמן בקרב עובדי משרד במשרה מלאה בדרום קוריאה</a:t>
-            </a:r>
-            <a:endParaRPr lang="he-IL" sz="1350" dirty="0"/>
-          </a:p>
-          <a:p>
-            <a:pPr algn="r" marL="342900" indent="-342900">
-              <a:spcAft>
-                <a:spcPts val="400"/>
-              </a:spcAft>
-              <a:buSzPct val="100000"/>
-              <a:buChar char="•"/>
-            </a:pPr>
-            <a:r>
-              <a:rPr lang="he-IL" altLang="en-US" sz="1350" dirty="0">
-                <a:solidFill>
-                  <a:srgbClr val="1F2937"/>
-                </a:solidFill>
-                <a:latin typeface="Arial" pitchFamily="34" charset="0"/>
-                <a:ea typeface="Arial" pitchFamily="34" charset="-122"/>
-                <a:cs typeface="Arial" pitchFamily="34" charset="-120"/>
-              </a:rPr>
-              <a:t>עצם המודעות לבינה מלאכותית, עוד לפני שינוי בפועל, מספיקה כדי לייצר חוסר ביטחון</a:t>
-            </a:r>
-            <a:endParaRPr lang="he-IL" sz="1350" dirty="0"/>
-          </a:p>
-          <a:p>
-            <a:pPr algn="r" marL="342900" indent="-342900">
-              <a:spcAft>
-                <a:spcPts val="400"/>
-              </a:spcAft>
-              <a:buSzPct val="100000"/>
-              <a:buChar char="•"/>
-            </a:pPr>
-            <a:r>
-              <a:rPr lang="he-IL" altLang="en-US" sz="1350" dirty="0">
-                <a:solidFill>
-                  <a:srgbClr val="1F2937"/>
-                </a:solidFill>
-                <a:latin typeface="Arial" pitchFamily="34" charset="0"/>
-                <a:ea typeface="Arial" pitchFamily="34" charset="-122"/>
-                <a:cs typeface="Arial" pitchFamily="34" charset="-120"/>
-              </a:rPr>
-              <a:t>החיבור למאמר שלנו: המשלים מראה את האיום ואת המשאב שממתן אותו. המרכזי מראה איך בונים משאב כזה בפועל</a:t>
-            </a:r>
-            <a:endParaRPr lang="he-IL" sz="1350" dirty="0"/>
+              <a:t>במחקר אורך בשלוש נקודות זמן בקרב עובדי משרד במשרה מלאה בדרום קוריאה נמצא שעצם המודעות לבינה מלאכותית, עוד לפני שינוי בפועל, מגבירה חוסר ביטחון תעסוקתי, ושחוסר הביטחון מתווך את הפגיעה בביצועים. חוסן קריירה החליש את הקשר (Chung et al., 2025). המאמר המשלים מספק אפוא את האבחנה, והמאמר המרכזי את הדרך לבנות את המשאב שממתן את האיום.</a:t>
+            </a:r>
+            <a:endParaRPr lang="he-IL" sz="1300" dirty="0"/>
           </a:p>
         </p:txBody>
       </p:sp>

</xml_diff>

<commit_message>
Style the academic deck in blue and orange
Blue titles and table headers, light-blue label column, alternating row
tint, blue and orange chart series, orange captions.

Co-Authored-By: Claude Fable 5.1 <noreply@anthropic.com>
Claude-Session: https://claude.ai/code/session_01XaGvnsaHG3kPyCY3aGBByx
</commit_message>
<xml_diff>
--- a/career-management-final-project/ניהול קריירה - התמודדות עם חוסר ודאות תעסוקתי - מצגת.pptx
+++ b/career-management-final-project/ניהול קריירה - התמודדות עם חוסר ודאות תעסוקתי - מצגת.pptx
@@ -136,7 +136,7 @@
             <a:pPr>
               <a:defRPr sz="1100" b="0" i="0" u="none" strike="noStrike">
                 <a:solidFill>
-                  <a:srgbClr val="000000"/>
+                  <a:srgbClr val="1F4E79"/>
                 </a:solidFill>
                 <a:latin typeface="David"/>
               </a:defRPr>
@@ -144,7 +144,7 @@
             <a:r>
               <a:rPr sz="1100" b="0" i="0" u="none" strike="noStrike">
                 <a:solidFill>
-                  <a:srgbClr val="000000"/>
+                  <a:srgbClr val="1F4E79"/>
                 </a:solidFill>
                 <a:latin typeface="David"/>
               </a:rPr>
@@ -179,7 +179,7 @@
           </c:tx>
           <c:spPr>
             <a:solidFill>
-              <a:srgbClr val="404040"/>
+              <a:srgbClr val="1F4E79"/>
             </a:solidFill>
             <a:effectLst/>
           </c:spPr>
@@ -262,7 +262,7 @@
           </c:tx>
           <c:spPr>
             <a:solidFill>
-              <a:srgbClr val="BFBFBF"/>
+              <a:srgbClr val="ED7D31"/>
             </a:solidFill>
             <a:effectLst/>
           </c:spPr>
@@ -2703,7 +2703,7 @@
             <a:r>
               <a:rPr lang="he-IL" altLang="en-US" sz="3600" b="1" dirty="0">
                 <a:solidFill>
-                  <a:srgbClr val="000000"/>
+                  <a:srgbClr val="1F4E79"/>
                 </a:solidFill>
                 <a:latin typeface="David" pitchFamily="34" charset="0"/>
                 <a:ea typeface="David" pitchFamily="34" charset="-122"/>
@@ -2742,7 +2742,7 @@
             <a:r>
               <a:rPr lang="he-IL" altLang="en-US" sz="1800" dirty="0">
                 <a:solidFill>
-                  <a:srgbClr val="000000"/>
+                  <a:srgbClr val="ED7D31"/>
                 </a:solidFill>
                 <a:latin typeface="David" pitchFamily="34" charset="0"/>
                 <a:ea typeface="David" pitchFamily="34" charset="-122"/>
@@ -2962,7 +2962,7 @@
             <a:r>
               <a:rPr lang="he-IL" altLang="en-US" sz="2800" b="1" dirty="0">
                 <a:solidFill>
-                  <a:srgbClr val="000000"/>
+                  <a:srgbClr val="1F4E79"/>
                 </a:solidFill>
                 <a:latin typeface="David" pitchFamily="34" charset="0"/>
                 <a:ea typeface="David" pitchFamily="34" charset="-122"/>
@@ -3054,7 +3054,7 @@
                       <a:r>
                         <a:rPr lang="en-US" sz="1300" b="1" dirty="0">
                           <a:solidFill>
-                            <a:srgbClr val="000000"/>
+                            <a:srgbClr val="FFFFFF"/>
                           </a:solidFill>
                           <a:latin typeface="David" pitchFamily="34" charset="0"/>
                           <a:ea typeface="David" pitchFamily="34" charset="-122"/>
@@ -3072,7 +3072,7 @@
                   <a:tcPr marL="54864" marR="54864" marT="54864" marB="54864" anchor="ctr">
                     <a:lnL w="9525" cap="flat" cmpd="sng" algn="ctr">
                       <a:solidFill>
-                        <a:srgbClr val="BFBFBF"/>
+                        <a:srgbClr val="9DC3E6"/>
                       </a:solidFill>
                       <a:prstDash val="solid"/>
                       <a:round/>
@@ -3081,7 +3081,7 @@
                     </a:lnL>
                     <a:lnR w="9525" cap="flat" cmpd="sng" algn="ctr">
                       <a:solidFill>
-                        <a:srgbClr val="BFBFBF"/>
+                        <a:srgbClr val="9DC3E6"/>
                       </a:solidFill>
                       <a:prstDash val="solid"/>
                       <a:round/>
@@ -3090,7 +3090,7 @@
                     </a:lnR>
                     <a:lnT w="9525" cap="flat" cmpd="sng" algn="ctr">
                       <a:solidFill>
-                        <a:srgbClr val="BFBFBF"/>
+                        <a:srgbClr val="9DC3E6"/>
                       </a:solidFill>
                       <a:prstDash val="solid"/>
                       <a:round/>
@@ -3099,7 +3099,7 @@
                     </a:lnT>
                     <a:lnB w="9525" cap="flat" cmpd="sng" algn="ctr">
                       <a:solidFill>
-                        <a:srgbClr val="BFBFBF"/>
+                        <a:srgbClr val="9DC3E6"/>
                       </a:solidFill>
                       <a:prstDash val="solid"/>
                       <a:round/>
@@ -3107,7 +3107,7 @@
                       <a:tailEnd type="none" w="med" len="med"/>
                     </a:lnB>
                     <a:solidFill>
-                      <a:srgbClr val="F2F2F2"/>
+                      <a:srgbClr val="1F4E79"/>
                     </a:solidFill>
                   </a:tcPr>
                 </a:tc>
@@ -3122,7 +3122,7 @@
                       <a:r>
                         <a:rPr lang="en-US" sz="1300" b="1" dirty="0">
                           <a:solidFill>
-                            <a:srgbClr val="000000"/>
+                            <a:srgbClr val="FFFFFF"/>
                           </a:solidFill>
                           <a:latin typeface="David" pitchFamily="34" charset="0"/>
                           <a:ea typeface="David" pitchFamily="34" charset="-122"/>
@@ -3140,7 +3140,7 @@
                   <a:tcPr marL="54864" marR="54864" marT="54864" marB="54864" anchor="ctr">
                     <a:lnL w="9525" cap="flat" cmpd="sng" algn="ctr">
                       <a:solidFill>
-                        <a:srgbClr val="BFBFBF"/>
+                        <a:srgbClr val="9DC3E6"/>
                       </a:solidFill>
                       <a:prstDash val="solid"/>
                       <a:round/>
@@ -3149,7 +3149,7 @@
                     </a:lnL>
                     <a:lnR w="9525" cap="flat" cmpd="sng" algn="ctr">
                       <a:solidFill>
-                        <a:srgbClr val="BFBFBF"/>
+                        <a:srgbClr val="9DC3E6"/>
                       </a:solidFill>
                       <a:prstDash val="solid"/>
                       <a:round/>
@@ -3158,7 +3158,7 @@
                     </a:lnR>
                     <a:lnT w="9525" cap="flat" cmpd="sng" algn="ctr">
                       <a:solidFill>
-                        <a:srgbClr val="BFBFBF"/>
+                        <a:srgbClr val="9DC3E6"/>
                       </a:solidFill>
                       <a:prstDash val="solid"/>
                       <a:round/>
@@ -3167,7 +3167,7 @@
                     </a:lnT>
                     <a:lnB w="9525" cap="flat" cmpd="sng" algn="ctr">
                       <a:solidFill>
-                        <a:srgbClr val="BFBFBF"/>
+                        <a:srgbClr val="9DC3E6"/>
                       </a:solidFill>
                       <a:prstDash val="solid"/>
                       <a:round/>
@@ -3175,7 +3175,7 @@
                       <a:tailEnd type="none" w="med" len="med"/>
                     </a:lnB>
                     <a:solidFill>
-                      <a:srgbClr val="F2F2F2"/>
+                      <a:srgbClr val="1F4E79"/>
                     </a:solidFill>
                   </a:tcPr>
                 </a:tc>
@@ -3210,7 +3210,7 @@
                   <a:tcPr marL="54864" marR="54864" marT="54864" marB="54864" anchor="ctr">
                     <a:lnL w="9525" cap="flat" cmpd="sng" algn="ctr">
                       <a:solidFill>
-                        <a:srgbClr val="BFBFBF"/>
+                        <a:srgbClr val="9DC3E6"/>
                       </a:solidFill>
                       <a:prstDash val="solid"/>
                       <a:round/>
@@ -3219,7 +3219,7 @@
                     </a:lnL>
                     <a:lnR w="9525" cap="flat" cmpd="sng" algn="ctr">
                       <a:solidFill>
-                        <a:srgbClr val="BFBFBF"/>
+                        <a:srgbClr val="9DC3E6"/>
                       </a:solidFill>
                       <a:prstDash val="solid"/>
                       <a:round/>
@@ -3228,7 +3228,7 @@
                     </a:lnR>
                     <a:lnT w="9525" cap="flat" cmpd="sng" algn="ctr">
                       <a:solidFill>
-                        <a:srgbClr val="BFBFBF"/>
+                        <a:srgbClr val="9DC3E6"/>
                       </a:solidFill>
                       <a:prstDash val="solid"/>
                       <a:round/>
@@ -3237,7 +3237,7 @@
                     </a:lnT>
                     <a:lnB w="9525" cap="flat" cmpd="sng" algn="ctr">
                       <a:solidFill>
-                        <a:srgbClr val="BFBFBF"/>
+                        <a:srgbClr val="9DC3E6"/>
                       </a:solidFill>
                       <a:prstDash val="solid"/>
                       <a:round/>
@@ -3260,7 +3260,7 @@
                       <a:r>
                         <a:rPr lang="en-US" sz="1250" b="1" dirty="0">
                           <a:solidFill>
-                            <a:srgbClr val="000000"/>
+                            <a:srgbClr val="1F4E79"/>
                           </a:solidFill>
                           <a:latin typeface="David" pitchFamily="34" charset="0"/>
                           <a:ea typeface="David" pitchFamily="34" charset="-122"/>
@@ -3278,7 +3278,7 @@
                   <a:tcPr marL="54864" marR="54864" marT="54864" marB="54864" anchor="ctr">
                     <a:lnL w="9525" cap="flat" cmpd="sng" algn="ctr">
                       <a:solidFill>
-                        <a:srgbClr val="BFBFBF"/>
+                        <a:srgbClr val="9DC3E6"/>
                       </a:solidFill>
                       <a:prstDash val="solid"/>
                       <a:round/>
@@ -3287,7 +3287,7 @@
                     </a:lnL>
                     <a:lnR w="9525" cap="flat" cmpd="sng" algn="ctr">
                       <a:solidFill>
-                        <a:srgbClr val="BFBFBF"/>
+                        <a:srgbClr val="9DC3E6"/>
                       </a:solidFill>
                       <a:prstDash val="solid"/>
                       <a:round/>
@@ -3296,7 +3296,7 @@
                     </a:lnR>
                     <a:lnT w="9525" cap="flat" cmpd="sng" algn="ctr">
                       <a:solidFill>
-                        <a:srgbClr val="BFBFBF"/>
+                        <a:srgbClr val="9DC3E6"/>
                       </a:solidFill>
                       <a:prstDash val="solid"/>
                       <a:round/>
@@ -3305,7 +3305,7 @@
                     </a:lnT>
                     <a:lnB w="9525" cap="flat" cmpd="sng" algn="ctr">
                       <a:solidFill>
-                        <a:srgbClr val="BFBFBF"/>
+                        <a:srgbClr val="9DC3E6"/>
                       </a:solidFill>
                       <a:prstDash val="solid"/>
                       <a:round/>
@@ -3313,7 +3313,7 @@
                       <a:tailEnd type="none" w="med" len="med"/>
                     </a:lnB>
                     <a:solidFill>
-                      <a:srgbClr val="FFFFFF"/>
+                      <a:srgbClr val="DEEAF6"/>
                     </a:solidFill>
                   </a:tcPr>
                 </a:tc>
@@ -3348,7 +3348,7 @@
                   <a:tcPr marL="54864" marR="54864" marT="54864" marB="54864" anchor="ctr">
                     <a:lnL w="9525" cap="flat" cmpd="sng" algn="ctr">
                       <a:solidFill>
-                        <a:srgbClr val="BFBFBF"/>
+                        <a:srgbClr val="9DC3E6"/>
                       </a:solidFill>
                       <a:prstDash val="solid"/>
                       <a:round/>
@@ -3357,7 +3357,7 @@
                     </a:lnL>
                     <a:lnR w="9525" cap="flat" cmpd="sng" algn="ctr">
                       <a:solidFill>
-                        <a:srgbClr val="BFBFBF"/>
+                        <a:srgbClr val="9DC3E6"/>
                       </a:solidFill>
                       <a:prstDash val="solid"/>
                       <a:round/>
@@ -3366,7 +3366,7 @@
                     </a:lnR>
                     <a:lnT w="9525" cap="flat" cmpd="sng" algn="ctr">
                       <a:solidFill>
-                        <a:srgbClr val="BFBFBF"/>
+                        <a:srgbClr val="9DC3E6"/>
                       </a:solidFill>
                       <a:prstDash val="solid"/>
                       <a:round/>
@@ -3375,7 +3375,7 @@
                     </a:lnT>
                     <a:lnB w="9525" cap="flat" cmpd="sng" algn="ctr">
                       <a:solidFill>
-                        <a:srgbClr val="BFBFBF"/>
+                        <a:srgbClr val="9DC3E6"/>
                       </a:solidFill>
                       <a:prstDash val="solid"/>
                       <a:round/>
@@ -3383,7 +3383,7 @@
                       <a:tailEnd type="none" w="med" len="med"/>
                     </a:lnB>
                     <a:solidFill>
-                      <a:srgbClr val="FFFFFF"/>
+                      <a:srgbClr val="F5F8FC"/>
                     </a:solidFill>
                   </a:tcPr>
                 </a:tc>
@@ -3398,7 +3398,7 @@
                       <a:r>
                         <a:rPr lang="en-US" sz="1250" b="1" dirty="0">
                           <a:solidFill>
-                            <a:srgbClr val="000000"/>
+                            <a:srgbClr val="1F4E79"/>
                           </a:solidFill>
                           <a:latin typeface="David" pitchFamily="34" charset="0"/>
                           <a:ea typeface="David" pitchFamily="34" charset="-122"/>
@@ -3416,7 +3416,7 @@
                   <a:tcPr marL="54864" marR="54864" marT="54864" marB="54864" anchor="ctr">
                     <a:lnL w="9525" cap="flat" cmpd="sng" algn="ctr">
                       <a:solidFill>
-                        <a:srgbClr val="BFBFBF"/>
+                        <a:srgbClr val="9DC3E6"/>
                       </a:solidFill>
                       <a:prstDash val="solid"/>
                       <a:round/>
@@ -3425,7 +3425,7 @@
                     </a:lnL>
                     <a:lnR w="9525" cap="flat" cmpd="sng" algn="ctr">
                       <a:solidFill>
-                        <a:srgbClr val="BFBFBF"/>
+                        <a:srgbClr val="9DC3E6"/>
                       </a:solidFill>
                       <a:prstDash val="solid"/>
                       <a:round/>
@@ -3434,7 +3434,7 @@
                     </a:lnR>
                     <a:lnT w="9525" cap="flat" cmpd="sng" algn="ctr">
                       <a:solidFill>
-                        <a:srgbClr val="BFBFBF"/>
+                        <a:srgbClr val="9DC3E6"/>
                       </a:solidFill>
                       <a:prstDash val="solid"/>
                       <a:round/>
@@ -3443,7 +3443,7 @@
                     </a:lnT>
                     <a:lnB w="9525" cap="flat" cmpd="sng" algn="ctr">
                       <a:solidFill>
-                        <a:srgbClr val="BFBFBF"/>
+                        <a:srgbClr val="9DC3E6"/>
                       </a:solidFill>
                       <a:prstDash val="solid"/>
                       <a:round/>
@@ -3451,7 +3451,7 @@
                       <a:tailEnd type="none" w="med" len="med"/>
                     </a:lnB>
                     <a:solidFill>
-                      <a:srgbClr val="FFFFFF"/>
+                      <a:srgbClr val="DEEAF6"/>
                     </a:solidFill>
                   </a:tcPr>
                 </a:tc>
@@ -3486,7 +3486,7 @@
                   <a:tcPr marL="54864" marR="54864" marT="54864" marB="54864" anchor="ctr">
                     <a:lnL w="9525" cap="flat" cmpd="sng" algn="ctr">
                       <a:solidFill>
-                        <a:srgbClr val="BFBFBF"/>
+                        <a:srgbClr val="9DC3E6"/>
                       </a:solidFill>
                       <a:prstDash val="solid"/>
                       <a:round/>
@@ -3495,7 +3495,7 @@
                     </a:lnL>
                     <a:lnR w="9525" cap="flat" cmpd="sng" algn="ctr">
                       <a:solidFill>
-                        <a:srgbClr val="BFBFBF"/>
+                        <a:srgbClr val="9DC3E6"/>
                       </a:solidFill>
                       <a:prstDash val="solid"/>
                       <a:round/>
@@ -3504,7 +3504,7 @@
                     </a:lnR>
                     <a:lnT w="9525" cap="flat" cmpd="sng" algn="ctr">
                       <a:solidFill>
-                        <a:srgbClr val="BFBFBF"/>
+                        <a:srgbClr val="9DC3E6"/>
                       </a:solidFill>
                       <a:prstDash val="solid"/>
                       <a:round/>
@@ -3513,7 +3513,7 @@
                     </a:lnT>
                     <a:lnB w="9525" cap="flat" cmpd="sng" algn="ctr">
                       <a:solidFill>
-                        <a:srgbClr val="BFBFBF"/>
+                        <a:srgbClr val="9DC3E6"/>
                       </a:solidFill>
                       <a:prstDash val="solid"/>
                       <a:round/>
@@ -3536,7 +3536,7 @@
                       <a:r>
                         <a:rPr lang="en-US" sz="1250" b="1" dirty="0">
                           <a:solidFill>
-                            <a:srgbClr val="000000"/>
+                            <a:srgbClr val="1F4E79"/>
                           </a:solidFill>
                           <a:latin typeface="David" pitchFamily="34" charset="0"/>
                           <a:ea typeface="David" pitchFamily="34" charset="-122"/>
@@ -3554,7 +3554,7 @@
                   <a:tcPr marL="54864" marR="54864" marT="54864" marB="54864" anchor="ctr">
                     <a:lnL w="9525" cap="flat" cmpd="sng" algn="ctr">
                       <a:solidFill>
-                        <a:srgbClr val="BFBFBF"/>
+                        <a:srgbClr val="9DC3E6"/>
                       </a:solidFill>
                       <a:prstDash val="solid"/>
                       <a:round/>
@@ -3563,7 +3563,7 @@
                     </a:lnL>
                     <a:lnR w="9525" cap="flat" cmpd="sng" algn="ctr">
                       <a:solidFill>
-                        <a:srgbClr val="BFBFBF"/>
+                        <a:srgbClr val="9DC3E6"/>
                       </a:solidFill>
                       <a:prstDash val="solid"/>
                       <a:round/>
@@ -3572,7 +3572,7 @@
                     </a:lnR>
                     <a:lnT w="9525" cap="flat" cmpd="sng" algn="ctr">
                       <a:solidFill>
-                        <a:srgbClr val="BFBFBF"/>
+                        <a:srgbClr val="9DC3E6"/>
                       </a:solidFill>
                       <a:prstDash val="solid"/>
                       <a:round/>
@@ -3581,7 +3581,7 @@
                     </a:lnT>
                     <a:lnB w="9525" cap="flat" cmpd="sng" algn="ctr">
                       <a:solidFill>
-                        <a:srgbClr val="BFBFBF"/>
+                        <a:srgbClr val="9DC3E6"/>
                       </a:solidFill>
                       <a:prstDash val="solid"/>
                       <a:round/>
@@ -3589,7 +3589,7 @@
                       <a:tailEnd type="none" w="med" len="med"/>
                     </a:lnB>
                     <a:solidFill>
-                      <a:srgbClr val="FFFFFF"/>
+                      <a:srgbClr val="DEEAF6"/>
                     </a:solidFill>
                   </a:tcPr>
                 </a:tc>
@@ -3624,7 +3624,7 @@
                   <a:tcPr marL="54864" marR="54864" marT="54864" marB="54864" anchor="ctr">
                     <a:lnL w="9525" cap="flat" cmpd="sng" algn="ctr">
                       <a:solidFill>
-                        <a:srgbClr val="BFBFBF"/>
+                        <a:srgbClr val="9DC3E6"/>
                       </a:solidFill>
                       <a:prstDash val="solid"/>
                       <a:round/>
@@ -3633,7 +3633,7 @@
                     </a:lnL>
                     <a:lnR w="9525" cap="flat" cmpd="sng" algn="ctr">
                       <a:solidFill>
-                        <a:srgbClr val="BFBFBF"/>
+                        <a:srgbClr val="9DC3E6"/>
                       </a:solidFill>
                       <a:prstDash val="solid"/>
                       <a:round/>
@@ -3642,7 +3642,7 @@
                     </a:lnR>
                     <a:lnT w="9525" cap="flat" cmpd="sng" algn="ctr">
                       <a:solidFill>
-                        <a:srgbClr val="BFBFBF"/>
+                        <a:srgbClr val="9DC3E6"/>
                       </a:solidFill>
                       <a:prstDash val="solid"/>
                       <a:round/>
@@ -3651,7 +3651,7 @@
                     </a:lnT>
                     <a:lnB w="9525" cap="flat" cmpd="sng" algn="ctr">
                       <a:solidFill>
-                        <a:srgbClr val="BFBFBF"/>
+                        <a:srgbClr val="9DC3E6"/>
                       </a:solidFill>
                       <a:prstDash val="solid"/>
                       <a:round/>
@@ -3659,7 +3659,7 @@
                       <a:tailEnd type="none" w="med" len="med"/>
                     </a:lnB>
                     <a:solidFill>
-                      <a:srgbClr val="FFFFFF"/>
+                      <a:srgbClr val="F5F8FC"/>
                     </a:solidFill>
                   </a:tcPr>
                 </a:tc>
@@ -3674,7 +3674,7 @@
                       <a:r>
                         <a:rPr lang="en-US" sz="1250" b="1" dirty="0">
                           <a:solidFill>
-                            <a:srgbClr val="000000"/>
+                            <a:srgbClr val="1F4E79"/>
                           </a:solidFill>
                           <a:latin typeface="David" pitchFamily="34" charset="0"/>
                           <a:ea typeface="David" pitchFamily="34" charset="-122"/>
@@ -3692,7 +3692,7 @@
                   <a:tcPr marL="54864" marR="54864" marT="54864" marB="54864" anchor="ctr">
                     <a:lnL w="9525" cap="flat" cmpd="sng" algn="ctr">
                       <a:solidFill>
-                        <a:srgbClr val="BFBFBF"/>
+                        <a:srgbClr val="9DC3E6"/>
                       </a:solidFill>
                       <a:prstDash val="solid"/>
                       <a:round/>
@@ -3701,7 +3701,7 @@
                     </a:lnL>
                     <a:lnR w="9525" cap="flat" cmpd="sng" algn="ctr">
                       <a:solidFill>
-                        <a:srgbClr val="BFBFBF"/>
+                        <a:srgbClr val="9DC3E6"/>
                       </a:solidFill>
                       <a:prstDash val="solid"/>
                       <a:round/>
@@ -3710,7 +3710,7 @@
                     </a:lnR>
                     <a:lnT w="9525" cap="flat" cmpd="sng" algn="ctr">
                       <a:solidFill>
-                        <a:srgbClr val="BFBFBF"/>
+                        <a:srgbClr val="9DC3E6"/>
                       </a:solidFill>
                       <a:prstDash val="solid"/>
                       <a:round/>
@@ -3719,7 +3719,7 @@
                     </a:lnT>
                     <a:lnB w="9525" cap="flat" cmpd="sng" algn="ctr">
                       <a:solidFill>
-                        <a:srgbClr val="BFBFBF"/>
+                        <a:srgbClr val="9DC3E6"/>
                       </a:solidFill>
                       <a:prstDash val="solid"/>
                       <a:round/>
@@ -3727,7 +3727,7 @@
                       <a:tailEnd type="none" w="med" len="med"/>
                     </a:lnB>
                     <a:solidFill>
-                      <a:srgbClr val="FFFFFF"/>
+                      <a:srgbClr val="DEEAF6"/>
                     </a:solidFill>
                   </a:tcPr>
                 </a:tc>
@@ -3762,7 +3762,7 @@
                   <a:tcPr marL="54864" marR="54864" marT="54864" marB="54864" anchor="ctr">
                     <a:lnL w="9525" cap="flat" cmpd="sng" algn="ctr">
                       <a:solidFill>
-                        <a:srgbClr val="BFBFBF"/>
+                        <a:srgbClr val="9DC3E6"/>
                       </a:solidFill>
                       <a:prstDash val="solid"/>
                       <a:round/>
@@ -3771,7 +3771,7 @@
                     </a:lnL>
                     <a:lnR w="9525" cap="flat" cmpd="sng" algn="ctr">
                       <a:solidFill>
-                        <a:srgbClr val="BFBFBF"/>
+                        <a:srgbClr val="9DC3E6"/>
                       </a:solidFill>
                       <a:prstDash val="solid"/>
                       <a:round/>
@@ -3780,7 +3780,7 @@
                     </a:lnR>
                     <a:lnT w="9525" cap="flat" cmpd="sng" algn="ctr">
                       <a:solidFill>
-                        <a:srgbClr val="BFBFBF"/>
+                        <a:srgbClr val="9DC3E6"/>
                       </a:solidFill>
                       <a:prstDash val="solid"/>
                       <a:round/>
@@ -3789,7 +3789,7 @@
                     </a:lnT>
                     <a:lnB w="9525" cap="flat" cmpd="sng" algn="ctr">
                       <a:solidFill>
-                        <a:srgbClr val="BFBFBF"/>
+                        <a:srgbClr val="9DC3E6"/>
                       </a:solidFill>
                       <a:prstDash val="solid"/>
                       <a:round/>
@@ -3812,7 +3812,7 @@
                       <a:r>
                         <a:rPr lang="en-US" sz="1250" b="1" dirty="0">
                           <a:solidFill>
-                            <a:srgbClr val="000000"/>
+                            <a:srgbClr val="1F4E79"/>
                           </a:solidFill>
                           <a:latin typeface="David" pitchFamily="34" charset="0"/>
                           <a:ea typeface="David" pitchFamily="34" charset="-122"/>
@@ -3830,7 +3830,7 @@
                   <a:tcPr marL="54864" marR="54864" marT="54864" marB="54864" anchor="ctr">
                     <a:lnL w="9525" cap="flat" cmpd="sng" algn="ctr">
                       <a:solidFill>
-                        <a:srgbClr val="BFBFBF"/>
+                        <a:srgbClr val="9DC3E6"/>
                       </a:solidFill>
                       <a:prstDash val="solid"/>
                       <a:round/>
@@ -3839,7 +3839,7 @@
                     </a:lnL>
                     <a:lnR w="9525" cap="flat" cmpd="sng" algn="ctr">
                       <a:solidFill>
-                        <a:srgbClr val="BFBFBF"/>
+                        <a:srgbClr val="9DC3E6"/>
                       </a:solidFill>
                       <a:prstDash val="solid"/>
                       <a:round/>
@@ -3848,7 +3848,7 @@
                     </a:lnR>
                     <a:lnT w="9525" cap="flat" cmpd="sng" algn="ctr">
                       <a:solidFill>
-                        <a:srgbClr val="BFBFBF"/>
+                        <a:srgbClr val="9DC3E6"/>
                       </a:solidFill>
                       <a:prstDash val="solid"/>
                       <a:round/>
@@ -3857,7 +3857,7 @@
                     </a:lnT>
                     <a:lnB w="9525" cap="flat" cmpd="sng" algn="ctr">
                       <a:solidFill>
-                        <a:srgbClr val="BFBFBF"/>
+                        <a:srgbClr val="9DC3E6"/>
                       </a:solidFill>
                       <a:prstDash val="solid"/>
                       <a:round/>
@@ -3865,7 +3865,7 @@
                       <a:tailEnd type="none" w="med" len="med"/>
                     </a:lnB>
                     <a:solidFill>
-                      <a:srgbClr val="FFFFFF"/>
+                      <a:srgbClr val="DEEAF6"/>
                     </a:solidFill>
                   </a:tcPr>
                 </a:tc>
@@ -3900,7 +3900,7 @@
                   <a:tcPr marL="54864" marR="54864" marT="54864" marB="54864" anchor="ctr">
                     <a:lnL w="9525" cap="flat" cmpd="sng" algn="ctr">
                       <a:solidFill>
-                        <a:srgbClr val="BFBFBF"/>
+                        <a:srgbClr val="9DC3E6"/>
                       </a:solidFill>
                       <a:prstDash val="solid"/>
                       <a:round/>
@@ -3909,7 +3909,7 @@
                     </a:lnL>
                     <a:lnR w="9525" cap="flat" cmpd="sng" algn="ctr">
                       <a:solidFill>
-                        <a:srgbClr val="BFBFBF"/>
+                        <a:srgbClr val="9DC3E6"/>
                       </a:solidFill>
                       <a:prstDash val="solid"/>
                       <a:round/>
@@ -3918,7 +3918,7 @@
                     </a:lnR>
                     <a:lnT w="9525" cap="flat" cmpd="sng" algn="ctr">
                       <a:solidFill>
-                        <a:srgbClr val="BFBFBF"/>
+                        <a:srgbClr val="9DC3E6"/>
                       </a:solidFill>
                       <a:prstDash val="solid"/>
                       <a:round/>
@@ -3927,7 +3927,7 @@
                     </a:lnT>
                     <a:lnB w="9525" cap="flat" cmpd="sng" algn="ctr">
                       <a:solidFill>
-                        <a:srgbClr val="BFBFBF"/>
+                        <a:srgbClr val="9DC3E6"/>
                       </a:solidFill>
                       <a:prstDash val="solid"/>
                       <a:round/>
@@ -3935,7 +3935,7 @@
                       <a:tailEnd type="none" w="med" len="med"/>
                     </a:lnB>
                     <a:solidFill>
-                      <a:srgbClr val="FFFFFF"/>
+                      <a:srgbClr val="F5F8FC"/>
                     </a:solidFill>
                   </a:tcPr>
                 </a:tc>
@@ -3950,7 +3950,7 @@
                       <a:r>
                         <a:rPr lang="en-US" sz="1250" b="1" dirty="0">
                           <a:solidFill>
-                            <a:srgbClr val="000000"/>
+                            <a:srgbClr val="1F4E79"/>
                           </a:solidFill>
                           <a:latin typeface="David" pitchFamily="34" charset="0"/>
                           <a:ea typeface="David" pitchFamily="34" charset="-122"/>
@@ -3968,7 +3968,7 @@
                   <a:tcPr marL="54864" marR="54864" marT="54864" marB="54864" anchor="ctr">
                     <a:lnL w="9525" cap="flat" cmpd="sng" algn="ctr">
                       <a:solidFill>
-                        <a:srgbClr val="BFBFBF"/>
+                        <a:srgbClr val="9DC3E6"/>
                       </a:solidFill>
                       <a:prstDash val="solid"/>
                       <a:round/>
@@ -3977,7 +3977,7 @@
                     </a:lnL>
                     <a:lnR w="9525" cap="flat" cmpd="sng" algn="ctr">
                       <a:solidFill>
-                        <a:srgbClr val="BFBFBF"/>
+                        <a:srgbClr val="9DC3E6"/>
                       </a:solidFill>
                       <a:prstDash val="solid"/>
                       <a:round/>
@@ -3986,7 +3986,7 @@
                     </a:lnR>
                     <a:lnT w="9525" cap="flat" cmpd="sng" algn="ctr">
                       <a:solidFill>
-                        <a:srgbClr val="BFBFBF"/>
+                        <a:srgbClr val="9DC3E6"/>
                       </a:solidFill>
                       <a:prstDash val="solid"/>
                       <a:round/>
@@ -3995,7 +3995,7 @@
                     </a:lnT>
                     <a:lnB w="9525" cap="flat" cmpd="sng" algn="ctr">
                       <a:solidFill>
-                        <a:srgbClr val="BFBFBF"/>
+                        <a:srgbClr val="9DC3E6"/>
                       </a:solidFill>
                       <a:prstDash val="solid"/>
                       <a:round/>
@@ -4003,7 +4003,7 @@
                       <a:tailEnd type="none" w="med" len="med"/>
                     </a:lnB>
                     <a:solidFill>
-                      <a:srgbClr val="FFFFFF"/>
+                      <a:srgbClr val="DEEAF6"/>
                     </a:solidFill>
                   </a:tcPr>
                 </a:tc>
@@ -4039,7 +4039,7 @@
             <a:r>
               <a:rPr lang="he-IL" altLang="en-US" sz="1000" dirty="0">
                 <a:solidFill>
-                  <a:srgbClr val="595959"/>
+                  <a:srgbClr val="1F4E79"/>
                 </a:solidFill>
                 <a:latin typeface="David" pitchFamily="34" charset="0"/>
                 <a:ea typeface="David" pitchFamily="34" charset="-122"/>
@@ -4142,7 +4142,7 @@
             <a:r>
               <a:rPr lang="he-IL" altLang="en-US" sz="2800" b="1" dirty="0">
                 <a:solidFill>
-                  <a:srgbClr val="000000"/>
+                  <a:srgbClr val="1F4E79"/>
                 </a:solidFill>
                 <a:latin typeface="David" pitchFamily="34" charset="0"/>
                 <a:ea typeface="David" pitchFamily="34" charset="-122"/>
@@ -4265,7 +4265,7 @@
             <a:r>
               <a:rPr lang="he-IL" altLang="en-US" sz="1000" dirty="0">
                 <a:solidFill>
-                  <a:srgbClr val="595959"/>
+                  <a:srgbClr val="1F4E79"/>
                 </a:solidFill>
                 <a:latin typeface="David" pitchFamily="34" charset="0"/>
                 <a:ea typeface="David" pitchFamily="34" charset="-122"/>
@@ -4368,7 +4368,7 @@
             <a:r>
               <a:rPr lang="he-IL" altLang="en-US" sz="2800" b="1" dirty="0">
                 <a:solidFill>
-                  <a:srgbClr val="000000"/>
+                  <a:srgbClr val="1F4E79"/>
                 </a:solidFill>
                 <a:latin typeface="David" pitchFamily="34" charset="0"/>
                 <a:ea typeface="David" pitchFamily="34" charset="-122"/>
@@ -4491,7 +4491,7 @@
             <a:r>
               <a:rPr lang="he-IL" altLang="en-US" sz="1000" dirty="0">
                 <a:solidFill>
-                  <a:srgbClr val="595959"/>
+                  <a:srgbClr val="1F4E79"/>
                 </a:solidFill>
                 <a:latin typeface="David" pitchFamily="34" charset="0"/>
                 <a:ea typeface="David" pitchFamily="34" charset="-122"/>
@@ -4594,7 +4594,7 @@
             <a:r>
               <a:rPr lang="he-IL" altLang="en-US" sz="2800" b="1" dirty="0">
                 <a:solidFill>
-                  <a:srgbClr val="000000"/>
+                  <a:srgbClr val="1F4E79"/>
                 </a:solidFill>
                 <a:latin typeface="David" pitchFamily="34" charset="0"/>
                 <a:ea typeface="David" pitchFamily="34" charset="-122"/>
@@ -4687,7 +4687,7 @@
                       <a:r>
                         <a:rPr lang="en-US" sz="1300" b="1" dirty="0">
                           <a:solidFill>
-                            <a:srgbClr val="000000"/>
+                            <a:srgbClr val="FFFFFF"/>
                           </a:solidFill>
                           <a:latin typeface="David" pitchFamily="34" charset="0"/>
                           <a:ea typeface="David" pitchFamily="34" charset="-122"/>
@@ -4705,7 +4705,7 @@
                   <a:tcPr marL="54864" marR="54864" marT="54864" marB="54864" anchor="ctr">
                     <a:lnL w="9525" cap="flat" cmpd="sng" algn="ctr">
                       <a:solidFill>
-                        <a:srgbClr val="BFBFBF"/>
+                        <a:srgbClr val="9DC3E6"/>
                       </a:solidFill>
                       <a:prstDash val="solid"/>
                       <a:round/>
@@ -4714,7 +4714,7 @@
                     </a:lnL>
                     <a:lnR w="9525" cap="flat" cmpd="sng" algn="ctr">
                       <a:solidFill>
-                        <a:srgbClr val="BFBFBF"/>
+                        <a:srgbClr val="9DC3E6"/>
                       </a:solidFill>
                       <a:prstDash val="solid"/>
                       <a:round/>
@@ -4723,7 +4723,7 @@
                     </a:lnR>
                     <a:lnT w="9525" cap="flat" cmpd="sng" algn="ctr">
                       <a:solidFill>
-                        <a:srgbClr val="BFBFBF"/>
+                        <a:srgbClr val="9DC3E6"/>
                       </a:solidFill>
                       <a:prstDash val="solid"/>
                       <a:round/>
@@ -4732,7 +4732,7 @@
                     </a:lnT>
                     <a:lnB w="9525" cap="flat" cmpd="sng" algn="ctr">
                       <a:solidFill>
-                        <a:srgbClr val="BFBFBF"/>
+                        <a:srgbClr val="9DC3E6"/>
                       </a:solidFill>
                       <a:prstDash val="solid"/>
                       <a:round/>
@@ -4740,7 +4740,7 @@
                       <a:tailEnd type="none" w="med" len="med"/>
                     </a:lnB>
                     <a:solidFill>
-                      <a:srgbClr val="F2F2F2"/>
+                      <a:srgbClr val="1F4E79"/>
                     </a:solidFill>
                   </a:tcPr>
                 </a:tc>
@@ -4755,7 +4755,7 @@
                       <a:r>
                         <a:rPr lang="en-US" sz="1300" b="1" dirty="0">
                           <a:solidFill>
-                            <a:srgbClr val="000000"/>
+                            <a:srgbClr val="FFFFFF"/>
                           </a:solidFill>
                           <a:latin typeface="David" pitchFamily="34" charset="0"/>
                           <a:ea typeface="David" pitchFamily="34" charset="-122"/>
@@ -4773,7 +4773,7 @@
                   <a:tcPr marL="54864" marR="54864" marT="54864" marB="54864" anchor="ctr">
                     <a:lnL w="9525" cap="flat" cmpd="sng" algn="ctr">
                       <a:solidFill>
-                        <a:srgbClr val="BFBFBF"/>
+                        <a:srgbClr val="9DC3E6"/>
                       </a:solidFill>
                       <a:prstDash val="solid"/>
                       <a:round/>
@@ -4782,7 +4782,7 @@
                     </a:lnL>
                     <a:lnR w="9525" cap="flat" cmpd="sng" algn="ctr">
                       <a:solidFill>
-                        <a:srgbClr val="BFBFBF"/>
+                        <a:srgbClr val="9DC3E6"/>
                       </a:solidFill>
                       <a:prstDash val="solid"/>
                       <a:round/>
@@ -4791,7 +4791,7 @@
                     </a:lnR>
                     <a:lnT w="9525" cap="flat" cmpd="sng" algn="ctr">
                       <a:solidFill>
-                        <a:srgbClr val="BFBFBF"/>
+                        <a:srgbClr val="9DC3E6"/>
                       </a:solidFill>
                       <a:prstDash val="solid"/>
                       <a:round/>
@@ -4800,7 +4800,7 @@
                     </a:lnT>
                     <a:lnB w="9525" cap="flat" cmpd="sng" algn="ctr">
                       <a:solidFill>
-                        <a:srgbClr val="BFBFBF"/>
+                        <a:srgbClr val="9DC3E6"/>
                       </a:solidFill>
                       <a:prstDash val="solid"/>
                       <a:round/>
@@ -4808,7 +4808,7 @@
                       <a:tailEnd type="none" w="med" len="med"/>
                     </a:lnB>
                     <a:solidFill>
-                      <a:srgbClr val="F2F2F2"/>
+                      <a:srgbClr val="1F4E79"/>
                     </a:solidFill>
                   </a:tcPr>
                 </a:tc>
@@ -4823,7 +4823,7 @@
                       <a:r>
                         <a:rPr lang="en-US" sz="1300" b="1" dirty="0">
                           <a:solidFill>
-                            <a:srgbClr val="000000"/>
+                            <a:srgbClr val="FFFFFF"/>
                           </a:solidFill>
                           <a:latin typeface="David" pitchFamily="34" charset="0"/>
                           <a:ea typeface="David" pitchFamily="34" charset="-122"/>
@@ -4841,7 +4841,7 @@
                   <a:tcPr marL="54864" marR="54864" marT="54864" marB="54864" anchor="ctr">
                     <a:lnL w="9525" cap="flat" cmpd="sng" algn="ctr">
                       <a:solidFill>
-                        <a:srgbClr val="BFBFBF"/>
+                        <a:srgbClr val="9DC3E6"/>
                       </a:solidFill>
                       <a:prstDash val="solid"/>
                       <a:round/>
@@ -4850,7 +4850,7 @@
                     </a:lnL>
                     <a:lnR w="9525" cap="flat" cmpd="sng" algn="ctr">
                       <a:solidFill>
-                        <a:srgbClr val="BFBFBF"/>
+                        <a:srgbClr val="9DC3E6"/>
                       </a:solidFill>
                       <a:prstDash val="solid"/>
                       <a:round/>
@@ -4859,7 +4859,7 @@
                     </a:lnR>
                     <a:lnT w="9525" cap="flat" cmpd="sng" algn="ctr">
                       <a:solidFill>
-                        <a:srgbClr val="BFBFBF"/>
+                        <a:srgbClr val="9DC3E6"/>
                       </a:solidFill>
                       <a:prstDash val="solid"/>
                       <a:round/>
@@ -4868,7 +4868,7 @@
                     </a:lnT>
                     <a:lnB w="9525" cap="flat" cmpd="sng" algn="ctr">
                       <a:solidFill>
-                        <a:srgbClr val="BFBFBF"/>
+                        <a:srgbClr val="9DC3E6"/>
                       </a:solidFill>
                       <a:prstDash val="solid"/>
                       <a:round/>
@@ -4876,7 +4876,7 @@
                       <a:tailEnd type="none" w="med" len="med"/>
                     </a:lnB>
                     <a:solidFill>
-                      <a:srgbClr val="F2F2F2"/>
+                      <a:srgbClr val="1F4E79"/>
                     </a:solidFill>
                   </a:tcPr>
                 </a:tc>
@@ -4911,7 +4911,7 @@
                   <a:tcPr marL="54864" marR="54864" marT="54864" marB="54864" anchor="ctr">
                     <a:lnL w="9525" cap="flat" cmpd="sng" algn="ctr">
                       <a:solidFill>
-                        <a:srgbClr val="BFBFBF"/>
+                        <a:srgbClr val="9DC3E6"/>
                       </a:solidFill>
                       <a:prstDash val="solid"/>
                       <a:round/>
@@ -4920,7 +4920,7 @@
                     </a:lnL>
                     <a:lnR w="9525" cap="flat" cmpd="sng" algn="ctr">
                       <a:solidFill>
-                        <a:srgbClr val="BFBFBF"/>
+                        <a:srgbClr val="9DC3E6"/>
                       </a:solidFill>
                       <a:prstDash val="solid"/>
                       <a:round/>
@@ -4929,7 +4929,7 @@
                     </a:lnR>
                     <a:lnT w="9525" cap="flat" cmpd="sng" algn="ctr">
                       <a:solidFill>
-                        <a:srgbClr val="BFBFBF"/>
+                        <a:srgbClr val="9DC3E6"/>
                       </a:solidFill>
                       <a:prstDash val="solid"/>
                       <a:round/>
@@ -4938,7 +4938,7 @@
                     </a:lnT>
                     <a:lnB w="9525" cap="flat" cmpd="sng" algn="ctr">
                       <a:solidFill>
-                        <a:srgbClr val="BFBFBF"/>
+                        <a:srgbClr val="9DC3E6"/>
                       </a:solidFill>
                       <a:prstDash val="solid"/>
                       <a:round/>
@@ -4979,7 +4979,7 @@
                   <a:tcPr marL="54864" marR="54864" marT="54864" marB="54864" anchor="ctr">
                     <a:lnL w="9525" cap="flat" cmpd="sng" algn="ctr">
                       <a:solidFill>
-                        <a:srgbClr val="BFBFBF"/>
+                        <a:srgbClr val="9DC3E6"/>
                       </a:solidFill>
                       <a:prstDash val="solid"/>
                       <a:round/>
@@ -4988,7 +4988,7 @@
                     </a:lnL>
                     <a:lnR w="9525" cap="flat" cmpd="sng" algn="ctr">
                       <a:solidFill>
-                        <a:srgbClr val="BFBFBF"/>
+                        <a:srgbClr val="9DC3E6"/>
                       </a:solidFill>
                       <a:prstDash val="solid"/>
                       <a:round/>
@@ -4997,7 +4997,7 @@
                     </a:lnR>
                     <a:lnT w="9525" cap="flat" cmpd="sng" algn="ctr">
                       <a:solidFill>
-                        <a:srgbClr val="BFBFBF"/>
+                        <a:srgbClr val="9DC3E6"/>
                       </a:solidFill>
                       <a:prstDash val="solid"/>
                       <a:round/>
@@ -5006,7 +5006,7 @@
                     </a:lnT>
                     <a:lnB w="9525" cap="flat" cmpd="sng" algn="ctr">
                       <a:solidFill>
-                        <a:srgbClr val="BFBFBF"/>
+                        <a:srgbClr val="9DC3E6"/>
                       </a:solidFill>
                       <a:prstDash val="solid"/>
                       <a:round/>
@@ -5029,7 +5029,7 @@
                       <a:r>
                         <a:rPr lang="en-US" sz="1250" b="1" dirty="0">
                           <a:solidFill>
-                            <a:srgbClr val="000000"/>
+                            <a:srgbClr val="1F4E79"/>
                           </a:solidFill>
                           <a:latin typeface="David" pitchFamily="34" charset="0"/>
                           <a:ea typeface="David" pitchFamily="34" charset="-122"/>
@@ -5047,7 +5047,7 @@
                   <a:tcPr marL="54864" marR="54864" marT="54864" marB="54864" anchor="ctr">
                     <a:lnL w="9525" cap="flat" cmpd="sng" algn="ctr">
                       <a:solidFill>
-                        <a:srgbClr val="BFBFBF"/>
+                        <a:srgbClr val="9DC3E6"/>
                       </a:solidFill>
                       <a:prstDash val="solid"/>
                       <a:round/>
@@ -5056,7 +5056,7 @@
                     </a:lnL>
                     <a:lnR w="9525" cap="flat" cmpd="sng" algn="ctr">
                       <a:solidFill>
-                        <a:srgbClr val="BFBFBF"/>
+                        <a:srgbClr val="9DC3E6"/>
                       </a:solidFill>
                       <a:prstDash val="solid"/>
                       <a:round/>
@@ -5065,7 +5065,7 @@
                     </a:lnR>
                     <a:lnT w="9525" cap="flat" cmpd="sng" algn="ctr">
                       <a:solidFill>
-                        <a:srgbClr val="BFBFBF"/>
+                        <a:srgbClr val="9DC3E6"/>
                       </a:solidFill>
                       <a:prstDash val="solid"/>
                       <a:round/>
@@ -5074,7 +5074,7 @@
                     </a:lnT>
                     <a:lnB w="9525" cap="flat" cmpd="sng" algn="ctr">
                       <a:solidFill>
-                        <a:srgbClr val="BFBFBF"/>
+                        <a:srgbClr val="9DC3E6"/>
                       </a:solidFill>
                       <a:prstDash val="solid"/>
                       <a:round/>
@@ -5082,7 +5082,7 @@
                       <a:tailEnd type="none" w="med" len="med"/>
                     </a:lnB>
                     <a:solidFill>
-                      <a:srgbClr val="FFFFFF"/>
+                      <a:srgbClr val="DEEAF6"/>
                     </a:solidFill>
                   </a:tcPr>
                 </a:tc>
@@ -5117,7 +5117,7 @@
                   <a:tcPr marL="54864" marR="54864" marT="54864" marB="54864" anchor="ctr">
                     <a:lnL w="9525" cap="flat" cmpd="sng" algn="ctr">
                       <a:solidFill>
-                        <a:srgbClr val="BFBFBF"/>
+                        <a:srgbClr val="9DC3E6"/>
                       </a:solidFill>
                       <a:prstDash val="solid"/>
                       <a:round/>
@@ -5126,7 +5126,7 @@
                     </a:lnL>
                     <a:lnR w="9525" cap="flat" cmpd="sng" algn="ctr">
                       <a:solidFill>
-                        <a:srgbClr val="BFBFBF"/>
+                        <a:srgbClr val="9DC3E6"/>
                       </a:solidFill>
                       <a:prstDash val="solid"/>
                       <a:round/>
@@ -5135,7 +5135,7 @@
                     </a:lnR>
                     <a:lnT w="9525" cap="flat" cmpd="sng" algn="ctr">
                       <a:solidFill>
-                        <a:srgbClr val="BFBFBF"/>
+                        <a:srgbClr val="9DC3E6"/>
                       </a:solidFill>
                       <a:prstDash val="solid"/>
                       <a:round/>
@@ -5144,7 +5144,7 @@
                     </a:lnT>
                     <a:lnB w="9525" cap="flat" cmpd="sng" algn="ctr">
                       <a:solidFill>
-                        <a:srgbClr val="BFBFBF"/>
+                        <a:srgbClr val="9DC3E6"/>
                       </a:solidFill>
                       <a:prstDash val="solid"/>
                       <a:round/>
@@ -5152,7 +5152,7 @@
                       <a:tailEnd type="none" w="med" len="med"/>
                     </a:lnB>
                     <a:solidFill>
-                      <a:srgbClr val="FFFFFF"/>
+                      <a:srgbClr val="F5F8FC"/>
                     </a:solidFill>
                   </a:tcPr>
                 </a:tc>
@@ -5185,7 +5185,7 @@
                   <a:tcPr marL="54864" marR="54864" marT="54864" marB="54864" anchor="ctr">
                     <a:lnL w="9525" cap="flat" cmpd="sng" algn="ctr">
                       <a:solidFill>
-                        <a:srgbClr val="BFBFBF"/>
+                        <a:srgbClr val="9DC3E6"/>
                       </a:solidFill>
                       <a:prstDash val="solid"/>
                       <a:round/>
@@ -5194,7 +5194,7 @@
                     </a:lnL>
                     <a:lnR w="9525" cap="flat" cmpd="sng" algn="ctr">
                       <a:solidFill>
-                        <a:srgbClr val="BFBFBF"/>
+                        <a:srgbClr val="9DC3E6"/>
                       </a:solidFill>
                       <a:prstDash val="solid"/>
                       <a:round/>
@@ -5203,7 +5203,7 @@
                     </a:lnR>
                     <a:lnT w="9525" cap="flat" cmpd="sng" algn="ctr">
                       <a:solidFill>
-                        <a:srgbClr val="BFBFBF"/>
+                        <a:srgbClr val="9DC3E6"/>
                       </a:solidFill>
                       <a:prstDash val="solid"/>
                       <a:round/>
@@ -5212,7 +5212,7 @@
                     </a:lnT>
                     <a:lnB w="9525" cap="flat" cmpd="sng" algn="ctr">
                       <a:solidFill>
-                        <a:srgbClr val="BFBFBF"/>
+                        <a:srgbClr val="9DC3E6"/>
                       </a:solidFill>
                       <a:prstDash val="solid"/>
                       <a:round/>
@@ -5220,7 +5220,7 @@
                       <a:tailEnd type="none" w="med" len="med"/>
                     </a:lnB>
                     <a:solidFill>
-                      <a:srgbClr val="FFFFFF"/>
+                      <a:srgbClr val="F5F8FC"/>
                     </a:solidFill>
                   </a:tcPr>
                 </a:tc>
@@ -5235,7 +5235,7 @@
                       <a:r>
                         <a:rPr lang="en-US" sz="1250" b="1" dirty="0">
                           <a:solidFill>
-                            <a:srgbClr val="000000"/>
+                            <a:srgbClr val="1F4E79"/>
                           </a:solidFill>
                           <a:latin typeface="David" pitchFamily="34" charset="0"/>
                           <a:ea typeface="David" pitchFamily="34" charset="-122"/>
@@ -5253,7 +5253,7 @@
                   <a:tcPr marL="54864" marR="54864" marT="54864" marB="54864" anchor="ctr">
                     <a:lnL w="9525" cap="flat" cmpd="sng" algn="ctr">
                       <a:solidFill>
-                        <a:srgbClr val="BFBFBF"/>
+                        <a:srgbClr val="9DC3E6"/>
                       </a:solidFill>
                       <a:prstDash val="solid"/>
                       <a:round/>
@@ -5262,7 +5262,7 @@
                     </a:lnL>
                     <a:lnR w="9525" cap="flat" cmpd="sng" algn="ctr">
                       <a:solidFill>
-                        <a:srgbClr val="BFBFBF"/>
+                        <a:srgbClr val="9DC3E6"/>
                       </a:solidFill>
                       <a:prstDash val="solid"/>
                       <a:round/>
@@ -5271,7 +5271,7 @@
                     </a:lnR>
                     <a:lnT w="9525" cap="flat" cmpd="sng" algn="ctr">
                       <a:solidFill>
-                        <a:srgbClr val="BFBFBF"/>
+                        <a:srgbClr val="9DC3E6"/>
                       </a:solidFill>
                       <a:prstDash val="solid"/>
                       <a:round/>
@@ -5280,7 +5280,7 @@
                     </a:lnT>
                     <a:lnB w="9525" cap="flat" cmpd="sng" algn="ctr">
                       <a:solidFill>
-                        <a:srgbClr val="BFBFBF"/>
+                        <a:srgbClr val="9DC3E6"/>
                       </a:solidFill>
                       <a:prstDash val="solid"/>
                       <a:round/>
@@ -5288,7 +5288,7 @@
                       <a:tailEnd type="none" w="med" len="med"/>
                     </a:lnB>
                     <a:solidFill>
-                      <a:srgbClr val="FFFFFF"/>
+                      <a:srgbClr val="DEEAF6"/>
                     </a:solidFill>
                   </a:tcPr>
                 </a:tc>
@@ -5323,7 +5323,7 @@
                   <a:tcPr marL="54864" marR="54864" marT="54864" marB="54864" anchor="ctr">
                     <a:lnL w="9525" cap="flat" cmpd="sng" algn="ctr">
                       <a:solidFill>
-                        <a:srgbClr val="BFBFBF"/>
+                        <a:srgbClr val="9DC3E6"/>
                       </a:solidFill>
                       <a:prstDash val="solid"/>
                       <a:round/>
@@ -5332,7 +5332,7 @@
                     </a:lnL>
                     <a:lnR w="9525" cap="flat" cmpd="sng" algn="ctr">
                       <a:solidFill>
-                        <a:srgbClr val="BFBFBF"/>
+                        <a:srgbClr val="9DC3E6"/>
                       </a:solidFill>
                       <a:prstDash val="solid"/>
                       <a:round/>
@@ -5341,7 +5341,7 @@
                     </a:lnR>
                     <a:lnT w="9525" cap="flat" cmpd="sng" algn="ctr">
                       <a:solidFill>
-                        <a:srgbClr val="BFBFBF"/>
+                        <a:srgbClr val="9DC3E6"/>
                       </a:solidFill>
                       <a:prstDash val="solid"/>
                       <a:round/>
@@ -5350,7 +5350,7 @@
                     </a:lnT>
                     <a:lnB w="9525" cap="flat" cmpd="sng" algn="ctr">
                       <a:solidFill>
-                        <a:srgbClr val="BFBFBF"/>
+                        <a:srgbClr val="9DC3E6"/>
                       </a:solidFill>
                       <a:prstDash val="solid"/>
                       <a:round/>
@@ -5391,7 +5391,7 @@
                   <a:tcPr marL="54864" marR="54864" marT="54864" marB="54864" anchor="ctr">
                     <a:lnL w="9525" cap="flat" cmpd="sng" algn="ctr">
                       <a:solidFill>
-                        <a:srgbClr val="BFBFBF"/>
+                        <a:srgbClr val="9DC3E6"/>
                       </a:solidFill>
                       <a:prstDash val="solid"/>
                       <a:round/>
@@ -5400,7 +5400,7 @@
                     </a:lnL>
                     <a:lnR w="9525" cap="flat" cmpd="sng" algn="ctr">
                       <a:solidFill>
-                        <a:srgbClr val="BFBFBF"/>
+                        <a:srgbClr val="9DC3E6"/>
                       </a:solidFill>
                       <a:prstDash val="solid"/>
                       <a:round/>
@@ -5409,7 +5409,7 @@
                     </a:lnR>
                     <a:lnT w="9525" cap="flat" cmpd="sng" algn="ctr">
                       <a:solidFill>
-                        <a:srgbClr val="BFBFBF"/>
+                        <a:srgbClr val="9DC3E6"/>
                       </a:solidFill>
                       <a:prstDash val="solid"/>
                       <a:round/>
@@ -5418,7 +5418,7 @@
                     </a:lnT>
                     <a:lnB w="9525" cap="flat" cmpd="sng" algn="ctr">
                       <a:solidFill>
-                        <a:srgbClr val="BFBFBF"/>
+                        <a:srgbClr val="9DC3E6"/>
                       </a:solidFill>
                       <a:prstDash val="solid"/>
                       <a:round/>
@@ -5441,7 +5441,7 @@
                       <a:r>
                         <a:rPr lang="en-US" sz="1250" b="1" dirty="0">
                           <a:solidFill>
-                            <a:srgbClr val="000000"/>
+                            <a:srgbClr val="1F4E79"/>
                           </a:solidFill>
                           <a:latin typeface="David" pitchFamily="34" charset="0"/>
                           <a:ea typeface="David" pitchFamily="34" charset="-122"/>
@@ -5459,7 +5459,7 @@
                   <a:tcPr marL="54864" marR="54864" marT="54864" marB="54864" anchor="ctr">
                     <a:lnL w="9525" cap="flat" cmpd="sng" algn="ctr">
                       <a:solidFill>
-                        <a:srgbClr val="BFBFBF"/>
+                        <a:srgbClr val="9DC3E6"/>
                       </a:solidFill>
                       <a:prstDash val="solid"/>
                       <a:round/>
@@ -5468,7 +5468,7 @@
                     </a:lnL>
                     <a:lnR w="9525" cap="flat" cmpd="sng" algn="ctr">
                       <a:solidFill>
-                        <a:srgbClr val="BFBFBF"/>
+                        <a:srgbClr val="9DC3E6"/>
                       </a:solidFill>
                       <a:prstDash val="solid"/>
                       <a:round/>
@@ -5477,7 +5477,7 @@
                     </a:lnR>
                     <a:lnT w="9525" cap="flat" cmpd="sng" algn="ctr">
                       <a:solidFill>
-                        <a:srgbClr val="BFBFBF"/>
+                        <a:srgbClr val="9DC3E6"/>
                       </a:solidFill>
                       <a:prstDash val="solid"/>
                       <a:round/>
@@ -5486,7 +5486,7 @@
                     </a:lnT>
                     <a:lnB w="9525" cap="flat" cmpd="sng" algn="ctr">
                       <a:solidFill>
-                        <a:srgbClr val="BFBFBF"/>
+                        <a:srgbClr val="9DC3E6"/>
                       </a:solidFill>
                       <a:prstDash val="solid"/>
                       <a:round/>
@@ -5494,7 +5494,7 @@
                       <a:tailEnd type="none" w="med" len="med"/>
                     </a:lnB>
                     <a:solidFill>
-                      <a:srgbClr val="FFFFFF"/>
+                      <a:srgbClr val="DEEAF6"/>
                     </a:solidFill>
                   </a:tcPr>
                 </a:tc>
@@ -5529,7 +5529,7 @@
                   <a:tcPr marL="54864" marR="54864" marT="54864" marB="54864" anchor="ctr">
                     <a:lnL w="9525" cap="flat" cmpd="sng" algn="ctr">
                       <a:solidFill>
-                        <a:srgbClr val="BFBFBF"/>
+                        <a:srgbClr val="9DC3E6"/>
                       </a:solidFill>
                       <a:prstDash val="solid"/>
                       <a:round/>
@@ -5538,7 +5538,7 @@
                     </a:lnL>
                     <a:lnR w="9525" cap="flat" cmpd="sng" algn="ctr">
                       <a:solidFill>
-                        <a:srgbClr val="BFBFBF"/>
+                        <a:srgbClr val="9DC3E6"/>
                       </a:solidFill>
                       <a:prstDash val="solid"/>
                       <a:round/>
@@ -5547,7 +5547,7 @@
                     </a:lnR>
                     <a:lnT w="9525" cap="flat" cmpd="sng" algn="ctr">
                       <a:solidFill>
-                        <a:srgbClr val="BFBFBF"/>
+                        <a:srgbClr val="9DC3E6"/>
                       </a:solidFill>
                       <a:prstDash val="solid"/>
                       <a:round/>
@@ -5556,7 +5556,7 @@
                     </a:lnT>
                     <a:lnB w="9525" cap="flat" cmpd="sng" algn="ctr">
                       <a:solidFill>
-                        <a:srgbClr val="BFBFBF"/>
+                        <a:srgbClr val="9DC3E6"/>
                       </a:solidFill>
                       <a:prstDash val="solid"/>
                       <a:round/>
@@ -5564,7 +5564,7 @@
                       <a:tailEnd type="none" w="med" len="med"/>
                     </a:lnB>
                     <a:solidFill>
-                      <a:srgbClr val="FFFFFF"/>
+                      <a:srgbClr val="F5F8FC"/>
                     </a:solidFill>
                   </a:tcPr>
                 </a:tc>
@@ -5597,7 +5597,7 @@
                   <a:tcPr marL="54864" marR="54864" marT="54864" marB="54864" anchor="ctr">
                     <a:lnL w="9525" cap="flat" cmpd="sng" algn="ctr">
                       <a:solidFill>
-                        <a:srgbClr val="BFBFBF"/>
+                        <a:srgbClr val="9DC3E6"/>
                       </a:solidFill>
                       <a:prstDash val="solid"/>
                       <a:round/>
@@ -5606,7 +5606,7 @@
                     </a:lnL>
                     <a:lnR w="9525" cap="flat" cmpd="sng" algn="ctr">
                       <a:solidFill>
-                        <a:srgbClr val="BFBFBF"/>
+                        <a:srgbClr val="9DC3E6"/>
                       </a:solidFill>
                       <a:prstDash val="solid"/>
                       <a:round/>
@@ -5615,7 +5615,7 @@
                     </a:lnR>
                     <a:lnT w="9525" cap="flat" cmpd="sng" algn="ctr">
                       <a:solidFill>
-                        <a:srgbClr val="BFBFBF"/>
+                        <a:srgbClr val="9DC3E6"/>
                       </a:solidFill>
                       <a:prstDash val="solid"/>
                       <a:round/>
@@ -5624,7 +5624,7 @@
                     </a:lnT>
                     <a:lnB w="9525" cap="flat" cmpd="sng" algn="ctr">
                       <a:solidFill>
-                        <a:srgbClr val="BFBFBF"/>
+                        <a:srgbClr val="9DC3E6"/>
                       </a:solidFill>
                       <a:prstDash val="solid"/>
                       <a:round/>
@@ -5632,7 +5632,7 @@
                       <a:tailEnd type="none" w="med" len="med"/>
                     </a:lnB>
                     <a:solidFill>
-                      <a:srgbClr val="FFFFFF"/>
+                      <a:srgbClr val="F5F8FC"/>
                     </a:solidFill>
                   </a:tcPr>
                 </a:tc>
@@ -5647,7 +5647,7 @@
                       <a:r>
                         <a:rPr lang="en-US" sz="1250" b="1" dirty="0">
                           <a:solidFill>
-                            <a:srgbClr val="000000"/>
+                            <a:srgbClr val="1F4E79"/>
                           </a:solidFill>
                           <a:latin typeface="David" pitchFamily="34" charset="0"/>
                           <a:ea typeface="David" pitchFamily="34" charset="-122"/>
@@ -5665,7 +5665,7 @@
                   <a:tcPr marL="54864" marR="54864" marT="54864" marB="54864" anchor="ctr">
                     <a:lnL w="9525" cap="flat" cmpd="sng" algn="ctr">
                       <a:solidFill>
-                        <a:srgbClr val="BFBFBF"/>
+                        <a:srgbClr val="9DC3E6"/>
                       </a:solidFill>
                       <a:prstDash val="solid"/>
                       <a:round/>
@@ -5674,7 +5674,7 @@
                     </a:lnL>
                     <a:lnR w="9525" cap="flat" cmpd="sng" algn="ctr">
                       <a:solidFill>
-                        <a:srgbClr val="BFBFBF"/>
+                        <a:srgbClr val="9DC3E6"/>
                       </a:solidFill>
                       <a:prstDash val="solid"/>
                       <a:round/>
@@ -5683,7 +5683,7 @@
                     </a:lnR>
                     <a:lnT w="9525" cap="flat" cmpd="sng" algn="ctr">
                       <a:solidFill>
-                        <a:srgbClr val="BFBFBF"/>
+                        <a:srgbClr val="9DC3E6"/>
                       </a:solidFill>
                       <a:prstDash val="solid"/>
                       <a:round/>
@@ -5692,7 +5692,7 @@
                     </a:lnT>
                     <a:lnB w="9525" cap="flat" cmpd="sng" algn="ctr">
                       <a:solidFill>
-                        <a:srgbClr val="BFBFBF"/>
+                        <a:srgbClr val="9DC3E6"/>
                       </a:solidFill>
                       <a:prstDash val="solid"/>
                       <a:round/>
@@ -5700,7 +5700,7 @@
                       <a:tailEnd type="none" w="med" len="med"/>
                     </a:lnB>
                     <a:solidFill>
-                      <a:srgbClr val="FFFFFF"/>
+                      <a:srgbClr val="DEEAF6"/>
                     </a:solidFill>
                   </a:tcPr>
                 </a:tc>
@@ -5736,7 +5736,7 @@
             <a:r>
               <a:rPr lang="he-IL" altLang="en-US" sz="1050" dirty="0">
                 <a:solidFill>
-                  <a:srgbClr val="595959"/>
+                  <a:srgbClr val="ED7D31"/>
                 </a:solidFill>
                 <a:latin typeface="David" pitchFamily="34" charset="0"/>
                 <a:ea typeface="David" pitchFamily="34" charset="-122"/>
@@ -5775,7 +5775,7 @@
             <a:r>
               <a:rPr lang="he-IL" altLang="en-US" sz="1000" dirty="0">
                 <a:solidFill>
-                  <a:srgbClr val="595959"/>
+                  <a:srgbClr val="1F4E79"/>
                 </a:solidFill>
                 <a:latin typeface="David" pitchFamily="34" charset="0"/>
                 <a:ea typeface="David" pitchFamily="34" charset="-122"/>
@@ -5878,7 +5878,7 @@
             <a:r>
               <a:rPr lang="he-IL" altLang="en-US" sz="2800" b="1" dirty="0">
                 <a:solidFill>
-                  <a:srgbClr val="000000"/>
+                  <a:srgbClr val="1F4E79"/>
                 </a:solidFill>
                 <a:latin typeface="David" pitchFamily="34" charset="0"/>
                 <a:ea typeface="David" pitchFamily="34" charset="-122"/>
@@ -6091,7 +6091,7 @@
             <a:r>
               <a:rPr lang="he-IL" altLang="en-US" sz="1000" dirty="0">
                 <a:solidFill>
-                  <a:srgbClr val="595959"/>
+                  <a:srgbClr val="1F4E79"/>
                 </a:solidFill>
                 <a:latin typeface="David" pitchFamily="34" charset="0"/>
                 <a:ea typeface="David" pitchFamily="34" charset="-122"/>
@@ -6194,7 +6194,7 @@
             <a:r>
               <a:rPr lang="he-IL" altLang="en-US" sz="2800" b="1" dirty="0">
                 <a:solidFill>
-                  <a:srgbClr val="000000"/>
+                  <a:srgbClr val="1F4E79"/>
                 </a:solidFill>
                 <a:latin typeface="David" pitchFamily="34" charset="0"/>
                 <a:ea typeface="David" pitchFamily="34" charset="-122"/>
@@ -6317,7 +6317,7 @@
             <a:r>
               <a:rPr lang="he-IL" altLang="en-US" sz="1600" b="1" dirty="0">
                 <a:solidFill>
-                  <a:srgbClr val="000000"/>
+                  <a:srgbClr val="ED7D31"/>
                 </a:solidFill>
                 <a:latin typeface="David" pitchFamily="34" charset="0"/>
                 <a:ea typeface="David" pitchFamily="34" charset="-122"/>
@@ -6356,7 +6356,7 @@
             <a:r>
               <a:rPr lang="he-IL" altLang="en-US" sz="1000" dirty="0">
                 <a:solidFill>
-                  <a:srgbClr val="595959"/>
+                  <a:srgbClr val="1F4E79"/>
                 </a:solidFill>
                 <a:latin typeface="David" pitchFamily="34" charset="0"/>
                 <a:ea typeface="David" pitchFamily="34" charset="-122"/>
@@ -6459,7 +6459,7 @@
             <a:r>
               <a:rPr lang="he-IL" altLang="en-US" sz="2800" b="1" dirty="0">
                 <a:solidFill>
-                  <a:srgbClr val="000000"/>
+                  <a:srgbClr val="1F4E79"/>
                 </a:solidFill>
                 <a:latin typeface="David" pitchFamily="34" charset="0"/>
                 <a:ea typeface="David" pitchFamily="34" charset="-122"/>
@@ -6656,7 +6656,7 @@
             <a:r>
               <a:rPr lang="he-IL" altLang="en-US" sz="1000" dirty="0">
                 <a:solidFill>
-                  <a:srgbClr val="595959"/>
+                  <a:srgbClr val="1F4E79"/>
                 </a:solidFill>
                 <a:latin typeface="David" pitchFamily="34" charset="0"/>
                 <a:ea typeface="David" pitchFamily="34" charset="-122"/>
@@ -6759,7 +6759,7 @@
             <a:r>
               <a:rPr lang="he-IL" altLang="en-US" sz="2800" b="1" dirty="0">
                 <a:solidFill>
-                  <a:srgbClr val="000000"/>
+                  <a:srgbClr val="1F4E79"/>
                 </a:solidFill>
                 <a:latin typeface="David" pitchFamily="34" charset="0"/>
                 <a:ea typeface="David" pitchFamily="34" charset="-122"/>
@@ -6882,7 +6882,7 @@
             <a:r>
               <a:rPr lang="he-IL" altLang="en-US" sz="1000" dirty="0">
                 <a:solidFill>
-                  <a:srgbClr val="595959"/>
+                  <a:srgbClr val="1F4E79"/>
                 </a:solidFill>
                 <a:latin typeface="David" pitchFamily="34" charset="0"/>
                 <a:ea typeface="David" pitchFamily="34" charset="-122"/>
@@ -6985,7 +6985,7 @@
             <a:r>
               <a:rPr lang="he-IL" altLang="en-US" sz="2800" b="1" dirty="0">
                 <a:solidFill>
-                  <a:srgbClr val="000000"/>
+                  <a:srgbClr val="1F4E79"/>
                 </a:solidFill>
                 <a:latin typeface="David" pitchFamily="34" charset="0"/>
                 <a:ea typeface="David" pitchFamily="34" charset="-122"/>
@@ -7077,7 +7077,7 @@
                       <a:r>
                         <a:rPr lang="en-US" sz="1300" b="1" dirty="0">
                           <a:solidFill>
-                            <a:srgbClr val="000000"/>
+                            <a:srgbClr val="FFFFFF"/>
                           </a:solidFill>
                           <a:latin typeface="David" pitchFamily="34" charset="0"/>
                           <a:ea typeface="David" pitchFamily="34" charset="-122"/>
@@ -7095,7 +7095,7 @@
                   <a:tcPr marL="54864" marR="54864" marT="54864" marB="54864" anchor="ctr">
                     <a:lnL w="9525" cap="flat" cmpd="sng" algn="ctr">
                       <a:solidFill>
-                        <a:srgbClr val="BFBFBF"/>
+                        <a:srgbClr val="9DC3E6"/>
                       </a:solidFill>
                       <a:prstDash val="solid"/>
                       <a:round/>
@@ -7104,7 +7104,7 @@
                     </a:lnL>
                     <a:lnR w="9525" cap="flat" cmpd="sng" algn="ctr">
                       <a:solidFill>
-                        <a:srgbClr val="BFBFBF"/>
+                        <a:srgbClr val="9DC3E6"/>
                       </a:solidFill>
                       <a:prstDash val="solid"/>
                       <a:round/>
@@ -7113,7 +7113,7 @@
                     </a:lnR>
                     <a:lnT w="9525" cap="flat" cmpd="sng" algn="ctr">
                       <a:solidFill>
-                        <a:srgbClr val="BFBFBF"/>
+                        <a:srgbClr val="9DC3E6"/>
                       </a:solidFill>
                       <a:prstDash val="solid"/>
                       <a:round/>
@@ -7122,7 +7122,7 @@
                     </a:lnT>
                     <a:lnB w="9525" cap="flat" cmpd="sng" algn="ctr">
                       <a:solidFill>
-                        <a:srgbClr val="BFBFBF"/>
+                        <a:srgbClr val="9DC3E6"/>
                       </a:solidFill>
                       <a:prstDash val="solid"/>
                       <a:round/>
@@ -7130,7 +7130,7 @@
                       <a:tailEnd type="none" w="med" len="med"/>
                     </a:lnB>
                     <a:solidFill>
-                      <a:srgbClr val="F2F2F2"/>
+                      <a:srgbClr val="1F4E79"/>
                     </a:solidFill>
                   </a:tcPr>
                 </a:tc>
@@ -7145,7 +7145,7 @@
                       <a:r>
                         <a:rPr lang="en-US" sz="1300" b="1" dirty="0">
                           <a:solidFill>
-                            <a:srgbClr val="000000"/>
+                            <a:srgbClr val="FFFFFF"/>
                           </a:solidFill>
                           <a:latin typeface="David" pitchFamily="34" charset="0"/>
                           <a:ea typeface="David" pitchFamily="34" charset="-122"/>
@@ -7163,7 +7163,7 @@
                   <a:tcPr marL="54864" marR="54864" marT="54864" marB="54864" anchor="ctr">
                     <a:lnL w="9525" cap="flat" cmpd="sng" algn="ctr">
                       <a:solidFill>
-                        <a:srgbClr val="BFBFBF"/>
+                        <a:srgbClr val="9DC3E6"/>
                       </a:solidFill>
                       <a:prstDash val="solid"/>
                       <a:round/>
@@ -7172,7 +7172,7 @@
                     </a:lnL>
                     <a:lnR w="9525" cap="flat" cmpd="sng" algn="ctr">
                       <a:solidFill>
-                        <a:srgbClr val="BFBFBF"/>
+                        <a:srgbClr val="9DC3E6"/>
                       </a:solidFill>
                       <a:prstDash val="solid"/>
                       <a:round/>
@@ -7181,7 +7181,7 @@
                     </a:lnR>
                     <a:lnT w="9525" cap="flat" cmpd="sng" algn="ctr">
                       <a:solidFill>
-                        <a:srgbClr val="BFBFBF"/>
+                        <a:srgbClr val="9DC3E6"/>
                       </a:solidFill>
                       <a:prstDash val="solid"/>
                       <a:round/>
@@ -7190,7 +7190,7 @@
                     </a:lnT>
                     <a:lnB w="9525" cap="flat" cmpd="sng" algn="ctr">
                       <a:solidFill>
-                        <a:srgbClr val="BFBFBF"/>
+                        <a:srgbClr val="9DC3E6"/>
                       </a:solidFill>
                       <a:prstDash val="solid"/>
                       <a:round/>
@@ -7198,7 +7198,7 @@
                       <a:tailEnd type="none" w="med" len="med"/>
                     </a:lnB>
                     <a:solidFill>
-                      <a:srgbClr val="F2F2F2"/>
+                      <a:srgbClr val="1F4E79"/>
                     </a:solidFill>
                   </a:tcPr>
                 </a:tc>
@@ -7233,7 +7233,7 @@
                   <a:tcPr marL="54864" marR="54864" marT="54864" marB="54864" anchor="ctr">
                     <a:lnL w="9525" cap="flat" cmpd="sng" algn="ctr">
                       <a:solidFill>
-                        <a:srgbClr val="BFBFBF"/>
+                        <a:srgbClr val="9DC3E6"/>
                       </a:solidFill>
                       <a:prstDash val="solid"/>
                       <a:round/>
@@ -7242,7 +7242,7 @@
                     </a:lnL>
                     <a:lnR w="9525" cap="flat" cmpd="sng" algn="ctr">
                       <a:solidFill>
-                        <a:srgbClr val="BFBFBF"/>
+                        <a:srgbClr val="9DC3E6"/>
                       </a:solidFill>
                       <a:prstDash val="solid"/>
                       <a:round/>
@@ -7251,7 +7251,7 @@
                     </a:lnR>
                     <a:lnT w="9525" cap="flat" cmpd="sng" algn="ctr">
                       <a:solidFill>
-                        <a:srgbClr val="BFBFBF"/>
+                        <a:srgbClr val="9DC3E6"/>
                       </a:solidFill>
                       <a:prstDash val="solid"/>
                       <a:round/>
@@ -7260,7 +7260,7 @@
                     </a:lnT>
                     <a:lnB w="9525" cap="flat" cmpd="sng" algn="ctr">
                       <a:solidFill>
-                        <a:srgbClr val="BFBFBF"/>
+                        <a:srgbClr val="9DC3E6"/>
                       </a:solidFill>
                       <a:prstDash val="solid"/>
                       <a:round/>
@@ -7283,7 +7283,7 @@
                       <a:r>
                         <a:rPr lang="en-US" sz="1250" b="1" dirty="0">
                           <a:solidFill>
-                            <a:srgbClr val="000000"/>
+                            <a:srgbClr val="1F4E79"/>
                           </a:solidFill>
                           <a:latin typeface="David" pitchFamily="34" charset="0"/>
                           <a:ea typeface="David" pitchFamily="34" charset="-122"/>
@@ -7301,7 +7301,7 @@
                   <a:tcPr marL="54864" marR="54864" marT="54864" marB="54864" anchor="ctr">
                     <a:lnL w="9525" cap="flat" cmpd="sng" algn="ctr">
                       <a:solidFill>
-                        <a:srgbClr val="BFBFBF"/>
+                        <a:srgbClr val="9DC3E6"/>
                       </a:solidFill>
                       <a:prstDash val="solid"/>
                       <a:round/>
@@ -7310,7 +7310,7 @@
                     </a:lnL>
                     <a:lnR w="9525" cap="flat" cmpd="sng" algn="ctr">
                       <a:solidFill>
-                        <a:srgbClr val="BFBFBF"/>
+                        <a:srgbClr val="9DC3E6"/>
                       </a:solidFill>
                       <a:prstDash val="solid"/>
                       <a:round/>
@@ -7319,7 +7319,7 @@
                     </a:lnR>
                     <a:lnT w="9525" cap="flat" cmpd="sng" algn="ctr">
                       <a:solidFill>
-                        <a:srgbClr val="BFBFBF"/>
+                        <a:srgbClr val="9DC3E6"/>
                       </a:solidFill>
                       <a:prstDash val="solid"/>
                       <a:round/>
@@ -7328,7 +7328,7 @@
                     </a:lnT>
                     <a:lnB w="9525" cap="flat" cmpd="sng" algn="ctr">
                       <a:solidFill>
-                        <a:srgbClr val="BFBFBF"/>
+                        <a:srgbClr val="9DC3E6"/>
                       </a:solidFill>
                       <a:prstDash val="solid"/>
                       <a:round/>
@@ -7336,7 +7336,7 @@
                       <a:tailEnd type="none" w="med" len="med"/>
                     </a:lnB>
                     <a:solidFill>
-                      <a:srgbClr val="FFFFFF"/>
+                      <a:srgbClr val="DEEAF6"/>
                     </a:solidFill>
                   </a:tcPr>
                 </a:tc>
@@ -7371,7 +7371,7 @@
                   <a:tcPr marL="54864" marR="54864" marT="54864" marB="54864" anchor="ctr">
                     <a:lnL w="9525" cap="flat" cmpd="sng" algn="ctr">
                       <a:solidFill>
-                        <a:srgbClr val="BFBFBF"/>
+                        <a:srgbClr val="9DC3E6"/>
                       </a:solidFill>
                       <a:prstDash val="solid"/>
                       <a:round/>
@@ -7380,7 +7380,7 @@
                     </a:lnL>
                     <a:lnR w="9525" cap="flat" cmpd="sng" algn="ctr">
                       <a:solidFill>
-                        <a:srgbClr val="BFBFBF"/>
+                        <a:srgbClr val="9DC3E6"/>
                       </a:solidFill>
                       <a:prstDash val="solid"/>
                       <a:round/>
@@ -7389,7 +7389,7 @@
                     </a:lnR>
                     <a:lnT w="9525" cap="flat" cmpd="sng" algn="ctr">
                       <a:solidFill>
-                        <a:srgbClr val="BFBFBF"/>
+                        <a:srgbClr val="9DC3E6"/>
                       </a:solidFill>
                       <a:prstDash val="solid"/>
                       <a:round/>
@@ -7398,7 +7398,7 @@
                     </a:lnT>
                     <a:lnB w="9525" cap="flat" cmpd="sng" algn="ctr">
                       <a:solidFill>
-                        <a:srgbClr val="BFBFBF"/>
+                        <a:srgbClr val="9DC3E6"/>
                       </a:solidFill>
                       <a:prstDash val="solid"/>
                       <a:round/>
@@ -7406,7 +7406,7 @@
                       <a:tailEnd type="none" w="med" len="med"/>
                     </a:lnB>
                     <a:solidFill>
-                      <a:srgbClr val="FFFFFF"/>
+                      <a:srgbClr val="F5F8FC"/>
                     </a:solidFill>
                   </a:tcPr>
                 </a:tc>
@@ -7421,7 +7421,7 @@
                       <a:r>
                         <a:rPr lang="en-US" sz="1250" b="1" dirty="0">
                           <a:solidFill>
-                            <a:srgbClr val="000000"/>
+                            <a:srgbClr val="1F4E79"/>
                           </a:solidFill>
                           <a:latin typeface="David" pitchFamily="34" charset="0"/>
                           <a:ea typeface="David" pitchFamily="34" charset="-122"/>
@@ -7439,7 +7439,7 @@
                   <a:tcPr marL="54864" marR="54864" marT="54864" marB="54864" anchor="ctr">
                     <a:lnL w="9525" cap="flat" cmpd="sng" algn="ctr">
                       <a:solidFill>
-                        <a:srgbClr val="BFBFBF"/>
+                        <a:srgbClr val="9DC3E6"/>
                       </a:solidFill>
                       <a:prstDash val="solid"/>
                       <a:round/>
@@ -7448,7 +7448,7 @@
                     </a:lnL>
                     <a:lnR w="9525" cap="flat" cmpd="sng" algn="ctr">
                       <a:solidFill>
-                        <a:srgbClr val="BFBFBF"/>
+                        <a:srgbClr val="9DC3E6"/>
                       </a:solidFill>
                       <a:prstDash val="solid"/>
                       <a:round/>
@@ -7457,7 +7457,7 @@
                     </a:lnR>
                     <a:lnT w="9525" cap="flat" cmpd="sng" algn="ctr">
                       <a:solidFill>
-                        <a:srgbClr val="BFBFBF"/>
+                        <a:srgbClr val="9DC3E6"/>
                       </a:solidFill>
                       <a:prstDash val="solid"/>
                       <a:round/>
@@ -7466,7 +7466,7 @@
                     </a:lnT>
                     <a:lnB w="9525" cap="flat" cmpd="sng" algn="ctr">
                       <a:solidFill>
-                        <a:srgbClr val="BFBFBF"/>
+                        <a:srgbClr val="9DC3E6"/>
                       </a:solidFill>
                       <a:prstDash val="solid"/>
                       <a:round/>
@@ -7474,7 +7474,7 @@
                       <a:tailEnd type="none" w="med" len="med"/>
                     </a:lnB>
                     <a:solidFill>
-                      <a:srgbClr val="FFFFFF"/>
+                      <a:srgbClr val="DEEAF6"/>
                     </a:solidFill>
                   </a:tcPr>
                 </a:tc>
@@ -7509,7 +7509,7 @@
                   <a:tcPr marL="54864" marR="54864" marT="54864" marB="54864" anchor="ctr">
                     <a:lnL w="9525" cap="flat" cmpd="sng" algn="ctr">
                       <a:solidFill>
-                        <a:srgbClr val="BFBFBF"/>
+                        <a:srgbClr val="9DC3E6"/>
                       </a:solidFill>
                       <a:prstDash val="solid"/>
                       <a:round/>
@@ -7518,7 +7518,7 @@
                     </a:lnL>
                     <a:lnR w="9525" cap="flat" cmpd="sng" algn="ctr">
                       <a:solidFill>
-                        <a:srgbClr val="BFBFBF"/>
+                        <a:srgbClr val="9DC3E6"/>
                       </a:solidFill>
                       <a:prstDash val="solid"/>
                       <a:round/>
@@ -7527,7 +7527,7 @@
                     </a:lnR>
                     <a:lnT w="9525" cap="flat" cmpd="sng" algn="ctr">
                       <a:solidFill>
-                        <a:srgbClr val="BFBFBF"/>
+                        <a:srgbClr val="9DC3E6"/>
                       </a:solidFill>
                       <a:prstDash val="solid"/>
                       <a:round/>
@@ -7536,7 +7536,7 @@
                     </a:lnT>
                     <a:lnB w="9525" cap="flat" cmpd="sng" algn="ctr">
                       <a:solidFill>
-                        <a:srgbClr val="BFBFBF"/>
+                        <a:srgbClr val="9DC3E6"/>
                       </a:solidFill>
                       <a:prstDash val="solid"/>
                       <a:round/>
@@ -7559,7 +7559,7 @@
                       <a:r>
                         <a:rPr lang="en-US" sz="1250" b="1" dirty="0">
                           <a:solidFill>
-                            <a:srgbClr val="000000"/>
+                            <a:srgbClr val="1F4E79"/>
                           </a:solidFill>
                           <a:latin typeface="David" pitchFamily="34" charset="0"/>
                           <a:ea typeface="David" pitchFamily="34" charset="-122"/>
@@ -7577,7 +7577,7 @@
                   <a:tcPr marL="54864" marR="54864" marT="54864" marB="54864" anchor="ctr">
                     <a:lnL w="9525" cap="flat" cmpd="sng" algn="ctr">
                       <a:solidFill>
-                        <a:srgbClr val="BFBFBF"/>
+                        <a:srgbClr val="9DC3E6"/>
                       </a:solidFill>
                       <a:prstDash val="solid"/>
                       <a:round/>
@@ -7586,7 +7586,7 @@
                     </a:lnL>
                     <a:lnR w="9525" cap="flat" cmpd="sng" algn="ctr">
                       <a:solidFill>
-                        <a:srgbClr val="BFBFBF"/>
+                        <a:srgbClr val="9DC3E6"/>
                       </a:solidFill>
                       <a:prstDash val="solid"/>
                       <a:round/>
@@ -7595,7 +7595,7 @@
                     </a:lnR>
                     <a:lnT w="9525" cap="flat" cmpd="sng" algn="ctr">
                       <a:solidFill>
-                        <a:srgbClr val="BFBFBF"/>
+                        <a:srgbClr val="9DC3E6"/>
                       </a:solidFill>
                       <a:prstDash val="solid"/>
                       <a:round/>
@@ -7604,7 +7604,7 @@
                     </a:lnT>
                     <a:lnB w="9525" cap="flat" cmpd="sng" algn="ctr">
                       <a:solidFill>
-                        <a:srgbClr val="BFBFBF"/>
+                        <a:srgbClr val="9DC3E6"/>
                       </a:solidFill>
                       <a:prstDash val="solid"/>
                       <a:round/>
@@ -7612,7 +7612,7 @@
                       <a:tailEnd type="none" w="med" len="med"/>
                     </a:lnB>
                     <a:solidFill>
-                      <a:srgbClr val="FFFFFF"/>
+                      <a:srgbClr val="DEEAF6"/>
                     </a:solidFill>
                   </a:tcPr>
                 </a:tc>
@@ -7647,7 +7647,7 @@
                   <a:tcPr marL="54864" marR="54864" marT="54864" marB="54864" anchor="ctr">
                     <a:lnL w="9525" cap="flat" cmpd="sng" algn="ctr">
                       <a:solidFill>
-                        <a:srgbClr val="BFBFBF"/>
+                        <a:srgbClr val="9DC3E6"/>
                       </a:solidFill>
                       <a:prstDash val="solid"/>
                       <a:round/>
@@ -7656,7 +7656,7 @@
                     </a:lnL>
                     <a:lnR w="9525" cap="flat" cmpd="sng" algn="ctr">
                       <a:solidFill>
-                        <a:srgbClr val="BFBFBF"/>
+                        <a:srgbClr val="9DC3E6"/>
                       </a:solidFill>
                       <a:prstDash val="solid"/>
                       <a:round/>
@@ -7665,7 +7665,7 @@
                     </a:lnR>
                     <a:lnT w="9525" cap="flat" cmpd="sng" algn="ctr">
                       <a:solidFill>
-                        <a:srgbClr val="BFBFBF"/>
+                        <a:srgbClr val="9DC3E6"/>
                       </a:solidFill>
                       <a:prstDash val="solid"/>
                       <a:round/>
@@ -7674,7 +7674,7 @@
                     </a:lnT>
                     <a:lnB w="9525" cap="flat" cmpd="sng" algn="ctr">
                       <a:solidFill>
-                        <a:srgbClr val="BFBFBF"/>
+                        <a:srgbClr val="9DC3E6"/>
                       </a:solidFill>
                       <a:prstDash val="solid"/>
                       <a:round/>
@@ -7682,7 +7682,7 @@
                       <a:tailEnd type="none" w="med" len="med"/>
                     </a:lnB>
                     <a:solidFill>
-                      <a:srgbClr val="FFFFFF"/>
+                      <a:srgbClr val="F5F8FC"/>
                     </a:solidFill>
                   </a:tcPr>
                 </a:tc>
@@ -7697,7 +7697,7 @@
                       <a:r>
                         <a:rPr lang="en-US" sz="1250" b="1" dirty="0">
                           <a:solidFill>
-                            <a:srgbClr val="000000"/>
+                            <a:srgbClr val="1F4E79"/>
                           </a:solidFill>
                           <a:latin typeface="David" pitchFamily="34" charset="0"/>
                           <a:ea typeface="David" pitchFamily="34" charset="-122"/>
@@ -7715,7 +7715,7 @@
                   <a:tcPr marL="54864" marR="54864" marT="54864" marB="54864" anchor="ctr">
                     <a:lnL w="9525" cap="flat" cmpd="sng" algn="ctr">
                       <a:solidFill>
-                        <a:srgbClr val="BFBFBF"/>
+                        <a:srgbClr val="9DC3E6"/>
                       </a:solidFill>
                       <a:prstDash val="solid"/>
                       <a:round/>
@@ -7724,7 +7724,7 @@
                     </a:lnL>
                     <a:lnR w="9525" cap="flat" cmpd="sng" algn="ctr">
                       <a:solidFill>
-                        <a:srgbClr val="BFBFBF"/>
+                        <a:srgbClr val="9DC3E6"/>
                       </a:solidFill>
                       <a:prstDash val="solid"/>
                       <a:round/>
@@ -7733,7 +7733,7 @@
                     </a:lnR>
                     <a:lnT w="9525" cap="flat" cmpd="sng" algn="ctr">
                       <a:solidFill>
-                        <a:srgbClr val="BFBFBF"/>
+                        <a:srgbClr val="9DC3E6"/>
                       </a:solidFill>
                       <a:prstDash val="solid"/>
                       <a:round/>
@@ -7742,7 +7742,7 @@
                     </a:lnT>
                     <a:lnB w="9525" cap="flat" cmpd="sng" algn="ctr">
                       <a:solidFill>
-                        <a:srgbClr val="BFBFBF"/>
+                        <a:srgbClr val="9DC3E6"/>
                       </a:solidFill>
                       <a:prstDash val="solid"/>
                       <a:round/>
@@ -7750,7 +7750,7 @@
                       <a:tailEnd type="none" w="med" len="med"/>
                     </a:lnB>
                     <a:solidFill>
-                      <a:srgbClr val="FFFFFF"/>
+                      <a:srgbClr val="DEEAF6"/>
                     </a:solidFill>
                   </a:tcPr>
                 </a:tc>
@@ -7785,7 +7785,7 @@
                   <a:tcPr marL="54864" marR="54864" marT="54864" marB="54864" anchor="ctr">
                     <a:lnL w="9525" cap="flat" cmpd="sng" algn="ctr">
                       <a:solidFill>
-                        <a:srgbClr val="BFBFBF"/>
+                        <a:srgbClr val="9DC3E6"/>
                       </a:solidFill>
                       <a:prstDash val="solid"/>
                       <a:round/>
@@ -7794,7 +7794,7 @@
                     </a:lnL>
                     <a:lnR w="9525" cap="flat" cmpd="sng" algn="ctr">
                       <a:solidFill>
-                        <a:srgbClr val="BFBFBF"/>
+                        <a:srgbClr val="9DC3E6"/>
                       </a:solidFill>
                       <a:prstDash val="solid"/>
                       <a:round/>
@@ -7803,7 +7803,7 @@
                     </a:lnR>
                     <a:lnT w="9525" cap="flat" cmpd="sng" algn="ctr">
                       <a:solidFill>
-                        <a:srgbClr val="BFBFBF"/>
+                        <a:srgbClr val="9DC3E6"/>
                       </a:solidFill>
                       <a:prstDash val="solid"/>
                       <a:round/>
@@ -7812,7 +7812,7 @@
                     </a:lnT>
                     <a:lnB w="9525" cap="flat" cmpd="sng" algn="ctr">
                       <a:solidFill>
-                        <a:srgbClr val="BFBFBF"/>
+                        <a:srgbClr val="9DC3E6"/>
                       </a:solidFill>
                       <a:prstDash val="solid"/>
                       <a:round/>
@@ -7835,7 +7835,7 @@
                       <a:r>
                         <a:rPr lang="en-US" sz="1250" b="1" dirty="0">
                           <a:solidFill>
-                            <a:srgbClr val="000000"/>
+                            <a:srgbClr val="1F4E79"/>
                           </a:solidFill>
                           <a:latin typeface="David" pitchFamily="34" charset="0"/>
                           <a:ea typeface="David" pitchFamily="34" charset="-122"/>
@@ -7853,7 +7853,7 @@
                   <a:tcPr marL="54864" marR="54864" marT="54864" marB="54864" anchor="ctr">
                     <a:lnL w="9525" cap="flat" cmpd="sng" algn="ctr">
                       <a:solidFill>
-                        <a:srgbClr val="BFBFBF"/>
+                        <a:srgbClr val="9DC3E6"/>
                       </a:solidFill>
                       <a:prstDash val="solid"/>
                       <a:round/>
@@ -7862,7 +7862,7 @@
                     </a:lnL>
                     <a:lnR w="9525" cap="flat" cmpd="sng" algn="ctr">
                       <a:solidFill>
-                        <a:srgbClr val="BFBFBF"/>
+                        <a:srgbClr val="9DC3E6"/>
                       </a:solidFill>
                       <a:prstDash val="solid"/>
                       <a:round/>
@@ -7871,7 +7871,7 @@
                     </a:lnR>
                     <a:lnT w="9525" cap="flat" cmpd="sng" algn="ctr">
                       <a:solidFill>
-                        <a:srgbClr val="BFBFBF"/>
+                        <a:srgbClr val="9DC3E6"/>
                       </a:solidFill>
                       <a:prstDash val="solid"/>
                       <a:round/>
@@ -7880,7 +7880,7 @@
                     </a:lnT>
                     <a:lnB w="9525" cap="flat" cmpd="sng" algn="ctr">
                       <a:solidFill>
-                        <a:srgbClr val="BFBFBF"/>
+                        <a:srgbClr val="9DC3E6"/>
                       </a:solidFill>
                       <a:prstDash val="solid"/>
                       <a:round/>
@@ -7888,7 +7888,7 @@
                       <a:tailEnd type="none" w="med" len="med"/>
                     </a:lnB>
                     <a:solidFill>
-                      <a:srgbClr val="FFFFFF"/>
+                      <a:srgbClr val="DEEAF6"/>
                     </a:solidFill>
                   </a:tcPr>
                 </a:tc>
@@ -7924,7 +7924,7 @@
             <a:r>
               <a:rPr lang="he-IL" altLang="en-US" sz="1000" dirty="0">
                 <a:solidFill>
-                  <a:srgbClr val="595959"/>
+                  <a:srgbClr val="1F4E79"/>
                 </a:solidFill>
                 <a:latin typeface="David" pitchFamily="34" charset="0"/>
                 <a:ea typeface="David" pitchFamily="34" charset="-122"/>
@@ -8027,7 +8027,7 @@
             <a:r>
               <a:rPr lang="he-IL" altLang="en-US" sz="2800" b="1" dirty="0">
                 <a:solidFill>
-                  <a:srgbClr val="000000"/>
+                  <a:srgbClr val="1F4E79"/>
                 </a:solidFill>
                 <a:latin typeface="David" pitchFamily="34" charset="0"/>
                 <a:ea typeface="David" pitchFamily="34" charset="-122"/>
@@ -8120,7 +8120,7 @@
                       <a:r>
                         <a:rPr lang="en-US" sz="1300" b="1" dirty="0">
                           <a:solidFill>
-                            <a:srgbClr val="000000"/>
+                            <a:srgbClr val="FFFFFF"/>
                           </a:solidFill>
                           <a:latin typeface="David" pitchFamily="34" charset="0"/>
                           <a:ea typeface="David" pitchFamily="34" charset="-122"/>
@@ -8138,7 +8138,7 @@
                   <a:tcPr marL="54864" marR="54864" marT="54864" marB="54864" anchor="ctr">
                     <a:lnL w="9525" cap="flat" cmpd="sng" algn="ctr">
                       <a:solidFill>
-                        <a:srgbClr val="BFBFBF"/>
+                        <a:srgbClr val="9DC3E6"/>
                       </a:solidFill>
                       <a:prstDash val="solid"/>
                       <a:round/>
@@ -8147,7 +8147,7 @@
                     </a:lnL>
                     <a:lnR w="9525" cap="flat" cmpd="sng" algn="ctr">
                       <a:solidFill>
-                        <a:srgbClr val="BFBFBF"/>
+                        <a:srgbClr val="9DC3E6"/>
                       </a:solidFill>
                       <a:prstDash val="solid"/>
                       <a:round/>
@@ -8156,7 +8156,7 @@
                     </a:lnR>
                     <a:lnT w="9525" cap="flat" cmpd="sng" algn="ctr">
                       <a:solidFill>
-                        <a:srgbClr val="BFBFBF"/>
+                        <a:srgbClr val="9DC3E6"/>
                       </a:solidFill>
                       <a:prstDash val="solid"/>
                       <a:round/>
@@ -8165,7 +8165,7 @@
                     </a:lnT>
                     <a:lnB w="9525" cap="flat" cmpd="sng" algn="ctr">
                       <a:solidFill>
-                        <a:srgbClr val="BFBFBF"/>
+                        <a:srgbClr val="9DC3E6"/>
                       </a:solidFill>
                       <a:prstDash val="solid"/>
                       <a:round/>
@@ -8173,7 +8173,7 @@
                       <a:tailEnd type="none" w="med" len="med"/>
                     </a:lnB>
                     <a:solidFill>
-                      <a:srgbClr val="F2F2F2"/>
+                      <a:srgbClr val="1F4E79"/>
                     </a:solidFill>
                   </a:tcPr>
                 </a:tc>
@@ -8188,7 +8188,7 @@
                       <a:r>
                         <a:rPr lang="en-US" sz="1300" b="1" dirty="0">
                           <a:solidFill>
-                            <a:srgbClr val="000000"/>
+                            <a:srgbClr val="FFFFFF"/>
                           </a:solidFill>
                           <a:latin typeface="David" pitchFamily="34" charset="0"/>
                           <a:ea typeface="David" pitchFamily="34" charset="-122"/>
@@ -8206,7 +8206,7 @@
                   <a:tcPr marL="54864" marR="54864" marT="54864" marB="54864" anchor="ctr">
                     <a:lnL w="9525" cap="flat" cmpd="sng" algn="ctr">
                       <a:solidFill>
-                        <a:srgbClr val="BFBFBF"/>
+                        <a:srgbClr val="9DC3E6"/>
                       </a:solidFill>
                       <a:prstDash val="solid"/>
                       <a:round/>
@@ -8215,7 +8215,7 @@
                     </a:lnL>
                     <a:lnR w="9525" cap="flat" cmpd="sng" algn="ctr">
                       <a:solidFill>
-                        <a:srgbClr val="BFBFBF"/>
+                        <a:srgbClr val="9DC3E6"/>
                       </a:solidFill>
                       <a:prstDash val="solid"/>
                       <a:round/>
@@ -8224,7 +8224,7 @@
                     </a:lnR>
                     <a:lnT w="9525" cap="flat" cmpd="sng" algn="ctr">
                       <a:solidFill>
-                        <a:srgbClr val="BFBFBF"/>
+                        <a:srgbClr val="9DC3E6"/>
                       </a:solidFill>
                       <a:prstDash val="solid"/>
                       <a:round/>
@@ -8233,7 +8233,7 @@
                     </a:lnT>
                     <a:lnB w="9525" cap="flat" cmpd="sng" algn="ctr">
                       <a:solidFill>
-                        <a:srgbClr val="BFBFBF"/>
+                        <a:srgbClr val="9DC3E6"/>
                       </a:solidFill>
                       <a:prstDash val="solid"/>
                       <a:round/>
@@ -8241,7 +8241,7 @@
                       <a:tailEnd type="none" w="med" len="med"/>
                     </a:lnB>
                     <a:solidFill>
-                      <a:srgbClr val="F2F2F2"/>
+                      <a:srgbClr val="1F4E79"/>
                     </a:solidFill>
                   </a:tcPr>
                 </a:tc>
@@ -8256,7 +8256,7 @@
                       <a:r>
                         <a:rPr lang="en-US" sz="1300" b="1" dirty="0">
                           <a:solidFill>
-                            <a:srgbClr val="000000"/>
+                            <a:srgbClr val="FFFFFF"/>
                           </a:solidFill>
                           <a:latin typeface="David" pitchFamily="34" charset="0"/>
                           <a:ea typeface="David" pitchFamily="34" charset="-122"/>
@@ -8274,7 +8274,7 @@
                   <a:tcPr marL="54864" marR="54864" marT="54864" marB="54864" anchor="ctr">
                     <a:lnL w="9525" cap="flat" cmpd="sng" algn="ctr">
                       <a:solidFill>
-                        <a:srgbClr val="BFBFBF"/>
+                        <a:srgbClr val="9DC3E6"/>
                       </a:solidFill>
                       <a:prstDash val="solid"/>
                       <a:round/>
@@ -8283,7 +8283,7 @@
                     </a:lnL>
                     <a:lnR w="9525" cap="flat" cmpd="sng" algn="ctr">
                       <a:solidFill>
-                        <a:srgbClr val="BFBFBF"/>
+                        <a:srgbClr val="9DC3E6"/>
                       </a:solidFill>
                       <a:prstDash val="solid"/>
                       <a:round/>
@@ -8292,7 +8292,7 @@
                     </a:lnR>
                     <a:lnT w="9525" cap="flat" cmpd="sng" algn="ctr">
                       <a:solidFill>
-                        <a:srgbClr val="BFBFBF"/>
+                        <a:srgbClr val="9DC3E6"/>
                       </a:solidFill>
                       <a:prstDash val="solid"/>
                       <a:round/>
@@ -8301,7 +8301,7 @@
                     </a:lnT>
                     <a:lnB w="9525" cap="flat" cmpd="sng" algn="ctr">
                       <a:solidFill>
-                        <a:srgbClr val="BFBFBF"/>
+                        <a:srgbClr val="9DC3E6"/>
                       </a:solidFill>
                       <a:prstDash val="solid"/>
                       <a:round/>
@@ -8309,7 +8309,7 @@
                       <a:tailEnd type="none" w="med" len="med"/>
                     </a:lnB>
                     <a:solidFill>
-                      <a:srgbClr val="F2F2F2"/>
+                      <a:srgbClr val="1F4E79"/>
                     </a:solidFill>
                   </a:tcPr>
                 </a:tc>
@@ -8344,7 +8344,7 @@
                   <a:tcPr marL="54864" marR="54864" marT="54864" marB="54864" anchor="ctr">
                     <a:lnL w="9525" cap="flat" cmpd="sng" algn="ctr">
                       <a:solidFill>
-                        <a:srgbClr val="BFBFBF"/>
+                        <a:srgbClr val="9DC3E6"/>
                       </a:solidFill>
                       <a:prstDash val="solid"/>
                       <a:round/>
@@ -8353,7 +8353,7 @@
                     </a:lnL>
                     <a:lnR w="9525" cap="flat" cmpd="sng" algn="ctr">
                       <a:solidFill>
-                        <a:srgbClr val="BFBFBF"/>
+                        <a:srgbClr val="9DC3E6"/>
                       </a:solidFill>
                       <a:prstDash val="solid"/>
                       <a:round/>
@@ -8362,7 +8362,7 @@
                     </a:lnR>
                     <a:lnT w="9525" cap="flat" cmpd="sng" algn="ctr">
                       <a:solidFill>
-                        <a:srgbClr val="BFBFBF"/>
+                        <a:srgbClr val="9DC3E6"/>
                       </a:solidFill>
                       <a:prstDash val="solid"/>
                       <a:round/>
@@ -8371,7 +8371,7 @@
                     </a:lnT>
                     <a:lnB w="9525" cap="flat" cmpd="sng" algn="ctr">
                       <a:solidFill>
-                        <a:srgbClr val="BFBFBF"/>
+                        <a:srgbClr val="9DC3E6"/>
                       </a:solidFill>
                       <a:prstDash val="solid"/>
                       <a:round/>
@@ -8412,7 +8412,7 @@
                   <a:tcPr marL="54864" marR="54864" marT="54864" marB="54864" anchor="ctr">
                     <a:lnL w="9525" cap="flat" cmpd="sng" algn="ctr">
                       <a:solidFill>
-                        <a:srgbClr val="BFBFBF"/>
+                        <a:srgbClr val="9DC3E6"/>
                       </a:solidFill>
                       <a:prstDash val="solid"/>
                       <a:round/>
@@ -8421,7 +8421,7 @@
                     </a:lnL>
                     <a:lnR w="9525" cap="flat" cmpd="sng" algn="ctr">
                       <a:solidFill>
-                        <a:srgbClr val="BFBFBF"/>
+                        <a:srgbClr val="9DC3E6"/>
                       </a:solidFill>
                       <a:prstDash val="solid"/>
                       <a:round/>
@@ -8430,7 +8430,7 @@
                     </a:lnR>
                     <a:lnT w="9525" cap="flat" cmpd="sng" algn="ctr">
                       <a:solidFill>
-                        <a:srgbClr val="BFBFBF"/>
+                        <a:srgbClr val="9DC3E6"/>
                       </a:solidFill>
                       <a:prstDash val="solid"/>
                       <a:round/>
@@ -8439,7 +8439,7 @@
                     </a:lnT>
                     <a:lnB w="9525" cap="flat" cmpd="sng" algn="ctr">
                       <a:solidFill>
-                        <a:srgbClr val="BFBFBF"/>
+                        <a:srgbClr val="9DC3E6"/>
                       </a:solidFill>
                       <a:prstDash val="solid"/>
                       <a:round/>
@@ -8462,7 +8462,7 @@
                       <a:r>
                         <a:rPr lang="en-US" sz="1250" b="1" dirty="0">
                           <a:solidFill>
-                            <a:srgbClr val="000000"/>
+                            <a:srgbClr val="1F4E79"/>
                           </a:solidFill>
                           <a:latin typeface="David" pitchFamily="34" charset="0"/>
                           <a:ea typeface="David" pitchFamily="34" charset="-122"/>
@@ -8480,7 +8480,7 @@
                   <a:tcPr marL="54864" marR="54864" marT="54864" marB="54864" anchor="ctr">
                     <a:lnL w="9525" cap="flat" cmpd="sng" algn="ctr">
                       <a:solidFill>
-                        <a:srgbClr val="BFBFBF"/>
+                        <a:srgbClr val="9DC3E6"/>
                       </a:solidFill>
                       <a:prstDash val="solid"/>
                       <a:round/>
@@ -8489,7 +8489,7 @@
                     </a:lnL>
                     <a:lnR w="9525" cap="flat" cmpd="sng" algn="ctr">
                       <a:solidFill>
-                        <a:srgbClr val="BFBFBF"/>
+                        <a:srgbClr val="9DC3E6"/>
                       </a:solidFill>
                       <a:prstDash val="solid"/>
                       <a:round/>
@@ -8498,7 +8498,7 @@
                     </a:lnR>
                     <a:lnT w="9525" cap="flat" cmpd="sng" algn="ctr">
                       <a:solidFill>
-                        <a:srgbClr val="BFBFBF"/>
+                        <a:srgbClr val="9DC3E6"/>
                       </a:solidFill>
                       <a:prstDash val="solid"/>
                       <a:round/>
@@ -8507,7 +8507,7 @@
                     </a:lnT>
                     <a:lnB w="9525" cap="flat" cmpd="sng" algn="ctr">
                       <a:solidFill>
-                        <a:srgbClr val="BFBFBF"/>
+                        <a:srgbClr val="9DC3E6"/>
                       </a:solidFill>
                       <a:prstDash val="solid"/>
                       <a:round/>
@@ -8515,7 +8515,7 @@
                       <a:tailEnd type="none" w="med" len="med"/>
                     </a:lnB>
                     <a:solidFill>
-                      <a:srgbClr val="FFFFFF"/>
+                      <a:srgbClr val="DEEAF6"/>
                     </a:solidFill>
                   </a:tcPr>
                 </a:tc>
@@ -8550,7 +8550,7 @@
                   <a:tcPr marL="54864" marR="54864" marT="54864" marB="54864" anchor="ctr">
                     <a:lnL w="9525" cap="flat" cmpd="sng" algn="ctr">
                       <a:solidFill>
-                        <a:srgbClr val="BFBFBF"/>
+                        <a:srgbClr val="9DC3E6"/>
                       </a:solidFill>
                       <a:prstDash val="solid"/>
                       <a:round/>
@@ -8559,7 +8559,7 @@
                     </a:lnL>
                     <a:lnR w="9525" cap="flat" cmpd="sng" algn="ctr">
                       <a:solidFill>
-                        <a:srgbClr val="BFBFBF"/>
+                        <a:srgbClr val="9DC3E6"/>
                       </a:solidFill>
                       <a:prstDash val="solid"/>
                       <a:round/>
@@ -8568,7 +8568,7 @@
                     </a:lnR>
                     <a:lnT w="9525" cap="flat" cmpd="sng" algn="ctr">
                       <a:solidFill>
-                        <a:srgbClr val="BFBFBF"/>
+                        <a:srgbClr val="9DC3E6"/>
                       </a:solidFill>
                       <a:prstDash val="solid"/>
                       <a:round/>
@@ -8577,7 +8577,7 @@
                     </a:lnT>
                     <a:lnB w="9525" cap="flat" cmpd="sng" algn="ctr">
                       <a:solidFill>
-                        <a:srgbClr val="BFBFBF"/>
+                        <a:srgbClr val="9DC3E6"/>
                       </a:solidFill>
                       <a:prstDash val="solid"/>
                       <a:round/>
@@ -8585,7 +8585,7 @@
                       <a:tailEnd type="none" w="med" len="med"/>
                     </a:lnB>
                     <a:solidFill>
-                      <a:srgbClr val="FFFFFF"/>
+                      <a:srgbClr val="F5F8FC"/>
                     </a:solidFill>
                   </a:tcPr>
                 </a:tc>
@@ -8618,7 +8618,7 @@
                   <a:tcPr marL="54864" marR="54864" marT="54864" marB="54864" anchor="ctr">
                     <a:lnL w="9525" cap="flat" cmpd="sng" algn="ctr">
                       <a:solidFill>
-                        <a:srgbClr val="BFBFBF"/>
+                        <a:srgbClr val="9DC3E6"/>
                       </a:solidFill>
                       <a:prstDash val="solid"/>
                       <a:round/>
@@ -8627,7 +8627,7 @@
                     </a:lnL>
                     <a:lnR w="9525" cap="flat" cmpd="sng" algn="ctr">
                       <a:solidFill>
-                        <a:srgbClr val="BFBFBF"/>
+                        <a:srgbClr val="9DC3E6"/>
                       </a:solidFill>
                       <a:prstDash val="solid"/>
                       <a:round/>
@@ -8636,7 +8636,7 @@
                     </a:lnR>
                     <a:lnT w="9525" cap="flat" cmpd="sng" algn="ctr">
                       <a:solidFill>
-                        <a:srgbClr val="BFBFBF"/>
+                        <a:srgbClr val="9DC3E6"/>
                       </a:solidFill>
                       <a:prstDash val="solid"/>
                       <a:round/>
@@ -8645,7 +8645,7 @@
                     </a:lnT>
                     <a:lnB w="9525" cap="flat" cmpd="sng" algn="ctr">
                       <a:solidFill>
-                        <a:srgbClr val="BFBFBF"/>
+                        <a:srgbClr val="9DC3E6"/>
                       </a:solidFill>
                       <a:prstDash val="solid"/>
                       <a:round/>
@@ -8653,7 +8653,7 @@
                       <a:tailEnd type="none" w="med" len="med"/>
                     </a:lnB>
                     <a:solidFill>
-                      <a:srgbClr val="FFFFFF"/>
+                      <a:srgbClr val="F5F8FC"/>
                     </a:solidFill>
                   </a:tcPr>
                 </a:tc>
@@ -8668,7 +8668,7 @@
                       <a:r>
                         <a:rPr lang="en-US" sz="1250" b="1" dirty="0">
                           <a:solidFill>
-                            <a:srgbClr val="000000"/>
+                            <a:srgbClr val="1F4E79"/>
                           </a:solidFill>
                           <a:latin typeface="David" pitchFamily="34" charset="0"/>
                           <a:ea typeface="David" pitchFamily="34" charset="-122"/>
@@ -8686,7 +8686,7 @@
                   <a:tcPr marL="54864" marR="54864" marT="54864" marB="54864" anchor="ctr">
                     <a:lnL w="9525" cap="flat" cmpd="sng" algn="ctr">
                       <a:solidFill>
-                        <a:srgbClr val="BFBFBF"/>
+                        <a:srgbClr val="9DC3E6"/>
                       </a:solidFill>
                       <a:prstDash val="solid"/>
                       <a:round/>
@@ -8695,7 +8695,7 @@
                     </a:lnL>
                     <a:lnR w="9525" cap="flat" cmpd="sng" algn="ctr">
                       <a:solidFill>
-                        <a:srgbClr val="BFBFBF"/>
+                        <a:srgbClr val="9DC3E6"/>
                       </a:solidFill>
                       <a:prstDash val="solid"/>
                       <a:round/>
@@ -8704,7 +8704,7 @@
                     </a:lnR>
                     <a:lnT w="9525" cap="flat" cmpd="sng" algn="ctr">
                       <a:solidFill>
-                        <a:srgbClr val="BFBFBF"/>
+                        <a:srgbClr val="9DC3E6"/>
                       </a:solidFill>
                       <a:prstDash val="solid"/>
                       <a:round/>
@@ -8713,7 +8713,7 @@
                     </a:lnT>
                     <a:lnB w="9525" cap="flat" cmpd="sng" algn="ctr">
                       <a:solidFill>
-                        <a:srgbClr val="BFBFBF"/>
+                        <a:srgbClr val="9DC3E6"/>
                       </a:solidFill>
                       <a:prstDash val="solid"/>
                       <a:round/>
@@ -8721,7 +8721,7 @@
                       <a:tailEnd type="none" w="med" len="med"/>
                     </a:lnB>
                     <a:solidFill>
-                      <a:srgbClr val="FFFFFF"/>
+                      <a:srgbClr val="DEEAF6"/>
                     </a:solidFill>
                   </a:tcPr>
                 </a:tc>
@@ -8756,7 +8756,7 @@
                   <a:tcPr marL="54864" marR="54864" marT="54864" marB="54864" anchor="ctr">
                     <a:lnL w="9525" cap="flat" cmpd="sng" algn="ctr">
                       <a:solidFill>
-                        <a:srgbClr val="BFBFBF"/>
+                        <a:srgbClr val="9DC3E6"/>
                       </a:solidFill>
                       <a:prstDash val="solid"/>
                       <a:round/>
@@ -8765,7 +8765,7 @@
                     </a:lnL>
                     <a:lnR w="9525" cap="flat" cmpd="sng" algn="ctr">
                       <a:solidFill>
-                        <a:srgbClr val="BFBFBF"/>
+                        <a:srgbClr val="9DC3E6"/>
                       </a:solidFill>
                       <a:prstDash val="solid"/>
                       <a:round/>
@@ -8774,7 +8774,7 @@
                     </a:lnR>
                     <a:lnT w="9525" cap="flat" cmpd="sng" algn="ctr">
                       <a:solidFill>
-                        <a:srgbClr val="BFBFBF"/>
+                        <a:srgbClr val="9DC3E6"/>
                       </a:solidFill>
                       <a:prstDash val="solid"/>
                       <a:round/>
@@ -8783,7 +8783,7 @@
                     </a:lnT>
                     <a:lnB w="9525" cap="flat" cmpd="sng" algn="ctr">
                       <a:solidFill>
-                        <a:srgbClr val="BFBFBF"/>
+                        <a:srgbClr val="9DC3E6"/>
                       </a:solidFill>
                       <a:prstDash val="solid"/>
                       <a:round/>
@@ -8824,7 +8824,7 @@
                   <a:tcPr marL="54864" marR="54864" marT="54864" marB="54864" anchor="ctr">
                     <a:lnL w="9525" cap="flat" cmpd="sng" algn="ctr">
                       <a:solidFill>
-                        <a:srgbClr val="BFBFBF"/>
+                        <a:srgbClr val="9DC3E6"/>
                       </a:solidFill>
                       <a:prstDash val="solid"/>
                       <a:round/>
@@ -8833,7 +8833,7 @@
                     </a:lnL>
                     <a:lnR w="9525" cap="flat" cmpd="sng" algn="ctr">
                       <a:solidFill>
-                        <a:srgbClr val="BFBFBF"/>
+                        <a:srgbClr val="9DC3E6"/>
                       </a:solidFill>
                       <a:prstDash val="solid"/>
                       <a:round/>
@@ -8842,7 +8842,7 @@
                     </a:lnR>
                     <a:lnT w="9525" cap="flat" cmpd="sng" algn="ctr">
                       <a:solidFill>
-                        <a:srgbClr val="BFBFBF"/>
+                        <a:srgbClr val="9DC3E6"/>
                       </a:solidFill>
                       <a:prstDash val="solid"/>
                       <a:round/>
@@ -8851,7 +8851,7 @@
                     </a:lnT>
                     <a:lnB w="9525" cap="flat" cmpd="sng" algn="ctr">
                       <a:solidFill>
-                        <a:srgbClr val="BFBFBF"/>
+                        <a:srgbClr val="9DC3E6"/>
                       </a:solidFill>
                       <a:prstDash val="solid"/>
                       <a:round/>
@@ -8874,7 +8874,7 @@
                       <a:r>
                         <a:rPr lang="en-US" sz="1250" b="1" dirty="0">
                           <a:solidFill>
-                            <a:srgbClr val="000000"/>
+                            <a:srgbClr val="1F4E79"/>
                           </a:solidFill>
                           <a:latin typeface="David" pitchFamily="34" charset="0"/>
                           <a:ea typeface="David" pitchFamily="34" charset="-122"/>
@@ -8892,7 +8892,7 @@
                   <a:tcPr marL="54864" marR="54864" marT="54864" marB="54864" anchor="ctr">
                     <a:lnL w="9525" cap="flat" cmpd="sng" algn="ctr">
                       <a:solidFill>
-                        <a:srgbClr val="BFBFBF"/>
+                        <a:srgbClr val="9DC3E6"/>
                       </a:solidFill>
                       <a:prstDash val="solid"/>
                       <a:round/>
@@ -8901,7 +8901,7 @@
                     </a:lnL>
                     <a:lnR w="9525" cap="flat" cmpd="sng" algn="ctr">
                       <a:solidFill>
-                        <a:srgbClr val="BFBFBF"/>
+                        <a:srgbClr val="9DC3E6"/>
                       </a:solidFill>
                       <a:prstDash val="solid"/>
                       <a:round/>
@@ -8910,7 +8910,7 @@
                     </a:lnR>
                     <a:lnT w="9525" cap="flat" cmpd="sng" algn="ctr">
                       <a:solidFill>
-                        <a:srgbClr val="BFBFBF"/>
+                        <a:srgbClr val="9DC3E6"/>
                       </a:solidFill>
                       <a:prstDash val="solid"/>
                       <a:round/>
@@ -8919,7 +8919,7 @@
                     </a:lnT>
                     <a:lnB w="9525" cap="flat" cmpd="sng" algn="ctr">
                       <a:solidFill>
-                        <a:srgbClr val="BFBFBF"/>
+                        <a:srgbClr val="9DC3E6"/>
                       </a:solidFill>
                       <a:prstDash val="solid"/>
                       <a:round/>
@@ -8927,7 +8927,7 @@
                       <a:tailEnd type="none" w="med" len="med"/>
                     </a:lnB>
                     <a:solidFill>
-                      <a:srgbClr val="FFFFFF"/>
+                      <a:srgbClr val="DEEAF6"/>
                     </a:solidFill>
                   </a:tcPr>
                 </a:tc>
@@ -9005,7 +9005,7 @@
             <a:r>
               <a:rPr lang="he-IL" altLang="en-US" sz="1000" dirty="0">
                 <a:solidFill>
-                  <a:srgbClr val="595959"/>
+                  <a:srgbClr val="1F4E79"/>
                 </a:solidFill>
                 <a:latin typeface="David" pitchFamily="34" charset="0"/>
                 <a:ea typeface="David" pitchFamily="34" charset="-122"/>
@@ -9108,7 +9108,7 @@
             <a:r>
               <a:rPr lang="he-IL" altLang="en-US" sz="2800" b="1" dirty="0">
                 <a:solidFill>
-                  <a:srgbClr val="000000"/>
+                  <a:srgbClr val="1F4E79"/>
                 </a:solidFill>
                 <a:latin typeface="David" pitchFamily="34" charset="0"/>
                 <a:ea typeface="David" pitchFamily="34" charset="-122"/>
@@ -9231,7 +9231,7 @@
             <a:r>
               <a:rPr lang="he-IL" altLang="en-US" sz="1000" dirty="0">
                 <a:solidFill>
-                  <a:srgbClr val="595959"/>
+                  <a:srgbClr val="1F4E79"/>
                 </a:solidFill>
                 <a:latin typeface="David" pitchFamily="34" charset="0"/>
                 <a:ea typeface="David" pitchFamily="34" charset="-122"/>
@@ -9334,7 +9334,7 @@
             <a:r>
               <a:rPr lang="he-IL" altLang="en-US" sz="2800" b="1" dirty="0">
                 <a:solidFill>
-                  <a:srgbClr val="000000"/>
+                  <a:srgbClr val="1F4E79"/>
                 </a:solidFill>
                 <a:latin typeface="David" pitchFamily="34" charset="0"/>
                 <a:ea typeface="David" pitchFamily="34" charset="-122"/>
@@ -9426,7 +9426,7 @@
                       <a:r>
                         <a:rPr lang="en-US" sz="1300" b="1" dirty="0">
                           <a:solidFill>
-                            <a:srgbClr val="000000"/>
+                            <a:srgbClr val="FFFFFF"/>
                           </a:solidFill>
                           <a:latin typeface="David" pitchFamily="34" charset="0"/>
                           <a:ea typeface="David" pitchFamily="34" charset="-122"/>
@@ -9444,7 +9444,7 @@
                   <a:tcPr marL="54864" marR="54864" marT="54864" marB="54864" anchor="ctr">
                     <a:lnL w="9525" cap="flat" cmpd="sng" algn="ctr">
                       <a:solidFill>
-                        <a:srgbClr val="BFBFBF"/>
+                        <a:srgbClr val="9DC3E6"/>
                       </a:solidFill>
                       <a:prstDash val="solid"/>
                       <a:round/>
@@ -9453,7 +9453,7 @@
                     </a:lnL>
                     <a:lnR w="9525" cap="flat" cmpd="sng" algn="ctr">
                       <a:solidFill>
-                        <a:srgbClr val="BFBFBF"/>
+                        <a:srgbClr val="9DC3E6"/>
                       </a:solidFill>
                       <a:prstDash val="solid"/>
                       <a:round/>
@@ -9462,7 +9462,7 @@
                     </a:lnR>
                     <a:lnT w="9525" cap="flat" cmpd="sng" algn="ctr">
                       <a:solidFill>
-                        <a:srgbClr val="BFBFBF"/>
+                        <a:srgbClr val="9DC3E6"/>
                       </a:solidFill>
                       <a:prstDash val="solid"/>
                       <a:round/>
@@ -9471,7 +9471,7 @@
                     </a:lnT>
                     <a:lnB w="9525" cap="flat" cmpd="sng" algn="ctr">
                       <a:solidFill>
-                        <a:srgbClr val="BFBFBF"/>
+                        <a:srgbClr val="9DC3E6"/>
                       </a:solidFill>
                       <a:prstDash val="solid"/>
                       <a:round/>
@@ -9479,7 +9479,7 @@
                       <a:tailEnd type="none" w="med" len="med"/>
                     </a:lnB>
                     <a:solidFill>
-                      <a:srgbClr val="F2F2F2"/>
+                      <a:srgbClr val="1F4E79"/>
                     </a:solidFill>
                   </a:tcPr>
                 </a:tc>
@@ -9494,7 +9494,7 @@
                       <a:r>
                         <a:rPr lang="en-US" sz="1300" b="1" dirty="0">
                           <a:solidFill>
-                            <a:srgbClr val="000000"/>
+                            <a:srgbClr val="FFFFFF"/>
                           </a:solidFill>
                           <a:latin typeface="David" pitchFamily="34" charset="0"/>
                           <a:ea typeface="David" pitchFamily="34" charset="-122"/>
@@ -9512,7 +9512,7 @@
                   <a:tcPr marL="54864" marR="54864" marT="54864" marB="54864" anchor="ctr">
                     <a:lnL w="9525" cap="flat" cmpd="sng" algn="ctr">
                       <a:solidFill>
-                        <a:srgbClr val="BFBFBF"/>
+                        <a:srgbClr val="9DC3E6"/>
                       </a:solidFill>
                       <a:prstDash val="solid"/>
                       <a:round/>
@@ -9521,7 +9521,7 @@
                     </a:lnL>
                     <a:lnR w="9525" cap="flat" cmpd="sng" algn="ctr">
                       <a:solidFill>
-                        <a:srgbClr val="BFBFBF"/>
+                        <a:srgbClr val="9DC3E6"/>
                       </a:solidFill>
                       <a:prstDash val="solid"/>
                       <a:round/>
@@ -9530,7 +9530,7 @@
                     </a:lnR>
                     <a:lnT w="9525" cap="flat" cmpd="sng" algn="ctr">
                       <a:solidFill>
-                        <a:srgbClr val="BFBFBF"/>
+                        <a:srgbClr val="9DC3E6"/>
                       </a:solidFill>
                       <a:prstDash val="solid"/>
                       <a:round/>
@@ -9539,7 +9539,7 @@
                     </a:lnT>
                     <a:lnB w="9525" cap="flat" cmpd="sng" algn="ctr">
                       <a:solidFill>
-                        <a:srgbClr val="BFBFBF"/>
+                        <a:srgbClr val="9DC3E6"/>
                       </a:solidFill>
                       <a:prstDash val="solid"/>
                       <a:round/>
@@ -9547,7 +9547,7 @@
                       <a:tailEnd type="none" w="med" len="med"/>
                     </a:lnB>
                     <a:solidFill>
-                      <a:srgbClr val="F2F2F2"/>
+                      <a:srgbClr val="1F4E79"/>
                     </a:solidFill>
                   </a:tcPr>
                 </a:tc>
@@ -9582,7 +9582,7 @@
                   <a:tcPr marL="54864" marR="54864" marT="54864" marB="54864" anchor="ctr">
                     <a:lnL w="9525" cap="flat" cmpd="sng" algn="ctr">
                       <a:solidFill>
-                        <a:srgbClr val="BFBFBF"/>
+                        <a:srgbClr val="9DC3E6"/>
                       </a:solidFill>
                       <a:prstDash val="solid"/>
                       <a:round/>
@@ -9591,7 +9591,7 @@
                     </a:lnL>
                     <a:lnR w="9525" cap="flat" cmpd="sng" algn="ctr">
                       <a:solidFill>
-                        <a:srgbClr val="BFBFBF"/>
+                        <a:srgbClr val="9DC3E6"/>
                       </a:solidFill>
                       <a:prstDash val="solid"/>
                       <a:round/>
@@ -9600,7 +9600,7 @@
                     </a:lnR>
                     <a:lnT w="9525" cap="flat" cmpd="sng" algn="ctr">
                       <a:solidFill>
-                        <a:srgbClr val="BFBFBF"/>
+                        <a:srgbClr val="9DC3E6"/>
                       </a:solidFill>
                       <a:prstDash val="solid"/>
                       <a:round/>
@@ -9609,7 +9609,7 @@
                     </a:lnT>
                     <a:lnB w="9525" cap="flat" cmpd="sng" algn="ctr">
                       <a:solidFill>
-                        <a:srgbClr val="BFBFBF"/>
+                        <a:srgbClr val="9DC3E6"/>
                       </a:solidFill>
                       <a:prstDash val="solid"/>
                       <a:round/>
@@ -9632,7 +9632,7 @@
                       <a:r>
                         <a:rPr lang="en-US" sz="1250" b="1" dirty="0">
                           <a:solidFill>
-                            <a:srgbClr val="000000"/>
+                            <a:srgbClr val="1F4E79"/>
                           </a:solidFill>
                           <a:latin typeface="David" pitchFamily="34" charset="0"/>
                           <a:ea typeface="David" pitchFamily="34" charset="-122"/>
@@ -9650,7 +9650,7 @@
                   <a:tcPr marL="54864" marR="54864" marT="54864" marB="54864" anchor="ctr">
                     <a:lnL w="9525" cap="flat" cmpd="sng" algn="ctr">
                       <a:solidFill>
-                        <a:srgbClr val="BFBFBF"/>
+                        <a:srgbClr val="9DC3E6"/>
                       </a:solidFill>
                       <a:prstDash val="solid"/>
                       <a:round/>
@@ -9659,7 +9659,7 @@
                     </a:lnL>
                     <a:lnR w="9525" cap="flat" cmpd="sng" algn="ctr">
                       <a:solidFill>
-                        <a:srgbClr val="BFBFBF"/>
+                        <a:srgbClr val="9DC3E6"/>
                       </a:solidFill>
                       <a:prstDash val="solid"/>
                       <a:round/>
@@ -9668,7 +9668,7 @@
                     </a:lnR>
                     <a:lnT w="9525" cap="flat" cmpd="sng" algn="ctr">
                       <a:solidFill>
-                        <a:srgbClr val="BFBFBF"/>
+                        <a:srgbClr val="9DC3E6"/>
                       </a:solidFill>
                       <a:prstDash val="solid"/>
                       <a:round/>
@@ -9677,7 +9677,7 @@
                     </a:lnT>
                     <a:lnB w="9525" cap="flat" cmpd="sng" algn="ctr">
                       <a:solidFill>
-                        <a:srgbClr val="BFBFBF"/>
+                        <a:srgbClr val="9DC3E6"/>
                       </a:solidFill>
                       <a:prstDash val="solid"/>
                       <a:round/>
@@ -9685,7 +9685,7 @@
                       <a:tailEnd type="none" w="med" len="med"/>
                     </a:lnB>
                     <a:solidFill>
-                      <a:srgbClr val="FFFFFF"/>
+                      <a:srgbClr val="DEEAF6"/>
                     </a:solidFill>
                   </a:tcPr>
                 </a:tc>
@@ -9720,7 +9720,7 @@
                   <a:tcPr marL="54864" marR="54864" marT="54864" marB="54864" anchor="ctr">
                     <a:lnL w="9525" cap="flat" cmpd="sng" algn="ctr">
                       <a:solidFill>
-                        <a:srgbClr val="BFBFBF"/>
+                        <a:srgbClr val="9DC3E6"/>
                       </a:solidFill>
                       <a:prstDash val="solid"/>
                       <a:round/>
@@ -9729,7 +9729,7 @@
                     </a:lnL>
                     <a:lnR w="9525" cap="flat" cmpd="sng" algn="ctr">
                       <a:solidFill>
-                        <a:srgbClr val="BFBFBF"/>
+                        <a:srgbClr val="9DC3E6"/>
                       </a:solidFill>
                       <a:prstDash val="solid"/>
                       <a:round/>
@@ -9738,7 +9738,7 @@
                     </a:lnR>
                     <a:lnT w="9525" cap="flat" cmpd="sng" algn="ctr">
                       <a:solidFill>
-                        <a:srgbClr val="BFBFBF"/>
+                        <a:srgbClr val="9DC3E6"/>
                       </a:solidFill>
                       <a:prstDash val="solid"/>
                       <a:round/>
@@ -9747,7 +9747,7 @@
                     </a:lnT>
                     <a:lnB w="9525" cap="flat" cmpd="sng" algn="ctr">
                       <a:solidFill>
-                        <a:srgbClr val="BFBFBF"/>
+                        <a:srgbClr val="9DC3E6"/>
                       </a:solidFill>
                       <a:prstDash val="solid"/>
                       <a:round/>
@@ -9755,7 +9755,7 @@
                       <a:tailEnd type="none" w="med" len="med"/>
                     </a:lnB>
                     <a:solidFill>
-                      <a:srgbClr val="FFFFFF"/>
+                      <a:srgbClr val="F5F8FC"/>
                     </a:solidFill>
                   </a:tcPr>
                 </a:tc>
@@ -9770,7 +9770,7 @@
                       <a:r>
                         <a:rPr lang="en-US" sz="1250" b="1" dirty="0">
                           <a:solidFill>
-                            <a:srgbClr val="000000"/>
+                            <a:srgbClr val="1F4E79"/>
                           </a:solidFill>
                           <a:latin typeface="David" pitchFamily="34" charset="0"/>
                           <a:ea typeface="David" pitchFamily="34" charset="-122"/>
@@ -9788,7 +9788,7 @@
                   <a:tcPr marL="54864" marR="54864" marT="54864" marB="54864" anchor="ctr">
                     <a:lnL w="9525" cap="flat" cmpd="sng" algn="ctr">
                       <a:solidFill>
-                        <a:srgbClr val="BFBFBF"/>
+                        <a:srgbClr val="9DC3E6"/>
                       </a:solidFill>
                       <a:prstDash val="solid"/>
                       <a:round/>
@@ -9797,7 +9797,7 @@
                     </a:lnL>
                     <a:lnR w="9525" cap="flat" cmpd="sng" algn="ctr">
                       <a:solidFill>
-                        <a:srgbClr val="BFBFBF"/>
+                        <a:srgbClr val="9DC3E6"/>
                       </a:solidFill>
                       <a:prstDash val="solid"/>
                       <a:round/>
@@ -9806,7 +9806,7 @@
                     </a:lnR>
                     <a:lnT w="9525" cap="flat" cmpd="sng" algn="ctr">
                       <a:solidFill>
-                        <a:srgbClr val="BFBFBF"/>
+                        <a:srgbClr val="9DC3E6"/>
                       </a:solidFill>
                       <a:prstDash val="solid"/>
                       <a:round/>
@@ -9815,7 +9815,7 @@
                     </a:lnT>
                     <a:lnB w="9525" cap="flat" cmpd="sng" algn="ctr">
                       <a:solidFill>
-                        <a:srgbClr val="BFBFBF"/>
+                        <a:srgbClr val="9DC3E6"/>
                       </a:solidFill>
                       <a:prstDash val="solid"/>
                       <a:round/>
@@ -9823,7 +9823,7 @@
                       <a:tailEnd type="none" w="med" len="med"/>
                     </a:lnB>
                     <a:solidFill>
-                      <a:srgbClr val="FFFFFF"/>
+                      <a:srgbClr val="DEEAF6"/>
                     </a:solidFill>
                   </a:tcPr>
                 </a:tc>
@@ -9858,7 +9858,7 @@
                   <a:tcPr marL="54864" marR="54864" marT="54864" marB="54864" anchor="ctr">
                     <a:lnL w="9525" cap="flat" cmpd="sng" algn="ctr">
                       <a:solidFill>
-                        <a:srgbClr val="BFBFBF"/>
+                        <a:srgbClr val="9DC3E6"/>
                       </a:solidFill>
                       <a:prstDash val="solid"/>
                       <a:round/>
@@ -9867,7 +9867,7 @@
                     </a:lnL>
                     <a:lnR w="9525" cap="flat" cmpd="sng" algn="ctr">
                       <a:solidFill>
-                        <a:srgbClr val="BFBFBF"/>
+                        <a:srgbClr val="9DC3E6"/>
                       </a:solidFill>
                       <a:prstDash val="solid"/>
                       <a:round/>
@@ -9876,7 +9876,7 @@
                     </a:lnR>
                     <a:lnT w="9525" cap="flat" cmpd="sng" algn="ctr">
                       <a:solidFill>
-                        <a:srgbClr val="BFBFBF"/>
+                        <a:srgbClr val="9DC3E6"/>
                       </a:solidFill>
                       <a:prstDash val="solid"/>
                       <a:round/>
@@ -9885,7 +9885,7 @@
                     </a:lnT>
                     <a:lnB w="9525" cap="flat" cmpd="sng" algn="ctr">
                       <a:solidFill>
-                        <a:srgbClr val="BFBFBF"/>
+                        <a:srgbClr val="9DC3E6"/>
                       </a:solidFill>
                       <a:prstDash val="solid"/>
                       <a:round/>
@@ -9908,7 +9908,7 @@
                       <a:r>
                         <a:rPr lang="en-US" sz="1250" b="1" dirty="0">
                           <a:solidFill>
-                            <a:srgbClr val="000000"/>
+                            <a:srgbClr val="1F4E79"/>
                           </a:solidFill>
                           <a:latin typeface="David" pitchFamily="34" charset="0"/>
                           <a:ea typeface="David" pitchFamily="34" charset="-122"/>
@@ -9926,7 +9926,7 @@
                   <a:tcPr marL="54864" marR="54864" marT="54864" marB="54864" anchor="ctr">
                     <a:lnL w="9525" cap="flat" cmpd="sng" algn="ctr">
                       <a:solidFill>
-                        <a:srgbClr val="BFBFBF"/>
+                        <a:srgbClr val="9DC3E6"/>
                       </a:solidFill>
                       <a:prstDash val="solid"/>
                       <a:round/>
@@ -9935,7 +9935,7 @@
                     </a:lnL>
                     <a:lnR w="9525" cap="flat" cmpd="sng" algn="ctr">
                       <a:solidFill>
-                        <a:srgbClr val="BFBFBF"/>
+                        <a:srgbClr val="9DC3E6"/>
                       </a:solidFill>
                       <a:prstDash val="solid"/>
                       <a:round/>
@@ -9944,7 +9944,7 @@
                     </a:lnR>
                     <a:lnT w="9525" cap="flat" cmpd="sng" algn="ctr">
                       <a:solidFill>
-                        <a:srgbClr val="BFBFBF"/>
+                        <a:srgbClr val="9DC3E6"/>
                       </a:solidFill>
                       <a:prstDash val="solid"/>
                       <a:round/>
@@ -9953,7 +9953,7 @@
                     </a:lnT>
                     <a:lnB w="9525" cap="flat" cmpd="sng" algn="ctr">
                       <a:solidFill>
-                        <a:srgbClr val="BFBFBF"/>
+                        <a:srgbClr val="9DC3E6"/>
                       </a:solidFill>
                       <a:prstDash val="solid"/>
                       <a:round/>
@@ -9961,7 +9961,7 @@
                       <a:tailEnd type="none" w="med" len="med"/>
                     </a:lnB>
                     <a:solidFill>
-                      <a:srgbClr val="FFFFFF"/>
+                      <a:srgbClr val="DEEAF6"/>
                     </a:solidFill>
                   </a:tcPr>
                 </a:tc>
@@ -9996,7 +9996,7 @@
                   <a:tcPr marL="54864" marR="54864" marT="54864" marB="54864" anchor="ctr">
                     <a:lnL w="9525" cap="flat" cmpd="sng" algn="ctr">
                       <a:solidFill>
-                        <a:srgbClr val="BFBFBF"/>
+                        <a:srgbClr val="9DC3E6"/>
                       </a:solidFill>
                       <a:prstDash val="solid"/>
                       <a:round/>
@@ -10005,7 +10005,7 @@
                     </a:lnL>
                     <a:lnR w="9525" cap="flat" cmpd="sng" algn="ctr">
                       <a:solidFill>
-                        <a:srgbClr val="BFBFBF"/>
+                        <a:srgbClr val="9DC3E6"/>
                       </a:solidFill>
                       <a:prstDash val="solid"/>
                       <a:round/>
@@ -10014,7 +10014,7 @@
                     </a:lnR>
                     <a:lnT w="9525" cap="flat" cmpd="sng" algn="ctr">
                       <a:solidFill>
-                        <a:srgbClr val="BFBFBF"/>
+                        <a:srgbClr val="9DC3E6"/>
                       </a:solidFill>
                       <a:prstDash val="solid"/>
                       <a:round/>
@@ -10023,7 +10023,7 @@
                     </a:lnT>
                     <a:lnB w="9525" cap="flat" cmpd="sng" algn="ctr">
                       <a:solidFill>
-                        <a:srgbClr val="BFBFBF"/>
+                        <a:srgbClr val="9DC3E6"/>
                       </a:solidFill>
                       <a:prstDash val="solid"/>
                       <a:round/>
@@ -10031,7 +10031,7 @@
                       <a:tailEnd type="none" w="med" len="med"/>
                     </a:lnB>
                     <a:solidFill>
-                      <a:srgbClr val="FFFFFF"/>
+                      <a:srgbClr val="F5F8FC"/>
                     </a:solidFill>
                   </a:tcPr>
                 </a:tc>
@@ -10046,7 +10046,7 @@
                       <a:r>
                         <a:rPr lang="en-US" sz="1250" b="1" dirty="0">
                           <a:solidFill>
-                            <a:srgbClr val="000000"/>
+                            <a:srgbClr val="1F4E79"/>
                           </a:solidFill>
                           <a:latin typeface="David" pitchFamily="34" charset="0"/>
                           <a:ea typeface="David" pitchFamily="34" charset="-122"/>
@@ -10064,7 +10064,7 @@
                   <a:tcPr marL="54864" marR="54864" marT="54864" marB="54864" anchor="ctr">
                     <a:lnL w="9525" cap="flat" cmpd="sng" algn="ctr">
                       <a:solidFill>
-                        <a:srgbClr val="BFBFBF"/>
+                        <a:srgbClr val="9DC3E6"/>
                       </a:solidFill>
                       <a:prstDash val="solid"/>
                       <a:round/>
@@ -10073,7 +10073,7 @@
                     </a:lnL>
                     <a:lnR w="9525" cap="flat" cmpd="sng" algn="ctr">
                       <a:solidFill>
-                        <a:srgbClr val="BFBFBF"/>
+                        <a:srgbClr val="9DC3E6"/>
                       </a:solidFill>
                       <a:prstDash val="solid"/>
                       <a:round/>
@@ -10082,7 +10082,7 @@
                     </a:lnR>
                     <a:lnT w="9525" cap="flat" cmpd="sng" algn="ctr">
                       <a:solidFill>
-                        <a:srgbClr val="BFBFBF"/>
+                        <a:srgbClr val="9DC3E6"/>
                       </a:solidFill>
                       <a:prstDash val="solid"/>
                       <a:round/>
@@ -10091,7 +10091,7 @@
                     </a:lnT>
                     <a:lnB w="9525" cap="flat" cmpd="sng" algn="ctr">
                       <a:solidFill>
-                        <a:srgbClr val="BFBFBF"/>
+                        <a:srgbClr val="9DC3E6"/>
                       </a:solidFill>
                       <a:prstDash val="solid"/>
                       <a:round/>
@@ -10099,7 +10099,7 @@
                       <a:tailEnd type="none" w="med" len="med"/>
                     </a:lnB>
                     <a:solidFill>
-                      <a:srgbClr val="FFFFFF"/>
+                      <a:srgbClr val="DEEAF6"/>
                     </a:solidFill>
                   </a:tcPr>
                 </a:tc>
@@ -10135,7 +10135,7 @@
             <a:r>
               <a:rPr lang="he-IL" altLang="en-US" sz="1000" dirty="0">
                 <a:solidFill>
-                  <a:srgbClr val="595959"/>
+                  <a:srgbClr val="1F4E79"/>
                 </a:solidFill>
                 <a:latin typeface="David" pitchFamily="34" charset="0"/>
                 <a:ea typeface="David" pitchFamily="34" charset="-122"/>
@@ -10238,7 +10238,7 @@
             <a:r>
               <a:rPr lang="he-IL" altLang="en-US" sz="2800" b="1" dirty="0">
                 <a:solidFill>
-                  <a:srgbClr val="000000"/>
+                  <a:srgbClr val="1F4E79"/>
                 </a:solidFill>
                 <a:latin typeface="David" pitchFamily="34" charset="0"/>
                 <a:ea typeface="David" pitchFamily="34" charset="-122"/>
@@ -10347,7 +10347,7 @@
                       <a:r>
                         <a:rPr lang="en-US" sz="1300" b="1" dirty="0">
                           <a:solidFill>
-                            <a:srgbClr val="000000"/>
+                            <a:srgbClr val="FFFFFF"/>
                           </a:solidFill>
                           <a:latin typeface="David" pitchFamily="34" charset="0"/>
                           <a:ea typeface="David" pitchFamily="34" charset="-122"/>
@@ -10365,7 +10365,7 @@
                   <a:tcPr marL="54864" marR="54864" marT="54864" marB="54864" anchor="ctr">
                     <a:lnL w="9525" cap="flat" cmpd="sng" algn="ctr">
                       <a:solidFill>
-                        <a:srgbClr val="BFBFBF"/>
+                        <a:srgbClr val="9DC3E6"/>
                       </a:solidFill>
                       <a:prstDash val="solid"/>
                       <a:round/>
@@ -10374,7 +10374,7 @@
                     </a:lnL>
                     <a:lnR w="9525" cap="flat" cmpd="sng" algn="ctr">
                       <a:solidFill>
-                        <a:srgbClr val="BFBFBF"/>
+                        <a:srgbClr val="9DC3E6"/>
                       </a:solidFill>
                       <a:prstDash val="solid"/>
                       <a:round/>
@@ -10383,7 +10383,7 @@
                     </a:lnR>
                     <a:lnT w="9525" cap="flat" cmpd="sng" algn="ctr">
                       <a:solidFill>
-                        <a:srgbClr val="BFBFBF"/>
+                        <a:srgbClr val="9DC3E6"/>
                       </a:solidFill>
                       <a:prstDash val="solid"/>
                       <a:round/>
@@ -10392,7 +10392,7 @@
                     </a:lnT>
                     <a:lnB w="9525" cap="flat" cmpd="sng" algn="ctr">
                       <a:solidFill>
-                        <a:srgbClr val="BFBFBF"/>
+                        <a:srgbClr val="9DC3E6"/>
                       </a:solidFill>
                       <a:prstDash val="solid"/>
                       <a:round/>
@@ -10400,7 +10400,7 @@
                       <a:tailEnd type="none" w="med" len="med"/>
                     </a:lnB>
                     <a:solidFill>
-                      <a:srgbClr val="F2F2F2"/>
+                      <a:srgbClr val="1F4E79"/>
                     </a:solidFill>
                   </a:tcPr>
                 </a:tc>
@@ -10415,7 +10415,7 @@
                       <a:r>
                         <a:rPr lang="en-US" sz="1300" b="1" dirty="0">
                           <a:solidFill>
-                            <a:srgbClr val="000000"/>
+                            <a:srgbClr val="FFFFFF"/>
                           </a:solidFill>
                           <a:latin typeface="David" pitchFamily="34" charset="0"/>
                           <a:ea typeface="David" pitchFamily="34" charset="-122"/>
@@ -10433,7 +10433,7 @@
                   <a:tcPr marL="54864" marR="54864" marT="54864" marB="54864" anchor="ctr">
                     <a:lnL w="9525" cap="flat" cmpd="sng" algn="ctr">
                       <a:solidFill>
-                        <a:srgbClr val="BFBFBF"/>
+                        <a:srgbClr val="9DC3E6"/>
                       </a:solidFill>
                       <a:prstDash val="solid"/>
                       <a:round/>
@@ -10442,7 +10442,7 @@
                     </a:lnL>
                     <a:lnR w="9525" cap="flat" cmpd="sng" algn="ctr">
                       <a:solidFill>
-                        <a:srgbClr val="BFBFBF"/>
+                        <a:srgbClr val="9DC3E6"/>
                       </a:solidFill>
                       <a:prstDash val="solid"/>
                       <a:round/>
@@ -10451,7 +10451,7 @@
                     </a:lnR>
                     <a:lnT w="9525" cap="flat" cmpd="sng" algn="ctr">
                       <a:solidFill>
-                        <a:srgbClr val="BFBFBF"/>
+                        <a:srgbClr val="9DC3E6"/>
                       </a:solidFill>
                       <a:prstDash val="solid"/>
                       <a:round/>
@@ -10460,7 +10460,7 @@
                     </a:lnT>
                     <a:lnB w="9525" cap="flat" cmpd="sng" algn="ctr">
                       <a:solidFill>
-                        <a:srgbClr val="BFBFBF"/>
+                        <a:srgbClr val="9DC3E6"/>
                       </a:solidFill>
                       <a:prstDash val="solid"/>
                       <a:round/>
@@ -10468,7 +10468,7 @@
                       <a:tailEnd type="none" w="med" len="med"/>
                     </a:lnB>
                     <a:solidFill>
-                      <a:srgbClr val="F2F2F2"/>
+                      <a:srgbClr val="1F4E79"/>
                     </a:solidFill>
                   </a:tcPr>
                 </a:tc>
@@ -10483,7 +10483,7 @@
                       <a:r>
                         <a:rPr lang="en-US" sz="1300" b="1" dirty="0">
                           <a:solidFill>
-                            <a:srgbClr val="000000"/>
+                            <a:srgbClr val="FFFFFF"/>
                           </a:solidFill>
                           <a:latin typeface="David" pitchFamily="34" charset="0"/>
                           <a:ea typeface="David" pitchFamily="34" charset="-122"/>
@@ -10501,7 +10501,7 @@
                   <a:tcPr marL="54864" marR="54864" marT="54864" marB="54864" anchor="ctr">
                     <a:lnL w="9525" cap="flat" cmpd="sng" algn="ctr">
                       <a:solidFill>
-                        <a:srgbClr val="BFBFBF"/>
+                        <a:srgbClr val="9DC3E6"/>
                       </a:solidFill>
                       <a:prstDash val="solid"/>
                       <a:round/>
@@ -10510,7 +10510,7 @@
                     </a:lnL>
                     <a:lnR w="9525" cap="flat" cmpd="sng" algn="ctr">
                       <a:solidFill>
-                        <a:srgbClr val="BFBFBF"/>
+                        <a:srgbClr val="9DC3E6"/>
                       </a:solidFill>
                       <a:prstDash val="solid"/>
                       <a:round/>
@@ -10519,7 +10519,7 @@
                     </a:lnR>
                     <a:lnT w="9525" cap="flat" cmpd="sng" algn="ctr">
                       <a:solidFill>
-                        <a:srgbClr val="BFBFBF"/>
+                        <a:srgbClr val="9DC3E6"/>
                       </a:solidFill>
                       <a:prstDash val="solid"/>
                       <a:round/>
@@ -10528,7 +10528,7 @@
                     </a:lnT>
                     <a:lnB w="9525" cap="flat" cmpd="sng" algn="ctr">
                       <a:solidFill>
-                        <a:srgbClr val="BFBFBF"/>
+                        <a:srgbClr val="9DC3E6"/>
                       </a:solidFill>
                       <a:prstDash val="solid"/>
                       <a:round/>
@@ -10536,7 +10536,7 @@
                       <a:tailEnd type="none" w="med" len="med"/>
                     </a:lnB>
                     <a:solidFill>
-                      <a:srgbClr val="F2F2F2"/>
+                      <a:srgbClr val="1F4E79"/>
                     </a:solidFill>
                   </a:tcPr>
                 </a:tc>
@@ -10571,7 +10571,7 @@
                   <a:tcPr marL="54864" marR="54864" marT="54864" marB="54864" anchor="ctr">
                     <a:lnL w="9525" cap="flat" cmpd="sng" algn="ctr">
                       <a:solidFill>
-                        <a:srgbClr val="BFBFBF"/>
+                        <a:srgbClr val="9DC3E6"/>
                       </a:solidFill>
                       <a:prstDash val="solid"/>
                       <a:round/>
@@ -10580,7 +10580,7 @@
                     </a:lnL>
                     <a:lnR w="9525" cap="flat" cmpd="sng" algn="ctr">
                       <a:solidFill>
-                        <a:srgbClr val="BFBFBF"/>
+                        <a:srgbClr val="9DC3E6"/>
                       </a:solidFill>
                       <a:prstDash val="solid"/>
                       <a:round/>
@@ -10589,7 +10589,7 @@
                     </a:lnR>
                     <a:lnT w="9525" cap="flat" cmpd="sng" algn="ctr">
                       <a:solidFill>
-                        <a:srgbClr val="BFBFBF"/>
+                        <a:srgbClr val="9DC3E6"/>
                       </a:solidFill>
                       <a:prstDash val="solid"/>
                       <a:round/>
@@ -10598,7 +10598,7 @@
                     </a:lnT>
                     <a:lnB w="9525" cap="flat" cmpd="sng" algn="ctr">
                       <a:solidFill>
-                        <a:srgbClr val="BFBFBF"/>
+                        <a:srgbClr val="9DC3E6"/>
                       </a:solidFill>
                       <a:prstDash val="solid"/>
                       <a:round/>
@@ -10639,7 +10639,7 @@
                   <a:tcPr marL="54864" marR="54864" marT="54864" marB="54864" anchor="ctr">
                     <a:lnL w="9525" cap="flat" cmpd="sng" algn="ctr">
                       <a:solidFill>
-                        <a:srgbClr val="BFBFBF"/>
+                        <a:srgbClr val="9DC3E6"/>
                       </a:solidFill>
                       <a:prstDash val="solid"/>
                       <a:round/>
@@ -10648,7 +10648,7 @@
                     </a:lnL>
                     <a:lnR w="9525" cap="flat" cmpd="sng" algn="ctr">
                       <a:solidFill>
-                        <a:srgbClr val="BFBFBF"/>
+                        <a:srgbClr val="9DC3E6"/>
                       </a:solidFill>
                       <a:prstDash val="solid"/>
                       <a:round/>
@@ -10657,7 +10657,7 @@
                     </a:lnR>
                     <a:lnT w="9525" cap="flat" cmpd="sng" algn="ctr">
                       <a:solidFill>
-                        <a:srgbClr val="BFBFBF"/>
+                        <a:srgbClr val="9DC3E6"/>
                       </a:solidFill>
                       <a:prstDash val="solid"/>
                       <a:round/>
@@ -10666,7 +10666,7 @@
                     </a:lnT>
                     <a:lnB w="9525" cap="flat" cmpd="sng" algn="ctr">
                       <a:solidFill>
-                        <a:srgbClr val="BFBFBF"/>
+                        <a:srgbClr val="9DC3E6"/>
                       </a:solidFill>
                       <a:prstDash val="solid"/>
                       <a:round/>
@@ -10707,7 +10707,7 @@
                   <a:tcPr marL="54864" marR="54864" marT="54864" marB="54864" anchor="ctr">
                     <a:lnL w="9525" cap="flat" cmpd="sng" algn="ctr">
                       <a:solidFill>
-                        <a:srgbClr val="BFBFBF"/>
+                        <a:srgbClr val="9DC3E6"/>
                       </a:solidFill>
                       <a:prstDash val="solid"/>
                       <a:round/>
@@ -10716,7 +10716,7 @@
                     </a:lnL>
                     <a:lnR w="9525" cap="flat" cmpd="sng" algn="ctr">
                       <a:solidFill>
-                        <a:srgbClr val="BFBFBF"/>
+                        <a:srgbClr val="9DC3E6"/>
                       </a:solidFill>
                       <a:prstDash val="solid"/>
                       <a:round/>
@@ -10725,7 +10725,7 @@
                     </a:lnR>
                     <a:lnT w="9525" cap="flat" cmpd="sng" algn="ctr">
                       <a:solidFill>
-                        <a:srgbClr val="BFBFBF"/>
+                        <a:srgbClr val="9DC3E6"/>
                       </a:solidFill>
                       <a:prstDash val="solid"/>
                       <a:round/>
@@ -10734,7 +10734,7 @@
                     </a:lnT>
                     <a:lnB w="9525" cap="flat" cmpd="sng" algn="ctr">
                       <a:solidFill>
-                        <a:srgbClr val="BFBFBF"/>
+                        <a:srgbClr val="9DC3E6"/>
                       </a:solidFill>
                       <a:prstDash val="solid"/>
                       <a:round/>
@@ -10777,7 +10777,7 @@
                   <a:tcPr marL="54864" marR="54864" marT="54864" marB="54864" anchor="ctr">
                     <a:lnL w="9525" cap="flat" cmpd="sng" algn="ctr">
                       <a:solidFill>
-                        <a:srgbClr val="BFBFBF"/>
+                        <a:srgbClr val="9DC3E6"/>
                       </a:solidFill>
                       <a:prstDash val="solid"/>
                       <a:round/>
@@ -10786,7 +10786,7 @@
                     </a:lnL>
                     <a:lnR w="9525" cap="flat" cmpd="sng" algn="ctr">
                       <a:solidFill>
-                        <a:srgbClr val="BFBFBF"/>
+                        <a:srgbClr val="9DC3E6"/>
                       </a:solidFill>
                       <a:prstDash val="solid"/>
                       <a:round/>
@@ -10795,7 +10795,7 @@
                     </a:lnR>
                     <a:lnT w="9525" cap="flat" cmpd="sng" algn="ctr">
                       <a:solidFill>
-                        <a:srgbClr val="BFBFBF"/>
+                        <a:srgbClr val="9DC3E6"/>
                       </a:solidFill>
                       <a:prstDash val="solid"/>
                       <a:round/>
@@ -10804,7 +10804,7 @@
                     </a:lnT>
                     <a:lnB w="9525" cap="flat" cmpd="sng" algn="ctr">
                       <a:solidFill>
-                        <a:srgbClr val="BFBFBF"/>
+                        <a:srgbClr val="9DC3E6"/>
                       </a:solidFill>
                       <a:prstDash val="solid"/>
                       <a:round/>
@@ -10812,7 +10812,7 @@
                       <a:tailEnd type="none" w="med" len="med"/>
                     </a:lnB>
                     <a:solidFill>
-                      <a:srgbClr val="FFFFFF"/>
+                      <a:srgbClr val="F5F8FC"/>
                     </a:solidFill>
                   </a:tcPr>
                 </a:tc>
@@ -10845,7 +10845,7 @@
                   <a:tcPr marL="54864" marR="54864" marT="54864" marB="54864" anchor="ctr">
                     <a:lnL w="9525" cap="flat" cmpd="sng" algn="ctr">
                       <a:solidFill>
-                        <a:srgbClr val="BFBFBF"/>
+                        <a:srgbClr val="9DC3E6"/>
                       </a:solidFill>
                       <a:prstDash val="solid"/>
                       <a:round/>
@@ -10854,7 +10854,7 @@
                     </a:lnL>
                     <a:lnR w="9525" cap="flat" cmpd="sng" algn="ctr">
                       <a:solidFill>
-                        <a:srgbClr val="BFBFBF"/>
+                        <a:srgbClr val="9DC3E6"/>
                       </a:solidFill>
                       <a:prstDash val="solid"/>
                       <a:round/>
@@ -10863,7 +10863,7 @@
                     </a:lnR>
                     <a:lnT w="9525" cap="flat" cmpd="sng" algn="ctr">
                       <a:solidFill>
-                        <a:srgbClr val="BFBFBF"/>
+                        <a:srgbClr val="9DC3E6"/>
                       </a:solidFill>
                       <a:prstDash val="solid"/>
                       <a:round/>
@@ -10872,7 +10872,7 @@
                     </a:lnT>
                     <a:lnB w="9525" cap="flat" cmpd="sng" algn="ctr">
                       <a:solidFill>
-                        <a:srgbClr val="BFBFBF"/>
+                        <a:srgbClr val="9DC3E6"/>
                       </a:solidFill>
                       <a:prstDash val="solid"/>
                       <a:round/>
@@ -10880,7 +10880,7 @@
                       <a:tailEnd type="none" w="med" len="med"/>
                     </a:lnB>
                     <a:solidFill>
-                      <a:srgbClr val="FFFFFF"/>
+                      <a:srgbClr val="F5F8FC"/>
                     </a:solidFill>
                   </a:tcPr>
                 </a:tc>
@@ -10913,7 +10913,7 @@
                   <a:tcPr marL="54864" marR="54864" marT="54864" marB="54864" anchor="ctr">
                     <a:lnL w="9525" cap="flat" cmpd="sng" algn="ctr">
                       <a:solidFill>
-                        <a:srgbClr val="BFBFBF"/>
+                        <a:srgbClr val="9DC3E6"/>
                       </a:solidFill>
                       <a:prstDash val="solid"/>
                       <a:round/>
@@ -10922,7 +10922,7 @@
                     </a:lnL>
                     <a:lnR w="9525" cap="flat" cmpd="sng" algn="ctr">
                       <a:solidFill>
-                        <a:srgbClr val="BFBFBF"/>
+                        <a:srgbClr val="9DC3E6"/>
                       </a:solidFill>
                       <a:prstDash val="solid"/>
                       <a:round/>
@@ -10931,7 +10931,7 @@
                     </a:lnR>
                     <a:lnT w="9525" cap="flat" cmpd="sng" algn="ctr">
                       <a:solidFill>
-                        <a:srgbClr val="BFBFBF"/>
+                        <a:srgbClr val="9DC3E6"/>
                       </a:solidFill>
                       <a:prstDash val="solid"/>
                       <a:round/>
@@ -10940,7 +10940,7 @@
                     </a:lnT>
                     <a:lnB w="9525" cap="flat" cmpd="sng" algn="ctr">
                       <a:solidFill>
-                        <a:srgbClr val="BFBFBF"/>
+                        <a:srgbClr val="9DC3E6"/>
                       </a:solidFill>
                       <a:prstDash val="solid"/>
                       <a:round/>
@@ -10948,7 +10948,7 @@
                       <a:tailEnd type="none" w="med" len="med"/>
                     </a:lnB>
                     <a:solidFill>
-                      <a:srgbClr val="FFFFFF"/>
+                      <a:srgbClr val="F5F8FC"/>
                     </a:solidFill>
                   </a:tcPr>
                 </a:tc>
@@ -10983,7 +10983,7 @@
                   <a:tcPr marL="54864" marR="54864" marT="54864" marB="54864" anchor="ctr">
                     <a:lnL w="9525" cap="flat" cmpd="sng" algn="ctr">
                       <a:solidFill>
-                        <a:srgbClr val="BFBFBF"/>
+                        <a:srgbClr val="9DC3E6"/>
                       </a:solidFill>
                       <a:prstDash val="solid"/>
                       <a:round/>
@@ -10992,7 +10992,7 @@
                     </a:lnL>
                     <a:lnR w="9525" cap="flat" cmpd="sng" algn="ctr">
                       <a:solidFill>
-                        <a:srgbClr val="BFBFBF"/>
+                        <a:srgbClr val="9DC3E6"/>
                       </a:solidFill>
                       <a:prstDash val="solid"/>
                       <a:round/>
@@ -11001,7 +11001,7 @@
                     </a:lnR>
                     <a:lnT w="9525" cap="flat" cmpd="sng" algn="ctr">
                       <a:solidFill>
-                        <a:srgbClr val="BFBFBF"/>
+                        <a:srgbClr val="9DC3E6"/>
                       </a:solidFill>
                       <a:prstDash val="solid"/>
                       <a:round/>
@@ -11010,7 +11010,7 @@
                     </a:lnT>
                     <a:lnB w="9525" cap="flat" cmpd="sng" algn="ctr">
                       <a:solidFill>
-                        <a:srgbClr val="BFBFBF"/>
+                        <a:srgbClr val="9DC3E6"/>
                       </a:solidFill>
                       <a:prstDash val="solid"/>
                       <a:round/>
@@ -11051,7 +11051,7 @@
                   <a:tcPr marL="54864" marR="54864" marT="54864" marB="54864" anchor="ctr">
                     <a:lnL w="9525" cap="flat" cmpd="sng" algn="ctr">
                       <a:solidFill>
-                        <a:srgbClr val="BFBFBF"/>
+                        <a:srgbClr val="9DC3E6"/>
                       </a:solidFill>
                       <a:prstDash val="solid"/>
                       <a:round/>
@@ -11060,7 +11060,7 @@
                     </a:lnL>
                     <a:lnR w="9525" cap="flat" cmpd="sng" algn="ctr">
                       <a:solidFill>
-                        <a:srgbClr val="BFBFBF"/>
+                        <a:srgbClr val="9DC3E6"/>
                       </a:solidFill>
                       <a:prstDash val="solid"/>
                       <a:round/>
@@ -11069,7 +11069,7 @@
                     </a:lnR>
                     <a:lnT w="9525" cap="flat" cmpd="sng" algn="ctr">
                       <a:solidFill>
-                        <a:srgbClr val="BFBFBF"/>
+                        <a:srgbClr val="9DC3E6"/>
                       </a:solidFill>
                       <a:prstDash val="solid"/>
                       <a:round/>
@@ -11078,7 +11078,7 @@
                     </a:lnT>
                     <a:lnB w="9525" cap="flat" cmpd="sng" algn="ctr">
                       <a:solidFill>
-                        <a:srgbClr val="BFBFBF"/>
+                        <a:srgbClr val="9DC3E6"/>
                       </a:solidFill>
                       <a:prstDash val="solid"/>
                       <a:round/>
@@ -11119,7 +11119,7 @@
                   <a:tcPr marL="54864" marR="54864" marT="54864" marB="54864" anchor="ctr">
                     <a:lnL w="9525" cap="flat" cmpd="sng" algn="ctr">
                       <a:solidFill>
-                        <a:srgbClr val="BFBFBF"/>
+                        <a:srgbClr val="9DC3E6"/>
                       </a:solidFill>
                       <a:prstDash val="solid"/>
                       <a:round/>
@@ -11128,7 +11128,7 @@
                     </a:lnL>
                     <a:lnR w="9525" cap="flat" cmpd="sng" algn="ctr">
                       <a:solidFill>
-                        <a:srgbClr val="BFBFBF"/>
+                        <a:srgbClr val="9DC3E6"/>
                       </a:solidFill>
                       <a:prstDash val="solid"/>
                       <a:round/>
@@ -11137,7 +11137,7 @@
                     </a:lnR>
                     <a:lnT w="9525" cap="flat" cmpd="sng" algn="ctr">
                       <a:solidFill>
-                        <a:srgbClr val="BFBFBF"/>
+                        <a:srgbClr val="9DC3E6"/>
                       </a:solidFill>
                       <a:prstDash val="solid"/>
                       <a:round/>
@@ -11146,7 +11146,7 @@
                     </a:lnT>
                     <a:lnB w="9525" cap="flat" cmpd="sng" algn="ctr">
                       <a:solidFill>
-                        <a:srgbClr val="BFBFBF"/>
+                        <a:srgbClr val="9DC3E6"/>
                       </a:solidFill>
                       <a:prstDash val="solid"/>
                       <a:round/>
@@ -11189,7 +11189,7 @@
                   <a:tcPr marL="54864" marR="54864" marT="54864" marB="54864" anchor="ctr">
                     <a:lnL w="9525" cap="flat" cmpd="sng" algn="ctr">
                       <a:solidFill>
-                        <a:srgbClr val="BFBFBF"/>
+                        <a:srgbClr val="9DC3E6"/>
                       </a:solidFill>
                       <a:prstDash val="solid"/>
                       <a:round/>
@@ -11198,7 +11198,7 @@
                     </a:lnL>
                     <a:lnR w="9525" cap="flat" cmpd="sng" algn="ctr">
                       <a:solidFill>
-                        <a:srgbClr val="BFBFBF"/>
+                        <a:srgbClr val="9DC3E6"/>
                       </a:solidFill>
                       <a:prstDash val="solid"/>
                       <a:round/>
@@ -11207,7 +11207,7 @@
                     </a:lnR>
                     <a:lnT w="9525" cap="flat" cmpd="sng" algn="ctr">
                       <a:solidFill>
-                        <a:srgbClr val="BFBFBF"/>
+                        <a:srgbClr val="9DC3E6"/>
                       </a:solidFill>
                       <a:prstDash val="solid"/>
                       <a:round/>
@@ -11216,7 +11216,7 @@
                     </a:lnT>
                     <a:lnB w="9525" cap="flat" cmpd="sng" algn="ctr">
                       <a:solidFill>
-                        <a:srgbClr val="BFBFBF"/>
+                        <a:srgbClr val="9DC3E6"/>
                       </a:solidFill>
                       <a:prstDash val="solid"/>
                       <a:round/>
@@ -11224,7 +11224,7 @@
                       <a:tailEnd type="none" w="med" len="med"/>
                     </a:lnB>
                     <a:solidFill>
-                      <a:srgbClr val="FFFFFF"/>
+                      <a:srgbClr val="F5F8FC"/>
                     </a:solidFill>
                   </a:tcPr>
                 </a:tc>
@@ -11257,7 +11257,7 @@
                   <a:tcPr marL="54864" marR="54864" marT="54864" marB="54864" anchor="ctr">
                     <a:lnL w="9525" cap="flat" cmpd="sng" algn="ctr">
                       <a:solidFill>
-                        <a:srgbClr val="BFBFBF"/>
+                        <a:srgbClr val="9DC3E6"/>
                       </a:solidFill>
                       <a:prstDash val="solid"/>
                       <a:round/>
@@ -11266,7 +11266,7 @@
                     </a:lnL>
                     <a:lnR w="9525" cap="flat" cmpd="sng" algn="ctr">
                       <a:solidFill>
-                        <a:srgbClr val="BFBFBF"/>
+                        <a:srgbClr val="9DC3E6"/>
                       </a:solidFill>
                       <a:prstDash val="solid"/>
                       <a:round/>
@@ -11275,7 +11275,7 @@
                     </a:lnR>
                     <a:lnT w="9525" cap="flat" cmpd="sng" algn="ctr">
                       <a:solidFill>
-                        <a:srgbClr val="BFBFBF"/>
+                        <a:srgbClr val="9DC3E6"/>
                       </a:solidFill>
                       <a:prstDash val="solid"/>
                       <a:round/>
@@ -11284,7 +11284,7 @@
                     </a:lnT>
                     <a:lnB w="9525" cap="flat" cmpd="sng" algn="ctr">
                       <a:solidFill>
-                        <a:srgbClr val="BFBFBF"/>
+                        <a:srgbClr val="9DC3E6"/>
                       </a:solidFill>
                       <a:prstDash val="solid"/>
                       <a:round/>
@@ -11292,7 +11292,7 @@
                       <a:tailEnd type="none" w="med" len="med"/>
                     </a:lnB>
                     <a:solidFill>
-                      <a:srgbClr val="FFFFFF"/>
+                      <a:srgbClr val="F5F8FC"/>
                     </a:solidFill>
                   </a:tcPr>
                 </a:tc>
@@ -11325,7 +11325,7 @@
                   <a:tcPr marL="54864" marR="54864" marT="54864" marB="54864" anchor="ctr">
                     <a:lnL w="9525" cap="flat" cmpd="sng" algn="ctr">
                       <a:solidFill>
-                        <a:srgbClr val="BFBFBF"/>
+                        <a:srgbClr val="9DC3E6"/>
                       </a:solidFill>
                       <a:prstDash val="solid"/>
                       <a:round/>
@@ -11334,7 +11334,7 @@
                     </a:lnL>
                     <a:lnR w="9525" cap="flat" cmpd="sng" algn="ctr">
                       <a:solidFill>
-                        <a:srgbClr val="BFBFBF"/>
+                        <a:srgbClr val="9DC3E6"/>
                       </a:solidFill>
                       <a:prstDash val="solid"/>
                       <a:round/>
@@ -11343,7 +11343,7 @@
                     </a:lnR>
                     <a:lnT w="9525" cap="flat" cmpd="sng" algn="ctr">
                       <a:solidFill>
-                        <a:srgbClr val="BFBFBF"/>
+                        <a:srgbClr val="9DC3E6"/>
                       </a:solidFill>
                       <a:prstDash val="solid"/>
                       <a:round/>
@@ -11352,7 +11352,7 @@
                     </a:lnT>
                     <a:lnB w="9525" cap="flat" cmpd="sng" algn="ctr">
                       <a:solidFill>
-                        <a:srgbClr val="BFBFBF"/>
+                        <a:srgbClr val="9DC3E6"/>
                       </a:solidFill>
                       <a:prstDash val="solid"/>
                       <a:round/>
@@ -11360,7 +11360,7 @@
                       <a:tailEnd type="none" w="med" len="med"/>
                     </a:lnB>
                     <a:solidFill>
-                      <a:srgbClr val="FFFFFF"/>
+                      <a:srgbClr val="F5F8FC"/>
                     </a:solidFill>
                   </a:tcPr>
                 </a:tc>
@@ -11395,7 +11395,7 @@
                   <a:tcPr marL="54864" marR="54864" marT="54864" marB="54864" anchor="ctr">
                     <a:lnL w="9525" cap="flat" cmpd="sng" algn="ctr">
                       <a:solidFill>
-                        <a:srgbClr val="BFBFBF"/>
+                        <a:srgbClr val="9DC3E6"/>
                       </a:solidFill>
                       <a:prstDash val="solid"/>
                       <a:round/>
@@ -11404,7 +11404,7 @@
                     </a:lnL>
                     <a:lnR w="9525" cap="flat" cmpd="sng" algn="ctr">
                       <a:solidFill>
-                        <a:srgbClr val="BFBFBF"/>
+                        <a:srgbClr val="9DC3E6"/>
                       </a:solidFill>
                       <a:prstDash val="solid"/>
                       <a:round/>
@@ -11413,7 +11413,7 @@
                     </a:lnR>
                     <a:lnT w="9525" cap="flat" cmpd="sng" algn="ctr">
                       <a:solidFill>
-                        <a:srgbClr val="BFBFBF"/>
+                        <a:srgbClr val="9DC3E6"/>
                       </a:solidFill>
                       <a:prstDash val="solid"/>
                       <a:round/>
@@ -11422,7 +11422,7 @@
                     </a:lnT>
                     <a:lnB w="9525" cap="flat" cmpd="sng" algn="ctr">
                       <a:solidFill>
-                        <a:srgbClr val="BFBFBF"/>
+                        <a:srgbClr val="9DC3E6"/>
                       </a:solidFill>
                       <a:prstDash val="solid"/>
                       <a:round/>
@@ -11463,7 +11463,7 @@
                   <a:tcPr marL="54864" marR="54864" marT="54864" marB="54864" anchor="ctr">
                     <a:lnL w="9525" cap="flat" cmpd="sng" algn="ctr">
                       <a:solidFill>
-                        <a:srgbClr val="BFBFBF"/>
+                        <a:srgbClr val="9DC3E6"/>
                       </a:solidFill>
                       <a:prstDash val="solid"/>
                       <a:round/>
@@ -11472,7 +11472,7 @@
                     </a:lnL>
                     <a:lnR w="9525" cap="flat" cmpd="sng" algn="ctr">
                       <a:solidFill>
-                        <a:srgbClr val="BFBFBF"/>
+                        <a:srgbClr val="9DC3E6"/>
                       </a:solidFill>
                       <a:prstDash val="solid"/>
                       <a:round/>
@@ -11481,7 +11481,7 @@
                     </a:lnR>
                     <a:lnT w="9525" cap="flat" cmpd="sng" algn="ctr">
                       <a:solidFill>
-                        <a:srgbClr val="BFBFBF"/>
+                        <a:srgbClr val="9DC3E6"/>
                       </a:solidFill>
                       <a:prstDash val="solid"/>
                       <a:round/>
@@ -11490,7 +11490,7 @@
                     </a:lnT>
                     <a:lnB w="9525" cap="flat" cmpd="sng" algn="ctr">
                       <a:solidFill>
-                        <a:srgbClr val="BFBFBF"/>
+                        <a:srgbClr val="9DC3E6"/>
                       </a:solidFill>
                       <a:prstDash val="solid"/>
                       <a:round/>
@@ -11531,7 +11531,7 @@
                   <a:tcPr marL="54864" marR="54864" marT="54864" marB="54864" anchor="ctr">
                     <a:lnL w="9525" cap="flat" cmpd="sng" algn="ctr">
                       <a:solidFill>
-                        <a:srgbClr val="BFBFBF"/>
+                        <a:srgbClr val="9DC3E6"/>
                       </a:solidFill>
                       <a:prstDash val="solid"/>
                       <a:round/>
@@ -11540,7 +11540,7 @@
                     </a:lnL>
                     <a:lnR w="9525" cap="flat" cmpd="sng" algn="ctr">
                       <a:solidFill>
-                        <a:srgbClr val="BFBFBF"/>
+                        <a:srgbClr val="9DC3E6"/>
                       </a:solidFill>
                       <a:prstDash val="solid"/>
                       <a:round/>
@@ -11549,7 +11549,7 @@
                     </a:lnR>
                     <a:lnT w="9525" cap="flat" cmpd="sng" algn="ctr">
                       <a:solidFill>
-                        <a:srgbClr val="BFBFBF"/>
+                        <a:srgbClr val="9DC3E6"/>
                       </a:solidFill>
                       <a:prstDash val="solid"/>
                       <a:round/>
@@ -11558,7 +11558,7 @@
                     </a:lnT>
                     <a:lnB w="9525" cap="flat" cmpd="sng" algn="ctr">
                       <a:solidFill>
-                        <a:srgbClr val="BFBFBF"/>
+                        <a:srgbClr val="9DC3E6"/>
                       </a:solidFill>
                       <a:prstDash val="solid"/>
                       <a:round/>
@@ -11602,7 +11602,7 @@
             <a:r>
               <a:rPr lang="he-IL" altLang="en-US" sz="1050" dirty="0">
                 <a:solidFill>
-                  <a:srgbClr val="595959"/>
+                  <a:srgbClr val="ED7D31"/>
                 </a:solidFill>
                 <a:latin typeface="David" pitchFamily="34" charset="0"/>
                 <a:ea typeface="David" pitchFamily="34" charset="-122"/>
@@ -11641,7 +11641,7 @@
             <a:r>
               <a:rPr lang="he-IL" altLang="en-US" sz="1000" dirty="0">
                 <a:solidFill>
-                  <a:srgbClr val="595959"/>
+                  <a:srgbClr val="1F4E79"/>
                 </a:solidFill>
                 <a:latin typeface="David" pitchFamily="34" charset="0"/>
                 <a:ea typeface="David" pitchFamily="34" charset="-122"/>
@@ -11744,7 +11744,7 @@
             <a:r>
               <a:rPr lang="he-IL" altLang="en-US" sz="2800" b="1" dirty="0">
                 <a:solidFill>
-                  <a:srgbClr val="000000"/>
+                  <a:srgbClr val="1F4E79"/>
                 </a:solidFill>
                 <a:latin typeface="David" pitchFamily="34" charset="0"/>
                 <a:ea typeface="David" pitchFamily="34" charset="-122"/>
@@ -11867,7 +11867,7 @@
             <a:r>
               <a:rPr lang="he-IL" altLang="en-US" sz="1000" dirty="0">
                 <a:solidFill>
-                  <a:srgbClr val="595959"/>
+                  <a:srgbClr val="1F4E79"/>
                 </a:solidFill>
                 <a:latin typeface="David" pitchFamily="34" charset="0"/>
                 <a:ea typeface="David" pitchFamily="34" charset="-122"/>
@@ -11970,7 +11970,7 @@
             <a:r>
               <a:rPr lang="he-IL" altLang="en-US" sz="2800" b="1" dirty="0">
                 <a:solidFill>
-                  <a:srgbClr val="000000"/>
+                  <a:srgbClr val="1F4E79"/>
                 </a:solidFill>
                 <a:latin typeface="David" pitchFamily="34" charset="0"/>
                 <a:ea typeface="David" pitchFamily="34" charset="-122"/>
@@ -12132,7 +12132,7 @@
             <a:r>
               <a:rPr lang="he-IL" altLang="en-US" sz="1000" dirty="0">
                 <a:solidFill>
-                  <a:srgbClr val="595959"/>
+                  <a:srgbClr val="1F4E79"/>
                 </a:solidFill>
                 <a:latin typeface="David" pitchFamily="34" charset="0"/>
                 <a:ea typeface="David" pitchFamily="34" charset="-122"/>

</xml_diff>

<commit_message>
Right-align deck paragraphs and add RTL marks for viewers that ignore rtl
Co-Authored-By: Claude Fable 5.1 <noreply@anthropic.com>
Claude-Session: https://claude.ai/code/session_01XaGvnsaHG3kPyCY3aGBByx
</commit_message>
<xml_diff>
--- a/career-management-final-project/ניהול קריירה - התמודדות עם חוסר ודאות תעסוקתי - מצגת.pptx
+++ b/career-management-final-project/ניהול קריירה - התמודדות עם חוסר ודאות תעסוקתי - מצגת.pptx
@@ -2659,7 +2659,7 @@
                 <a:ea typeface="David" pitchFamily="34" charset="-122"/>
                 <a:cs typeface="David" pitchFamily="34" charset="-120"/>
               </a:rPr>
-              <a:t>הקריה האקדמית אונו, הפקולטה למנהל עסקים</a:t>
+              <a:t>‏הקריה האקדמית אונו, הפקולטה למנהל עסקים</a:t>
             </a:r>
             <a:endParaRPr lang="he-IL" sz="1700" dirty="0"/>
           </a:p>
@@ -2698,7 +2698,7 @@
                 <a:ea typeface="David" pitchFamily="34" charset="-122"/>
                 <a:cs typeface="David" pitchFamily="34" charset="-120"/>
               </a:rPr>
-              <a:t>עבודה מסכמת בקורס ניהול קריירה בארגונים</a:t>
+              <a:t>‏עבודה מסכמת בקורס ניהול קריירה בארגונים</a:t>
             </a:r>
             <a:endParaRPr lang="he-IL" sz="1700" dirty="0"/>
           </a:p>
@@ -2737,7 +2737,7 @@
                 <a:ea typeface="David" pitchFamily="34" charset="-122"/>
                 <a:cs typeface="David" pitchFamily="34" charset="-120"/>
               </a:rPr>
-              <a:t>התמודדות עם חוסר ודאות תעסוקתי</a:t>
+              <a:t>‏התמודדות עם חוסר ודאות תעסוקתי</a:t>
             </a:r>
             <a:endParaRPr lang="he-IL" sz="3800" dirty="0"/>
           </a:p>
@@ -2776,7 +2776,7 @@
                 <a:ea typeface="David" pitchFamily="34" charset="-122"/>
                 <a:cs typeface="David" pitchFamily="34" charset="-120"/>
               </a:rPr>
-              <a:t>עיצוב תפקיד מבוסס צרכים כדרך לבנות בהירות, שליטה ומשמעות בעבודה</a:t>
+              <a:t>‏עיצוב תפקיד מבוסס צרכים כדרך לבנות בהירות, שליטה ומשמעות בעבודה</a:t>
             </a:r>
             <a:endParaRPr lang="he-IL" sz="1800" dirty="0"/>
           </a:p>
@@ -2854,7 +2854,7 @@
                 <a:ea typeface="David" pitchFamily="34" charset="-122"/>
                 <a:cs typeface="David" pitchFamily="34" charset="-120"/>
               </a:rPr>
-              <a:t>מגיש/ה: דוחה עמאש, מספר תעודת זהות 208121137</a:t>
+              <a:t>‏מגיש/ה: דוחה עמאש, מספר תעודת זהות 208121137</a:t>
             </a:r>
             <a:endParaRPr lang="he-IL" sz="1800" dirty="0"/>
           </a:p>
@@ -2893,7 +2893,7 @@
                 <a:ea typeface="David" pitchFamily="34" charset="-122"/>
                 <a:cs typeface="David" pitchFamily="34" charset="-120"/>
               </a:rPr>
-              <a:t>מרצה: גב' מורן דבדבני דקל   |   עוזר הוראה: מר פאר רועי</a:t>
+              <a:t>‏מרצה: גב' מורן דבדבני דקל   |   עוזר הוראה: מר פאר רועי</a:t>
             </a:r>
             <a:endParaRPr lang="he-IL" sz="1500" dirty="0"/>
           </a:p>
@@ -2932,7 +2932,7 @@
                 <a:ea typeface="David" pitchFamily="34" charset="-122"/>
                 <a:cs typeface="David" pitchFamily="34" charset="-120"/>
               </a:rPr>
-              <a:t>תשפ"ו, סמסטר 3   |   ספטמבר 2026</a:t>
+              <a:t>‏תשפ"ו, סמסטר 3   |   ספטמבר 2026</a:t>
             </a:r>
             <a:endParaRPr lang="he-IL" sz="1400" dirty="0"/>
           </a:p>
@@ -3053,7 +3053,7 @@
                 <a:ea typeface="David" pitchFamily="34" charset="-122"/>
                 <a:cs typeface="David" pitchFamily="34" charset="-120"/>
               </a:rPr>
-              <a:t>חיבור לחומר הנלמד בקורס</a:t>
+              <a:t>‏חיבור לחומר הנלמד בקורס</a:t>
             </a:r>
             <a:endParaRPr lang="he-IL" sz="2800" dirty="0"/>
           </a:p>
@@ -3080,7 +3080,7 @@
           <a:bodyPr wrap="square" lIns="0" tIns="0" rIns="0" bIns="0" rtlCol="0" anchor="t"/>
           <a:lstStyle/>
           <a:p>
-            <a:pPr rtl="1" algn="just" indent="0" marL="0">
+            <a:pPr rtl="1" algn="r" indent="0" marL="0">
               <a:lnSpc>
                 <a:spcPct val="125000"/>
               </a:lnSpc>
@@ -3095,7 +3095,7 @@
                 <a:ea typeface="David" pitchFamily="34" charset="-122"/>
                 <a:cs typeface="David" pitchFamily="34" charset="-120"/>
               </a:rPr>
-              <a:t>המאמר אינו זר לחומר הקורס אלא מעניק לו בסיס אמפירי. שלושת סלי הכלים שנלמדו בקורס, רשת אנשים, זהות מקצועית והתפתחות, מקבילים כמעט אחד לאחד לצרכי ההתקרבות שנמצאו כבונים תחושת קוהרנטיות: רשת האנשים היא צורך השייכות, חמש השאלות של הזהות המקצועית הן עיצוב תפקיד לצורך המשמעות, וההתפתחות היא צורך המיומנות. הרעיון של קריירה רבודה וקיר הטיפוס, שבהם כל שלב נבנה על קודמו, הוא בדיוק ספירלת הרווח שהמחקר מתעד, שבה כל צעד של עיצוב תפקיד מגדיל את המשאבים לצעד הבא (Cetkovská et al., 2026).</a:t>
+              <a:t>‏המאמר אינו זר לחומר הקורס אלא מעניק לו בסיס אמפירי. שלושת סלי הכלים שנלמדו בקורס, רשת אנשים, זהות מקצועית והתפתחות, מקבילים כמעט אחד לאחד לצרכי ההתקרבות שנמצאו כבונים תחושת קוהרנטיות: רשת האנשים היא צורך השייכות, חמש השאלות של הזהות המקצועית הן עיצוב תפקיד לצורך המשמעות, וההתפתחות היא צורך המיומנות. הרעיון של קריירה רבודה וקיר הטיפוס, שבהם כל שלב נבנה על קודמו, הוא בדיוק ספירלת הרווח שהמחקר מתעד, שבה כל צעד של עיצוב תפקיד מגדיל את המשאבים לצעד הבא (Cetkovská et al., 2026).</a:t>
             </a:r>
             <a:endParaRPr lang="he-IL" sz="1600" dirty="0"/>
           </a:p>
@@ -3122,7 +3122,7 @@
           <a:bodyPr wrap="square" lIns="0" tIns="0" rIns="0" bIns="0" rtlCol="0" anchor="t"/>
           <a:lstStyle/>
           <a:p>
-            <a:pPr rtl="1" algn="just" indent="0" marL="0">
+            <a:pPr rtl="1" algn="r" indent="0" marL="0">
               <a:lnSpc>
                 <a:spcPct val="125000"/>
               </a:lnSpc>
@@ -3137,7 +3137,7 @@
                 <a:ea typeface="David" pitchFamily="34" charset="-122"/>
                 <a:cs typeface="David" pitchFamily="34" charset="-120"/>
               </a:rPr>
-              <a:t>הגורמים המניעים של הרצברג, הישג, הכרה ומשמעות, מקבילים לצרכי ההתקרבות, ואילו הגורמים ההיגייניים מקבילים לצרכי ההימנעות, מה שמסביר מדוע רק הראשונים שינו את תפיסת העבודה. עוגני הקריירה של שיין מסבירים מדוע צרכים שונים חשובים לעובדים שונים: מי שעוגנו הוא אוטונומיה יעצב את תפקידו סביב חופש הפעולה, ומי שעוגנו הוא ביטחון ויציבות יחפש קודם כול מובנות. מאמר החובה בקורס מראה שתמיכה במקום העבודה ובמשפחה משפרת את הזמינות הפסיכולוגית של העובד (Russo et al., 2016), כלומר את תחושת הניהוליות שהמחקר מזהה כמנוע החזק ביותר ליוזמה (Cetkovská et al., 2026).</a:t>
+              <a:t>‏הגורמים המניעים של הרצברג, הישג, הכרה ומשמעות, מקבילים לצרכי ההתקרבות, ואילו הגורמים ההיגייניים מקבילים לצרכי ההימנעות, מה שמסביר מדוע רק הראשונים שינו את תפיסת העבודה. עוגני הקריירה של שיין מסבירים מדוע צרכים שונים חשובים לעובדים שונים: מי שעוגנו הוא אוטונומיה יעצב את תפקידו סביב חופש הפעולה, ומי שעוגנו הוא ביטחון ויציבות יחפש קודם כול מובנות. מאמר החובה בקורס מראה שתמיכה במקום העבודה ובמשפחה משפרת את הזמינות הפסיכולוגית של העובד (Russo et al., 2016), כלומר את תחושת הניהוליות שהמחקר מזהה כמנוע החזק ביותר ליוזמה (Cetkovská et al., 2026).</a:t>
             </a:r>
             <a:endParaRPr lang="he-IL" sz="1600" dirty="0"/>
           </a:p>
@@ -3199,7 +3199,7 @@
                 <a:ea typeface="David" pitchFamily="34" charset="-122"/>
                 <a:cs typeface="David" pitchFamily="34" charset="-120"/>
               </a:rPr>
-              <a:t>ניהול קריירה בארגונים, הקריה האקדמית אונו</a:t>
+              <a:t>‏ניהול קריירה בארגונים, הקריה האקדמית אונו</a:t>
             </a:r>
             <a:endParaRPr lang="he-IL" sz="1000" dirty="0"/>
           </a:p>
@@ -3238,7 +3238,7 @@
                 <a:ea typeface="David" pitchFamily="34" charset="-122"/>
                 <a:cs typeface="David" pitchFamily="34" charset="-120"/>
               </a:rPr>
-              <a:t>10</a:t>
+              <a:t>‏10</a:t>
             </a:r>
             <a:endParaRPr lang="he-IL" sz="1100" dirty="0"/>
           </a:p>
@@ -3359,7 +3359,7 @@
                 <a:ea typeface="David" pitchFamily="34" charset="-122"/>
                 <a:cs typeface="David" pitchFamily="34" charset="-120"/>
               </a:rPr>
-              <a:t>תובנות ומסקנות</a:t>
+              <a:t>‏תובנות ומסקנות</a:t>
             </a:r>
             <a:endParaRPr lang="he-IL" sz="2800" dirty="0"/>
           </a:p>
@@ -3386,7 +3386,7 @@
           <a:bodyPr wrap="square" lIns="0" tIns="0" rIns="0" bIns="0" rtlCol="0" anchor="t"/>
           <a:lstStyle/>
           <a:p>
-            <a:pPr rtl="1" algn="just" indent="0" marL="0">
+            <a:pPr rtl="1" algn="r" indent="0" marL="0">
               <a:lnSpc>
                 <a:spcPct val="125000"/>
               </a:lnSpc>
@@ -3401,7 +3401,7 @@
                 <a:ea typeface="David" pitchFamily="34" charset="-122"/>
                 <a:cs typeface="David" pitchFamily="34" charset="-120"/>
               </a:rPr>
-              <a:t>התובנה הראשונה היא שבהירות, שליטה ומשמעות אינן רק תוצר של הסביבה: תחושת הקוהרנטיות עולה כשהעובד פועל על תפקידו, גם כשהסביבה לא השתנתה. התובנה השנייה היא שההבדל בין התקרבות להימנעות מכריע, שכן מאמצים להתנתק ולנוח חשובים להתאוששות אך אינם משנים את תפיסת העבודה. התובנה השלישית היא שהמשאבים קודמים ליוזמה: תחושת הניהוליות ניבאה עיצוב תפקיד עתידי במקדם החזק ביותר במודל, ולכן מי שמרגיש שאין לו משאבים מגן על מה שנותר במקום להשקיע (Cetkovská et al., 2026). התובנה הרביעית, מהמאמר המשלים, היא שמשאב אישי ממתן את הקשר בין האיום הטכנולוגי לבין חוסר הביטחון (Chung et al., 2025).</a:t>
+              <a:t>‏התובנה הראשונה היא שבהירות, שליטה ומשמעות אינן רק תוצר של הסביבה: תחושת הקוהרנטיות עולה כשהעובד פועל על תפקידו, גם כשהסביבה לא השתנתה. התובנה השנייה היא שההבדל בין התקרבות להימנעות מכריע, שכן מאמצים להתנתק ולנוח חשובים להתאוששות אך אינם משנים את תפיסת העבודה. התובנה השלישית היא שהמשאבים קודמים ליוזמה: תחושת הניהוליות ניבאה עיצוב תפקיד עתידי במקדם החזק ביותר במודל, ולכן מי שמרגיש שאין לו משאבים מגן על מה שנותר במקום להשקיע (Cetkovská et al., 2026). התובנה הרביעית, מהמאמר המשלים, היא שמשאב אישי ממתן את הקשר בין האיום הטכנולוגי לבין חוסר הביטחון (Chung et al., 2025).</a:t>
             </a:r>
             <a:endParaRPr lang="he-IL" sz="1600" dirty="0"/>
           </a:p>
@@ -3428,7 +3428,7 @@
           <a:bodyPr wrap="square" lIns="0" tIns="0" rIns="0" bIns="0" rtlCol="0" anchor="t"/>
           <a:lstStyle/>
           <a:p>
-            <a:pPr rtl="1" algn="just" indent="0" marL="0">
+            <a:pPr rtl="1" algn="r" indent="0" marL="0">
               <a:lnSpc>
                 <a:spcPct val="125000"/>
               </a:lnSpc>
@@ -3443,7 +3443,7 @@
                 <a:ea typeface="David" pitchFamily="34" charset="-122"/>
                 <a:cs typeface="David" pitchFamily="34" charset="-120"/>
               </a:rPr>
-              <a:t>המסקנה המרכזית היא שההתמודדות עם חוסר ודאות תעסוקתי אינה מסתכמת בהגנה מפני האיום, אלא בבנייה יזומה של בהירות, שליטה ומשמעות בתוך התפקיד הקיים, ושאת המשאבים לכך יש לבנות בתקופות של יציבות, לפני שהאיום מדלדל אותם. ברמה הארגונית, מנהלים שרוצים עובדים יוזמים בתקופת שינוי צריכים קודם כול לדאוג לתחושת ניהוליות: משאבים מספיקים, מידע ברור ומרחב לעיצוב התפקיד.</a:t>
+              <a:t>‏המסקנה המרכזית היא שההתמודדות עם חוסר ודאות תעסוקתי אינה מסתכמת בהגנה מפני האיום, אלא בבנייה יזומה של בהירות, שליטה ומשמעות בתוך התפקיד הקיים, ושאת המשאבים לכך יש לבנות בתקופות של יציבות, לפני שהאיום מדלדל אותם. ברמה הארגונית, מנהלים שרוצים עובדים יוזמים בתקופת שינוי צריכים קודם כול לדאוג לתחושת ניהוליות: משאבים מספיקים, מידע ברור ומרחב לעיצוב התפקיד.</a:t>
             </a:r>
             <a:endParaRPr lang="he-IL" sz="1600" dirty="0"/>
           </a:p>
@@ -3505,7 +3505,7 @@
                 <a:ea typeface="David" pitchFamily="34" charset="-122"/>
                 <a:cs typeface="David" pitchFamily="34" charset="-120"/>
               </a:rPr>
-              <a:t>ניהול קריירה בארגונים, הקריה האקדמית אונו</a:t>
+              <a:t>‏ניהול קריירה בארגונים, הקריה האקדמית אונו</a:t>
             </a:r>
             <a:endParaRPr lang="he-IL" sz="1000" dirty="0"/>
           </a:p>
@@ -3544,7 +3544,7 @@
                 <a:ea typeface="David" pitchFamily="34" charset="-122"/>
                 <a:cs typeface="David" pitchFamily="34" charset="-120"/>
               </a:rPr>
-              <a:t>11</a:t>
+              <a:t>‏11</a:t>
             </a:r>
             <a:endParaRPr lang="he-IL" sz="1100" dirty="0"/>
           </a:p>
@@ -3665,7 +3665,7 @@
                 <a:ea typeface="David" pitchFamily="34" charset="-122"/>
                 <a:cs typeface="David" pitchFamily="34" charset="-120"/>
               </a:rPr>
-              <a:t>דעה אישית על המאמר</a:t>
+              <a:t>‏דעה אישית על המאמר</a:t>
             </a:r>
             <a:endParaRPr lang="he-IL" sz="2800" dirty="0"/>
           </a:p>
@@ -3692,7 +3692,7 @@
           <a:bodyPr wrap="square" lIns="0" tIns="0" rIns="0" bIns="0" rtlCol="0" anchor="t"/>
           <a:lstStyle/>
           <a:p>
-            <a:pPr rtl="1" algn="just" indent="0" marL="0">
+            <a:pPr rtl="1" algn="r" indent="0" marL="0">
               <a:lnSpc>
                 <a:spcPct val="125000"/>
               </a:lnSpc>
@@ -3707,7 +3707,7 @@
                 <a:ea typeface="David" pitchFamily="34" charset="-122"/>
                 <a:cs typeface="David" pitchFamily="34" charset="-120"/>
               </a:rPr>
-              <a:t>מה שאהבתי במאמר הוא נקודת המבט, ששואלת מה עוזר לעובדים ולא רק מה מזיק להם, והעובדה שהיא נשענת על רעיון של חוקר שפעל בישראל. אהבתי את הפרקטיות שלו, שישה צרכים, שאלות פשוטות ופעולות לשבועיים, ואת הכנות של המחברים, שמקדישים כמעט עמוד שלם למגבלות, כולל הודאה שהמקדם השלילי של המובנות קשה להם להסביר. העובדה שהמאמר זמין לכולם בחינם חשובה בעיניי (Cetkovská et al., 2026).</a:t>
+              <a:t>‏מה שאהבתי במאמר הוא נקודת המבט, ששואלת מה עוזר לעובדים ולא רק מה מזיק להם, והעובדה שהיא נשענת על רעיון של חוקר שפעל בישראל. אהבתי את הפרקטיות שלו, שישה צרכים, שאלות פשוטות ופעולות לשבועיים, ואת הכנות של המחברים, שמקדישים כמעט עמוד שלם למגבלות, כולל הודאה שהמקדם השלילי של המובנות קשה להם להסביר. העובדה שהמאמר זמין לכולם בחינם חשובה בעיניי (Cetkovská et al., 2026).</a:t>
             </a:r>
             <a:endParaRPr lang="he-IL" sz="1600" dirty="0"/>
           </a:p>
@@ -3734,7 +3734,7 @@
           <a:bodyPr wrap="square" lIns="0" tIns="0" rIns="0" bIns="0" rtlCol="0" anchor="t"/>
           <a:lstStyle/>
           <a:p>
-            <a:pPr rtl="1" algn="just" indent="0" marL="0">
+            <a:pPr rtl="1" algn="r" indent="0" marL="0">
               <a:lnSpc>
                 <a:spcPct val="125000"/>
               </a:lnSpc>
@@ -3749,7 +3749,7 @@
                 <a:ea typeface="David" pitchFamily="34" charset="-122"/>
                 <a:cs typeface="David" pitchFamily="34" charset="-120"/>
               </a:rPr>
-              <a:t>חסרו לי שלושה דברים. המאמר אינו מודד חוסר ביטחון תעסוקתי במישרין, ואת החיבור לנושא בניתי דרך המאמר המשלים. המדגם גרמני ושווייצרי, בגיל ממוצע של כמעט 49 ומתרבות עבודה עם ביטחון סוציאלי גבוה, ולא ברור שהמרחב לעצב תפקיד קיים גם אצל סטודנטים ישראלים בתחילת הדרך. המחקר עוסק בשכירים בתפקיד קיים בלבד. עמדתי היא שהמאמר משלים את המסר "ממשבר להזדמנות" שנלמד בקורס: משבר הופך להזדמנות לא מעצמו, אלא כשמישהו מעצב אותו כך, ומי שמרגיש שאין לו משאבים צריך קודם תמיכה ולא עצות.</a:t>
+              <a:t>‏חסרו לי שלושה דברים. המאמר אינו מודד חוסר ביטחון תעסוקתי במישרין, ואת החיבור לנושא בניתי דרך המאמר המשלים. המדגם גרמני ושווייצרי, בגיל ממוצע של כמעט 49 ומתרבות עבודה עם ביטחון סוציאלי גבוה, ולא ברור שהמרחב לעצב תפקיד קיים גם אצל סטודנטים ישראלים בתחילת הדרך. המחקר עוסק בשכירים בתפקיד קיים בלבד. עמדתי היא שהמאמר משלים את המסר "ממשבר להזדמנות" שנלמד בקורס: משבר הופך להזדמנות לא מעצמו, אלא כשמישהו מעצב אותו כך, ומי שמרגיש שאין לו משאבים צריך קודם תמיכה ולא עצות.</a:t>
             </a:r>
             <a:endParaRPr lang="he-IL" sz="1600" dirty="0"/>
           </a:p>
@@ -3811,7 +3811,7 @@
                 <a:ea typeface="David" pitchFamily="34" charset="-122"/>
                 <a:cs typeface="David" pitchFamily="34" charset="-120"/>
               </a:rPr>
-              <a:t>ניהול קריירה בארגונים, הקריה האקדמית אונו</a:t>
+              <a:t>‏ניהול קריירה בארגונים, הקריה האקדמית אונו</a:t>
             </a:r>
             <a:endParaRPr lang="he-IL" sz="1000" dirty="0"/>
           </a:p>
@@ -3850,7 +3850,7 @@
                 <a:ea typeface="David" pitchFamily="34" charset="-122"/>
                 <a:cs typeface="David" pitchFamily="34" charset="-120"/>
               </a:rPr>
-              <a:t>12</a:t>
+              <a:t>‏12</a:t>
             </a:r>
             <a:endParaRPr lang="he-IL" sz="1100" dirty="0"/>
           </a:p>
@@ -3971,7 +3971,7 @@
                 <a:ea typeface="David" pitchFamily="34" charset="-122"/>
                 <a:cs typeface="David" pitchFamily="34" charset="-120"/>
               </a:rPr>
-              <a:t>יישום מעשי: תוכנית עיצוב תפקיד אישית</a:t>
+              <a:t>‏יישום מעשי: תוכנית עיצוב תפקיד אישית</a:t>
             </a:r>
             <a:endParaRPr lang="he-IL" sz="2800" dirty="0"/>
           </a:p>
@@ -3998,7 +3998,7 @@
           <a:bodyPr wrap="square" lIns="0" tIns="0" rIns="0" bIns="0" rtlCol="0" anchor="t"/>
           <a:lstStyle/>
           <a:p>
-            <a:pPr rtl="1" algn="just" indent="0" marL="0">
+            <a:pPr rtl="1" algn="r" indent="0" marL="0">
               <a:lnSpc>
                 <a:spcPct val="125000"/>
               </a:lnSpc>
@@ -4013,7 +4013,7 @@
                 <a:ea typeface="David" pitchFamily="34" charset="-122"/>
                 <a:cs typeface="David" pitchFamily="34" charset="-120"/>
               </a:rPr>
-              <a:t>ממצאי המאמר תורגמו לכלי אישי המבוסס על ארבעת צרכי ההתקרבות, שנמצאו כבונים תחושת קוהרנטיות. לכל צורך שאלה מנחה ודוגמאות לפעולה שאפשר לבצע בשבועיים, גם בתפקיד סטודנטיאלי או במשרה חלקית. את צרכי ההימנעות מומלץ לטפח לצורך התאוששות, אך לפי המאמר הם אינם משנים את תפיסת העבודה (Cetkovská et al., 2026).</a:t>
+              <a:t>‏ממצאי המאמר תורגמו לכלי אישי המבוסס על ארבעת צרכי ההתקרבות, שנמצאו כבונים תחושת קוהרנטיות. לכל צורך שאלה מנחה ודוגמאות לפעולה שאפשר לבצע בשבועיים, גם בתפקיד סטודנטיאלי או במשרה חלקית. את צרכי ההימנעות מומלץ לטפח לצורך התאוששות, אך לפי המאמר הם אינם משנים את תפיסת העבודה (Cetkovská et al., 2026).</a:t>
             </a:r>
             <a:endParaRPr lang="he-IL" sz="1500" dirty="0"/>
           </a:p>
@@ -4127,7 +4127,7 @@
                 <a:ea typeface="David" pitchFamily="34" charset="-122"/>
                 <a:cs typeface="David" pitchFamily="34" charset="-120"/>
               </a:rPr>
-              <a:t>אוטונומיה</a:t>
+              <a:t>‏אוטונומיה</a:t>
             </a:r>
             <a:endParaRPr lang="he-IL" sz="1600" dirty="0"/>
           </a:p>
@@ -4169,7 +4169,7 @@
                 <a:ea typeface="David" pitchFamily="34" charset="-122"/>
                 <a:cs typeface="David" pitchFamily="34" charset="-120"/>
               </a:rPr>
-              <a:t>שאלה מנחה: באילו החלטות קטנות אני יכול/ה לבחור בעצמי?</a:t>
+              <a:t>‏שאלה מנחה: באילו החלטות קטנות אני יכול/ה לבחור בעצמי?</a:t>
             </a:r>
             <a:endParaRPr lang="he-IL" sz="1250" dirty="0"/>
           </a:p>
@@ -4198,7 +4198,7 @@
                 <a:ea typeface="David" pitchFamily="34" charset="-122"/>
                 <a:cs typeface="David" pitchFamily="34" charset="-120"/>
               </a:rPr>
-              <a:t>לשבועיים הקרובים: לקבוע את סדר המשימות של הבוקר; להציע דרך משלי למשימה חוזרת; שעה קבועה ללא הפרעות.</a:t>
+              <a:t>‏לשבועיים הקרובים: לקבוע את סדר המשימות של הבוקר; להציע דרך משלי למשימה חוזרת; שעה קבועה ללא הפרעות.</a:t>
             </a:r>
             <a:endParaRPr lang="he-IL" sz="1250" dirty="0"/>
           </a:p>
@@ -4312,7 +4312,7 @@
                 <a:ea typeface="David" pitchFamily="34" charset="-122"/>
                 <a:cs typeface="David" pitchFamily="34" charset="-120"/>
               </a:rPr>
-              <a:t>מיומנות</a:t>
+              <a:t>‏מיומנות</a:t>
             </a:r>
             <a:endParaRPr lang="he-IL" sz="1600" dirty="0"/>
           </a:p>
@@ -4354,7 +4354,7 @@
                 <a:ea typeface="David" pitchFamily="34" charset="-122"/>
                 <a:cs typeface="David" pitchFamily="34" charset="-120"/>
               </a:rPr>
-              <a:t>שאלה מנחה: איזה אתגר בגובה הנכון יגרום לי להרגיש שאני מתקדם/ת?</a:t>
+              <a:t>‏שאלה מנחה: איזה אתגר בגובה הנכון יגרום לי להרגיש שאני מתקדם/ת?</a:t>
             </a:r>
             <a:endParaRPr lang="he-IL" sz="1250" dirty="0"/>
           </a:p>
@@ -4383,7 +4383,7 @@
                 <a:ea typeface="David" pitchFamily="34" charset="-122"/>
                 <a:cs typeface="David" pitchFamily="34" charset="-120"/>
               </a:rPr>
-              <a:t>לשבועיים הקרובים: משימה אחת מעט מעבר ליכולת; כלי בינה מלאכותית אחד בתחום; לתעד בסוף השבוע דבר אחד שלמדתי.</a:t>
+              <a:t>‏לשבועיים הקרובים: משימה אחת מעט מעבר ליכולת; כלי בינה מלאכותית אחד בתחום; לתעד בסוף השבוע דבר אחד שלמדתי.</a:t>
             </a:r>
             <a:endParaRPr lang="he-IL" sz="1250" dirty="0"/>
           </a:p>
@@ -4497,7 +4497,7 @@
                 <a:ea typeface="David" pitchFamily="34" charset="-122"/>
                 <a:cs typeface="David" pitchFamily="34" charset="-120"/>
               </a:rPr>
-              <a:t>משמעות</a:t>
+              <a:t>‏משמעות</a:t>
             </a:r>
             <a:endParaRPr lang="he-IL" sz="1600" dirty="0"/>
           </a:p>
@@ -4539,7 +4539,7 @@
                 <a:ea typeface="David" pitchFamily="34" charset="-122"/>
                 <a:cs typeface="David" pitchFamily="34" charset="-120"/>
               </a:rPr>
-              <a:t>שאלה מנחה: איזה חלק בעבודה מתחבר למה שחשוב לי, ואיך מגדילים אותו?</a:t>
+              <a:t>‏שאלה מנחה: איזה חלק בעבודה מתחבר למה שחשוב לי, ואיך מגדילים אותו?</a:t>
             </a:r>
             <a:endParaRPr lang="he-IL" sz="1250" dirty="0"/>
           </a:p>
@@ -4568,7 +4568,7 @@
                 <a:ea typeface="David" pitchFamily="34" charset="-122"/>
                 <a:cs typeface="David" pitchFamily="34" charset="-120"/>
               </a:rPr>
-              <a:t>לשבועיים הקרובים: לזהות למי העבודה שלי עוזרת ולדבר איתו; לנסח במשפט למה התפקיד חשוב; להתנדב למשימה שמתחברת לערכים.</a:t>
+              <a:t>‏לשבועיים הקרובים: לזהות למי העבודה שלי עוזרת ולדבר איתו; לנסח במשפט למה התפקיד חשוב; להתנדב למשימה שמתחברת לערכים.</a:t>
             </a:r>
             <a:endParaRPr lang="he-IL" sz="1250" dirty="0"/>
           </a:p>
@@ -4682,7 +4682,7 @@
                 <a:ea typeface="David" pitchFamily="34" charset="-122"/>
                 <a:cs typeface="David" pitchFamily="34" charset="-120"/>
               </a:rPr>
-              <a:t>שייכות</a:t>
+              <a:t>‏שייכות</a:t>
             </a:r>
             <a:endParaRPr lang="he-IL" sz="1600" dirty="0"/>
           </a:p>
@@ -4724,7 +4724,7 @@
                 <a:ea typeface="David" pitchFamily="34" charset="-122"/>
                 <a:cs typeface="David" pitchFamily="34" charset="-120"/>
               </a:rPr>
-              <a:t>שאלה מנחה: עם מי בעבודה אני רוצה קשר אמיתי יותר?</a:t>
+              <a:t>‏שאלה מנחה: עם מי בעבודה אני רוצה קשר אמיתי יותר?</a:t>
             </a:r>
             <a:endParaRPr lang="he-IL" sz="1250" dirty="0"/>
           </a:p>
@@ -4753,7 +4753,7 @@
                 <a:ea typeface="David" pitchFamily="34" charset="-122"/>
                 <a:cs typeface="David" pitchFamily="34" charset="-120"/>
               </a:rPr>
-              <a:t>לשבועיים הקרובים: הפסקת קפה קבועה עם עמית; להציע עזרה לפני שמבקשים; להצטרף לפרויקט חוצה מחלקות.</a:t>
+              <a:t>‏לשבועיים הקרובים: הפסקת קפה קבועה עם עמית; להציע עזרה לפני שמבקשים; להצטרף לפרויקט חוצה מחלקות.</a:t>
             </a:r>
             <a:endParaRPr lang="he-IL" sz="1250" dirty="0"/>
           </a:p>
@@ -4792,7 +4792,7 @@
                 <a:ea typeface="David" pitchFamily="34" charset="-122"/>
                 <a:cs typeface="David" pitchFamily="34" charset="-120"/>
               </a:rPr>
-              <a:t>איור 2: תוכנית עיצוב תפקיד אישית לפי ארבעת צרכי ההתקרבות. פיתוח על פי Cetkovská et al. (2026)</a:t>
+              <a:t>‏איור 2: תוכנית עיצוב תפקיד אישית לפי ארבעת צרכי ההתקרבות. פיתוח על פי Cetkovská et al. (2026)</a:t>
             </a:r>
             <a:endParaRPr lang="he-IL" sz="1100" dirty="0"/>
           </a:p>
@@ -4854,7 +4854,7 @@
                 <a:ea typeface="David" pitchFamily="34" charset="-122"/>
                 <a:cs typeface="David" pitchFamily="34" charset="-120"/>
               </a:rPr>
-              <a:t>ניהול קריירה בארגונים, הקריה האקדמית אונו</a:t>
+              <a:t>‏ניהול קריירה בארגונים, הקריה האקדמית אונו</a:t>
             </a:r>
             <a:endParaRPr lang="he-IL" sz="1000" dirty="0"/>
           </a:p>
@@ -4893,7 +4893,7 @@
                 <a:ea typeface="David" pitchFamily="34" charset="-122"/>
                 <a:cs typeface="David" pitchFamily="34" charset="-120"/>
               </a:rPr>
-              <a:t>13</a:t>
+              <a:t>‏13</a:t>
             </a:r>
             <a:endParaRPr lang="he-IL" sz="1100" dirty="0"/>
           </a:p>
@@ -5014,7 +5014,7 @@
                 <a:ea typeface="David" pitchFamily="34" charset="-122"/>
                 <a:cs typeface="David" pitchFamily="34" charset="-120"/>
               </a:rPr>
-              <a:t>אמצעי עזר להמחשה ולהפעלה</a:t>
+              <a:t>‏אמצעי עזר להמחשה ולהפעלה</a:t>
             </a:r>
             <a:endParaRPr lang="he-IL" sz="2800" dirty="0"/>
           </a:p>
@@ -5041,7 +5041,7 @@
           <a:bodyPr wrap="square" lIns="0" tIns="0" rIns="0" bIns="0" rtlCol="0" anchor="t"/>
           <a:lstStyle/>
           <a:p>
-            <a:pPr rtl="1" algn="just" indent="0" marL="0">
+            <a:pPr rtl="1" algn="r" indent="0" marL="0">
               <a:lnSpc>
                 <a:spcPct val="125000"/>
               </a:lnSpc>
@@ -5056,7 +5056,7 @@
                 <a:ea typeface="David" pitchFamily="34" charset="-122"/>
                 <a:cs typeface="David" pitchFamily="34" charset="-120"/>
               </a:rPr>
-              <a:t>כתבת עיתון וסקר פתיחה. ההצגה נפתחת בכותרת מהעיתונות הכלכלית על התייעלות באמצעות בינה מלאכותית בענף ההייטק ("הקשיים של מנהלי הייטק", 2026), ולאחריה הכיתה מתבקשת לדרג, בסולם 1 עד 5, עד כמה העבודה או הלימודים הנוכחיים מרגישים ברורים, בשליטה ומשמעותיים. שלוש השאלות הן שלושת רכיבי תחושת הקוהרנטיות בעבודה, והתוצאות נשמרות לדיון בסיום.</a:t>
+              <a:t>‏כתבת עיתון וסקר פתיחה. ההצגה נפתחת בכותרת מהעיתונות הכלכלית על התייעלות באמצעות בינה מלאכותית בענף ההייטק ("הקשיים של מנהלי הייטק", 2026), ולאחריה הכיתה מתבקשת לדרג, בסולם 1 עד 5, עד כמה העבודה או הלימודים הנוכחיים מרגישים ברורים, בשליטה ומשמעותיים. שלוש השאלות הן שלושת רכיבי תחושת הקוהרנטיות בעבודה, והתוצאות נשמרות לדיון בסיום.</a:t>
             </a:r>
             <a:endParaRPr lang="he-IL" sz="1600" dirty="0"/>
           </a:p>
@@ -5083,7 +5083,7 @@
           <a:bodyPr wrap="square" lIns="0" tIns="0" rIns="0" bIns="0" rtlCol="0" anchor="t"/>
           <a:lstStyle/>
           <a:p>
-            <a:pPr rtl="1" algn="just" indent="0" marL="0">
+            <a:pPr rtl="1" algn="r" indent="0" marL="0">
               <a:lnSpc>
                 <a:spcPct val="125000"/>
               </a:lnSpc>
@@ -5098,7 +5098,7 @@
                 <a:ea typeface="David" pitchFamily="34" charset="-122"/>
                 <a:cs typeface="David" pitchFamily="34" charset="-120"/>
               </a:rPr>
-              <a:t>סרטון. יוקרן קטע של כ-75 שניות מהרצאת TED של חוקרת החוסן לוסי הון, המציעה שלושה עקרונות: לקבל שדברים רעים קורים, לבחור במה להתמקד ולהפנות את הקשב למה שבשליטתנו, ולשאול על כל פעולה האם היא עוזרת או פוגעת (Hone, 2019). שני העקרונות האחרונים הם, במונחי המאמר, חיזוק המובנות והניהוליות והבחירה לעצב את המצב במקום רק לשרוד אותו.</a:t>
+              <a:t>‏סרטון. יוקרן קטע של כ-75 שניות מהרצאת TED של חוקרת החוסן לוסי הון, המציעה שלושה עקרונות: לקבל שדברים רעים קורים, לבחור במה להתמקד ולהפנות את הקשב למה שבשליטתנו, ולשאול על כל פעולה האם היא עוזרת או פוגעת (Hone, 2019). שני העקרונות האחרונים הם, במונחי המאמר, חיזוק המובנות והניהוליות והבחירה לעצב את המצב במקום רק לשרוד אותו.</a:t>
             </a:r>
             <a:endParaRPr lang="he-IL" sz="1600" dirty="0"/>
           </a:p>
@@ -5173,7 +5173,7 @@
           <a:bodyPr wrap="square" lIns="0" tIns="0" rIns="0" bIns="0" rtlCol="0" anchor="t"/>
           <a:lstStyle/>
           <a:p>
-            <a:pPr rtl="1" algn="just" indent="0" marL="0">
+            <a:pPr rtl="1" algn="r" indent="0" marL="0">
               <a:lnSpc>
                 <a:spcPct val="125000"/>
               </a:lnSpc>
@@ -5188,7 +5188,7 @@
                 <a:ea typeface="David" pitchFamily="34" charset="-122"/>
                 <a:cs typeface="David" pitchFamily="34" charset="-120"/>
               </a:rPr>
-              <a:t>הפעלה. כל סטודנט בוחר צורך התקרבות אחד מתוך ארבעת הצרכים שבאיור 2, כותב פעולה אחת קונקרטית ומועד לביצועה, ומשתף את השכן במשפט אחד. לאחר מכן נאספות שתיים או שלוש דוגמאות מהכיתה ומחוברות לממצא: פעולות מסוג זה, לפי המאמר, מנבאות עלייה בבהירות, בשליטה ובמשמעות חצי שנה מאוחר יותר (Cetkovská et al., 2026). משך ההפעלה כשתי דקות.</a:t>
+              <a:t>‏הפעלה. כל סטודנט בוחר צורך התקרבות אחד מתוך ארבעת הצרכים שבאיור 2, כותב פעולה אחת קונקרטית ומועד לביצועה, ומשתף את השכן במשפט אחד. לאחר מכן נאספות שתיים או שלוש דוגמאות מהכיתה ומחוברות לממצא: פעולות מסוג זה, לפי המאמר, מנבאות עלייה בבהירות, בשליטה ובמשמעות חצי שנה מאוחר יותר (Cetkovská et al., 2026). משך ההפעלה כשתי דקות.</a:t>
             </a:r>
             <a:endParaRPr lang="he-IL" sz="1600" dirty="0"/>
           </a:p>
@@ -5250,7 +5250,7 @@
                 <a:ea typeface="David" pitchFamily="34" charset="-122"/>
                 <a:cs typeface="David" pitchFamily="34" charset="-120"/>
               </a:rPr>
-              <a:t>ניהול קריירה בארגונים, הקריה האקדמית אונו</a:t>
+              <a:t>‏ניהול קריירה בארגונים, הקריה האקדמית אונו</a:t>
             </a:r>
             <a:endParaRPr lang="he-IL" sz="1000" dirty="0"/>
           </a:p>
@@ -5289,7 +5289,7 @@
                 <a:ea typeface="David" pitchFamily="34" charset="-122"/>
                 <a:cs typeface="David" pitchFamily="34" charset="-120"/>
               </a:rPr>
-              <a:t>14</a:t>
+              <a:t>‏14</a:t>
             </a:r>
             <a:endParaRPr lang="he-IL" sz="1100" dirty="0"/>
           </a:p>
@@ -5410,7 +5410,7 @@
                 <a:ea typeface="David" pitchFamily="34" charset="-122"/>
                 <a:cs typeface="David" pitchFamily="34" charset="-120"/>
               </a:rPr>
-              <a:t>סיכום</a:t>
+              <a:t>‏סיכום</a:t>
             </a:r>
             <a:endParaRPr lang="he-IL" sz="2800" dirty="0"/>
           </a:p>
@@ -5437,7 +5437,7 @@
           <a:bodyPr wrap="square" lIns="0" tIns="0" rIns="0" bIns="0" rtlCol="0" anchor="t"/>
           <a:lstStyle/>
           <a:p>
-            <a:pPr rtl="1" algn="just" indent="0" marL="0">
+            <a:pPr rtl="1" algn="r" indent="0" marL="0">
               <a:lnSpc>
                 <a:spcPct val="125000"/>
               </a:lnSpc>
@@ -5452,7 +5452,7 @@
                 <a:ea typeface="David" pitchFamily="34" charset="-122"/>
                 <a:cs typeface="David" pitchFamily="34" charset="-120"/>
               </a:rPr>
-              <a:t>העבודה פתחה בשאלה מה מאפשר לעובדים להישאר בריאים ומתפקדים כשעולם העבודה אינו יציב. התשובה שעלתה ממחקר האורך של צטקובסקה ואחרים היא שתחושת הקוהרנטיות בעבודה היא משאב דינמי שהעובד יכול לחזק בעצמו באמצעות עיצוב תפקיד המכוון לצרכי אוטונומיה, מיומנות, משמעות ושייכות, ושהמשאב הזה בתורו מזין יוזמה נוספת (Cetkovská et al., 2026). המאמר המשלים הראה שהמודעות לבינה מלאכותית היא מקור מרכזי לחוסר הביטחון של ימינו ושמשאב אישי ממתן אותו (Chung et al., 2025).</a:t>
+              <a:t>‏העבודה פתחה בשאלה מה מאפשר לעובדים להישאר בריאים ומתפקדים כשעולם העבודה אינו יציב. התשובה שעלתה ממחקר האורך של צטקובסקה ואחרים היא שתחושת הקוהרנטיות בעבודה היא משאב דינמי שהעובד יכול לחזק בעצמו באמצעות עיצוב תפקיד המכוון לצרכי אוטונומיה, מיומנות, משמעות ושייכות, ושהמשאב הזה בתורו מזין יוזמה נוספת (Cetkovská et al., 2026). המאמר המשלים הראה שהמודעות לבינה מלאכותית היא מקור מרכזי לחוסר הביטחון של ימינו ושמשאב אישי ממתן אותו (Chung et al., 2025).</a:t>
             </a:r>
             <a:endParaRPr lang="he-IL" sz="1600" dirty="0"/>
           </a:p>
@@ -5479,7 +5479,7 @@
           <a:bodyPr wrap="square" lIns="0" tIns="0" rIns="0" bIns="0" rtlCol="0" anchor="t"/>
           <a:lstStyle/>
           <a:p>
-            <a:pPr rtl="1" algn="just" indent="0" marL="0">
+            <a:pPr rtl="1" algn="r" indent="0" marL="0">
               <a:lnSpc>
                 <a:spcPct val="125000"/>
               </a:lnSpc>
@@ -5494,7 +5494,7 @@
                 <a:ea typeface="David" pitchFamily="34" charset="-122"/>
                 <a:cs typeface="David" pitchFamily="34" charset="-120"/>
               </a:rPr>
-              <a:t>מכאן ההמלצות היישומיות. לסטודנט: לבחור בכל שבועיים צורך התקרבות אחד ופעולה אחת של עיצוב תפקיד, ללמוד כלי בינה מלאכותית אחד בתחום העיסוק, ולתעד בסוף כל שבוע דבר אחד שנלמד. למנהל: לטפח תחושת ניהוליות באמצעות משאבים ומידע ברור, לתת מרחב לעיצוב תפקיד, ולתקשר שינויים טכנולוגיים בשקיפות. את חוסר הוודאות לא תמיד אפשר למנוע. את הבהירות, השליטה והמשמעות בתוך התפקיד אפשר לבנות.</a:t>
+              <a:t>‏מכאן ההמלצות היישומיות. לסטודנט: לבחור בכל שבועיים צורך התקרבות אחד ופעולה אחת של עיצוב תפקיד, ללמוד כלי בינה מלאכותית אחד בתחום העיסוק, ולתעד בסוף כל שבוע דבר אחד שנלמד. למנהל: לטפח תחושת ניהוליות באמצעות משאבים ומידע ברור, לתת מרחב לעיצוב תפקיד, ולתקשר שינויים טכנולוגיים בשקיפות. את חוסר הוודאות לא תמיד אפשר למנוע. את הבהירות, השליטה והמשמעות בתוך התפקיד אפשר לבנות.</a:t>
             </a:r>
             <a:endParaRPr lang="he-IL" sz="1600" dirty="0"/>
           </a:p>
@@ -5533,7 +5533,7 @@
                 <a:ea typeface="David" pitchFamily="34" charset="-122"/>
                 <a:cs typeface="David" pitchFamily="34" charset="-120"/>
               </a:rPr>
-              <a:t>תודה. אשמח לשאלות.</a:t>
+              <a:t>‏תודה. אשמח לשאלות.</a:t>
             </a:r>
             <a:endParaRPr lang="he-IL" sz="1600" dirty="0"/>
           </a:p>
@@ -5595,7 +5595,7 @@
                 <a:ea typeface="David" pitchFamily="34" charset="-122"/>
                 <a:cs typeface="David" pitchFamily="34" charset="-120"/>
               </a:rPr>
-              <a:t>ניהול קריירה בארגונים, הקריה האקדמית אונו</a:t>
+              <a:t>‏ניהול קריירה בארגונים, הקריה האקדמית אונו</a:t>
             </a:r>
             <a:endParaRPr lang="he-IL" sz="1000" dirty="0"/>
           </a:p>
@@ -5634,7 +5634,7 @@
                 <a:ea typeface="David" pitchFamily="34" charset="-122"/>
                 <a:cs typeface="David" pitchFamily="34" charset="-120"/>
               </a:rPr>
-              <a:t>15</a:t>
+              <a:t>‏15</a:t>
             </a:r>
             <a:endParaRPr lang="he-IL" sz="1100" dirty="0"/>
           </a:p>
@@ -5755,7 +5755,7 @@
                 <a:ea typeface="David" pitchFamily="34" charset="-122"/>
                 <a:cs typeface="David" pitchFamily="34" charset="-120"/>
               </a:rPr>
-              <a:t>רשימת מקורות</a:t>
+              <a:t>‏רשימת מקורות</a:t>
             </a:r>
             <a:endParaRPr lang="he-IL" sz="2800" dirty="0"/>
           </a:p>
@@ -5797,7 +5797,7 @@
                 <a:ea typeface="David" pitchFamily="34" charset="-122"/>
                 <a:cs typeface="David" pitchFamily="34" charset="-120"/>
               </a:rPr>
-              <a:t>בנק ישראל. (2025, 11 במרץ). ההשפעה הצפויה של בינה מלאכותית יוצרת על העובדים: השלכות על המדיניות בשוק העבודה [תיבה מתוך דוח בנק ישראל לשנת 2024].</a:t>
+              <a:t>‏בנק ישראל. (2025, 11 במרץ). ההשפעה הצפויה של בינה מלאכותית יוצרת על העובדים: השלכות על המדיניות בשוק העבודה [תיבה מתוך דוח בנק ישראל לשנת 2024].</a:t>
             </a:r>
             <a:endParaRPr lang="he-IL" sz="1300" dirty="0"/>
           </a:p>
@@ -5814,7 +5814,7 @@
                 <a:ea typeface="David" pitchFamily="34" charset="-122"/>
                 <a:cs typeface="David" pitchFamily="34" charset="-120"/>
               </a:rPr>
-              <a:t>הקשיים של מנהלי הייטק ב-2026: גיוס עובדים מתאימים והתייעלות AI. (2026, 21 ביוני). TheMarker.</a:t>
+              <a:t>‏הקשיים של מנהלי הייטק ב-2026: גיוס עובדים מתאימים והתייעלות AI. (2026, 21 ביוני). TheMarker.</a:t>
             </a:r>
             <a:endParaRPr lang="he-IL" sz="1300" dirty="0"/>
           </a:p>
@@ -5975,7 +5975,7 @@
                 <a:ea typeface="David" pitchFamily="34" charset="-122"/>
                 <a:cs typeface="David" pitchFamily="34" charset="-120"/>
               </a:rPr>
-              <a:t>ניהול קריירה בארגונים, הקריה האקדמית אונו</a:t>
+              <a:t>‏ניהול קריירה בארגונים, הקריה האקדמית אונו</a:t>
             </a:r>
             <a:endParaRPr lang="he-IL" sz="1000" dirty="0"/>
           </a:p>
@@ -6014,7 +6014,7 @@
                 <a:ea typeface="David" pitchFamily="34" charset="-122"/>
                 <a:cs typeface="David" pitchFamily="34" charset="-120"/>
               </a:rPr>
-              <a:t>16</a:t>
+              <a:t>‏16</a:t>
             </a:r>
             <a:endParaRPr lang="he-IL" sz="1100" dirty="0"/>
           </a:p>
@@ -6135,7 +6135,7 @@
                 <a:ea typeface="David" pitchFamily="34" charset="-122"/>
                 <a:cs typeface="David" pitchFamily="34" charset="-120"/>
               </a:rPr>
-              <a:t>מבוא: הצגת הנושא</a:t>
+              <a:t>‏מבוא: הצגת הנושא</a:t>
             </a:r>
             <a:endParaRPr lang="he-IL" sz="2800" dirty="0"/>
           </a:p>
@@ -6162,7 +6162,7 @@
           <a:bodyPr wrap="square" lIns="0" tIns="0" rIns="0" bIns="0" rtlCol="0" anchor="t"/>
           <a:lstStyle/>
           <a:p>
-            <a:pPr rtl="1" algn="just" indent="0" marL="0">
+            <a:pPr rtl="1" algn="r" indent="0" marL="0">
               <a:lnSpc>
                 <a:spcPct val="125000"/>
               </a:lnSpc>
@@ -6177,7 +6177,7 @@
                 <a:ea typeface="David" pitchFamily="34" charset="-122"/>
                 <a:cs typeface="David" pitchFamily="34" charset="-120"/>
               </a:rPr>
-              <a:t>עולם העבודה של שנת 2026 מתאפיין באי-ודאות. גלי ההתייעלות בענף ההייטק, כניסת הבינה המלאכותית היוצרת לתפקידי צווארון לבן, המלחמה ושירות המילואים הממושך והמעבר לצורות העסקה גמישות יצרו מציאות שבה גם עובדים בעלי ותק אינם יודעים כיצד ייראה תפקידם בעוד שנה. תיבה בדוח בנק ישראל לשנת 2024 העריכה כי כחמישית מהמועסקים בישראל עובדים במקצועות שבהם הביקוש צפוי לרדת באופן משמעותי עם התרחבות השימוש בבינה מלאכותית (בנק ישראל, 2025), ובעיתונות הכלכלית דווח כי ההתייעלות באמצעות בינה מלאכותית עומדת בראש סדר היום של מנהלי ההייטק ("הקשיים של מנהלי הייטק", 2026). חוסר ביטחון תעסוקתי, החשש לאבד את המשרה או את מאפייניה החשובים, הפך מאירוע חריג לתנאי קבוע (Chung et al., 2025).</a:t>
+              <a:t>‏עולם העבודה של שנת 2026 מתאפיין באי-ודאות. גלי ההתייעלות בענף ההייטק, כניסת הבינה המלאכותית היוצרת לתפקידי צווארון לבן, המלחמה ושירות המילואים הממושך והמעבר לצורות העסקה גמישות יצרו מציאות שבה גם עובדים בעלי ותק אינם יודעים כיצד ייראה תפקידם בעוד שנה. תיבה בדוח בנק ישראל לשנת 2024 העריכה כי כחמישית מהמועסקים בישראל עובדים במקצועות שבהם הביקוש צפוי לרדת באופן משמעותי עם התרחבות השימוש בבינה מלאכותית (בנק ישראל, 2025), ובעיתונות הכלכלית דווח כי ההתייעלות באמצעות בינה מלאכותית עומדת בראש סדר היום של מנהלי ההייטק ("הקשיים של מנהלי הייטק", 2026). חוסר ביטחון תעסוקתי, החשש לאבד את המשרה או את מאפייניה החשובים, הפך מאירוע חריג לתנאי קבוע (Chung et al., 2025).</a:t>
             </a:r>
             <a:endParaRPr lang="he-IL" sz="1600" dirty="0"/>
           </a:p>
@@ -6204,7 +6204,7 @@
           <a:bodyPr wrap="square" lIns="0" tIns="0" rIns="0" bIns="0" rtlCol="0" anchor="t"/>
           <a:lstStyle/>
           <a:p>
-            <a:pPr rtl="1" algn="just" indent="0" marL="0">
+            <a:pPr rtl="1" algn="r" indent="0" marL="0">
               <a:lnSpc>
                 <a:spcPct val="125000"/>
               </a:lnSpc>
@@ -6219,7 +6219,7 @@
                 <a:ea typeface="David" pitchFamily="34" charset="-122"/>
                 <a:cs typeface="David" pitchFamily="34" charset="-120"/>
               </a:rPr>
-              <a:t>רוב המחקר בתחום שואל מה הנזק שאי-הוודאות גורמת. עבודה זו בוחרת בשאלה ההפוכה, שהציב אהרן אנטונובסקי מאוניברסיטת בן-גוריון: מה מאפשר לעובדים להישאר בריאים ומתפקדים גם כשהסביבה אינה יציבה (Antonovsky, 1987, כפי שמצוטט אצל Cetkovská et al., 2026). המאמר שנבחר מציע תשובה שנמצאת בשליטת העובד עצמו.</a:t>
+              <a:t>‏רוב המחקר בתחום שואל מה הנזק שאי-הוודאות גורמת. עבודה זו בוחרת בשאלה ההפוכה, שהציב אהרן אנטונובסקי מאוניברסיטת בן-גוריון: מה מאפשר לעובדים להישאר בריאים ומתפקדים גם כשהסביבה אינה יציבה (Antonovsky, 1987, כפי שמצוטט אצל Cetkovská et al., 2026). המאמר שנבחר מציע תשובה שנמצאת בשליטת העובד עצמו.</a:t>
             </a:r>
             <a:endParaRPr lang="he-IL" sz="1600" dirty="0"/>
           </a:p>
@@ -6281,7 +6281,7 @@
                 <a:ea typeface="David" pitchFamily="34" charset="-122"/>
                 <a:cs typeface="David" pitchFamily="34" charset="-120"/>
               </a:rPr>
-              <a:t>ניהול קריירה בארגונים, הקריה האקדמית אונו</a:t>
+              <a:t>‏ניהול קריירה בארגונים, הקריה האקדמית אונו</a:t>
             </a:r>
             <a:endParaRPr lang="he-IL" sz="1000" dirty="0"/>
           </a:p>
@@ -6320,7 +6320,7 @@
                 <a:ea typeface="David" pitchFamily="34" charset="-122"/>
                 <a:cs typeface="David" pitchFamily="34" charset="-120"/>
               </a:rPr>
-              <a:t>2</a:t>
+              <a:t>‏2</a:t>
             </a:r>
             <a:endParaRPr lang="he-IL" sz="1100" dirty="0"/>
           </a:p>
@@ -6441,7 +6441,7 @@
                 <a:ea typeface="David" pitchFamily="34" charset="-122"/>
                 <a:cs typeface="David" pitchFamily="34" charset="-120"/>
               </a:rPr>
-              <a:t>מבוא: הצגת המאמר</a:t>
+              <a:t>‏מבוא: הצגת המאמר</a:t>
             </a:r>
             <a:endParaRPr lang="he-IL" sz="2800" dirty="0"/>
           </a:p>
@@ -6507,7 +6507,7 @@
           <a:bodyPr wrap="square" lIns="0" tIns="0" rIns="0" bIns="0" rtlCol="0" anchor="t"/>
           <a:lstStyle/>
           <a:p>
-            <a:pPr rtl="1" algn="just" indent="0" marL="0">
+            <a:pPr rtl="1" algn="r" indent="0" marL="0">
               <a:lnSpc>
                 <a:spcPct val="125000"/>
               </a:lnSpc>
@@ -6522,7 +6522,7 @@
                 <a:ea typeface="David" pitchFamily="34" charset="-122"/>
                 <a:cs typeface="David" pitchFamily="34" charset="-120"/>
               </a:rPr>
-              <a:t>המאמר שנבחר הוא מחקר אמפירי כמותי במערך אורך, שפורסם בשנת 2026 בכתב העת השפיט Scandinavian Journal of Work and Organizational Psychology, היוצא לאור בהוצאת אוניברסיטת סטוקהולם, בגישה פתוחה מלאה. מחבריו הם קריסטינה צטקובסקה מאוניברסיטת קארל בפראג, וגאורג באואר ומרטין טושל מהמרכז לסלוטוגנזה באוניברסיטת ציריך, והמחקר מומן על ידי הקרן הלאומית השווייצרית למדע (Cetkovská et al., 2026).</a:t>
+              <a:t>‏המאמר שנבחר הוא מחקר אמפירי כמותי במערך אורך, שפורסם בשנת 2026 בכתב העת השפיט Scandinavian Journal of Work and Organizational Psychology, היוצא לאור בהוצאת אוניברסיטת סטוקהולם, בגישה פתוחה מלאה. מחבריו הם קריסטינה צטקובסקה מאוניברסיטת קארל בפראג, וגאורג באואר ומרטין טושל מהמרכז לסלוטוגנזה באוניברסיטת ציריך, והמחקר מומן על ידי הקרן הלאומית השווייצרית למדע (Cetkovská et al., 2026).</a:t>
             </a:r>
             <a:endParaRPr lang="he-IL" sz="1600" dirty="0"/>
           </a:p>
@@ -6549,7 +6549,7 @@
           <a:bodyPr wrap="square" lIns="0" tIns="0" rIns="0" bIns="0" rtlCol="0" anchor="t"/>
           <a:lstStyle/>
           <a:p>
-            <a:pPr rtl="1" algn="just" indent="0" marL="0">
+            <a:pPr rtl="1" algn="r" indent="0" marL="0">
               <a:lnSpc>
                 <a:spcPct val="125000"/>
               </a:lnSpc>
@@ -6564,7 +6564,7 @@
                 <a:ea typeface="David" pitchFamily="34" charset="-122"/>
                 <a:cs typeface="David" pitchFamily="34" charset="-120"/>
               </a:rPr>
-              <a:t>מדובר במחקר פאנל בשני גלי מדידה בהפרש של שישה חודשים, שבו השתתפו 924 עובדים מגרמניה ומשווייץ. המאמר נבחר משום שהוא שואל מה עוזר לעובדים ולא רק מה מזיק להם, משום שהוא מציע כלי שאינו תלוי בארגון, ומשום שהוא עומד בדרישות המטלה: מאמר שפיט מחמש השנים האחרונות, מקיף ומהימן, הזמין במלואו לכל קורא (Cetkovská et al., 2026).</a:t>
+              <a:t>‏מדובר במחקר פאנל בשני גלי מדידה בהפרש של שישה חודשים, שבו השתתפו 924 עובדים מגרמניה ומשווייץ. המאמר נבחר משום שהוא שואל מה עוזר לעובדים ולא רק מה מזיק להם, משום שהוא מציע כלי שאינו תלוי בארגון, ומשום שהוא עומד בדרישות המטלה: מאמר שפיט מחמש השנים האחרונות, מקיף ומהימן, הזמין במלואו לכל קורא (Cetkovská et al., 2026).</a:t>
             </a:r>
             <a:endParaRPr lang="he-IL" sz="1600" dirty="0"/>
           </a:p>
@@ -6626,7 +6626,7 @@
                 <a:ea typeface="David" pitchFamily="34" charset="-122"/>
                 <a:cs typeface="David" pitchFamily="34" charset="-120"/>
               </a:rPr>
-              <a:t>ניהול קריירה בארגונים, הקריה האקדמית אונו</a:t>
+              <a:t>‏ניהול קריירה בארגונים, הקריה האקדמית אונו</a:t>
             </a:r>
             <a:endParaRPr lang="he-IL" sz="1000" dirty="0"/>
           </a:p>
@@ -6665,7 +6665,7 @@
                 <a:ea typeface="David" pitchFamily="34" charset="-122"/>
                 <a:cs typeface="David" pitchFamily="34" charset="-120"/>
               </a:rPr>
-              <a:t>3</a:t>
+              <a:t>‏3</a:t>
             </a:r>
             <a:endParaRPr lang="he-IL" sz="1100" dirty="0"/>
           </a:p>
@@ -6786,7 +6786,7 @@
                 <a:ea typeface="David" pitchFamily="34" charset="-122"/>
                 <a:cs typeface="David" pitchFamily="34" charset="-120"/>
               </a:rPr>
-              <a:t>תמצית המאמר: הרקע התיאורטי</a:t>
+              <a:t>‏תמצית המאמר: הרקע התיאורטי</a:t>
             </a:r>
             <a:endParaRPr lang="he-IL" sz="2800" dirty="0"/>
           </a:p>
@@ -6813,7 +6813,7 @@
           <a:bodyPr wrap="square" lIns="0" tIns="0" rIns="0" bIns="0" rtlCol="0" anchor="t"/>
           <a:lstStyle/>
           <a:p>
-            <a:pPr rtl="1" algn="just" indent="0" marL="0">
+            <a:pPr rtl="1" algn="r" indent="0" marL="0">
               <a:lnSpc>
                 <a:spcPct val="125000"/>
               </a:lnSpc>
@@ -6828,7 +6828,7 @@
                 <a:ea typeface="David" pitchFamily="34" charset="-122"/>
                 <a:cs typeface="David" pitchFamily="34" charset="-120"/>
               </a:rPr>
-              <a:t>הגישה הסלוטוגנית הופכת את שאלת המחקר המקובלת: במקום לשאול מדוע אנשים חולים, היא שואלת כיצד הם שומרים על בריאותם למרות גורמי דחק. במרכזה עומדת תחושת הקוהרנטיות, המידה שבה האדם תופס את חייו כמובנים, כניתנים לניהול וכמשמעותיים (Antonovsky, 1987, כפי שמצוטט אצל Cetkovská et al., 2026). על בסיס זה פותח המושג תחושת קוהרנטיות בעבודה, המתייחס למצב העבודה הנוכחי בלבד ומורכב משלושה רכיבים. בניגוד לתחושת הקוהרנטיות הכללית, המתייצבת בבגרות הצעירה, הרכיב התעסוקתי דינמי ומעוצב ללא הרף על ידי תנאי העבודה (Cetkovská et al., 2026).</a:t>
+              <a:t>‏הגישה הסלוטוגנית הופכת את שאלת המחקר המקובלת: במקום לשאול מדוע אנשים חולים, היא שואלת כיצד הם שומרים על בריאותם למרות גורמי דחק. במרכזה עומדת תחושת הקוהרנטיות, המידה שבה האדם תופס את חייו כמובנים, כניתנים לניהול וכמשמעותיים (Antonovsky, 1987, כפי שמצוטט אצל Cetkovská et al., 2026). על בסיס זה פותח המושג תחושת קוהרנטיות בעבודה, המתייחס למצב העבודה הנוכחי בלבד ומורכב משלושה רכיבים. בניגוד לתחושת הקוהרנטיות הכללית, המתייצבת בבגרות הצעירה, הרכיב התעסוקתי דינמי ומעוצב ללא הרף על ידי תנאי העבודה (Cetkovská et al., 2026).</a:t>
             </a:r>
             <a:endParaRPr lang="he-IL" sz="1600" dirty="0"/>
           </a:p>
@@ -6942,7 +6942,7 @@
                 <a:ea typeface="David" pitchFamily="34" charset="-122"/>
                 <a:cs typeface="David" pitchFamily="34" charset="-120"/>
               </a:rPr>
-              <a:t>מובנות (רכיב קוגניטיבי)</a:t>
+              <a:t>‏מובנות (רכיב קוגניטיבי)</a:t>
             </a:r>
             <a:endParaRPr lang="he-IL" sz="1600" dirty="0"/>
           </a:p>
@@ -6984,7 +6984,7 @@
                 <a:ea typeface="David" pitchFamily="34" charset="-122"/>
                 <a:cs typeface="David" pitchFamily="34" charset="-120"/>
               </a:rPr>
-              <a:t>מצב העבודה נתפס כמובנה, עקבי וברור. חוסר ודאות פוגע ברכיב זה ראשון: העתיד אינו צפוי.</a:t>
+              <a:t>‏מצב העבודה נתפס כמובנה, עקבי וברור. חוסר ודאות פוגע ברכיב זה ראשון: העתיד אינו צפוי.</a:t>
             </a:r>
             <a:endParaRPr lang="he-IL" sz="1300" dirty="0"/>
           </a:p>
@@ -7098,7 +7098,7 @@
                 <a:ea typeface="David" pitchFamily="34" charset="-122"/>
                 <a:cs typeface="David" pitchFamily="34" charset="-120"/>
               </a:rPr>
-              <a:t>ניהוליות (רכיב התנהגותי)</a:t>
+              <a:t>‏ניהוליות (רכיב התנהגותי)</a:t>
             </a:r>
             <a:endParaRPr lang="he-IL" sz="1600" dirty="0"/>
           </a:p>
@@ -7140,7 +7140,7 @@
                 <a:ea typeface="David" pitchFamily="34" charset="-122"/>
                 <a:cs typeface="David" pitchFamily="34" charset="-120"/>
               </a:rPr>
-              <a:t>לעובד יש משאבים מספיקים להתמודד עם הדרישות. בתקופת אי-ודאות המשאבים נראים בלתי מספיקים.</a:t>
+              <a:t>‏לעובד יש משאבים מספיקים להתמודד עם הדרישות. בתקופת אי-ודאות המשאבים נראים בלתי מספיקים.</a:t>
             </a:r>
             <a:endParaRPr lang="he-IL" sz="1300" dirty="0"/>
           </a:p>
@@ -7254,7 +7254,7 @@
                 <a:ea typeface="David" pitchFamily="34" charset="-122"/>
                 <a:cs typeface="David" pitchFamily="34" charset="-120"/>
               </a:rPr>
-              <a:t>משמעותיות (רכיב מוטיבציוני)</a:t>
+              <a:t>‏משמעותיות (רכיב מוטיבציוני)</a:t>
             </a:r>
             <a:endParaRPr lang="he-IL" sz="1600" dirty="0"/>
           </a:p>
@@ -7296,7 +7296,7 @@
                 <a:ea typeface="David" pitchFamily="34" charset="-122"/>
                 <a:cs typeface="David" pitchFamily="34" charset="-120"/>
               </a:rPr>
-              <a:t>מצב העבודה נתפס כראוי למחויבות ולמעורבות. קשה להתחייב למה שעלול להיעלם.</a:t>
+              <a:t>‏מצב העבודה נתפס כראוי למחויבות ולמעורבות. קשה להתחייב למה שעלול להיעלם.</a:t>
             </a:r>
             <a:endParaRPr lang="he-IL" sz="1300" dirty="0"/>
           </a:p>
@@ -7335,7 +7335,7 @@
                 <a:ea typeface="David" pitchFamily="34" charset="-122"/>
                 <a:cs typeface="David" pitchFamily="34" charset="-120"/>
               </a:rPr>
-              <a:t>איור 1: שלושת רכיבי תחושת הקוהרנטיות בעבודה ופגיעתו של חוסר הוודאות בכל אחד מהם (על פי Cetkovská et al., 2026)</a:t>
+              <a:t>‏איור 1: שלושת רכיבי תחושת הקוהרנטיות בעבודה ופגיעתו של חוסר הוודאות בכל אחד מהם (על פי Cetkovská et al., 2026)</a:t>
             </a:r>
             <a:endParaRPr lang="he-IL" sz="1100" dirty="0"/>
           </a:p>
@@ -7397,7 +7397,7 @@
                 <a:ea typeface="David" pitchFamily="34" charset="-122"/>
                 <a:cs typeface="David" pitchFamily="34" charset="-120"/>
               </a:rPr>
-              <a:t>ניהול קריירה בארגונים, הקריה האקדמית אונו</a:t>
+              <a:t>‏ניהול קריירה בארגונים, הקריה האקדמית אונו</a:t>
             </a:r>
             <a:endParaRPr lang="he-IL" sz="1000" dirty="0"/>
           </a:p>
@@ -7436,7 +7436,7 @@
                 <a:ea typeface="David" pitchFamily="34" charset="-122"/>
                 <a:cs typeface="David" pitchFamily="34" charset="-120"/>
               </a:rPr>
-              <a:t>4</a:t>
+              <a:t>‏4</a:t>
             </a:r>
             <a:endParaRPr lang="he-IL" sz="1100" dirty="0"/>
           </a:p>
@@ -7557,7 +7557,7 @@
                 <a:ea typeface="David" pitchFamily="34" charset="-122"/>
                 <a:cs typeface="David" pitchFamily="34" charset="-120"/>
               </a:rPr>
-              <a:t>תמצית המאמר: עיצוב תפקיד מבוסס צרכים והשערות המחקר</a:t>
+              <a:t>‏תמצית המאמר: עיצוב תפקיד מבוסס צרכים והשערות המחקר</a:t>
             </a:r>
             <a:endParaRPr lang="he-IL" sz="2800" dirty="0"/>
           </a:p>
@@ -7584,7 +7584,7 @@
           <a:bodyPr wrap="square" lIns="0" tIns="0" rIns="0" bIns="0" rtlCol="0" anchor="t"/>
           <a:lstStyle/>
           <a:p>
-            <a:pPr rtl="1" algn="just" indent="0" marL="0">
+            <a:pPr rtl="1" algn="r" indent="0" marL="0">
               <a:lnSpc>
                 <a:spcPct val="125000"/>
               </a:lnSpc>
@@ -7599,7 +7599,7 @@
                 <a:ea typeface="David" pitchFamily="34" charset="-122"/>
                 <a:cs typeface="David" pitchFamily="34" charset="-120"/>
               </a:rPr>
-              <a:t>עיצוב תפקיד הוגדר לראשונה כמאמצים יזומים של עובדים להתאים היבטים של תפקידם לצרכיהם ולכישוריהם, גישה שהעבירה את העובד ממקבל פסיבי של תנאי עבודה לשחקן פעיל בעיצובם (Wrzesniewski &amp; Dutton, 2001, כפי שמצוטט אצל Cetkovská et al., 2026). המאמר משתמש בגרסה המתמקדת בסיפוק שישה צרכים פסיכולוגיים בעבודה, צרכי DRAMMA: ניתוק והרפיה הם צרכי הימנעות שמטרתם להפחית מאמץ ולהשיב אנרגיה, ואילו אוטונומיה, מיומנות, משמעות ושייכות הם צרכי התקרבות שמטרתם לייצר מצבים חיוביים, צמיחה ומשאבים חדשים. פריט לדוגמה: "ארגנתי את עבודתי כך שאשיג תחושת תכלית במה שאני עושה" (Cetkovská et al., 2026).</a:t>
+              <a:t>‏עיצוב תפקיד הוגדר לראשונה כמאמצים יזומים של עובדים להתאים היבטים של תפקידם לצרכיהם ולכישוריהם, גישה שהעבירה את העובד ממקבל פסיבי של תנאי עבודה לשחקן פעיל בעיצובם (Wrzesniewski &amp; Dutton, 2001, כפי שמצוטט אצל Cetkovská et al., 2026). המאמר משתמש בגרסה המתמקדת בסיפוק שישה צרכים פסיכולוגיים בעבודה, צרכי DRAMMA: ניתוק והרפיה הם צרכי הימנעות שמטרתם להפחית מאמץ ולהשיב אנרגיה, ואילו אוטונומיה, מיומנות, משמעות ושייכות הם צרכי התקרבות שמטרתם לייצר מצבים חיוביים, צמיחה ומשאבים חדשים. פריט לדוגמה: "ארגנתי את עבודתי כך שאשיג תחושת תכלית במה שאני עושה" (Cetkovská et al., 2026).</a:t>
             </a:r>
             <a:endParaRPr lang="he-IL" sz="1600" dirty="0"/>
           </a:p>
@@ -7626,7 +7626,7 @@
           <a:bodyPr wrap="square" lIns="0" tIns="0" rIns="0" bIns="0" rtlCol="0" anchor="t"/>
           <a:lstStyle/>
           <a:p>
-            <a:pPr rtl="1" algn="just" indent="0" marL="0">
+            <a:pPr rtl="1" algn="r" indent="0" marL="0">
               <a:lnSpc>
                 <a:spcPct val="125000"/>
               </a:lnSpc>
@@ -7641,7 +7641,7 @@
                 <a:ea typeface="David" pitchFamily="34" charset="-122"/>
                 <a:cs typeface="David" pitchFamily="34" charset="-120"/>
               </a:rPr>
-              <a:t>על בסיס תיאוריית שימור המשאבים, שלפיה מי שמחזיק במשאבים נוטה לפתח משאבים נוספים (Hobfoll, 2001, כפי שמצוטט אצל Cetkovská et al., 2026), הועלו שתי השערות. ההשערה הראשונה היא שעיצוב תפקיד מבוסס צרכים מנבא באופן חיובי את שלושת רכיבי תחושת הקוהרנטיות חצי שנה מאוחר יותר. ההשערה השנייה היא שתחושת קוהרנטיות בעבודה מנבאת עיצוב תפקיד עתידי. יחד הן מתארות "ספירלת רווח" שבה שני המשתנים מחזקים זה את זה לאורך זמן (Cetkovská et al., 2026).</a:t>
+              <a:t>‏על בסיס תיאוריית שימור המשאבים, שלפיה מי שמחזיק במשאבים נוטה לפתח משאבים נוספים (Hobfoll, 2001, כפי שמצוטט אצל Cetkovská et al., 2026), הועלו שתי השערות. ההשערה הראשונה היא שעיצוב תפקיד מבוסס צרכים מנבא באופן חיובי את שלושת רכיבי תחושת הקוהרנטיות חצי שנה מאוחר יותר. ההשערה השנייה היא שתחושת קוהרנטיות בעבודה מנבאת עיצוב תפקיד עתידי. יחד הן מתארות "ספירלת רווח" שבה שני המשתנים מחזקים זה את זה לאורך זמן (Cetkovská et al., 2026).</a:t>
             </a:r>
             <a:endParaRPr lang="he-IL" sz="1600" dirty="0"/>
           </a:p>
@@ -7703,7 +7703,7 @@
                 <a:ea typeface="David" pitchFamily="34" charset="-122"/>
                 <a:cs typeface="David" pitchFamily="34" charset="-120"/>
               </a:rPr>
-              <a:t>ניהול קריירה בארגונים, הקריה האקדמית אונו</a:t>
+              <a:t>‏ניהול קריירה בארגונים, הקריה האקדמית אונו</a:t>
             </a:r>
             <a:endParaRPr lang="he-IL" sz="1000" dirty="0"/>
           </a:p>
@@ -7742,7 +7742,7 @@
                 <a:ea typeface="David" pitchFamily="34" charset="-122"/>
                 <a:cs typeface="David" pitchFamily="34" charset="-120"/>
               </a:rPr>
-              <a:t>5</a:t>
+              <a:t>‏5</a:t>
             </a:r>
             <a:endParaRPr lang="he-IL" sz="1100" dirty="0"/>
           </a:p>
@@ -7863,7 +7863,7 @@
                 <a:ea typeface="David" pitchFamily="34" charset="-122"/>
                 <a:cs typeface="David" pitchFamily="34" charset="-120"/>
               </a:rPr>
-              <a:t>תמצית המאמר: שיטת המחקר</a:t>
+              <a:t>‏תמצית המאמר: שיטת המחקר</a:t>
             </a:r>
             <a:endParaRPr lang="he-IL" sz="2800" dirty="0"/>
           </a:p>
@@ -7890,7 +7890,7 @@
           <a:bodyPr wrap="square" lIns="0" tIns="0" rIns="0" bIns="0" rtlCol="0" anchor="t"/>
           <a:lstStyle/>
           <a:p>
-            <a:pPr rtl="1" algn="just" indent="0" marL="0">
+            <a:pPr rtl="1" algn="r" indent="0" marL="0">
               <a:lnSpc>
                 <a:spcPct val="125000"/>
               </a:lnSpc>
@@ -7905,7 +7905,7 @@
                 <a:ea typeface="David" pitchFamily="34" charset="-122"/>
                 <a:cs typeface="David" pitchFamily="34" charset="-120"/>
               </a:rPr>
-              <a:t>המחקר הוא מחקר פאנל בשני גלים בהפרש של שישה חודשים, במסגרת פרויקט Craft4Health. הנתונים נאספו בשאלון מקוון ממדגם מכסות של האוכלוסייה העובדת בגרמניה ובאזור דובר הגרמנית בשווייץ, בדצמבר 2021 עד ינואר 2022 וביוני עד יולי 2022. בגל הראשון השתתפו 924 עובדים, לאחר סינון 53 משיבים רשלניים, ו-740 מהם השלימו את הגל השני, שיעור השתתפות של 80%. במדגם 56% גברים, הגיל הממוצע 48.9, ממוצע שעות העבודה השבועיות 38.1, ו-35% מהמשתתפים בעלי תואר אקדמי (Cetkovská et al., 2026).</a:t>
+              <a:t>‏המחקר הוא מחקר פאנל בשני גלים בהפרש של שישה חודשים, במסגרת פרויקט Craft4Health. הנתונים נאספו בשאלון מקוון ממדגם מכסות של האוכלוסייה העובדת בגרמניה ובאזור דובר הגרמנית בשווייץ, בדצמבר 2021 עד ינואר 2022 וביוני עד יולי 2022. בגל הראשון השתתפו 924 עובדים, לאחר סינון 53 משיבים רשלניים, ו-740 מהם השלימו את הגל השני, שיעור השתתפות של 80%. במדגם 56% גברים, הגיל הממוצע 48.9, ממוצע שעות העבודה השבועיות 38.1, ו-35% מהמשתתפים בעלי תואר אקדמי (Cetkovská et al., 2026).</a:t>
             </a:r>
             <a:endParaRPr lang="he-IL" sz="1600" dirty="0"/>
           </a:p>
@@ -7932,7 +7932,7 @@
           <a:bodyPr wrap="square" lIns="0" tIns="0" rIns="0" bIns="0" rtlCol="0" anchor="t"/>
           <a:lstStyle/>
           <a:p>
-            <a:pPr rtl="1" algn="just" indent="0" marL="0">
+            <a:pPr rtl="1" algn="r" indent="0" marL="0">
               <a:lnSpc>
                 <a:spcPct val="125000"/>
               </a:lnSpc>
@@ -7947,7 +7947,7 @@
                 <a:ea typeface="David" pitchFamily="34" charset="-122"/>
                 <a:cs typeface="David" pitchFamily="34" charset="-120"/>
               </a:rPr>
-              <a:t>תחושת קוהרנטיות בעבודה נמדדה בסולם של תשעה פריטים, שלושה לכל רכיב, בדיפרנציאל סמנטי בן שבע דרגות, למשל צפוי לעומת בלתי צפוי. עיצוב תפקיד מבוסס צרכים נמדד בסולם של 18 פריטים, שלושה לכל אחד משישה הצרכים, בסולם של חמש דרגות ביחס לשבועיים האחרונים. הניתוח נערך במודל פאנל צולב, לאחר ניתוח גורמים מאשש ובדיקת אי-שונות מדידה בין הגלים, והושוו ארבעה מודלים: יציבות בלבד, שני מודלים חד-כיווניים ומודל הדדי (Cetkovská et al., 2026).</a:t>
+              <a:t>‏תחושת קוהרנטיות בעבודה נמדדה בסולם של תשעה פריטים, שלושה לכל רכיב, בדיפרנציאל סמנטי בן שבע דרגות, למשל צפוי לעומת בלתי צפוי. עיצוב תפקיד מבוסס צרכים נמדד בסולם של 18 פריטים, שלושה לכל אחד משישה הצרכים, בסולם של חמש דרגות ביחס לשבועיים האחרונים. הניתוח נערך במודל פאנל צולב, לאחר ניתוח גורמים מאשש ובדיקת אי-שונות מדידה בין הגלים, והושוו ארבעה מודלים: יציבות בלבד, שני מודלים חד-כיווניים ומודל הדדי (Cetkovská et al., 2026).</a:t>
             </a:r>
             <a:endParaRPr lang="he-IL" sz="1600" dirty="0"/>
           </a:p>
@@ -8009,7 +8009,7 @@
                 <a:ea typeface="David" pitchFamily="34" charset="-122"/>
                 <a:cs typeface="David" pitchFamily="34" charset="-120"/>
               </a:rPr>
-              <a:t>ניהול קריירה בארגונים, הקריה האקדמית אונו</a:t>
+              <a:t>‏ניהול קריירה בארגונים, הקריה האקדמית אונו</a:t>
             </a:r>
             <a:endParaRPr lang="he-IL" sz="1000" dirty="0"/>
           </a:p>
@@ -8048,7 +8048,7 @@
                 <a:ea typeface="David" pitchFamily="34" charset="-122"/>
                 <a:cs typeface="David" pitchFamily="34" charset="-120"/>
               </a:rPr>
-              <a:t>6</a:t>
+              <a:t>‏6</a:t>
             </a:r>
             <a:endParaRPr lang="he-IL" sz="1100" dirty="0"/>
           </a:p>
@@ -8169,7 +8169,7 @@
                 <a:ea typeface="David" pitchFamily="34" charset="-122"/>
                 <a:cs typeface="David" pitchFamily="34" charset="-120"/>
               </a:rPr>
-              <a:t>תמצית המאמר: הממצאים המרכזיים</a:t>
+              <a:t>‏תמצית המאמר: הממצאים המרכזיים</a:t>
             </a:r>
             <a:endParaRPr lang="he-IL" sz="2800" dirty="0"/>
           </a:p>
@@ -8196,7 +8196,7 @@
           <a:bodyPr wrap="square" lIns="0" tIns="0" rIns="0" bIns="0" rtlCol="0" anchor="t"/>
           <a:lstStyle/>
           <a:p>
-            <a:pPr rtl="1" algn="just" indent="0" marL="0">
+            <a:pPr rtl="1" algn="r" indent="0" marL="0">
               <a:lnSpc>
                 <a:spcPct val="125000"/>
               </a:lnSpc>
@@ -8211,7 +8211,7 @@
                 <a:ea typeface="David" pitchFamily="34" charset="-122"/>
                 <a:cs typeface="David" pitchFamily="34" charset="-120"/>
               </a:rPr>
-              <a:t>המודל ההדדי השיג את ההתאמה הטובה ביותר לנתונים. עיצוב תפקיד לצרכי התקרבות ניבא באופן מובהק את שלושת הרכיבים חצי שנה מאוחר יותר: מובנות (β = 0.142, p = .002), ניהוליות (β = 0.137, p = .003) ומשמעותיות (β = 0.166, p &lt; .001). עיצוב תפקיד לצרכי הימנעות לא ניבא אף אחד מהם (β בין 0.03 ל-0.09, לא מובהק). בכיוון ההפוך, ניהוליות (β = 0.431, p &lt; .001) ומשמעותיות (β = 0.095) ניבאו עיצוב תפקיד עתידי לצרכי התקרבות, ומובנות הראתה מקדם שלילי שהמחברים מייחסים לאפקט דיכוי סטטיסטי. המודל הסביר 56% עד 66% מהשונות ברכיבי תחושת הקוהרנטיות (Cetkovská et al., 2026).</a:t>
+              <a:t>‏המודל ההדדי השיג את ההתאמה הטובה ביותר לנתונים. עיצוב תפקיד לצרכי התקרבות ניבא באופן מובהק את שלושת הרכיבים חצי שנה מאוחר יותר: מובנות (β = 0.142, p = .002), ניהוליות (β = 0.137, p = .003) ומשמעותיות (β = 0.166, p &lt; .001). עיצוב תפקיד לצרכי הימנעות לא ניבא אף אחד מהם (β בין 0.03 ל-0.09, לא מובהק). בכיוון ההפוך, ניהוליות (β = 0.431, p &lt; .001) ומשמעותיות (β = 0.095) ניבאו עיצוב תפקיד עתידי לצרכי התקרבות, ומובנות הראתה מקדם שלילי שהמחברים מייחסים לאפקט דיכוי סטטיסטי. המודל הסביר 56% עד 66% מהשונות ברכיבי תחושת הקוהרנטיות (Cetkovská et al., 2026).</a:t>
             </a:r>
             <a:endParaRPr lang="he-IL" sz="1500" dirty="0"/>
           </a:p>
@@ -8266,7 +8266,7 @@
                 <a:ea typeface="David" pitchFamily="34" charset="-122"/>
                 <a:cs typeface="David" pitchFamily="34" charset="-120"/>
               </a:rPr>
-              <a:t>תרשים 1: מקדמי ניבוי מתוקננים (β) של שלושת רכיבי תחושת הקוהרנטיות בגל 2 לפי סוג עיצוב התפקיד בגל 1 (Cetkovská et al., 2026, טבלה 4)</a:t>
+              <a:t>‏תרשים 1: מקדמי ניבוי מתוקננים (β) של שלושת רכיבי תחושת הקוהרנטיות בגל 2 לפי סוג עיצוב התפקיד בגל 1 (Cetkovská et al., 2026, טבלה 4)</a:t>
             </a:r>
             <a:endParaRPr lang="he-IL" sz="1100" dirty="0"/>
           </a:p>
@@ -8328,7 +8328,7 @@
                 <a:ea typeface="David" pitchFamily="34" charset="-122"/>
                 <a:cs typeface="David" pitchFamily="34" charset="-120"/>
               </a:rPr>
-              <a:t>ניהול קריירה בארגונים, הקריה האקדמית אונו</a:t>
+              <a:t>‏ניהול קריירה בארגונים, הקריה האקדמית אונו</a:t>
             </a:r>
             <a:endParaRPr lang="he-IL" sz="1000" dirty="0"/>
           </a:p>
@@ -8367,7 +8367,7 @@
                 <a:ea typeface="David" pitchFamily="34" charset="-122"/>
                 <a:cs typeface="David" pitchFamily="34" charset="-120"/>
               </a:rPr>
-              <a:t>7</a:t>
+              <a:t>‏7</a:t>
             </a:r>
             <a:endParaRPr lang="he-IL" sz="1100" dirty="0"/>
           </a:p>
@@ -8488,7 +8488,7 @@
                 <a:ea typeface="David" pitchFamily="34" charset="-122"/>
                 <a:cs typeface="David" pitchFamily="34" charset="-120"/>
               </a:rPr>
-              <a:t>תמצית המאמר: מסקנות המחברים, חוזקות ומגבלות</a:t>
+              <a:t>‏תמצית המאמר: מסקנות המחברים, חוזקות ומגבלות</a:t>
             </a:r>
             <a:endParaRPr lang="he-IL" sz="2800" dirty="0"/>
           </a:p>
@@ -8515,7 +8515,7 @@
           <a:bodyPr wrap="square" lIns="0" tIns="0" rIns="0" bIns="0" rtlCol="0" anchor="t"/>
           <a:lstStyle/>
           <a:p>
-            <a:pPr rtl="1" algn="just" indent="0" marL="0">
+            <a:pPr rtl="1" algn="r" indent="0" marL="0">
               <a:lnSpc>
                 <a:spcPct val="125000"/>
               </a:lnSpc>
@@ -8530,7 +8530,7 @@
                 <a:ea typeface="David" pitchFamily="34" charset="-122"/>
                 <a:cs typeface="David" pitchFamily="34" charset="-120"/>
               </a:rPr>
-              <a:t>המחברים מסיקים שתחושת הקוהרנטיות בעבודה היא משאב דינמי שמגיב לשינויים שהעובד עצמו יוזם. עובדים שמעצבים את תפקידם כדי לספק את צרכי האוטונומיה, המיומנות, המשמעות והשייכות תופסים את עבודתם, חצי שנה מאוחר יותר, כמובנת יותר, ניתנת לניהול יותר ומשמעותית יותר. עיצוב תפקיד שמכוון רק להתרחק מהעבודה ולנוח תומך בהתאוששות אך אינו משנה את תפיסת העבודה עצמה. לארגונים המסקנה היא שיש לטפח תחושת ניהוליות ולתת מרחב לעיצוב תפקיד, משום שהניהוליות היא המניע החזק ביותר ליוזמה נוספת (Cetkovská et al., 2026).</a:t>
+              <a:t>‏המחברים מסיקים שתחושת הקוהרנטיות בעבודה היא משאב דינמי שמגיב לשינויים שהעובד עצמו יוזם. עובדים שמעצבים את תפקידם כדי לספק את צרכי האוטונומיה, המיומנות, המשמעות והשייכות תופסים את עבודתם, חצי שנה מאוחר יותר, כמובנת יותר, ניתנת לניהול יותר ומשמעותית יותר. עיצוב תפקיד שמכוון רק להתרחק מהעבודה ולנוח תומך בהתאוששות אך אינו משנה את תפיסת העבודה עצמה. לארגונים המסקנה היא שיש לטפח תחושת ניהוליות ולתת מרחב לעיצוב תפקיד, משום שהניהוליות היא המניע החזק ביותר ליוזמה נוספת (Cetkovská et al., 2026).</a:t>
             </a:r>
             <a:endParaRPr lang="he-IL" sz="1600" dirty="0"/>
           </a:p>
@@ -8557,7 +8557,7 @@
           <a:bodyPr wrap="square" lIns="0" tIns="0" rIns="0" bIns="0" rtlCol="0" anchor="t"/>
           <a:lstStyle/>
           <a:p>
-            <a:pPr rtl="1" algn="just" indent="0" marL="0">
+            <a:pPr rtl="1" algn="r" indent="0" marL="0">
               <a:lnSpc>
                 <a:spcPct val="125000"/>
               </a:lnSpc>
@@ -8572,7 +8572,7 @@
                 <a:ea typeface="David" pitchFamily="34" charset="-122"/>
                 <a:cs typeface="David" pitchFamily="34" charset="-120"/>
               </a:rPr>
-              <a:t>חוזקות המחקר הן מערך האורך המאפשר לבחון כיווניות בזמן, המדגם הגדול והמאוזן, שיעור ההשתתפות הגבוה בגל השני וכלי המדידה המתוקפים. מגבלותיו, שהמחברים עצמם מפרטים, הן מדגם מערבי ולא מייצג לחלוטין, איסוף נתונים בתקופת הקורונה, דיווח עצמי בלבד, הקושי לפרש את המקדם השלילי של המובנות, ומודל פאנל צולב שאינו מפריד בין שונות בין-אישית לתוך-אישית, ולכן יש לפרש את הממצאים כקשרים בזמן ולא כהוכחה סיבתית (Cetkovská et al., 2026).</a:t>
+              <a:t>‏חוזקות המחקר הן מערך האורך המאפשר לבחון כיווניות בזמן, המדגם הגדול והמאוזן, שיעור ההשתתפות הגבוה בגל השני וכלי המדידה המתוקפים. מגבלותיו, שהמחברים עצמם מפרטים, הן מדגם מערבי ולא מייצג לחלוטין, איסוף נתונים בתקופת הקורונה, דיווח עצמי בלבד, הקושי לפרש את המקדם השלילי של המובנות, ומודל פאנל צולב שאינו מפריד בין שונות בין-אישית לתוך-אישית, ולכן יש לפרש את הממצאים כקשרים בזמן ולא כהוכחה סיבתית (Cetkovská et al., 2026).</a:t>
             </a:r>
             <a:endParaRPr lang="he-IL" sz="1600" dirty="0"/>
           </a:p>
@@ -8634,7 +8634,7 @@
                 <a:ea typeface="David" pitchFamily="34" charset="-122"/>
                 <a:cs typeface="David" pitchFamily="34" charset="-120"/>
               </a:rPr>
-              <a:t>ניהול קריירה בארגונים, הקריה האקדמית אונו</a:t>
+              <a:t>‏ניהול קריירה בארגונים, הקריה האקדמית אונו</a:t>
             </a:r>
             <a:endParaRPr lang="he-IL" sz="1000" dirty="0"/>
           </a:p>
@@ -8673,7 +8673,7 @@
                 <a:ea typeface="David" pitchFamily="34" charset="-122"/>
                 <a:cs typeface="David" pitchFamily="34" charset="-120"/>
               </a:rPr>
-              <a:t>8</a:t>
+              <a:t>‏8</a:t>
             </a:r>
             <a:endParaRPr lang="he-IL" sz="1100" dirty="0"/>
           </a:p>
@@ -8794,7 +8794,7 @@
                 <a:ea typeface="David" pitchFamily="34" charset="-122"/>
                 <a:cs typeface="David" pitchFamily="34" charset="-120"/>
               </a:rPr>
-              <a:t>המאמר המשלים: מודעות לבינה מלאכותית, חוסר ביטחון וחוסן קריירה</a:t>
+              <a:t>‏המאמר המשלים: מודעות לבינה מלאכותית, חוסר ביטחון וחוסן קריירה</a:t>
             </a:r>
             <a:endParaRPr lang="he-IL" sz="2800" dirty="0"/>
           </a:p>
@@ -8860,7 +8860,7 @@
           <a:bodyPr wrap="square" lIns="0" tIns="0" rIns="0" bIns="0" rtlCol="0" anchor="t"/>
           <a:lstStyle/>
           <a:p>
-            <a:pPr rtl="1" algn="just" indent="0" marL="0">
+            <a:pPr rtl="1" algn="r" indent="0" marL="0">
               <a:lnSpc>
                 <a:spcPct val="125000"/>
               </a:lnSpc>
@@ -8875,7 +8875,7 @@
                 <a:ea typeface="David" pitchFamily="34" charset="-122"/>
                 <a:cs typeface="David" pitchFamily="34" charset="-120"/>
               </a:rPr>
-              <a:t>לחיזוק הקשר בין המאמר המרכזי לבין נושא העבודה נבחר מחקר אורך נוסף, שפורסם בגישה פתוחה בכתב עת שפיט. המחברים, מאוניברסיטת סוּוֹן בדרום קוריאה, בחנו את ההשלכות של מודעות לבינה מלאכותית, כלומר תפיסת העובד שטכנולוגיה עלולה להחליף אותו או לשנות את תפקידו, על חוסר ביטחון תעסוקתי, על ביצועי משימה ועל התנהגות סוטה בעבודה. הנתונים נאספו בשלוש נקודות זמן מעובדי משרד במשרה מלאה (Chung et al., 2025).</a:t>
+              <a:t>‏לחיזוק הקשר בין המאמר המרכזי לבין נושא העבודה נבחר מחקר אורך נוסף, שפורסם בגישה פתוחה בכתב עת שפיט. המחברים, מאוניברסיטת סוּוֹן בדרום קוריאה, בחנו את ההשלכות של מודעות לבינה מלאכותית, כלומר תפיסת העובד שטכנולוגיה עלולה להחליף אותו או לשנות את תפקידו, על חוסר ביטחון תעסוקתי, על ביצועי משימה ועל התנהגות סוטה בעבודה. הנתונים נאספו בשלוש נקודות זמן מעובדי משרד במשרה מלאה (Chung et al., 2025).</a:t>
             </a:r>
             <a:endParaRPr lang="he-IL" sz="1600" dirty="0"/>
           </a:p>
@@ -8902,7 +8902,7 @@
           <a:bodyPr wrap="square" lIns="0" tIns="0" rIns="0" bIns="0" rtlCol="0" anchor="t"/>
           <a:lstStyle/>
           <a:p>
-            <a:pPr rtl="1" algn="just" indent="0" marL="0">
+            <a:pPr rtl="1" algn="r" indent="0" marL="0">
               <a:lnSpc>
                 <a:spcPct val="125000"/>
               </a:lnSpc>
@@ -8917,7 +8917,7 @@
                 <a:ea typeface="David" pitchFamily="34" charset="-122"/>
                 <a:cs typeface="David" pitchFamily="34" charset="-120"/>
               </a:rPr>
-              <a:t>הממצאים מראים שעצם המודעות לבינה מלאכותית, עוד לפני שינוי בפועל, מגבירה חוסר ביטחון תעסוקתי, ושחוסר הביטחון מתווך את הקשר בין המודעות לבין ירידה בביצועי המשימה ועלייה בהתנהגות סוטה. אצל עובדים בעלי חוסן קריירה גבוה הקשר בין המודעות לבין חוסר הביטחון היה חלש יותר (Chung et al., 2025). שני המאמרים משלימים זה את זה: המאמר המשלים מתאר את מקור חוסר הוודאות של שנת 2026 ומראה שמשאב אישי ממתן אותו, והמאמר המרכזי מראה כיצד בונים משאב כזה בפועל, באמצעות עיצוב תפקיד יזום (Cetkovská et al., 2026).</a:t>
+              <a:t>‏הממצאים מראים שעצם המודעות לבינה מלאכותית, עוד לפני שינוי בפועל, מגבירה חוסר ביטחון תעסוקתי, ושחוסר הביטחון מתווך את הקשר בין המודעות לבין ירידה בביצועי המשימה ועלייה בהתנהגות סוטה. אצל עובדים בעלי חוסן קריירה גבוה הקשר בין המודעות לבין חוסר הביטחון היה חלש יותר (Chung et al., 2025). שני המאמרים משלימים זה את זה: המאמר המשלים מתאר את מקור חוסר הוודאות של שנת 2026 ומראה שמשאב אישי ממתן אותו, והמאמר המרכזי מראה כיצד בונים משאב כזה בפועל, באמצעות עיצוב תפקיד יזום (Cetkovská et al., 2026).</a:t>
             </a:r>
             <a:endParaRPr lang="he-IL" sz="1600" dirty="0"/>
           </a:p>
@@ -8979,7 +8979,7 @@
                 <a:ea typeface="David" pitchFamily="34" charset="-122"/>
                 <a:cs typeface="David" pitchFamily="34" charset="-120"/>
               </a:rPr>
-              <a:t>ניהול קריירה בארגונים, הקריה האקדמית אונו</a:t>
+              <a:t>‏ניהול קריירה בארגונים, הקריה האקדמית אונו</a:t>
             </a:r>
             <a:endParaRPr lang="he-IL" sz="1000" dirty="0"/>
           </a:p>
@@ -9018,7 +9018,7 @@
                 <a:ea typeface="David" pitchFamily="34" charset="-122"/>
                 <a:cs typeface="David" pitchFamily="34" charset="-120"/>
               </a:rPr>
-              <a:t>9</a:t>
+              <a:t>‏9</a:t>
             </a:r>
             <a:endParaRPr lang="he-IL" sz="1100" dirty="0"/>
           </a:p>

</xml_diff>

<commit_message>
Wrap Hebrew slide paragraphs in RTL embedding marks
Co-Authored-By: Claude Fable 5.1 <noreply@anthropic.com>
Claude-Session: https://claude.ai/code/session_01XaGvnsaHG3kPyCY3aGBByx
</commit_message>
<xml_diff>
--- a/career-management-final-project/ניהול קריירה - התמודדות עם חוסר ודאות תעסוקתי - מצגת.pptx
+++ b/career-management-final-project/ניהול קריירה - התמודדות עם חוסר ודאות תעסוקתי - מצגת.pptx
@@ -2659,7 +2659,7 @@
                 <a:ea typeface="David" pitchFamily="34" charset="-122"/>
                 <a:cs typeface="David" pitchFamily="34" charset="-120"/>
               </a:rPr>
-              <a:t>‏הקריה האקדמית אונו, הפקולטה למנהל עסקים</a:t>
+              <a:t>‫הקריה האקדמית אונו, הפקולטה למנהל עסקים‬</a:t>
             </a:r>
             <a:endParaRPr lang="he-IL" sz="1700" dirty="0"/>
           </a:p>
@@ -2698,7 +2698,7 @@
                 <a:ea typeface="David" pitchFamily="34" charset="-122"/>
                 <a:cs typeface="David" pitchFamily="34" charset="-120"/>
               </a:rPr>
-              <a:t>‏עבודה מסכמת בקורס ניהול קריירה בארגונים</a:t>
+              <a:t>‫עבודה מסכמת בקורס ניהול קריירה בארגונים‬</a:t>
             </a:r>
             <a:endParaRPr lang="he-IL" sz="1700" dirty="0"/>
           </a:p>
@@ -2737,7 +2737,7 @@
                 <a:ea typeface="David" pitchFamily="34" charset="-122"/>
                 <a:cs typeface="David" pitchFamily="34" charset="-120"/>
               </a:rPr>
-              <a:t>‏התמודדות עם חוסר ודאות תעסוקתי</a:t>
+              <a:t>‫התמודדות עם חוסר ודאות תעסוקתי‬</a:t>
             </a:r>
             <a:endParaRPr lang="he-IL" sz="3800" dirty="0"/>
           </a:p>
@@ -2776,7 +2776,7 @@
                 <a:ea typeface="David" pitchFamily="34" charset="-122"/>
                 <a:cs typeface="David" pitchFamily="34" charset="-120"/>
               </a:rPr>
-              <a:t>‏עיצוב תפקיד מבוסס צרכים כדרך לבנות בהירות, שליטה ומשמעות בעבודה</a:t>
+              <a:t>‫עיצוב תפקיד מבוסס צרכים כדרך לבנות בהירות, שליטה ומשמעות בעבודה‬</a:t>
             </a:r>
             <a:endParaRPr lang="he-IL" sz="1800" dirty="0"/>
           </a:p>
@@ -2854,7 +2854,7 @@
                 <a:ea typeface="David" pitchFamily="34" charset="-122"/>
                 <a:cs typeface="David" pitchFamily="34" charset="-120"/>
               </a:rPr>
-              <a:t>‏מגיש/ה: דוחה עמאש, מספר תעודת זהות 208121137</a:t>
+              <a:t>‫מגיש/ה: דוחה עמאש, מספר תעודת זהות 208121137‬</a:t>
             </a:r>
             <a:endParaRPr lang="he-IL" sz="1800" dirty="0"/>
           </a:p>
@@ -2893,7 +2893,7 @@
                 <a:ea typeface="David" pitchFamily="34" charset="-122"/>
                 <a:cs typeface="David" pitchFamily="34" charset="-120"/>
               </a:rPr>
-              <a:t>‏מרצה: גב' מורן דבדבני דקל   |   עוזר הוראה: מר פאר רועי</a:t>
+              <a:t>‫מרצה: גב' מורן דבדבני דקל   |   עוזר הוראה: מר פאר רועי‬</a:t>
             </a:r>
             <a:endParaRPr lang="he-IL" sz="1500" dirty="0"/>
           </a:p>
@@ -2932,7 +2932,7 @@
                 <a:ea typeface="David" pitchFamily="34" charset="-122"/>
                 <a:cs typeface="David" pitchFamily="34" charset="-120"/>
               </a:rPr>
-              <a:t>‏תשפ"ו, סמסטר 3   |   ספטמבר 2026</a:t>
+              <a:t>‫תשפ"ו, סמסטר 3   |   ספטמבר 2026‬</a:t>
             </a:r>
             <a:endParaRPr lang="he-IL" sz="1400" dirty="0"/>
           </a:p>
@@ -3053,7 +3053,7 @@
                 <a:ea typeface="David" pitchFamily="34" charset="-122"/>
                 <a:cs typeface="David" pitchFamily="34" charset="-120"/>
               </a:rPr>
-              <a:t>‏חיבור לחומר הנלמד בקורס</a:t>
+              <a:t>‫חיבור לחומר הנלמד בקורס‬</a:t>
             </a:r>
             <a:endParaRPr lang="he-IL" sz="2800" dirty="0"/>
           </a:p>
@@ -3095,7 +3095,7 @@
                 <a:ea typeface="David" pitchFamily="34" charset="-122"/>
                 <a:cs typeface="David" pitchFamily="34" charset="-120"/>
               </a:rPr>
-              <a:t>‏המאמר אינו זר לחומר הקורס אלא מעניק לו בסיס אמפירי. שלושת סלי הכלים שנלמדו בקורס, רשת אנשים, זהות מקצועית והתפתחות, מקבילים כמעט אחד לאחד לצרכי ההתקרבות שנמצאו כבונים תחושת קוהרנטיות: רשת האנשים היא צורך השייכות, חמש השאלות של הזהות המקצועית הן עיצוב תפקיד לצורך המשמעות, וההתפתחות היא צורך המיומנות. הרעיון של קריירה רבודה וקיר הטיפוס, שבהם כל שלב נבנה על קודמו, הוא בדיוק ספירלת הרווח שהמחקר מתעד, שבה כל צעד של עיצוב תפקיד מגדיל את המשאבים לצעד הבא (Cetkovská et al., 2026).</a:t>
+              <a:t>‫המאמר אינו זר לחומר הקורס אלא מעניק לו בסיס אמפירי. שלושת סלי הכלים שנלמדו בקורס, רשת אנשים, זהות מקצועית והתפתחות, מקבילים כמעט אחד לאחד לצרכי ההתקרבות שנמצאו כבונים תחושת קוהרנטיות: רשת האנשים היא צורך השייכות, חמש השאלות של הזהות המקצועית הן עיצוב תפקיד לצורך המשמעות, וההתפתחות היא צורך המיומנות. הרעיון של קריירה רבודה וקיר הטיפוס, שבהם כל שלב נבנה על קודמו, הוא בדיוק ספירלת הרווח שהמחקר מתעד, שבה כל צעד של עיצוב תפקיד מגדיל את המשאבים לצעד הבא (Cetkovská et al., 2026).‬</a:t>
             </a:r>
             <a:endParaRPr lang="he-IL" sz="1600" dirty="0"/>
           </a:p>
@@ -3137,7 +3137,7 @@
                 <a:ea typeface="David" pitchFamily="34" charset="-122"/>
                 <a:cs typeface="David" pitchFamily="34" charset="-120"/>
               </a:rPr>
-              <a:t>‏הגורמים המניעים של הרצברג, הישג, הכרה ומשמעות, מקבילים לצרכי ההתקרבות, ואילו הגורמים ההיגייניים מקבילים לצרכי ההימנעות, מה שמסביר מדוע רק הראשונים שינו את תפיסת העבודה. עוגני הקריירה של שיין מסבירים מדוע צרכים שונים חשובים לעובדים שונים: מי שעוגנו הוא אוטונומיה יעצב את תפקידו סביב חופש הפעולה, ומי שעוגנו הוא ביטחון ויציבות יחפש קודם כול מובנות. מאמר החובה בקורס מראה שתמיכה במקום העבודה ובמשפחה משפרת את הזמינות הפסיכולוגית של העובד (Russo et al., 2016), כלומר את תחושת הניהוליות שהמחקר מזהה כמנוע החזק ביותר ליוזמה (Cetkovská et al., 2026).</a:t>
+              <a:t>‫הגורמים המניעים של הרצברג, הישג, הכרה ומשמעות, מקבילים לצרכי ההתקרבות, ואילו הגורמים ההיגייניים מקבילים לצרכי ההימנעות, מה שמסביר מדוע רק הראשונים שינו את תפיסת העבודה. עוגני הקריירה של שיין מסבירים מדוע צרכים שונים חשובים לעובדים שונים: מי שעוגנו הוא אוטונומיה יעצב את תפקידו סביב חופש הפעולה, ומי שעוגנו הוא ביטחון ויציבות יחפש קודם כול מובנות. מאמר החובה בקורס מראה שתמיכה במקום העבודה ובמשפחה משפרת את הזמינות הפסיכולוגית של העובד (Russo et al., 2016), כלומר את תחושת הניהוליות שהמחקר מזהה כמנוע החזק ביותר ליוזמה (Cetkovská et al., 2026).‬</a:t>
             </a:r>
             <a:endParaRPr lang="he-IL" sz="1600" dirty="0"/>
           </a:p>
@@ -3199,7 +3199,7 @@
                 <a:ea typeface="David" pitchFamily="34" charset="-122"/>
                 <a:cs typeface="David" pitchFamily="34" charset="-120"/>
               </a:rPr>
-              <a:t>‏ניהול קריירה בארגונים, הקריה האקדמית אונו</a:t>
+              <a:t>‫ניהול קריירה בארגונים, הקריה האקדמית אונו‬</a:t>
             </a:r>
             <a:endParaRPr lang="he-IL" sz="1000" dirty="0"/>
           </a:p>
@@ -3238,7 +3238,7 @@
                 <a:ea typeface="David" pitchFamily="34" charset="-122"/>
                 <a:cs typeface="David" pitchFamily="34" charset="-120"/>
               </a:rPr>
-              <a:t>‏10</a:t>
+              <a:t>‫10‬</a:t>
             </a:r>
             <a:endParaRPr lang="he-IL" sz="1100" dirty="0"/>
           </a:p>
@@ -3359,7 +3359,7 @@
                 <a:ea typeface="David" pitchFamily="34" charset="-122"/>
                 <a:cs typeface="David" pitchFamily="34" charset="-120"/>
               </a:rPr>
-              <a:t>‏תובנות ומסקנות</a:t>
+              <a:t>‫תובנות ומסקנות‬</a:t>
             </a:r>
             <a:endParaRPr lang="he-IL" sz="2800" dirty="0"/>
           </a:p>
@@ -3401,7 +3401,7 @@
                 <a:ea typeface="David" pitchFamily="34" charset="-122"/>
                 <a:cs typeface="David" pitchFamily="34" charset="-120"/>
               </a:rPr>
-              <a:t>‏התובנה הראשונה היא שבהירות, שליטה ומשמעות אינן רק תוצר של הסביבה: תחושת הקוהרנטיות עולה כשהעובד פועל על תפקידו, גם כשהסביבה לא השתנתה. התובנה השנייה היא שההבדל בין התקרבות להימנעות מכריע, שכן מאמצים להתנתק ולנוח חשובים להתאוששות אך אינם משנים את תפיסת העבודה. התובנה השלישית היא שהמשאבים קודמים ליוזמה: תחושת הניהוליות ניבאה עיצוב תפקיד עתידי במקדם החזק ביותר במודל, ולכן מי שמרגיש שאין לו משאבים מגן על מה שנותר במקום להשקיע (Cetkovská et al., 2026). התובנה הרביעית, מהמאמר המשלים, היא שמשאב אישי ממתן את הקשר בין האיום הטכנולוגי לבין חוסר הביטחון (Chung et al., 2025).</a:t>
+              <a:t>‫התובנה הראשונה היא שבהירות, שליטה ומשמעות אינן רק תוצר של הסביבה: תחושת הקוהרנטיות עולה כשהעובד פועל על תפקידו, גם כשהסביבה לא השתנתה. התובנה השנייה היא שההבדל בין התקרבות להימנעות מכריע, שכן מאמצים להתנתק ולנוח חשובים להתאוששות אך אינם משנים את תפיסת העבודה. התובנה השלישית היא שהמשאבים קודמים ליוזמה: תחושת הניהוליות ניבאה עיצוב תפקיד עתידי במקדם החזק ביותר במודל, ולכן מי שמרגיש שאין לו משאבים מגן על מה שנותר במקום להשקיע (Cetkovská et al., 2026). התובנה הרביעית, מהמאמר המשלים, היא שמשאב אישי ממתן את הקשר בין האיום הטכנולוגי לבין חוסר הביטחון (Chung et al., 2025).‬</a:t>
             </a:r>
             <a:endParaRPr lang="he-IL" sz="1600" dirty="0"/>
           </a:p>
@@ -3443,7 +3443,7 @@
                 <a:ea typeface="David" pitchFamily="34" charset="-122"/>
                 <a:cs typeface="David" pitchFamily="34" charset="-120"/>
               </a:rPr>
-              <a:t>‏המסקנה המרכזית היא שההתמודדות עם חוסר ודאות תעסוקתי אינה מסתכמת בהגנה מפני האיום, אלא בבנייה יזומה של בהירות, שליטה ומשמעות בתוך התפקיד הקיים, ושאת המשאבים לכך יש לבנות בתקופות של יציבות, לפני שהאיום מדלדל אותם. ברמה הארגונית, מנהלים שרוצים עובדים יוזמים בתקופת שינוי צריכים קודם כול לדאוג לתחושת ניהוליות: משאבים מספיקים, מידע ברור ומרחב לעיצוב התפקיד.</a:t>
+              <a:t>‫המסקנה המרכזית היא שההתמודדות עם חוסר ודאות תעסוקתי אינה מסתכמת בהגנה מפני האיום, אלא בבנייה יזומה של בהירות, שליטה ומשמעות בתוך התפקיד הקיים, ושאת המשאבים לכך יש לבנות בתקופות של יציבות, לפני שהאיום מדלדל אותם. ברמה הארגונית, מנהלים שרוצים עובדים יוזמים בתקופת שינוי צריכים קודם כול לדאוג לתחושת ניהוליות: משאבים מספיקים, מידע ברור ומרחב לעיצוב התפקיד.‬</a:t>
             </a:r>
             <a:endParaRPr lang="he-IL" sz="1600" dirty="0"/>
           </a:p>
@@ -3505,7 +3505,7 @@
                 <a:ea typeface="David" pitchFamily="34" charset="-122"/>
                 <a:cs typeface="David" pitchFamily="34" charset="-120"/>
               </a:rPr>
-              <a:t>‏ניהול קריירה בארגונים, הקריה האקדמית אונו</a:t>
+              <a:t>‫ניהול קריירה בארגונים, הקריה האקדמית אונו‬</a:t>
             </a:r>
             <a:endParaRPr lang="he-IL" sz="1000" dirty="0"/>
           </a:p>
@@ -3544,7 +3544,7 @@
                 <a:ea typeface="David" pitchFamily="34" charset="-122"/>
                 <a:cs typeface="David" pitchFamily="34" charset="-120"/>
               </a:rPr>
-              <a:t>‏11</a:t>
+              <a:t>‫11‬</a:t>
             </a:r>
             <a:endParaRPr lang="he-IL" sz="1100" dirty="0"/>
           </a:p>
@@ -3665,7 +3665,7 @@
                 <a:ea typeface="David" pitchFamily="34" charset="-122"/>
                 <a:cs typeface="David" pitchFamily="34" charset="-120"/>
               </a:rPr>
-              <a:t>‏דעה אישית על המאמר</a:t>
+              <a:t>‫דעה אישית על המאמר‬</a:t>
             </a:r>
             <a:endParaRPr lang="he-IL" sz="2800" dirty="0"/>
           </a:p>
@@ -3707,7 +3707,7 @@
                 <a:ea typeface="David" pitchFamily="34" charset="-122"/>
                 <a:cs typeface="David" pitchFamily="34" charset="-120"/>
               </a:rPr>
-              <a:t>‏מה שאהבתי במאמר הוא נקודת המבט, ששואלת מה עוזר לעובדים ולא רק מה מזיק להם, והעובדה שהיא נשענת על רעיון של חוקר שפעל בישראל. אהבתי את הפרקטיות שלו, שישה צרכים, שאלות פשוטות ופעולות לשבועיים, ואת הכנות של המחברים, שמקדישים כמעט עמוד שלם למגבלות, כולל הודאה שהמקדם השלילי של המובנות קשה להם להסביר. העובדה שהמאמר זמין לכולם בחינם חשובה בעיניי (Cetkovská et al., 2026).</a:t>
+              <a:t>‫מה שאהבתי במאמר הוא נקודת המבט, ששואלת מה עוזר לעובדים ולא רק מה מזיק להם, והעובדה שהיא נשענת על רעיון של חוקר שפעל בישראל. אהבתי את הפרקטיות שלו, שישה צרכים, שאלות פשוטות ופעולות לשבועיים, ואת הכנות של המחברים, שמקדישים כמעט עמוד שלם למגבלות, כולל הודאה שהמקדם השלילי של המובנות קשה להם להסביר. העובדה שהמאמר זמין לכולם בחינם חשובה בעיניי (Cetkovská et al., 2026).‬</a:t>
             </a:r>
             <a:endParaRPr lang="he-IL" sz="1600" dirty="0"/>
           </a:p>
@@ -3749,7 +3749,7 @@
                 <a:ea typeface="David" pitchFamily="34" charset="-122"/>
                 <a:cs typeface="David" pitchFamily="34" charset="-120"/>
               </a:rPr>
-              <a:t>‏חסרו לי שלושה דברים. המאמר אינו מודד חוסר ביטחון תעסוקתי במישרין, ואת החיבור לנושא בניתי דרך המאמר המשלים. המדגם גרמני ושווייצרי, בגיל ממוצע של כמעט 49 ומתרבות עבודה עם ביטחון סוציאלי גבוה, ולא ברור שהמרחב לעצב תפקיד קיים גם אצל סטודנטים ישראלים בתחילת הדרך. המחקר עוסק בשכירים בתפקיד קיים בלבד. עמדתי היא שהמאמר משלים את המסר "ממשבר להזדמנות" שנלמד בקורס: משבר הופך להזדמנות לא מעצמו, אלא כשמישהו מעצב אותו כך, ומי שמרגיש שאין לו משאבים צריך קודם תמיכה ולא עצות.</a:t>
+              <a:t>‫חסרו לי שלושה דברים. המאמר אינו מודד חוסר ביטחון תעסוקתי במישרין, ואת החיבור לנושא בניתי דרך המאמר המשלים. המדגם גרמני ושווייצרי, בגיל ממוצע של כמעט 49 ומתרבות עבודה עם ביטחון סוציאלי גבוה, ולא ברור שהמרחב לעצב תפקיד קיים גם אצל סטודנטים ישראלים בתחילת הדרך. המחקר עוסק בשכירים בתפקיד קיים בלבד. עמדתי היא שהמאמר משלים את המסר "ממשבר להזדמנות" שנלמד בקורס: משבר הופך להזדמנות לא מעצמו, אלא כשמישהו מעצב אותו כך, ומי שמרגיש שאין לו משאבים צריך קודם תמיכה ולא עצות.‬</a:t>
             </a:r>
             <a:endParaRPr lang="he-IL" sz="1600" dirty="0"/>
           </a:p>
@@ -3811,7 +3811,7 @@
                 <a:ea typeface="David" pitchFamily="34" charset="-122"/>
                 <a:cs typeface="David" pitchFamily="34" charset="-120"/>
               </a:rPr>
-              <a:t>‏ניהול קריירה בארגונים, הקריה האקדמית אונו</a:t>
+              <a:t>‫ניהול קריירה בארגונים, הקריה האקדמית אונו‬</a:t>
             </a:r>
             <a:endParaRPr lang="he-IL" sz="1000" dirty="0"/>
           </a:p>
@@ -3850,7 +3850,7 @@
                 <a:ea typeface="David" pitchFamily="34" charset="-122"/>
                 <a:cs typeface="David" pitchFamily="34" charset="-120"/>
               </a:rPr>
-              <a:t>‏12</a:t>
+              <a:t>‫12‬</a:t>
             </a:r>
             <a:endParaRPr lang="he-IL" sz="1100" dirty="0"/>
           </a:p>
@@ -3971,7 +3971,7 @@
                 <a:ea typeface="David" pitchFamily="34" charset="-122"/>
                 <a:cs typeface="David" pitchFamily="34" charset="-120"/>
               </a:rPr>
-              <a:t>‏יישום מעשי: תוכנית עיצוב תפקיד אישית</a:t>
+              <a:t>‫יישום מעשי: תוכנית עיצוב תפקיד אישית‬</a:t>
             </a:r>
             <a:endParaRPr lang="he-IL" sz="2800" dirty="0"/>
           </a:p>
@@ -4013,7 +4013,7 @@
                 <a:ea typeface="David" pitchFamily="34" charset="-122"/>
                 <a:cs typeface="David" pitchFamily="34" charset="-120"/>
               </a:rPr>
-              <a:t>‏ממצאי המאמר תורגמו לכלי אישי המבוסס על ארבעת צרכי ההתקרבות, שנמצאו כבונים תחושת קוהרנטיות. לכל צורך שאלה מנחה ודוגמאות לפעולה שאפשר לבצע בשבועיים, גם בתפקיד סטודנטיאלי או במשרה חלקית. את צרכי ההימנעות מומלץ לטפח לצורך התאוששות, אך לפי המאמר הם אינם משנים את תפיסת העבודה (Cetkovská et al., 2026).</a:t>
+              <a:t>‫ממצאי המאמר תורגמו לכלי אישי המבוסס על ארבעת צרכי ההתקרבות, שנמצאו כבונים תחושת קוהרנטיות. לכל צורך שאלה מנחה ודוגמאות לפעולה שאפשר לבצע בשבועיים, גם בתפקיד סטודנטיאלי או במשרה חלקית. את צרכי ההימנעות מומלץ לטפח לצורך התאוששות, אך לפי המאמר הם אינם משנים את תפיסת העבודה (Cetkovská et al., 2026).‬</a:t>
             </a:r>
             <a:endParaRPr lang="he-IL" sz="1500" dirty="0"/>
           </a:p>
@@ -4127,7 +4127,7 @@
                 <a:ea typeface="David" pitchFamily="34" charset="-122"/>
                 <a:cs typeface="David" pitchFamily="34" charset="-120"/>
               </a:rPr>
-              <a:t>‏אוטונומיה</a:t>
+              <a:t>‫אוטונומיה‬</a:t>
             </a:r>
             <a:endParaRPr lang="he-IL" sz="1600" dirty="0"/>
           </a:p>
@@ -4169,7 +4169,7 @@
                 <a:ea typeface="David" pitchFamily="34" charset="-122"/>
                 <a:cs typeface="David" pitchFamily="34" charset="-120"/>
               </a:rPr>
-              <a:t>‏שאלה מנחה: באילו החלטות קטנות אני יכול/ה לבחור בעצמי?</a:t>
+              <a:t>‫שאלה מנחה: באילו החלטות קטנות אני יכול/ה לבחור בעצמי?‬</a:t>
             </a:r>
             <a:endParaRPr lang="he-IL" sz="1250" dirty="0"/>
           </a:p>
@@ -4198,7 +4198,7 @@
                 <a:ea typeface="David" pitchFamily="34" charset="-122"/>
                 <a:cs typeface="David" pitchFamily="34" charset="-120"/>
               </a:rPr>
-              <a:t>‏לשבועיים הקרובים: לקבוע את סדר המשימות של הבוקר; להציע דרך משלי למשימה חוזרת; שעה קבועה ללא הפרעות.</a:t>
+              <a:t>‫לשבועיים הקרובים: לקבוע את סדר המשימות של הבוקר; להציע דרך משלי למשימה חוזרת; שעה קבועה ללא הפרעות.‬</a:t>
             </a:r>
             <a:endParaRPr lang="he-IL" sz="1250" dirty="0"/>
           </a:p>
@@ -4312,7 +4312,7 @@
                 <a:ea typeface="David" pitchFamily="34" charset="-122"/>
                 <a:cs typeface="David" pitchFamily="34" charset="-120"/>
               </a:rPr>
-              <a:t>‏מיומנות</a:t>
+              <a:t>‫מיומנות‬</a:t>
             </a:r>
             <a:endParaRPr lang="he-IL" sz="1600" dirty="0"/>
           </a:p>
@@ -4354,7 +4354,7 @@
                 <a:ea typeface="David" pitchFamily="34" charset="-122"/>
                 <a:cs typeface="David" pitchFamily="34" charset="-120"/>
               </a:rPr>
-              <a:t>‏שאלה מנחה: איזה אתגר בגובה הנכון יגרום לי להרגיש שאני מתקדם/ת?</a:t>
+              <a:t>‫שאלה מנחה: איזה אתגר בגובה הנכון יגרום לי להרגיש שאני מתקדם/ת?‬</a:t>
             </a:r>
             <a:endParaRPr lang="he-IL" sz="1250" dirty="0"/>
           </a:p>
@@ -4383,7 +4383,7 @@
                 <a:ea typeface="David" pitchFamily="34" charset="-122"/>
                 <a:cs typeface="David" pitchFamily="34" charset="-120"/>
               </a:rPr>
-              <a:t>‏לשבועיים הקרובים: משימה אחת מעט מעבר ליכולת; כלי בינה מלאכותית אחד בתחום; לתעד בסוף השבוע דבר אחד שלמדתי.</a:t>
+              <a:t>‫לשבועיים הקרובים: משימה אחת מעט מעבר ליכולת; כלי בינה מלאכותית אחד בתחום; לתעד בסוף השבוע דבר אחד שלמדתי.‬</a:t>
             </a:r>
             <a:endParaRPr lang="he-IL" sz="1250" dirty="0"/>
           </a:p>
@@ -4497,7 +4497,7 @@
                 <a:ea typeface="David" pitchFamily="34" charset="-122"/>
                 <a:cs typeface="David" pitchFamily="34" charset="-120"/>
               </a:rPr>
-              <a:t>‏משמעות</a:t>
+              <a:t>‫משמעות‬</a:t>
             </a:r>
             <a:endParaRPr lang="he-IL" sz="1600" dirty="0"/>
           </a:p>
@@ -4539,7 +4539,7 @@
                 <a:ea typeface="David" pitchFamily="34" charset="-122"/>
                 <a:cs typeface="David" pitchFamily="34" charset="-120"/>
               </a:rPr>
-              <a:t>‏שאלה מנחה: איזה חלק בעבודה מתחבר למה שחשוב לי, ואיך מגדילים אותו?</a:t>
+              <a:t>‫שאלה מנחה: איזה חלק בעבודה מתחבר למה שחשוב לי, ואיך מגדילים אותו?‬</a:t>
             </a:r>
             <a:endParaRPr lang="he-IL" sz="1250" dirty="0"/>
           </a:p>
@@ -4568,7 +4568,7 @@
                 <a:ea typeface="David" pitchFamily="34" charset="-122"/>
                 <a:cs typeface="David" pitchFamily="34" charset="-120"/>
               </a:rPr>
-              <a:t>‏לשבועיים הקרובים: לזהות למי העבודה שלי עוזרת ולדבר איתו; לנסח במשפט למה התפקיד חשוב; להתנדב למשימה שמתחברת לערכים.</a:t>
+              <a:t>‫לשבועיים הקרובים: לזהות למי העבודה שלי עוזרת ולדבר איתו; לנסח במשפט למה התפקיד חשוב; להתנדב למשימה שמתחברת לערכים.‬</a:t>
             </a:r>
             <a:endParaRPr lang="he-IL" sz="1250" dirty="0"/>
           </a:p>
@@ -4682,7 +4682,7 @@
                 <a:ea typeface="David" pitchFamily="34" charset="-122"/>
                 <a:cs typeface="David" pitchFamily="34" charset="-120"/>
               </a:rPr>
-              <a:t>‏שייכות</a:t>
+              <a:t>‫שייכות‬</a:t>
             </a:r>
             <a:endParaRPr lang="he-IL" sz="1600" dirty="0"/>
           </a:p>
@@ -4724,7 +4724,7 @@
                 <a:ea typeface="David" pitchFamily="34" charset="-122"/>
                 <a:cs typeface="David" pitchFamily="34" charset="-120"/>
               </a:rPr>
-              <a:t>‏שאלה מנחה: עם מי בעבודה אני רוצה קשר אמיתי יותר?</a:t>
+              <a:t>‫שאלה מנחה: עם מי בעבודה אני רוצה קשר אמיתי יותר?‬</a:t>
             </a:r>
             <a:endParaRPr lang="he-IL" sz="1250" dirty="0"/>
           </a:p>
@@ -4753,7 +4753,7 @@
                 <a:ea typeface="David" pitchFamily="34" charset="-122"/>
                 <a:cs typeface="David" pitchFamily="34" charset="-120"/>
               </a:rPr>
-              <a:t>‏לשבועיים הקרובים: הפסקת קפה קבועה עם עמית; להציע עזרה לפני שמבקשים; להצטרף לפרויקט חוצה מחלקות.</a:t>
+              <a:t>‫לשבועיים הקרובים: הפסקת קפה קבועה עם עמית; להציע עזרה לפני שמבקשים; להצטרף לפרויקט חוצה מחלקות.‬</a:t>
             </a:r>
             <a:endParaRPr lang="he-IL" sz="1250" dirty="0"/>
           </a:p>
@@ -4792,7 +4792,7 @@
                 <a:ea typeface="David" pitchFamily="34" charset="-122"/>
                 <a:cs typeface="David" pitchFamily="34" charset="-120"/>
               </a:rPr>
-              <a:t>‏איור 2: תוכנית עיצוב תפקיד אישית לפי ארבעת צרכי ההתקרבות. פיתוח על פי Cetkovská et al. (2026)</a:t>
+              <a:t>‫איור 2: תוכנית עיצוב תפקיד אישית לפי ארבעת צרכי ההתקרבות. פיתוח על פי Cetkovská et al. (2026)‬</a:t>
             </a:r>
             <a:endParaRPr lang="he-IL" sz="1100" dirty="0"/>
           </a:p>
@@ -4854,7 +4854,7 @@
                 <a:ea typeface="David" pitchFamily="34" charset="-122"/>
                 <a:cs typeface="David" pitchFamily="34" charset="-120"/>
               </a:rPr>
-              <a:t>‏ניהול קריירה בארגונים, הקריה האקדמית אונו</a:t>
+              <a:t>‫ניהול קריירה בארגונים, הקריה האקדמית אונו‬</a:t>
             </a:r>
             <a:endParaRPr lang="he-IL" sz="1000" dirty="0"/>
           </a:p>
@@ -4893,7 +4893,7 @@
                 <a:ea typeface="David" pitchFamily="34" charset="-122"/>
                 <a:cs typeface="David" pitchFamily="34" charset="-120"/>
               </a:rPr>
-              <a:t>‏13</a:t>
+              <a:t>‫13‬</a:t>
             </a:r>
             <a:endParaRPr lang="he-IL" sz="1100" dirty="0"/>
           </a:p>
@@ -5014,7 +5014,7 @@
                 <a:ea typeface="David" pitchFamily="34" charset="-122"/>
                 <a:cs typeface="David" pitchFamily="34" charset="-120"/>
               </a:rPr>
-              <a:t>‏אמצעי עזר להמחשה ולהפעלה</a:t>
+              <a:t>‫אמצעי עזר להמחשה ולהפעלה‬</a:t>
             </a:r>
             <a:endParaRPr lang="he-IL" sz="2800" dirty="0"/>
           </a:p>
@@ -5056,7 +5056,7 @@
                 <a:ea typeface="David" pitchFamily="34" charset="-122"/>
                 <a:cs typeface="David" pitchFamily="34" charset="-120"/>
               </a:rPr>
-              <a:t>‏כתבת עיתון וסקר פתיחה. ההצגה נפתחת בכותרת מהעיתונות הכלכלית על התייעלות באמצעות בינה מלאכותית בענף ההייטק ("הקשיים של מנהלי הייטק", 2026), ולאחריה הכיתה מתבקשת לדרג, בסולם 1 עד 5, עד כמה העבודה או הלימודים הנוכחיים מרגישים ברורים, בשליטה ומשמעותיים. שלוש השאלות הן שלושת רכיבי תחושת הקוהרנטיות בעבודה, והתוצאות נשמרות לדיון בסיום.</a:t>
+              <a:t>‫כתבת עיתון וסקר פתיחה. ההצגה נפתחת בכותרת מהעיתונות הכלכלית על התייעלות באמצעות בינה מלאכותית בענף ההייטק ("הקשיים של מנהלי הייטק", 2026), ולאחריה הכיתה מתבקשת לדרג, בסולם 1 עד 5, עד כמה העבודה או הלימודים הנוכחיים מרגישים ברורים, בשליטה ומשמעותיים. שלוש השאלות הן שלושת רכיבי תחושת הקוהרנטיות בעבודה, והתוצאות נשמרות לדיון בסיום.‬</a:t>
             </a:r>
             <a:endParaRPr lang="he-IL" sz="1600" dirty="0"/>
           </a:p>
@@ -5098,7 +5098,7 @@
                 <a:ea typeface="David" pitchFamily="34" charset="-122"/>
                 <a:cs typeface="David" pitchFamily="34" charset="-120"/>
               </a:rPr>
-              <a:t>‏סרטון. יוקרן קטע של כ-75 שניות מהרצאת TED של חוקרת החוסן לוסי הון, המציעה שלושה עקרונות: לקבל שדברים רעים קורים, לבחור במה להתמקד ולהפנות את הקשב למה שבשליטתנו, ולשאול על כל פעולה האם היא עוזרת או פוגעת (Hone, 2019). שני העקרונות האחרונים הם, במונחי המאמר, חיזוק המובנות והניהוליות והבחירה לעצב את המצב במקום רק לשרוד אותו.</a:t>
+              <a:t>‫סרטון. יוקרן קטע של כ-75 שניות מהרצאת TED של חוקרת החוסן לוסי הון, המציעה שלושה עקרונות: לקבל שדברים רעים קורים, לבחור במה להתמקד ולהפנות את הקשב למה שבשליטתנו, ולשאול על כל פעולה האם היא עוזרת או פוגעת (Hone, 2019). שני העקרונות האחרונים הם, במונחי המאמר, חיזוק המובנות והניהוליות והבחירה לעצב את המצב במקום רק לשרוד אותו.‬</a:t>
             </a:r>
             <a:endParaRPr lang="he-IL" sz="1600" dirty="0"/>
           </a:p>
@@ -5188,7 +5188,7 @@
                 <a:ea typeface="David" pitchFamily="34" charset="-122"/>
                 <a:cs typeface="David" pitchFamily="34" charset="-120"/>
               </a:rPr>
-              <a:t>‏הפעלה. כל סטודנט בוחר צורך התקרבות אחד מתוך ארבעת הצרכים שבאיור 2, כותב פעולה אחת קונקרטית ומועד לביצועה, ומשתף את השכן במשפט אחד. לאחר מכן נאספות שתיים או שלוש דוגמאות מהכיתה ומחוברות לממצא: פעולות מסוג זה, לפי המאמר, מנבאות עלייה בבהירות, בשליטה ובמשמעות חצי שנה מאוחר יותר (Cetkovská et al., 2026). משך ההפעלה כשתי דקות.</a:t>
+              <a:t>‫הפעלה. כל סטודנט בוחר צורך התקרבות אחד מתוך ארבעת הצרכים שבאיור 2, כותב פעולה אחת קונקרטית ומועד לביצועה, ומשתף את השכן במשפט אחד. לאחר מכן נאספות שתיים או שלוש דוגמאות מהכיתה ומחוברות לממצא: פעולות מסוג זה, לפי המאמר, מנבאות עלייה בבהירות, בשליטה ובמשמעות חצי שנה מאוחר יותר (Cetkovská et al., 2026). משך ההפעלה כשתי דקות.‬</a:t>
             </a:r>
             <a:endParaRPr lang="he-IL" sz="1600" dirty="0"/>
           </a:p>
@@ -5250,7 +5250,7 @@
                 <a:ea typeface="David" pitchFamily="34" charset="-122"/>
                 <a:cs typeface="David" pitchFamily="34" charset="-120"/>
               </a:rPr>
-              <a:t>‏ניהול קריירה בארגונים, הקריה האקדמית אונו</a:t>
+              <a:t>‫ניהול קריירה בארגונים, הקריה האקדמית אונו‬</a:t>
             </a:r>
             <a:endParaRPr lang="he-IL" sz="1000" dirty="0"/>
           </a:p>
@@ -5289,7 +5289,7 @@
                 <a:ea typeface="David" pitchFamily="34" charset="-122"/>
                 <a:cs typeface="David" pitchFamily="34" charset="-120"/>
               </a:rPr>
-              <a:t>‏14</a:t>
+              <a:t>‫14‬</a:t>
             </a:r>
             <a:endParaRPr lang="he-IL" sz="1100" dirty="0"/>
           </a:p>
@@ -5410,7 +5410,7 @@
                 <a:ea typeface="David" pitchFamily="34" charset="-122"/>
                 <a:cs typeface="David" pitchFamily="34" charset="-120"/>
               </a:rPr>
-              <a:t>‏סיכום</a:t>
+              <a:t>‫סיכום‬</a:t>
             </a:r>
             <a:endParaRPr lang="he-IL" sz="2800" dirty="0"/>
           </a:p>
@@ -5452,7 +5452,7 @@
                 <a:ea typeface="David" pitchFamily="34" charset="-122"/>
                 <a:cs typeface="David" pitchFamily="34" charset="-120"/>
               </a:rPr>
-              <a:t>‏העבודה פתחה בשאלה מה מאפשר לעובדים להישאר בריאים ומתפקדים כשעולם העבודה אינו יציב. התשובה שעלתה ממחקר האורך של צטקובסקה ואחרים היא שתחושת הקוהרנטיות בעבודה היא משאב דינמי שהעובד יכול לחזק בעצמו באמצעות עיצוב תפקיד המכוון לצרכי אוטונומיה, מיומנות, משמעות ושייכות, ושהמשאב הזה בתורו מזין יוזמה נוספת (Cetkovská et al., 2026). המאמר המשלים הראה שהמודעות לבינה מלאכותית היא מקור מרכזי לחוסר הביטחון של ימינו ושמשאב אישי ממתן אותו (Chung et al., 2025).</a:t>
+              <a:t>‫העבודה פתחה בשאלה מה מאפשר לעובדים להישאר בריאים ומתפקדים כשעולם העבודה אינו יציב. התשובה שעלתה ממחקר האורך של צטקובסקה ואחרים היא שתחושת הקוהרנטיות בעבודה היא משאב דינמי שהעובד יכול לחזק בעצמו באמצעות עיצוב תפקיד המכוון לצרכי אוטונומיה, מיומנות, משמעות ושייכות, ושהמשאב הזה בתורו מזין יוזמה נוספת (Cetkovská et al., 2026). המאמר המשלים הראה שהמודעות לבינה מלאכותית היא מקור מרכזי לחוסר הביטחון של ימינו ושמשאב אישי ממתן אותו (Chung et al., 2025).‬</a:t>
             </a:r>
             <a:endParaRPr lang="he-IL" sz="1600" dirty="0"/>
           </a:p>
@@ -5494,7 +5494,7 @@
                 <a:ea typeface="David" pitchFamily="34" charset="-122"/>
                 <a:cs typeface="David" pitchFamily="34" charset="-120"/>
               </a:rPr>
-              <a:t>‏מכאן ההמלצות היישומיות. לסטודנט: לבחור בכל שבועיים צורך התקרבות אחד ופעולה אחת של עיצוב תפקיד, ללמוד כלי בינה מלאכותית אחד בתחום העיסוק, ולתעד בסוף כל שבוע דבר אחד שנלמד. למנהל: לטפח תחושת ניהוליות באמצעות משאבים ומידע ברור, לתת מרחב לעיצוב תפקיד, ולתקשר שינויים טכנולוגיים בשקיפות. את חוסר הוודאות לא תמיד אפשר למנוע. את הבהירות, השליטה והמשמעות בתוך התפקיד אפשר לבנות.</a:t>
+              <a:t>‫מכאן ההמלצות היישומיות. לסטודנט: לבחור בכל שבועיים צורך התקרבות אחד ופעולה אחת של עיצוב תפקיד, ללמוד כלי בינה מלאכותית אחד בתחום העיסוק, ולתעד בסוף כל שבוע דבר אחד שנלמד. למנהל: לטפח תחושת ניהוליות באמצעות משאבים ומידע ברור, לתת מרחב לעיצוב תפקיד, ולתקשר שינויים טכנולוגיים בשקיפות. את חוסר הוודאות לא תמיד אפשר למנוע. את הבהירות, השליטה והמשמעות בתוך התפקיד אפשר לבנות.‬</a:t>
             </a:r>
             <a:endParaRPr lang="he-IL" sz="1600" dirty="0"/>
           </a:p>
@@ -5533,7 +5533,7 @@
                 <a:ea typeface="David" pitchFamily="34" charset="-122"/>
                 <a:cs typeface="David" pitchFamily="34" charset="-120"/>
               </a:rPr>
-              <a:t>‏תודה. אשמח לשאלות.</a:t>
+              <a:t>‫תודה. אשמח לשאלות.‬</a:t>
             </a:r>
             <a:endParaRPr lang="he-IL" sz="1600" dirty="0"/>
           </a:p>
@@ -5595,7 +5595,7 @@
                 <a:ea typeface="David" pitchFamily="34" charset="-122"/>
                 <a:cs typeface="David" pitchFamily="34" charset="-120"/>
               </a:rPr>
-              <a:t>‏ניהול קריירה בארגונים, הקריה האקדמית אונו</a:t>
+              <a:t>‫ניהול קריירה בארגונים, הקריה האקדמית אונו‬</a:t>
             </a:r>
             <a:endParaRPr lang="he-IL" sz="1000" dirty="0"/>
           </a:p>
@@ -5634,7 +5634,7 @@
                 <a:ea typeface="David" pitchFamily="34" charset="-122"/>
                 <a:cs typeface="David" pitchFamily="34" charset="-120"/>
               </a:rPr>
-              <a:t>‏15</a:t>
+              <a:t>‫15‬</a:t>
             </a:r>
             <a:endParaRPr lang="he-IL" sz="1100" dirty="0"/>
           </a:p>
@@ -5755,7 +5755,7 @@
                 <a:ea typeface="David" pitchFamily="34" charset="-122"/>
                 <a:cs typeface="David" pitchFamily="34" charset="-120"/>
               </a:rPr>
-              <a:t>‏רשימת מקורות</a:t>
+              <a:t>‫רשימת מקורות‬</a:t>
             </a:r>
             <a:endParaRPr lang="he-IL" sz="2800" dirty="0"/>
           </a:p>
@@ -5797,7 +5797,7 @@
                 <a:ea typeface="David" pitchFamily="34" charset="-122"/>
                 <a:cs typeface="David" pitchFamily="34" charset="-120"/>
               </a:rPr>
-              <a:t>‏בנק ישראל. (2025, 11 במרץ). ההשפעה הצפויה של בינה מלאכותית יוצרת על העובדים: השלכות על המדיניות בשוק העבודה [תיבה מתוך דוח בנק ישראל לשנת 2024].</a:t>
+              <a:t>‫בנק ישראל. (2025, 11 במרץ). ההשפעה הצפויה של בינה מלאכותית יוצרת על העובדים: השלכות על המדיניות בשוק העבודה [תיבה מתוך דוח בנק ישראל לשנת 2024].‬</a:t>
             </a:r>
             <a:endParaRPr lang="he-IL" sz="1300" dirty="0"/>
           </a:p>
@@ -5814,7 +5814,7 @@
                 <a:ea typeface="David" pitchFamily="34" charset="-122"/>
                 <a:cs typeface="David" pitchFamily="34" charset="-120"/>
               </a:rPr>
-              <a:t>‏הקשיים של מנהלי הייטק ב-2026: גיוס עובדים מתאימים והתייעלות AI. (2026, 21 ביוני). TheMarker.</a:t>
+              <a:t>‫הקשיים של מנהלי הייטק ב-2026: גיוס עובדים מתאימים והתייעלות AI. (2026, 21 ביוני). TheMarker.‬</a:t>
             </a:r>
             <a:endParaRPr lang="he-IL" sz="1300" dirty="0"/>
           </a:p>
@@ -5975,7 +5975,7 @@
                 <a:ea typeface="David" pitchFamily="34" charset="-122"/>
                 <a:cs typeface="David" pitchFamily="34" charset="-120"/>
               </a:rPr>
-              <a:t>‏ניהול קריירה בארגונים, הקריה האקדמית אונו</a:t>
+              <a:t>‫ניהול קריירה בארגונים, הקריה האקדמית אונו‬</a:t>
             </a:r>
             <a:endParaRPr lang="he-IL" sz="1000" dirty="0"/>
           </a:p>
@@ -6014,7 +6014,7 @@
                 <a:ea typeface="David" pitchFamily="34" charset="-122"/>
                 <a:cs typeface="David" pitchFamily="34" charset="-120"/>
               </a:rPr>
-              <a:t>‏16</a:t>
+              <a:t>‫16‬</a:t>
             </a:r>
             <a:endParaRPr lang="he-IL" sz="1100" dirty="0"/>
           </a:p>
@@ -6135,7 +6135,7 @@
                 <a:ea typeface="David" pitchFamily="34" charset="-122"/>
                 <a:cs typeface="David" pitchFamily="34" charset="-120"/>
               </a:rPr>
-              <a:t>‏מבוא: הצגת הנושא</a:t>
+              <a:t>‫מבוא: הצגת הנושא‬</a:t>
             </a:r>
             <a:endParaRPr lang="he-IL" sz="2800" dirty="0"/>
           </a:p>
@@ -6177,7 +6177,7 @@
                 <a:ea typeface="David" pitchFamily="34" charset="-122"/>
                 <a:cs typeface="David" pitchFamily="34" charset="-120"/>
               </a:rPr>
-              <a:t>‏עולם העבודה של שנת 2026 מתאפיין באי-ודאות. גלי ההתייעלות בענף ההייטק, כניסת הבינה המלאכותית היוצרת לתפקידי צווארון לבן, המלחמה ושירות המילואים הממושך והמעבר לצורות העסקה גמישות יצרו מציאות שבה גם עובדים בעלי ותק אינם יודעים כיצד ייראה תפקידם בעוד שנה. תיבה בדוח בנק ישראל לשנת 2024 העריכה כי כחמישית מהמועסקים בישראל עובדים במקצועות שבהם הביקוש צפוי לרדת באופן משמעותי עם התרחבות השימוש בבינה מלאכותית (בנק ישראל, 2025), ובעיתונות הכלכלית דווח כי ההתייעלות באמצעות בינה מלאכותית עומדת בראש סדר היום של מנהלי ההייטק ("הקשיים של מנהלי הייטק", 2026). חוסר ביטחון תעסוקתי, החשש לאבד את המשרה או את מאפייניה החשובים, הפך מאירוע חריג לתנאי קבוע (Chung et al., 2025).</a:t>
+              <a:t>‫עולם העבודה של שנת 2026 מתאפיין באי-ודאות. גלי ההתייעלות בענף ההייטק, כניסת הבינה המלאכותית היוצרת לתפקידי צווארון לבן, המלחמה ושירות המילואים הממושך והמעבר לצורות העסקה גמישות יצרו מציאות שבה גם עובדים בעלי ותק אינם יודעים כיצד ייראה תפקידם בעוד שנה. תיבה בדוח בנק ישראל לשנת 2024 העריכה כי כחמישית מהמועסקים בישראל עובדים במקצועות שבהם הביקוש צפוי לרדת באופן משמעותי עם התרחבות השימוש בבינה מלאכותית (בנק ישראל, 2025), ובעיתונות הכלכלית דווח כי ההתייעלות באמצעות בינה מלאכותית עומדת בראש סדר היום של מנהלי ההייטק ("הקשיים של מנהלי הייטק", 2026). חוסר ביטחון תעסוקתי, החשש לאבד את המשרה או את מאפייניה החשובים, הפך מאירוע חריג לתנאי קבוע (Chung et al., 2025).‬</a:t>
             </a:r>
             <a:endParaRPr lang="he-IL" sz="1600" dirty="0"/>
           </a:p>
@@ -6219,7 +6219,7 @@
                 <a:ea typeface="David" pitchFamily="34" charset="-122"/>
                 <a:cs typeface="David" pitchFamily="34" charset="-120"/>
               </a:rPr>
-              <a:t>‏רוב המחקר בתחום שואל מה הנזק שאי-הוודאות גורמת. עבודה זו בוחרת בשאלה ההפוכה, שהציב אהרן אנטונובסקי מאוניברסיטת בן-גוריון: מה מאפשר לעובדים להישאר בריאים ומתפקדים גם כשהסביבה אינה יציבה (Antonovsky, 1987, כפי שמצוטט אצל Cetkovská et al., 2026). המאמר שנבחר מציע תשובה שנמצאת בשליטת העובד עצמו.</a:t>
+              <a:t>‫רוב המחקר בתחום שואל מה הנזק שאי-הוודאות גורמת. עבודה זו בוחרת בשאלה ההפוכה, שהציב אהרן אנטונובסקי מאוניברסיטת בן-גוריון: מה מאפשר לעובדים להישאר בריאים ומתפקדים גם כשהסביבה אינה יציבה (Antonovsky, 1987, כפי שמצוטט אצל Cetkovská et al., 2026). המאמר שנבחר מציע תשובה שנמצאת בשליטת העובד עצמו.‬</a:t>
             </a:r>
             <a:endParaRPr lang="he-IL" sz="1600" dirty="0"/>
           </a:p>
@@ -6281,7 +6281,7 @@
                 <a:ea typeface="David" pitchFamily="34" charset="-122"/>
                 <a:cs typeface="David" pitchFamily="34" charset="-120"/>
               </a:rPr>
-              <a:t>‏ניהול קריירה בארגונים, הקריה האקדמית אונו</a:t>
+              <a:t>‫ניהול קריירה בארגונים, הקריה האקדמית אונו‬</a:t>
             </a:r>
             <a:endParaRPr lang="he-IL" sz="1000" dirty="0"/>
           </a:p>
@@ -6320,7 +6320,7 @@
                 <a:ea typeface="David" pitchFamily="34" charset="-122"/>
                 <a:cs typeface="David" pitchFamily="34" charset="-120"/>
               </a:rPr>
-              <a:t>‏2</a:t>
+              <a:t>‫2‬</a:t>
             </a:r>
             <a:endParaRPr lang="he-IL" sz="1100" dirty="0"/>
           </a:p>
@@ -6441,7 +6441,7 @@
                 <a:ea typeface="David" pitchFamily="34" charset="-122"/>
                 <a:cs typeface="David" pitchFamily="34" charset="-120"/>
               </a:rPr>
-              <a:t>‏מבוא: הצגת המאמר</a:t>
+              <a:t>‫מבוא: הצגת המאמר‬</a:t>
             </a:r>
             <a:endParaRPr lang="he-IL" sz="2800" dirty="0"/>
           </a:p>
@@ -6522,7 +6522,7 @@
                 <a:ea typeface="David" pitchFamily="34" charset="-122"/>
                 <a:cs typeface="David" pitchFamily="34" charset="-120"/>
               </a:rPr>
-              <a:t>‏המאמר שנבחר הוא מחקר אמפירי כמותי במערך אורך, שפורסם בשנת 2026 בכתב העת השפיט Scandinavian Journal of Work and Organizational Psychology, היוצא לאור בהוצאת אוניברסיטת סטוקהולם, בגישה פתוחה מלאה. מחבריו הם קריסטינה צטקובסקה מאוניברסיטת קארל בפראג, וגאורג באואר ומרטין טושל מהמרכז לסלוטוגנזה באוניברסיטת ציריך, והמחקר מומן על ידי הקרן הלאומית השווייצרית למדע (Cetkovská et al., 2026).</a:t>
+              <a:t>‫המאמר שנבחר הוא מחקר אמפירי כמותי במערך אורך, שפורסם בשנת 2026 בכתב העת השפיט Scandinavian Journal of Work and Organizational Psychology, היוצא לאור בהוצאת אוניברסיטת סטוקהולם, בגישה פתוחה מלאה. מחבריו הם קריסטינה צטקובסקה מאוניברסיטת קארל בפראג, וגאורג באואר ומרטין טושל מהמרכז לסלוטוגנזה באוניברסיטת ציריך, והמחקר מומן על ידי הקרן הלאומית השווייצרית למדע (Cetkovská et al., 2026).‬</a:t>
             </a:r>
             <a:endParaRPr lang="he-IL" sz="1600" dirty="0"/>
           </a:p>
@@ -6564,7 +6564,7 @@
                 <a:ea typeface="David" pitchFamily="34" charset="-122"/>
                 <a:cs typeface="David" pitchFamily="34" charset="-120"/>
               </a:rPr>
-              <a:t>‏מדובר במחקר פאנל בשני גלי מדידה בהפרש של שישה חודשים, שבו השתתפו 924 עובדים מגרמניה ומשווייץ. המאמר נבחר משום שהוא שואל מה עוזר לעובדים ולא רק מה מזיק להם, משום שהוא מציע כלי שאינו תלוי בארגון, ומשום שהוא עומד בדרישות המטלה: מאמר שפיט מחמש השנים האחרונות, מקיף ומהימן, הזמין במלואו לכל קורא (Cetkovská et al., 2026).</a:t>
+              <a:t>‫מדובר במחקר פאנל בשני גלי מדידה בהפרש של שישה חודשים, שבו השתתפו 924 עובדים מגרמניה ומשווייץ. המאמר נבחר משום שהוא שואל מה עוזר לעובדים ולא רק מה מזיק להם, משום שהוא מציע כלי שאינו תלוי בארגון, ומשום שהוא עומד בדרישות המטלה: מאמר שפיט מחמש השנים האחרונות, מקיף ומהימן, הזמין במלואו לכל קורא (Cetkovská et al., 2026).‬</a:t>
             </a:r>
             <a:endParaRPr lang="he-IL" sz="1600" dirty="0"/>
           </a:p>
@@ -6626,7 +6626,7 @@
                 <a:ea typeface="David" pitchFamily="34" charset="-122"/>
                 <a:cs typeface="David" pitchFamily="34" charset="-120"/>
               </a:rPr>
-              <a:t>‏ניהול קריירה בארגונים, הקריה האקדמית אונו</a:t>
+              <a:t>‫ניהול קריירה בארגונים, הקריה האקדמית אונו‬</a:t>
             </a:r>
             <a:endParaRPr lang="he-IL" sz="1000" dirty="0"/>
           </a:p>
@@ -6665,7 +6665,7 @@
                 <a:ea typeface="David" pitchFamily="34" charset="-122"/>
                 <a:cs typeface="David" pitchFamily="34" charset="-120"/>
               </a:rPr>
-              <a:t>‏3</a:t>
+              <a:t>‫3‬</a:t>
             </a:r>
             <a:endParaRPr lang="he-IL" sz="1100" dirty="0"/>
           </a:p>
@@ -6786,7 +6786,7 @@
                 <a:ea typeface="David" pitchFamily="34" charset="-122"/>
                 <a:cs typeface="David" pitchFamily="34" charset="-120"/>
               </a:rPr>
-              <a:t>‏תמצית המאמר: הרקע התיאורטי</a:t>
+              <a:t>‫תמצית המאמר: הרקע התיאורטי‬</a:t>
             </a:r>
             <a:endParaRPr lang="he-IL" sz="2800" dirty="0"/>
           </a:p>
@@ -6828,7 +6828,7 @@
                 <a:ea typeface="David" pitchFamily="34" charset="-122"/>
                 <a:cs typeface="David" pitchFamily="34" charset="-120"/>
               </a:rPr>
-              <a:t>‏הגישה הסלוטוגנית הופכת את שאלת המחקר המקובלת: במקום לשאול מדוע אנשים חולים, היא שואלת כיצד הם שומרים על בריאותם למרות גורמי דחק. במרכזה עומדת תחושת הקוהרנטיות, המידה שבה האדם תופס את חייו כמובנים, כניתנים לניהול וכמשמעותיים (Antonovsky, 1987, כפי שמצוטט אצל Cetkovská et al., 2026). על בסיס זה פותח המושג תחושת קוהרנטיות בעבודה, המתייחס למצב העבודה הנוכחי בלבד ומורכב משלושה רכיבים. בניגוד לתחושת הקוהרנטיות הכללית, המתייצבת בבגרות הצעירה, הרכיב התעסוקתי דינמי ומעוצב ללא הרף על ידי תנאי העבודה (Cetkovská et al., 2026).</a:t>
+              <a:t>‫הגישה הסלוטוגנית הופכת את שאלת המחקר המקובלת: במקום לשאול מדוע אנשים חולים, היא שואלת כיצד הם שומרים על בריאותם למרות גורמי דחק. במרכזה עומדת תחושת הקוהרנטיות, המידה שבה האדם תופס את חייו כמובנים, כניתנים לניהול וכמשמעותיים (Antonovsky, 1987, כפי שמצוטט אצל Cetkovská et al., 2026). על בסיס זה פותח המושג תחושת קוהרנטיות בעבודה, המתייחס למצב העבודה הנוכחי בלבד ומורכב משלושה רכיבים. בניגוד לתחושת הקוהרנטיות הכללית, המתייצבת בבגרות הצעירה, הרכיב התעסוקתי דינמי ומעוצב ללא הרף על ידי תנאי העבודה (Cetkovská et al., 2026).‬</a:t>
             </a:r>
             <a:endParaRPr lang="he-IL" sz="1600" dirty="0"/>
           </a:p>
@@ -6942,7 +6942,7 @@
                 <a:ea typeface="David" pitchFamily="34" charset="-122"/>
                 <a:cs typeface="David" pitchFamily="34" charset="-120"/>
               </a:rPr>
-              <a:t>‏מובנות (רכיב קוגניטיבי)</a:t>
+              <a:t>‫מובנות (רכיב קוגניטיבי)‬</a:t>
             </a:r>
             <a:endParaRPr lang="he-IL" sz="1600" dirty="0"/>
           </a:p>
@@ -6984,7 +6984,7 @@
                 <a:ea typeface="David" pitchFamily="34" charset="-122"/>
                 <a:cs typeface="David" pitchFamily="34" charset="-120"/>
               </a:rPr>
-              <a:t>‏מצב העבודה נתפס כמובנה, עקבי וברור. חוסר ודאות פוגע ברכיב זה ראשון: העתיד אינו צפוי.</a:t>
+              <a:t>‫מצב העבודה נתפס כמובנה, עקבי וברור. חוסר ודאות פוגע ברכיב זה ראשון: העתיד אינו צפוי.‬</a:t>
             </a:r>
             <a:endParaRPr lang="he-IL" sz="1300" dirty="0"/>
           </a:p>
@@ -7098,7 +7098,7 @@
                 <a:ea typeface="David" pitchFamily="34" charset="-122"/>
                 <a:cs typeface="David" pitchFamily="34" charset="-120"/>
               </a:rPr>
-              <a:t>‏ניהוליות (רכיב התנהגותי)</a:t>
+              <a:t>‫ניהוליות (רכיב התנהגותי)‬</a:t>
             </a:r>
             <a:endParaRPr lang="he-IL" sz="1600" dirty="0"/>
           </a:p>
@@ -7140,7 +7140,7 @@
                 <a:ea typeface="David" pitchFamily="34" charset="-122"/>
                 <a:cs typeface="David" pitchFamily="34" charset="-120"/>
               </a:rPr>
-              <a:t>‏לעובד יש משאבים מספיקים להתמודד עם הדרישות. בתקופת אי-ודאות המשאבים נראים בלתי מספיקים.</a:t>
+              <a:t>‫לעובד יש משאבים מספיקים להתמודד עם הדרישות. בתקופת אי-ודאות המשאבים נראים בלתי מספיקים.‬</a:t>
             </a:r>
             <a:endParaRPr lang="he-IL" sz="1300" dirty="0"/>
           </a:p>
@@ -7254,7 +7254,7 @@
                 <a:ea typeface="David" pitchFamily="34" charset="-122"/>
                 <a:cs typeface="David" pitchFamily="34" charset="-120"/>
               </a:rPr>
-              <a:t>‏משמעותיות (רכיב מוטיבציוני)</a:t>
+              <a:t>‫משמעותיות (רכיב מוטיבציוני)‬</a:t>
             </a:r>
             <a:endParaRPr lang="he-IL" sz="1600" dirty="0"/>
           </a:p>
@@ -7296,7 +7296,7 @@
                 <a:ea typeface="David" pitchFamily="34" charset="-122"/>
                 <a:cs typeface="David" pitchFamily="34" charset="-120"/>
               </a:rPr>
-              <a:t>‏מצב העבודה נתפס כראוי למחויבות ולמעורבות. קשה להתחייב למה שעלול להיעלם.</a:t>
+              <a:t>‫מצב העבודה נתפס כראוי למחויבות ולמעורבות. קשה להתחייב למה שעלול להיעלם.‬</a:t>
             </a:r>
             <a:endParaRPr lang="he-IL" sz="1300" dirty="0"/>
           </a:p>
@@ -7335,7 +7335,7 @@
                 <a:ea typeface="David" pitchFamily="34" charset="-122"/>
                 <a:cs typeface="David" pitchFamily="34" charset="-120"/>
               </a:rPr>
-              <a:t>‏איור 1: שלושת רכיבי תחושת הקוהרנטיות בעבודה ופגיעתו של חוסר הוודאות בכל אחד מהם (על פי Cetkovská et al., 2026)</a:t>
+              <a:t>‫איור 1: שלושת רכיבי תחושת הקוהרנטיות בעבודה ופגיעתו של חוסר הוודאות בכל אחד מהם (על פי Cetkovská et al., 2026)‬</a:t>
             </a:r>
             <a:endParaRPr lang="he-IL" sz="1100" dirty="0"/>
           </a:p>
@@ -7397,7 +7397,7 @@
                 <a:ea typeface="David" pitchFamily="34" charset="-122"/>
                 <a:cs typeface="David" pitchFamily="34" charset="-120"/>
               </a:rPr>
-              <a:t>‏ניהול קריירה בארגונים, הקריה האקדמית אונו</a:t>
+              <a:t>‫ניהול קריירה בארגונים, הקריה האקדמית אונו‬</a:t>
             </a:r>
             <a:endParaRPr lang="he-IL" sz="1000" dirty="0"/>
           </a:p>
@@ -7436,7 +7436,7 @@
                 <a:ea typeface="David" pitchFamily="34" charset="-122"/>
                 <a:cs typeface="David" pitchFamily="34" charset="-120"/>
               </a:rPr>
-              <a:t>‏4</a:t>
+              <a:t>‫4‬</a:t>
             </a:r>
             <a:endParaRPr lang="he-IL" sz="1100" dirty="0"/>
           </a:p>
@@ -7557,7 +7557,7 @@
                 <a:ea typeface="David" pitchFamily="34" charset="-122"/>
                 <a:cs typeface="David" pitchFamily="34" charset="-120"/>
               </a:rPr>
-              <a:t>‏תמצית המאמר: עיצוב תפקיד מבוסס צרכים והשערות המחקר</a:t>
+              <a:t>‫תמצית המאמר: עיצוב תפקיד מבוסס צרכים והשערות המחקר‬</a:t>
             </a:r>
             <a:endParaRPr lang="he-IL" sz="2800" dirty="0"/>
           </a:p>
@@ -7599,7 +7599,7 @@
                 <a:ea typeface="David" pitchFamily="34" charset="-122"/>
                 <a:cs typeface="David" pitchFamily="34" charset="-120"/>
               </a:rPr>
-              <a:t>‏עיצוב תפקיד הוגדר לראשונה כמאמצים יזומים של עובדים להתאים היבטים של תפקידם לצרכיהם ולכישוריהם, גישה שהעבירה את העובד ממקבל פסיבי של תנאי עבודה לשחקן פעיל בעיצובם (Wrzesniewski &amp; Dutton, 2001, כפי שמצוטט אצל Cetkovská et al., 2026). המאמר משתמש בגרסה המתמקדת בסיפוק שישה צרכים פסיכולוגיים בעבודה, צרכי DRAMMA: ניתוק והרפיה הם צרכי הימנעות שמטרתם להפחית מאמץ ולהשיב אנרגיה, ואילו אוטונומיה, מיומנות, משמעות ושייכות הם צרכי התקרבות שמטרתם לייצר מצבים חיוביים, צמיחה ומשאבים חדשים. פריט לדוגמה: "ארגנתי את עבודתי כך שאשיג תחושת תכלית במה שאני עושה" (Cetkovská et al., 2026).</a:t>
+              <a:t>‫עיצוב תפקיד הוגדר לראשונה כמאמצים יזומים של עובדים להתאים היבטים של תפקידם לצרכיהם ולכישוריהם, גישה שהעבירה את העובד ממקבל פסיבי של תנאי עבודה לשחקן פעיל בעיצובם (Wrzesniewski &amp; Dutton, 2001, כפי שמצוטט אצל Cetkovská et al., 2026). המאמר משתמש בגרסה המתמקדת בסיפוק שישה צרכים פסיכולוגיים בעבודה, צרכי DRAMMA: ניתוק והרפיה הם צרכי הימנעות שמטרתם להפחית מאמץ ולהשיב אנרגיה, ואילו אוטונומיה, מיומנות, משמעות ושייכות הם צרכי התקרבות שמטרתם לייצר מצבים חיוביים, צמיחה ומשאבים חדשים. פריט לדוגמה: "ארגנתי את עבודתי כך שאשיג תחושת תכלית במה שאני עושה" (Cetkovská et al., 2026).‬</a:t>
             </a:r>
             <a:endParaRPr lang="he-IL" sz="1600" dirty="0"/>
           </a:p>
@@ -7641,7 +7641,7 @@
                 <a:ea typeface="David" pitchFamily="34" charset="-122"/>
                 <a:cs typeface="David" pitchFamily="34" charset="-120"/>
               </a:rPr>
-              <a:t>‏על בסיס תיאוריית שימור המשאבים, שלפיה מי שמחזיק במשאבים נוטה לפתח משאבים נוספים (Hobfoll, 2001, כפי שמצוטט אצל Cetkovská et al., 2026), הועלו שתי השערות. ההשערה הראשונה היא שעיצוב תפקיד מבוסס צרכים מנבא באופן חיובי את שלושת רכיבי תחושת הקוהרנטיות חצי שנה מאוחר יותר. ההשערה השנייה היא שתחושת קוהרנטיות בעבודה מנבאת עיצוב תפקיד עתידי. יחד הן מתארות "ספירלת רווח" שבה שני המשתנים מחזקים זה את זה לאורך זמן (Cetkovská et al., 2026).</a:t>
+              <a:t>‫על בסיס תיאוריית שימור המשאבים, שלפיה מי שמחזיק במשאבים נוטה לפתח משאבים נוספים (Hobfoll, 2001, כפי שמצוטט אצל Cetkovská et al., 2026), הועלו שתי השערות. ההשערה הראשונה היא שעיצוב תפקיד מבוסס צרכים מנבא באופן חיובי את שלושת רכיבי תחושת הקוהרנטיות חצי שנה מאוחר יותר. ההשערה השנייה היא שתחושת קוהרנטיות בעבודה מנבאת עיצוב תפקיד עתידי. יחד הן מתארות "ספירלת רווח" שבה שני המשתנים מחזקים זה את זה לאורך זמן (Cetkovská et al., 2026).‬</a:t>
             </a:r>
             <a:endParaRPr lang="he-IL" sz="1600" dirty="0"/>
           </a:p>
@@ -7703,7 +7703,7 @@
                 <a:ea typeface="David" pitchFamily="34" charset="-122"/>
                 <a:cs typeface="David" pitchFamily="34" charset="-120"/>
               </a:rPr>
-              <a:t>‏ניהול קריירה בארגונים, הקריה האקדמית אונו</a:t>
+              <a:t>‫ניהול קריירה בארגונים, הקריה האקדמית אונו‬</a:t>
             </a:r>
             <a:endParaRPr lang="he-IL" sz="1000" dirty="0"/>
           </a:p>
@@ -7742,7 +7742,7 @@
                 <a:ea typeface="David" pitchFamily="34" charset="-122"/>
                 <a:cs typeface="David" pitchFamily="34" charset="-120"/>
               </a:rPr>
-              <a:t>‏5</a:t>
+              <a:t>‫5‬</a:t>
             </a:r>
             <a:endParaRPr lang="he-IL" sz="1100" dirty="0"/>
           </a:p>
@@ -7863,7 +7863,7 @@
                 <a:ea typeface="David" pitchFamily="34" charset="-122"/>
                 <a:cs typeface="David" pitchFamily="34" charset="-120"/>
               </a:rPr>
-              <a:t>‏תמצית המאמר: שיטת המחקר</a:t>
+              <a:t>‫תמצית המאמר: שיטת המחקר‬</a:t>
             </a:r>
             <a:endParaRPr lang="he-IL" sz="2800" dirty="0"/>
           </a:p>
@@ -7905,7 +7905,7 @@
                 <a:ea typeface="David" pitchFamily="34" charset="-122"/>
                 <a:cs typeface="David" pitchFamily="34" charset="-120"/>
               </a:rPr>
-              <a:t>‏המחקר הוא מחקר פאנל בשני גלים בהפרש של שישה חודשים, במסגרת פרויקט Craft4Health. הנתונים נאספו בשאלון מקוון ממדגם מכסות של האוכלוסייה העובדת בגרמניה ובאזור דובר הגרמנית בשווייץ, בדצמבר 2021 עד ינואר 2022 וביוני עד יולי 2022. בגל הראשון השתתפו 924 עובדים, לאחר סינון 53 משיבים רשלניים, ו-740 מהם השלימו את הגל השני, שיעור השתתפות של 80%. במדגם 56% גברים, הגיל הממוצע 48.9, ממוצע שעות העבודה השבועיות 38.1, ו-35% מהמשתתפים בעלי תואר אקדמי (Cetkovská et al., 2026).</a:t>
+              <a:t>‫המחקר הוא מחקר פאנל בשני גלים בהפרש של שישה חודשים, במסגרת פרויקט Craft4Health. הנתונים נאספו בשאלון מקוון ממדגם מכסות של האוכלוסייה העובדת בגרמניה ובאזור דובר הגרמנית בשווייץ, בדצמבר 2021 עד ינואר 2022 וביוני עד יולי 2022. בגל הראשון השתתפו 924 עובדים, לאחר סינון 53 משיבים רשלניים, ו-740 מהם השלימו את הגל השני, שיעור השתתפות של 80%. במדגם 56% גברים, הגיל הממוצע 48.9, ממוצע שעות העבודה השבועיות 38.1, ו-35% מהמשתתפים בעלי תואר אקדמי (Cetkovská et al., 2026).‬</a:t>
             </a:r>
             <a:endParaRPr lang="he-IL" sz="1600" dirty="0"/>
           </a:p>
@@ -7947,7 +7947,7 @@
                 <a:ea typeface="David" pitchFamily="34" charset="-122"/>
                 <a:cs typeface="David" pitchFamily="34" charset="-120"/>
               </a:rPr>
-              <a:t>‏תחושת קוהרנטיות בעבודה נמדדה בסולם של תשעה פריטים, שלושה לכל רכיב, בדיפרנציאל סמנטי בן שבע דרגות, למשל צפוי לעומת בלתי צפוי. עיצוב תפקיד מבוסס צרכים נמדד בסולם של 18 פריטים, שלושה לכל אחד משישה הצרכים, בסולם של חמש דרגות ביחס לשבועיים האחרונים. הניתוח נערך במודל פאנל צולב, לאחר ניתוח גורמים מאשש ובדיקת אי-שונות מדידה בין הגלים, והושוו ארבעה מודלים: יציבות בלבד, שני מודלים חד-כיווניים ומודל הדדי (Cetkovská et al., 2026).</a:t>
+              <a:t>‫תחושת קוהרנטיות בעבודה נמדדה בסולם של תשעה פריטים, שלושה לכל רכיב, בדיפרנציאל סמנטי בן שבע דרגות, למשל צפוי לעומת בלתי צפוי. עיצוב תפקיד מבוסס צרכים נמדד בסולם של 18 פריטים, שלושה לכל אחד משישה הצרכים, בסולם של חמש דרגות ביחס לשבועיים האחרונים. הניתוח נערך במודל פאנל צולב, לאחר ניתוח גורמים מאשש ובדיקת אי-שונות מדידה בין הגלים, והושוו ארבעה מודלים: יציבות בלבד, שני מודלים חד-כיווניים ומודל הדדי (Cetkovská et al., 2026).‬</a:t>
             </a:r>
             <a:endParaRPr lang="he-IL" sz="1600" dirty="0"/>
           </a:p>
@@ -8009,7 +8009,7 @@
                 <a:ea typeface="David" pitchFamily="34" charset="-122"/>
                 <a:cs typeface="David" pitchFamily="34" charset="-120"/>
               </a:rPr>
-              <a:t>‏ניהול קריירה בארגונים, הקריה האקדמית אונו</a:t>
+              <a:t>‫ניהול קריירה בארגונים, הקריה האקדמית אונו‬</a:t>
             </a:r>
             <a:endParaRPr lang="he-IL" sz="1000" dirty="0"/>
           </a:p>
@@ -8048,7 +8048,7 @@
                 <a:ea typeface="David" pitchFamily="34" charset="-122"/>
                 <a:cs typeface="David" pitchFamily="34" charset="-120"/>
               </a:rPr>
-              <a:t>‏6</a:t>
+              <a:t>‫6‬</a:t>
             </a:r>
             <a:endParaRPr lang="he-IL" sz="1100" dirty="0"/>
           </a:p>
@@ -8169,7 +8169,7 @@
                 <a:ea typeface="David" pitchFamily="34" charset="-122"/>
                 <a:cs typeface="David" pitchFamily="34" charset="-120"/>
               </a:rPr>
-              <a:t>‏תמצית המאמר: הממצאים המרכזיים</a:t>
+              <a:t>‫תמצית המאמר: הממצאים המרכזיים‬</a:t>
             </a:r>
             <a:endParaRPr lang="he-IL" sz="2800" dirty="0"/>
           </a:p>
@@ -8211,7 +8211,7 @@
                 <a:ea typeface="David" pitchFamily="34" charset="-122"/>
                 <a:cs typeface="David" pitchFamily="34" charset="-120"/>
               </a:rPr>
-              <a:t>‏המודל ההדדי השיג את ההתאמה הטובה ביותר לנתונים. עיצוב תפקיד לצרכי התקרבות ניבא באופן מובהק את שלושת הרכיבים חצי שנה מאוחר יותר: מובנות (β = 0.142, p = .002), ניהוליות (β = 0.137, p = .003) ומשמעותיות (β = 0.166, p &lt; .001). עיצוב תפקיד לצרכי הימנעות לא ניבא אף אחד מהם (β בין 0.03 ל-0.09, לא מובהק). בכיוון ההפוך, ניהוליות (β = 0.431, p &lt; .001) ומשמעותיות (β = 0.095) ניבאו עיצוב תפקיד עתידי לצרכי התקרבות, ומובנות הראתה מקדם שלילי שהמחברים מייחסים לאפקט דיכוי סטטיסטי. המודל הסביר 56% עד 66% מהשונות ברכיבי תחושת הקוהרנטיות (Cetkovská et al., 2026).</a:t>
+              <a:t>‫המודל ההדדי השיג את ההתאמה הטובה ביותר לנתונים. עיצוב תפקיד לצרכי התקרבות ניבא באופן מובהק את שלושת הרכיבים חצי שנה מאוחר יותר: מובנות (β = 0.142, p = .002), ניהוליות (β = 0.137, p = .003) ומשמעותיות (β = 0.166, p &lt; .001). עיצוב תפקיד לצרכי הימנעות לא ניבא אף אחד מהם (β בין 0.03 ל-0.09, לא מובהק). בכיוון ההפוך, ניהוליות (β = 0.431, p &lt; .001) ומשמעותיות (β = 0.095) ניבאו עיצוב תפקיד עתידי לצרכי התקרבות, ומובנות הראתה מקדם שלילי שהמחברים מייחסים לאפקט דיכוי סטטיסטי. המודל הסביר 56% עד 66% מהשונות ברכיבי תחושת הקוהרנטיות (Cetkovská et al., 2026).‬</a:t>
             </a:r>
             <a:endParaRPr lang="he-IL" sz="1500" dirty="0"/>
           </a:p>
@@ -8266,7 +8266,7 @@
                 <a:ea typeface="David" pitchFamily="34" charset="-122"/>
                 <a:cs typeface="David" pitchFamily="34" charset="-120"/>
               </a:rPr>
-              <a:t>‏תרשים 1: מקדמי ניבוי מתוקננים (β) של שלושת רכיבי תחושת הקוהרנטיות בגל 2 לפי סוג עיצוב התפקיד בגל 1 (Cetkovská et al., 2026, טבלה 4)</a:t>
+              <a:t>‫תרשים 1: מקדמי ניבוי מתוקננים (β) של שלושת רכיבי תחושת הקוהרנטיות בגל 2 לפי סוג עיצוב התפקיד בגל 1 (Cetkovská et al., 2026, טבלה 4)‬</a:t>
             </a:r>
             <a:endParaRPr lang="he-IL" sz="1100" dirty="0"/>
           </a:p>
@@ -8328,7 +8328,7 @@
                 <a:ea typeface="David" pitchFamily="34" charset="-122"/>
                 <a:cs typeface="David" pitchFamily="34" charset="-120"/>
               </a:rPr>
-              <a:t>‏ניהול קריירה בארגונים, הקריה האקדמית אונו</a:t>
+              <a:t>‫ניהול קריירה בארגונים, הקריה האקדמית אונו‬</a:t>
             </a:r>
             <a:endParaRPr lang="he-IL" sz="1000" dirty="0"/>
           </a:p>
@@ -8367,7 +8367,7 @@
                 <a:ea typeface="David" pitchFamily="34" charset="-122"/>
                 <a:cs typeface="David" pitchFamily="34" charset="-120"/>
               </a:rPr>
-              <a:t>‏7</a:t>
+              <a:t>‫7‬</a:t>
             </a:r>
             <a:endParaRPr lang="he-IL" sz="1100" dirty="0"/>
           </a:p>
@@ -8488,7 +8488,7 @@
                 <a:ea typeface="David" pitchFamily="34" charset="-122"/>
                 <a:cs typeface="David" pitchFamily="34" charset="-120"/>
               </a:rPr>
-              <a:t>‏תמצית המאמר: מסקנות המחברים, חוזקות ומגבלות</a:t>
+              <a:t>‫תמצית המאמר: מסקנות המחברים, חוזקות ומגבלות‬</a:t>
             </a:r>
             <a:endParaRPr lang="he-IL" sz="2800" dirty="0"/>
           </a:p>
@@ -8530,7 +8530,7 @@
                 <a:ea typeface="David" pitchFamily="34" charset="-122"/>
                 <a:cs typeface="David" pitchFamily="34" charset="-120"/>
               </a:rPr>
-              <a:t>‏המחברים מסיקים שתחושת הקוהרנטיות בעבודה היא משאב דינמי שמגיב לשינויים שהעובד עצמו יוזם. עובדים שמעצבים את תפקידם כדי לספק את צרכי האוטונומיה, המיומנות, המשמעות והשייכות תופסים את עבודתם, חצי שנה מאוחר יותר, כמובנת יותר, ניתנת לניהול יותר ומשמעותית יותר. עיצוב תפקיד שמכוון רק להתרחק מהעבודה ולנוח תומך בהתאוששות אך אינו משנה את תפיסת העבודה עצמה. לארגונים המסקנה היא שיש לטפח תחושת ניהוליות ולתת מרחב לעיצוב תפקיד, משום שהניהוליות היא המניע החזק ביותר ליוזמה נוספת (Cetkovská et al., 2026).</a:t>
+              <a:t>‫המחברים מסיקים שתחושת הקוהרנטיות בעבודה היא משאב דינמי שמגיב לשינויים שהעובד עצמו יוזם. עובדים שמעצבים את תפקידם כדי לספק את צרכי האוטונומיה, המיומנות, המשמעות והשייכות תופסים את עבודתם, חצי שנה מאוחר יותר, כמובנת יותר, ניתנת לניהול יותר ומשמעותית יותר. עיצוב תפקיד שמכוון רק להתרחק מהעבודה ולנוח תומך בהתאוששות אך אינו משנה את תפיסת העבודה עצמה. לארגונים המסקנה היא שיש לטפח תחושת ניהוליות ולתת מרחב לעיצוב תפקיד, משום שהניהוליות היא המניע החזק ביותר ליוזמה נוספת (Cetkovská et al., 2026).‬</a:t>
             </a:r>
             <a:endParaRPr lang="he-IL" sz="1600" dirty="0"/>
           </a:p>
@@ -8572,7 +8572,7 @@
                 <a:ea typeface="David" pitchFamily="34" charset="-122"/>
                 <a:cs typeface="David" pitchFamily="34" charset="-120"/>
               </a:rPr>
-              <a:t>‏חוזקות המחקר הן מערך האורך המאפשר לבחון כיווניות בזמן, המדגם הגדול והמאוזן, שיעור ההשתתפות הגבוה בגל השני וכלי המדידה המתוקפים. מגבלותיו, שהמחברים עצמם מפרטים, הן מדגם מערבי ולא מייצג לחלוטין, איסוף נתונים בתקופת הקורונה, דיווח עצמי בלבד, הקושי לפרש את המקדם השלילי של המובנות, ומודל פאנל צולב שאינו מפריד בין שונות בין-אישית לתוך-אישית, ולכן יש לפרש את הממצאים כקשרים בזמן ולא כהוכחה סיבתית (Cetkovská et al., 2026).</a:t>
+              <a:t>‫חוזקות המחקר הן מערך האורך המאפשר לבחון כיווניות בזמן, המדגם הגדול והמאוזן, שיעור ההשתתפות הגבוה בגל השני וכלי המדידה המתוקפים. מגבלותיו, שהמחברים עצמם מפרטים, הן מדגם מערבי ולא מייצג לחלוטין, איסוף נתונים בתקופת הקורונה, דיווח עצמי בלבד, הקושי לפרש את המקדם השלילי של המובנות, ומודל פאנל צולב שאינו מפריד בין שונות בין-אישית לתוך-אישית, ולכן יש לפרש את הממצאים כקשרים בזמן ולא כהוכחה סיבתית (Cetkovská et al., 2026).‬</a:t>
             </a:r>
             <a:endParaRPr lang="he-IL" sz="1600" dirty="0"/>
           </a:p>
@@ -8634,7 +8634,7 @@
                 <a:ea typeface="David" pitchFamily="34" charset="-122"/>
                 <a:cs typeface="David" pitchFamily="34" charset="-120"/>
               </a:rPr>
-              <a:t>‏ניהול קריירה בארגונים, הקריה האקדמית אונו</a:t>
+              <a:t>‫ניהול קריירה בארגונים, הקריה האקדמית אונו‬</a:t>
             </a:r>
             <a:endParaRPr lang="he-IL" sz="1000" dirty="0"/>
           </a:p>
@@ -8673,7 +8673,7 @@
                 <a:ea typeface="David" pitchFamily="34" charset="-122"/>
                 <a:cs typeface="David" pitchFamily="34" charset="-120"/>
               </a:rPr>
-              <a:t>‏8</a:t>
+              <a:t>‫8‬</a:t>
             </a:r>
             <a:endParaRPr lang="he-IL" sz="1100" dirty="0"/>
           </a:p>
@@ -8794,7 +8794,7 @@
                 <a:ea typeface="David" pitchFamily="34" charset="-122"/>
                 <a:cs typeface="David" pitchFamily="34" charset="-120"/>
               </a:rPr>
-              <a:t>‏המאמר המשלים: מודעות לבינה מלאכותית, חוסר ביטחון וחוסן קריירה</a:t>
+              <a:t>‫המאמר המשלים: מודעות לבינה מלאכותית, חוסר ביטחון וחוסן קריירה‬</a:t>
             </a:r>
             <a:endParaRPr lang="he-IL" sz="2800" dirty="0"/>
           </a:p>
@@ -8875,7 +8875,7 @@
                 <a:ea typeface="David" pitchFamily="34" charset="-122"/>
                 <a:cs typeface="David" pitchFamily="34" charset="-120"/>
               </a:rPr>
-              <a:t>‏לחיזוק הקשר בין המאמר המרכזי לבין נושא העבודה נבחר מחקר אורך נוסף, שפורסם בגישה פתוחה בכתב עת שפיט. המחברים, מאוניברסיטת סוּוֹן בדרום קוריאה, בחנו את ההשלכות של מודעות לבינה מלאכותית, כלומר תפיסת העובד שטכנולוגיה עלולה להחליף אותו או לשנות את תפקידו, על חוסר ביטחון תעסוקתי, על ביצועי משימה ועל התנהגות סוטה בעבודה. הנתונים נאספו בשלוש נקודות זמן מעובדי משרד במשרה מלאה (Chung et al., 2025).</a:t>
+              <a:t>‫לחיזוק הקשר בין המאמר המרכזי לבין נושא העבודה נבחר מחקר אורך נוסף, שפורסם בגישה פתוחה בכתב עת שפיט. המחברים, מאוניברסיטת סוּוֹן בדרום קוריאה, בחנו את ההשלכות של מודעות לבינה מלאכותית, כלומר תפיסת העובד שטכנולוגיה עלולה להחליף אותו או לשנות את תפקידו, על חוסר ביטחון תעסוקתי, על ביצועי משימה ועל התנהגות סוטה בעבודה. הנתונים נאספו בשלוש נקודות זמן מעובדי משרד במשרה מלאה (Chung et al., 2025).‬</a:t>
             </a:r>
             <a:endParaRPr lang="he-IL" sz="1600" dirty="0"/>
           </a:p>
@@ -8917,7 +8917,7 @@
                 <a:ea typeface="David" pitchFamily="34" charset="-122"/>
                 <a:cs typeface="David" pitchFamily="34" charset="-120"/>
               </a:rPr>
-              <a:t>‏הממצאים מראים שעצם המודעות לבינה מלאכותית, עוד לפני שינוי בפועל, מגבירה חוסר ביטחון תעסוקתי, ושחוסר הביטחון מתווך את הקשר בין המודעות לבין ירידה בביצועי המשימה ועלייה בהתנהגות סוטה. אצל עובדים בעלי חוסן קריירה גבוה הקשר בין המודעות לבין חוסר הביטחון היה חלש יותר (Chung et al., 2025). שני המאמרים משלימים זה את זה: המאמר המשלים מתאר את מקור חוסר הוודאות של שנת 2026 ומראה שמשאב אישי ממתן אותו, והמאמר המרכזי מראה כיצד בונים משאב כזה בפועל, באמצעות עיצוב תפקיד יזום (Cetkovská et al., 2026).</a:t>
+              <a:t>‫הממצאים מראים שעצם המודעות לבינה מלאכותית, עוד לפני שינוי בפועל, מגבירה חוסר ביטחון תעסוקתי, ושחוסר הביטחון מתווך את הקשר בין המודעות לבין ירידה בביצועי המשימה ועלייה בהתנהגות סוטה. אצל עובדים בעלי חוסן קריירה גבוה הקשר בין המודעות לבין חוסר הביטחון היה חלש יותר (Chung et al., 2025). שני המאמרים משלימים זה את זה: המאמר המשלים מתאר את מקור חוסר הוודאות של שנת 2026 ומראה שמשאב אישי ממתן אותו, והמאמר המרכזי מראה כיצד בונים משאב כזה בפועל, באמצעות עיצוב תפקיד יזום (Cetkovská et al., 2026).‬</a:t>
             </a:r>
             <a:endParaRPr lang="he-IL" sz="1600" dirty="0"/>
           </a:p>
@@ -8979,7 +8979,7 @@
                 <a:ea typeface="David" pitchFamily="34" charset="-122"/>
                 <a:cs typeface="David" pitchFamily="34" charset="-120"/>
               </a:rPr>
-              <a:t>‏ניהול קריירה בארגונים, הקריה האקדמית אונו</a:t>
+              <a:t>‫ניהול קריירה בארגונים, הקריה האקדמית אונו‬</a:t>
             </a:r>
             <a:endParaRPr lang="he-IL" sz="1000" dirty="0"/>
           </a:p>
@@ -9018,7 +9018,7 @@
                 <a:ea typeface="David" pitchFamily="34" charset="-122"/>
                 <a:cs typeface="David" pitchFamily="34" charset="-120"/>
               </a:rPr>
-              <a:t>‏9</a:t>
+              <a:t>‫9‬</a:t>
             </a:r>
             <a:endParaRPr lang="he-IL" sz="1100" dirty="0"/>
           </a:p>

</xml_diff>